<commit_message>
Devis: description libre par ouvrage/fourniture (titre + sous-titre affiche sur le PDF/Word), reprise automatique de la description depuis la bibliotheque, et fiche Client et chantier reorganisee (reference client en texte libre au lieu d'une liste a choisir, champs regroupes par paires : reference/client, telephone/email, adresse seule).
Nettoyage approfondi du projet: suppression de 6 pages orphelines (onboarding, welcome, compte, ancien flux devis en 3 etapes), d'une route de connexion de demonstration, d'un dossier de composants duplique obsolete (data/components), de plusieurs fonctions inutilisees (auth, mailer, base de donnees, mots de passe), d'un ancien generateur de PDF devenu inaccessible, et d'une dependance logicielle non utilisee.
</commit_message>
<xml_diff>
--- a/docs/manager-recap/Recap-Koji-Manager.pptx
+++ b/docs/manager-recap/Recap-Koji-Manager.pptx
@@ -37,9 +37,11 @@
     <p:sldId id="285" r:id="rId31"/>
     <p:sldId id="286" r:id="rId32"/>
     <p:sldId id="287" r:id="rId33"/>
+    <p:sldId id="288" r:id="rId34"/>
+    <p:sldId id="289" r:id="rId35"/>
   </p:sldIdLst>
   <p:notesMasterIdLst>
-    <p:notesMasterId r:id="rId34"/>
+    <p:notesMasterId r:id="rId36"/>
   </p:notesMasterIdLst>
   <p:sldSz cx="12191695" cy="6858000"/>
   <p:notesSz cx="6858000" cy="12191695"/>
@@ -2757,6 +2759,182 @@
             <a:fld id="{F7021451-1387-4CA6-816F-3879F97B5CBC}" type="slidenum">
               <a:rPr lang="en-US"/>
               <a:t>32</a:t>
+            </a:fld>
+            <a:endParaRPr lang="en-US"/>
+          </a:p>
+        </p:txBody>
+      </p:sp>
+    </p:spTree>
+    <p:extLst>
+      <p:ext uri="{BB962C8B-B14F-4D97-AF65-F5344CB8AC3E}">
+        <p14:creationId xmlns:p14="http://schemas.microsoft.com/office/powerpoint/2010/main" val="1024086991"/>
+      </p:ext>
+    </p:extLst>
+  </p:cSld>
+  <p:clrMapOvr>
+    <a:masterClrMapping/>
+  </p:clrMapOvr>
+</p:notes>
+</file>
+
+<file path=ppt/notesSlides/notesSlide33.xml><?xml version="1.0" encoding="utf-8"?>
+<p:notes xmlns:a="http://schemas.openxmlformats.org/drawingml/2006/main" xmlns:r="http://schemas.openxmlformats.org/officeDocument/2006/relationships" xmlns:p="http://schemas.openxmlformats.org/presentationml/2006/main">
+  <p:cSld>
+    <p:spTree>
+      <p:nvGrpSpPr>
+        <p:cNvPr id="1" name=""/>
+        <p:cNvGrpSpPr/>
+        <p:nvPr/>
+      </p:nvGrpSpPr>
+      <p:grpSpPr>
+        <a:xfrm>
+          <a:off x="0" y="0"/>
+          <a:ext cx="0" cy="0"/>
+          <a:chOff x="0" y="0"/>
+          <a:chExt cx="0" cy="0"/>
+        </a:xfrm>
+      </p:grpSpPr>
+      <p:sp>
+        <p:nvSpPr>
+          <p:cNvPr id="2" name="Slide Image Placeholder 1"/>
+          <p:cNvSpPr>
+            <a:spLocks noGrp="1" noRot="1" noChangeAspect="1"/>
+          </p:cNvSpPr>
+          <p:nvPr>
+            <p:ph type="sldImg"/>
+          </p:nvPr>
+        </p:nvSpPr>
+        <p:spPr/>
+      </p:sp>
+      <p:sp>
+        <p:nvSpPr>
+          <p:cNvPr id="3" name="Notes Placeholder 2"/>
+          <p:cNvSpPr>
+            <a:spLocks noGrp="1"/>
+          </p:cNvSpPr>
+          <p:nvPr>
+            <p:ph type="body" idx="1"/>
+          </p:nvPr>
+        </p:nvSpPr>
+        <p:spPr/>
+        <p:txBody>
+          <a:bodyPr/>
+          <a:lstStyle/>
+          <a:p>
+            <a:r>
+              <a:rPr lang="en-US" dirty="0"/>
+              <a:t/>
+            </a:r>
+            <a:endParaRPr lang="en-US" dirty="0"/>
+          </a:p>
+        </p:txBody>
+      </p:sp>
+      <p:sp>
+        <p:nvSpPr>
+          <p:cNvPr id="4" name="Slide Number Placeholder 3"/>
+          <p:cNvSpPr>
+            <a:spLocks noGrp="1"/>
+          </p:cNvSpPr>
+          <p:nvPr>
+            <p:ph type="sldNum" sz="quarter" idx="10"/>
+          </p:nvPr>
+        </p:nvSpPr>
+        <p:spPr/>
+        <p:txBody>
+          <a:bodyPr/>
+          <a:lstStyle/>
+          <a:p>
+            <a:fld id="{F7021451-1387-4CA6-816F-3879F97B5CBC}" type="slidenum">
+              <a:rPr lang="en-US"/>
+              <a:t>33</a:t>
+            </a:fld>
+            <a:endParaRPr lang="en-US"/>
+          </a:p>
+        </p:txBody>
+      </p:sp>
+    </p:spTree>
+    <p:extLst>
+      <p:ext uri="{BB962C8B-B14F-4D97-AF65-F5344CB8AC3E}">
+        <p14:creationId xmlns:p14="http://schemas.microsoft.com/office/powerpoint/2010/main" val="1024086991"/>
+      </p:ext>
+    </p:extLst>
+  </p:cSld>
+  <p:clrMapOvr>
+    <a:masterClrMapping/>
+  </p:clrMapOvr>
+</p:notes>
+</file>
+
+<file path=ppt/notesSlides/notesSlide34.xml><?xml version="1.0" encoding="utf-8"?>
+<p:notes xmlns:a="http://schemas.openxmlformats.org/drawingml/2006/main" xmlns:r="http://schemas.openxmlformats.org/officeDocument/2006/relationships" xmlns:p="http://schemas.openxmlformats.org/presentationml/2006/main">
+  <p:cSld>
+    <p:spTree>
+      <p:nvGrpSpPr>
+        <p:cNvPr id="1" name=""/>
+        <p:cNvGrpSpPr/>
+        <p:nvPr/>
+      </p:nvGrpSpPr>
+      <p:grpSpPr>
+        <a:xfrm>
+          <a:off x="0" y="0"/>
+          <a:ext cx="0" cy="0"/>
+          <a:chOff x="0" y="0"/>
+          <a:chExt cx="0" cy="0"/>
+        </a:xfrm>
+      </p:grpSpPr>
+      <p:sp>
+        <p:nvSpPr>
+          <p:cNvPr id="2" name="Slide Image Placeholder 1"/>
+          <p:cNvSpPr>
+            <a:spLocks noGrp="1" noRot="1" noChangeAspect="1"/>
+          </p:cNvSpPr>
+          <p:nvPr>
+            <p:ph type="sldImg"/>
+          </p:nvPr>
+        </p:nvSpPr>
+        <p:spPr/>
+      </p:sp>
+      <p:sp>
+        <p:nvSpPr>
+          <p:cNvPr id="3" name="Notes Placeholder 2"/>
+          <p:cNvSpPr>
+            <a:spLocks noGrp="1"/>
+          </p:cNvSpPr>
+          <p:nvPr>
+            <p:ph type="body" idx="1"/>
+          </p:nvPr>
+        </p:nvSpPr>
+        <p:spPr/>
+        <p:txBody>
+          <a:bodyPr/>
+          <a:lstStyle/>
+          <a:p>
+            <a:r>
+              <a:rPr lang="en-US" dirty="0"/>
+              <a:t/>
+            </a:r>
+            <a:endParaRPr lang="en-US" dirty="0"/>
+          </a:p>
+        </p:txBody>
+      </p:sp>
+      <p:sp>
+        <p:nvSpPr>
+          <p:cNvPr id="4" name="Slide Number Placeholder 3"/>
+          <p:cNvSpPr>
+            <a:spLocks noGrp="1"/>
+          </p:cNvSpPr>
+          <p:nvPr>
+            <p:ph type="sldNum" sz="quarter" idx="10"/>
+          </p:nvPr>
+        </p:nvSpPr>
+        <p:spPr/>
+        <p:txBody>
+          <a:bodyPr/>
+          <a:lstStyle/>
+          <a:p>
+            <a:fld id="{F7021451-1387-4CA6-816F-3879F97B5CBC}" type="slidenum">
+              <a:rPr lang="en-US"/>
+              <a:t>34</a:t>
             </a:fld>
             <a:endParaRPr lang="en-US"/>
           </a:p>
@@ -6893,7 +7071,7 @@
                 <a:ea typeface="Segoe UI" pitchFamily="34" charset="-122"/>
                 <a:cs typeface="Segoe UI" pitchFamily="34" charset="-120"/>
               </a:rPr>
-              <a:t>23 mise(s) à jour</a:t>
+              <a:t>25 mise(s) à jour</a:t>
             </a:r>
             <a:endParaRPr lang="en-US" sz="1200" dirty="0"/>
           </a:p>
@@ -7961,7 +8139,135 @@
       </p:sp>
       <p:sp>
         <p:nvSpPr>
-          <p:cNvPr id="17" name="Text 15"/>
+          <p:cNvPr id="17" name="Shape 15"/>
+          <p:cNvSpPr/>
+          <p:nvPr/>
+        </p:nvSpPr>
+        <p:spPr>
+          <a:xfrm>
+            <a:off x="640080" y="5394960"/>
+            <a:ext cx="10881360" cy="1097280"/>
+          </a:xfrm>
+          <a:prstGeom prst="roundRect">
+            <a:avLst>
+              <a:gd name="adj" fmla="val 5000"/>
+            </a:avLst>
+          </a:prstGeom>
+          <a:solidFill>
+            <a:srgbClr val="FFFFFF"/>
+          </a:solidFill>
+          <a:ln w="12700">
+            <a:solidFill>
+              <a:srgbClr val="E4DCCB"/>
+            </a:solidFill>
+            <a:prstDash val="solid"/>
+          </a:ln>
+        </p:spPr>
+      </p:sp>
+      <p:sp>
+        <p:nvSpPr>
+          <p:cNvPr id="18" name="Shape 16"/>
+          <p:cNvSpPr/>
+          <p:nvPr/>
+        </p:nvSpPr>
+        <p:spPr>
+          <a:xfrm>
+            <a:off x="640080" y="5394960"/>
+            <a:ext cx="54864" cy="1097280"/>
+          </a:xfrm>
+          <a:prstGeom prst="rect">
+            <a:avLst/>
+          </a:prstGeom>
+          <a:solidFill>
+            <a:srgbClr val="9A4C1F"/>
+          </a:solidFill>
+          <a:ln/>
+        </p:spPr>
+      </p:sp>
+      <p:sp>
+        <p:nvSpPr>
+          <p:cNvPr id="19" name="Text 17"/>
+          <p:cNvSpPr/>
+          <p:nvPr/>
+        </p:nvSpPr>
+        <p:spPr>
+          <a:xfrm>
+            <a:off x="914400" y="5504688"/>
+            <a:ext cx="10332720" cy="365760"/>
+          </a:xfrm>
+          <a:prstGeom prst="rect">
+            <a:avLst/>
+          </a:prstGeom>
+          <a:noFill/>
+          <a:ln/>
+        </p:spPr>
+        <p:txBody>
+          <a:bodyPr wrap="square" rtlCol="0" anchor="ctr"/>
+          <a:lstStyle/>
+          <a:p>
+            <a:pPr indent="0" marL="0">
+              <a:buNone/>
+            </a:pPr>
+            <a:r>
+              <a:rPr lang="en-US" sz="1400" b="1" dirty="0">
+                <a:solidFill>
+                  <a:srgbClr val="1B1F3B"/>
+                </a:solidFill>
+                <a:latin typeface="Segoe UI" pitchFamily="34" charset="0"/>
+                <a:ea typeface="Segoe UI" pitchFamily="34" charset="-122"/>
+                <a:cs typeface="Segoe UI" pitchFamily="34" charset="-120"/>
+              </a:rPr>
+              <a:t>Restauration de la description des ouvrages de bibliothèque</a:t>
+            </a:r>
+            <a:endParaRPr lang="en-US" sz="1400" dirty="0"/>
+          </a:p>
+        </p:txBody>
+      </p:sp>
+      <p:sp>
+        <p:nvSpPr>
+          <p:cNvPr id="20" name="Text 18"/>
+          <p:cNvSpPr/>
+          <p:nvPr/>
+        </p:nvSpPr>
+        <p:spPr>
+          <a:xfrm>
+            <a:off x="914400" y="5852160"/>
+            <a:ext cx="10332720" cy="594360"/>
+          </a:xfrm>
+          <a:prstGeom prst="rect">
+            <a:avLst/>
+          </a:prstGeom>
+          <a:noFill/>
+          <a:ln/>
+        </p:spPr>
+        <p:txBody>
+          <a:bodyPr wrap="square" rtlCol="0" anchor="ctr"/>
+          <a:lstStyle/>
+          <a:p>
+            <a:pPr indent="0" marL="0">
+              <a:lnSpc>
+                <a:spcPts val="1400"/>
+              </a:lnSpc>
+              <a:buNone/>
+            </a:pPr>
+            <a:r>
+              <a:rPr lang="en-US" sz="1100" dirty="0">
+                <a:solidFill>
+                  <a:srgbClr val="8A7C68"/>
+                </a:solidFill>
+                <a:latin typeface="Segoe UI" pitchFamily="34" charset="0"/>
+                <a:ea typeface="Segoe UI" pitchFamily="34" charset="-122"/>
+                <a:cs typeface="Segoe UI" pitchFamily="34" charset="-120"/>
+              </a:rPr>
+              <a:t>La description déjà saisie dans la Bibliothèque d'ouvrages est désormais reprise automatiquement quand l'ouvrage est ajouté à un devis, au lieu d'être perdue comme auparavant.</a:t>
+            </a:r>
+            <a:endParaRPr lang="en-US" sz="1100" dirty="0"/>
+          </a:p>
+        </p:txBody>
+      </p:sp>
+      <p:sp>
+        <p:nvSpPr>
+          <p:cNvPr id="21" name="Text 19"/>
           <p:cNvSpPr/>
           <p:nvPr/>
         </p:nvSpPr>
@@ -8000,7 +8306,7 @@
       </p:sp>
       <p:sp>
         <p:nvSpPr>
-          <p:cNvPr id="18" name="Text 16"/>
+          <p:cNvPr id="22" name="Text 20"/>
           <p:cNvSpPr/>
           <p:nvPr/>
         </p:nvSpPr>
@@ -8163,7 +8469,7 @@
                 <a:ea typeface="Georgia" pitchFamily="34" charset="-122"/>
                 <a:cs typeface="Georgia" pitchFamily="34" charset="-120"/>
               </a:rPr>
-              <a:t>Chantiers</a:t>
+              <a:t>Devis (suite)</a:t>
             </a:r>
             <a:endParaRPr lang="en-US" sz="2400" dirty="0"/>
           </a:p>
@@ -8249,7 +8555,7 @@
                 <a:ea typeface="Segoe UI" pitchFamily="34" charset="-122"/>
                 <a:cs typeface="Segoe UI" pitchFamily="34" charset="-120"/>
               </a:rPr>
-              <a:t>Correction d'un bug bloquant majeur</a:t>
+              <a:t>Référence client en texte libre</a:t>
             </a:r>
             <a:endParaRPr lang="en-US" sz="1400" dirty="0"/>
           </a:p>
@@ -8291,7 +8597,7 @@
                 <a:ea typeface="Segoe UI" pitchFamily="34" charset="-122"/>
                 <a:cs typeface="Segoe UI" pitchFamily="34" charset="-120"/>
               </a:rPr>
-              <a:t>Un chantier ne pouvait être consulté que si son devis était déjà signé par le client, empêchant toute préparation en amont. Corrigé : la fiche chantier est désormais accessible dès sa création.</a:t>
+              <a:t>La 'Référence client' n'est plus une liste déroulante à choisir (qui pouvait donner l'impression que l'information saisie disparaissait) : c'est maintenant un champ texte simple qui garde exactement ce qui a été écrit.</a:t>
             </a:r>
             <a:endParaRPr lang="en-US" sz="1100" dirty="0"/>
           </a:p>
@@ -8299,135 +8605,7 @@
       </p:sp>
       <p:sp>
         <p:nvSpPr>
-          <p:cNvPr id="9" name="Shape 7"/>
-          <p:cNvSpPr/>
-          <p:nvPr/>
-        </p:nvSpPr>
-        <p:spPr>
-          <a:xfrm>
-            <a:off x="640080" y="2926080"/>
-            <a:ext cx="10881360" cy="1097280"/>
-          </a:xfrm>
-          <a:prstGeom prst="roundRect">
-            <a:avLst>
-              <a:gd name="adj" fmla="val 5000"/>
-            </a:avLst>
-          </a:prstGeom>
-          <a:solidFill>
-            <a:srgbClr val="FFFFFF"/>
-          </a:solidFill>
-          <a:ln w="12700">
-            <a:solidFill>
-              <a:srgbClr val="E4DCCB"/>
-            </a:solidFill>
-            <a:prstDash val="solid"/>
-          </a:ln>
-        </p:spPr>
-      </p:sp>
-      <p:sp>
-        <p:nvSpPr>
-          <p:cNvPr id="10" name="Shape 8"/>
-          <p:cNvSpPr/>
-          <p:nvPr/>
-        </p:nvSpPr>
-        <p:spPr>
-          <a:xfrm>
-            <a:off x="640080" y="2926080"/>
-            <a:ext cx="54864" cy="1097280"/>
-          </a:xfrm>
-          <a:prstGeom prst="rect">
-            <a:avLst/>
-          </a:prstGeom>
-          <a:solidFill>
-            <a:srgbClr val="9A4C1F"/>
-          </a:solidFill>
-          <a:ln/>
-        </p:spPr>
-      </p:sp>
-      <p:sp>
-        <p:nvSpPr>
-          <p:cNvPr id="11" name="Text 9"/>
-          <p:cNvSpPr/>
-          <p:nvPr/>
-        </p:nvSpPr>
-        <p:spPr>
-          <a:xfrm>
-            <a:off x="914400" y="3035808"/>
-            <a:ext cx="10332720" cy="365760"/>
-          </a:xfrm>
-          <a:prstGeom prst="rect">
-            <a:avLst/>
-          </a:prstGeom>
-          <a:noFill/>
-          <a:ln/>
-        </p:spPr>
-        <p:txBody>
-          <a:bodyPr wrap="square" rtlCol="0" anchor="ctr"/>
-          <a:lstStyle/>
-          <a:p>
-            <a:pPr indent="0" marL="0">
-              <a:buNone/>
-            </a:pPr>
-            <a:r>
-              <a:rPr lang="en-US" sz="1400" b="1" dirty="0">
-                <a:solidFill>
-                  <a:srgbClr val="1B1F3B"/>
-                </a:solidFill>
-                <a:latin typeface="Segoe UI" pitchFamily="34" charset="0"/>
-                <a:ea typeface="Segoe UI" pitchFamily="34" charset="-122"/>
-                <a:cs typeface="Segoe UI" pitchFamily="34" charset="-120"/>
-              </a:rPr>
-              <a:t>Dépenses liées à un ouvrage précis</a:t>
-            </a:r>
-            <a:endParaRPr lang="en-US" sz="1400" dirty="0"/>
-          </a:p>
-        </p:txBody>
-      </p:sp>
-      <p:sp>
-        <p:nvSpPr>
-          <p:cNvPr id="12" name="Text 10"/>
-          <p:cNvSpPr/>
-          <p:nvPr/>
-        </p:nvSpPr>
-        <p:spPr>
-          <a:xfrm>
-            <a:off x="914400" y="3383280"/>
-            <a:ext cx="10332720" cy="594360"/>
-          </a:xfrm>
-          <a:prstGeom prst="rect">
-            <a:avLst/>
-          </a:prstGeom>
-          <a:noFill/>
-          <a:ln/>
-        </p:spPr>
-        <p:txBody>
-          <a:bodyPr wrap="square" rtlCol="0" anchor="ctr"/>
-          <a:lstStyle/>
-          <a:p>
-            <a:pPr indent="0" marL="0">
-              <a:lnSpc>
-                <a:spcPts val="1400"/>
-              </a:lnSpc>
-              <a:buNone/>
-            </a:pPr>
-            <a:r>
-              <a:rPr lang="en-US" sz="1100" dirty="0">
-                <a:solidFill>
-                  <a:srgbClr val="8A7C68"/>
-                </a:solidFill>
-                <a:latin typeface="Segoe UI" pitchFamily="34" charset="0"/>
-                <a:ea typeface="Segoe UI" pitchFamily="34" charset="-122"/>
-                <a:cs typeface="Segoe UI" pitchFamily="34" charset="-120"/>
-              </a:rPr>
-              <a:t>L'API des dépenses accepte désormais un identifiant de tâche (ouvrage) en plus du chantier, pour un suivi financier plus fin.</a:t>
-            </a:r>
-            <a:endParaRPr lang="en-US" sz="1100" dirty="0"/>
-          </a:p>
-        </p:txBody>
-      </p:sp>
-      <p:sp>
-        <p:nvSpPr>
-          <p:cNvPr id="13" name="Text 11"/>
+          <p:cNvPr id="9" name="Text 7"/>
           <p:cNvSpPr/>
           <p:nvPr/>
         </p:nvSpPr>
@@ -8466,7 +8644,7 @@
       </p:sp>
       <p:sp>
         <p:nvSpPr>
-          <p:cNvPr id="14" name="Text 12"/>
+          <p:cNvPr id="10" name="Text 8"/>
           <p:cNvSpPr/>
           <p:nvPr/>
         </p:nvSpPr>
@@ -8629,7 +8807,7 @@
                 <a:ea typeface="Georgia" pitchFamily="34" charset="-122"/>
                 <a:cs typeface="Georgia" pitchFamily="34" charset="-120"/>
               </a:rPr>
-              <a:t>Équipe</a:t>
+              <a:t>Chantiers</a:t>
             </a:r>
             <a:endParaRPr lang="en-US" sz="2400" dirty="0"/>
           </a:p>
@@ -8715,7 +8893,7 @@
                 <a:ea typeface="Segoe UI" pitchFamily="34" charset="-122"/>
                 <a:cs typeface="Segoe UI" pitchFamily="34" charset="-120"/>
               </a:rPr>
-              <a:t>Six types de pointage</a:t>
+              <a:t>Correction d'un bug bloquant majeur</a:t>
             </a:r>
             <a:endParaRPr lang="en-US" sz="1400" dirty="0"/>
           </a:p>
@@ -8757,7 +8935,7 @@
                 <a:ea typeface="Segoe UI" pitchFamily="34" charset="-122"/>
                 <a:cs typeface="Segoe UI" pitchFamily="34" charset="-120"/>
               </a:rPr>
-              <a:t>Heures de travail, jour de travail, forfait, ouvrage, passage, déplacement — chacun avec date et montant ; le montant des heures est calculé automatiquement à partir du taux horaire de l'ouvrier.</a:t>
+              <a:t>Un chantier ne pouvait être consulté que si son devis était déjà signé par le client, empêchant toute préparation en amont. Corrigé : la fiche chantier est désormais accessible dès sa création.</a:t>
             </a:r>
             <a:endParaRPr lang="en-US" sz="1100" dirty="0"/>
           </a:p>
@@ -8843,7 +9021,7 @@
                 <a:ea typeface="Segoe UI" pitchFamily="34" charset="-122"/>
                 <a:cs typeface="Segoe UI" pitchFamily="34" charset="-120"/>
               </a:rPr>
-              <a:t>Alertes automatiques de dépassement / manque d'heures</a:t>
+              <a:t>Dépenses liées à un ouvrage précis</a:t>
             </a:r>
             <a:endParaRPr lang="en-US" sz="1400" dirty="0"/>
           </a:p>
@@ -8885,7 +9063,7 @@
                 <a:ea typeface="Segoe UI" pitchFamily="34" charset="-122"/>
                 <a:cs typeface="Segoe UI" pitchFamily="34" charset="-120"/>
               </a:rPr>
-              <a:t>À la fin de chaque semaine, si le total travaillé diffère du contrat de plus de 15 minutes, une notification est envoyée automatiquement à l'entreprise (une seule fois par semaine et par ouvrier).</a:t>
+              <a:t>L'API des dépenses accepte désormais un identifiant de tâche (ouvrage) en plus du chantier, pour un suivi financier plus fin.</a:t>
             </a:r>
             <a:endParaRPr lang="en-US" sz="1100" dirty="0"/>
           </a:p>
@@ -8893,135 +9071,7 @@
       </p:sp>
       <p:sp>
         <p:nvSpPr>
-          <p:cNvPr id="13" name="Shape 11"/>
-          <p:cNvSpPr/>
-          <p:nvPr/>
-        </p:nvSpPr>
-        <p:spPr>
-          <a:xfrm>
-            <a:off x="640080" y="4160520"/>
-            <a:ext cx="10881360" cy="1097280"/>
-          </a:xfrm>
-          <a:prstGeom prst="roundRect">
-            <a:avLst>
-              <a:gd name="adj" fmla="val 5000"/>
-            </a:avLst>
-          </a:prstGeom>
-          <a:solidFill>
-            <a:srgbClr val="FFFFFF"/>
-          </a:solidFill>
-          <a:ln w="12700">
-            <a:solidFill>
-              <a:srgbClr val="E4DCCB"/>
-            </a:solidFill>
-            <a:prstDash val="solid"/>
-          </a:ln>
-        </p:spPr>
-      </p:sp>
-      <p:sp>
-        <p:nvSpPr>
-          <p:cNvPr id="14" name="Shape 12"/>
-          <p:cNvSpPr/>
-          <p:nvPr/>
-        </p:nvSpPr>
-        <p:spPr>
-          <a:xfrm>
-            <a:off x="640080" y="4160520"/>
-            <a:ext cx="54864" cy="1097280"/>
-          </a:xfrm>
-          <a:prstGeom prst="rect">
-            <a:avLst/>
-          </a:prstGeom>
-          <a:solidFill>
-            <a:srgbClr val="9A4C1F"/>
-          </a:solidFill>
-          <a:ln/>
-        </p:spPr>
-      </p:sp>
-      <p:sp>
-        <p:nvSpPr>
-          <p:cNvPr id="15" name="Text 13"/>
-          <p:cNvSpPr/>
-          <p:nvPr/>
-        </p:nvSpPr>
-        <p:spPr>
-          <a:xfrm>
-            <a:off x="914400" y="4270248"/>
-            <a:ext cx="10332720" cy="365760"/>
-          </a:xfrm>
-          <a:prstGeom prst="rect">
-            <a:avLst/>
-          </a:prstGeom>
-          <a:noFill/>
-          <a:ln/>
-        </p:spPr>
-        <p:txBody>
-          <a:bodyPr wrap="square" rtlCol="0" anchor="ctr"/>
-          <a:lstStyle/>
-          <a:p>
-            <a:pPr indent="0" marL="0">
-              <a:buNone/>
-            </a:pPr>
-            <a:r>
-              <a:rPr lang="en-US" sz="1400" b="1" dirty="0">
-                <a:solidFill>
-                  <a:srgbClr val="1B1F3B"/>
-                </a:solidFill>
-                <a:latin typeface="Segoe UI" pitchFamily="34" charset="0"/>
-                <a:ea typeface="Segoe UI" pitchFamily="34" charset="-122"/>
-                <a:cs typeface="Segoe UI" pitchFamily="34" charset="-120"/>
-              </a:rPr>
-              <a:t>Export PDF du relevé d'heures</a:t>
-            </a:r>
-            <a:endParaRPr lang="en-US" sz="1400" dirty="0"/>
-          </a:p>
-        </p:txBody>
-      </p:sp>
-      <p:sp>
-        <p:nvSpPr>
-          <p:cNvPr id="16" name="Text 14"/>
-          <p:cNvSpPr/>
-          <p:nvPr/>
-        </p:nvSpPr>
-        <p:spPr>
-          <a:xfrm>
-            <a:off x="914400" y="4617720"/>
-            <a:ext cx="10332720" cy="594360"/>
-          </a:xfrm>
-          <a:prstGeom prst="rect">
-            <a:avLst/>
-          </a:prstGeom>
-          <a:noFill/>
-          <a:ln/>
-        </p:spPr>
-        <p:txBody>
-          <a:bodyPr wrap="square" rtlCol="0" anchor="ctr"/>
-          <a:lstStyle/>
-          <a:p>
-            <a:pPr indent="0" marL="0">
-              <a:lnSpc>
-                <a:spcPts val="1400"/>
-              </a:lnSpc>
-              <a:buNone/>
-            </a:pPr>
-            <a:r>
-              <a:rPr lang="en-US" sz="1100" dirty="0">
-                <a:solidFill>
-                  <a:srgbClr val="8A7C68"/>
-                </a:solidFill>
-                <a:latin typeface="Segoe UI" pitchFamily="34" charset="0"/>
-                <a:ea typeface="Segoe UI" pitchFamily="34" charset="-122"/>
-                <a:cs typeface="Segoe UI" pitchFamily="34" charset="-120"/>
-              </a:rPr>
-              <a:t>Génération d'un PDF mensuel par ouvrier : détail par journée/type de pointage, totaux hebdomadaires, total du mois en heures et en montant — pensé pour la comptabilité et la gestion de la paie.</a:t>
-            </a:r>
-            <a:endParaRPr lang="en-US" sz="1100" dirty="0"/>
-          </a:p>
-        </p:txBody>
-      </p:sp>
-      <p:sp>
-        <p:nvSpPr>
-          <p:cNvPr id="17" name="Text 15"/>
+          <p:cNvPr id="13" name="Text 11"/>
           <p:cNvSpPr/>
           <p:nvPr/>
         </p:nvSpPr>
@@ -9060,7 +9110,7 @@
       </p:sp>
       <p:sp>
         <p:nvSpPr>
-          <p:cNvPr id="18" name="Text 16"/>
+          <p:cNvPr id="14" name="Text 12"/>
           <p:cNvSpPr/>
           <p:nvPr/>
         </p:nvSpPr>
@@ -9267,7 +9317,7 @@
                 <a:ea typeface="Georgia" pitchFamily="34" charset="-122"/>
                 <a:cs typeface="Georgia" pitchFamily="34" charset="-120"/>
               </a:rPr>
-              <a:t>61</a:t>
+              <a:t>67</a:t>
             </a:r>
             <a:endParaRPr lang="en-US" sz="3200" dirty="0"/>
           </a:p>
@@ -9372,7 +9422,7 @@
                 <a:ea typeface="Georgia" pitchFamily="34" charset="-122"/>
                 <a:cs typeface="Georgia" pitchFamily="34" charset="-120"/>
               </a:rPr>
-              <a:t>33</a:t>
+              <a:t>35</a:t>
             </a:r>
             <a:endParaRPr lang="en-US" sz="3200" dirty="0"/>
           </a:p>
@@ -9477,7 +9527,7 @@
                 <a:ea typeface="Georgia" pitchFamily="34" charset="-122"/>
                 <a:cs typeface="Georgia" pitchFamily="34" charset="-120"/>
               </a:rPr>
-              <a:t>23</a:t>
+              <a:t>25</a:t>
             </a:r>
             <a:endParaRPr lang="en-US" sz="3200" dirty="0"/>
           </a:p>
@@ -9582,7 +9632,7 @@
                 <a:ea typeface="Georgia" pitchFamily="34" charset="-122"/>
                 <a:cs typeface="Georgia" pitchFamily="34" charset="-120"/>
               </a:rPr>
-              <a:t>5</a:t>
+              <a:t>7</a:t>
             </a:r>
             <a:endParaRPr lang="en-US" sz="3200" dirty="0"/>
           </a:p>
@@ -9988,7 +10038,7 @@
                 <a:ea typeface="Georgia" pitchFamily="34" charset="-122"/>
                 <a:cs typeface="Georgia" pitchFamily="34" charset="-120"/>
               </a:rPr>
-              <a:t>Notifications</a:t>
+              <a:t>Équipe</a:t>
             </a:r>
             <a:endParaRPr lang="en-US" sz="2400" dirty="0"/>
           </a:p>
@@ -10074,7 +10124,7 @@
                 <a:ea typeface="Segoe UI" pitchFamily="34" charset="-122"/>
                 <a:cs typeface="Segoe UI" pitchFamily="34" charset="-120"/>
               </a:rPr>
-              <a:t>Envoi d'email réel à la signature du devis</a:t>
+              <a:t>Six types de pointage</a:t>
             </a:r>
             <a:endParaRPr lang="en-US" sz="1400" dirty="0"/>
           </a:p>
@@ -10116,7 +10166,7 @@
                 <a:ea typeface="Segoe UI" pitchFamily="34" charset="-122"/>
                 <a:cs typeface="Segoe UI" pitchFamily="34" charset="-120"/>
               </a:rPr>
-              <a:t>Le premier envoi des identifiants client déclenche désormais un vrai email (SMTP), et plus seulement une file d'attente locale.</a:t>
+              <a:t>Heures de travail, jour de travail, forfait, ouvrage, passage, déplacement — chacun avec date et montant ; le montant des heures est calculé automatiquement à partir du taux horaire de l'ouvrier.</a:t>
             </a:r>
             <a:endParaRPr lang="en-US" sz="1100" dirty="0"/>
           </a:p>
@@ -10124,7 +10174,263 @@
       </p:sp>
       <p:sp>
         <p:nvSpPr>
-          <p:cNvPr id="9" name="Text 7"/>
+          <p:cNvPr id="9" name="Shape 7"/>
+          <p:cNvSpPr/>
+          <p:nvPr/>
+        </p:nvSpPr>
+        <p:spPr>
+          <a:xfrm>
+            <a:off x="640080" y="2926080"/>
+            <a:ext cx="10881360" cy="1097280"/>
+          </a:xfrm>
+          <a:prstGeom prst="roundRect">
+            <a:avLst>
+              <a:gd name="adj" fmla="val 5000"/>
+            </a:avLst>
+          </a:prstGeom>
+          <a:solidFill>
+            <a:srgbClr val="FFFFFF"/>
+          </a:solidFill>
+          <a:ln w="12700">
+            <a:solidFill>
+              <a:srgbClr val="E4DCCB"/>
+            </a:solidFill>
+            <a:prstDash val="solid"/>
+          </a:ln>
+        </p:spPr>
+      </p:sp>
+      <p:sp>
+        <p:nvSpPr>
+          <p:cNvPr id="10" name="Shape 8"/>
+          <p:cNvSpPr/>
+          <p:nvPr/>
+        </p:nvSpPr>
+        <p:spPr>
+          <a:xfrm>
+            <a:off x="640080" y="2926080"/>
+            <a:ext cx="54864" cy="1097280"/>
+          </a:xfrm>
+          <a:prstGeom prst="rect">
+            <a:avLst/>
+          </a:prstGeom>
+          <a:solidFill>
+            <a:srgbClr val="9A4C1F"/>
+          </a:solidFill>
+          <a:ln/>
+        </p:spPr>
+      </p:sp>
+      <p:sp>
+        <p:nvSpPr>
+          <p:cNvPr id="11" name="Text 9"/>
+          <p:cNvSpPr/>
+          <p:nvPr/>
+        </p:nvSpPr>
+        <p:spPr>
+          <a:xfrm>
+            <a:off x="914400" y="3035808"/>
+            <a:ext cx="10332720" cy="365760"/>
+          </a:xfrm>
+          <a:prstGeom prst="rect">
+            <a:avLst/>
+          </a:prstGeom>
+          <a:noFill/>
+          <a:ln/>
+        </p:spPr>
+        <p:txBody>
+          <a:bodyPr wrap="square" rtlCol="0" anchor="ctr"/>
+          <a:lstStyle/>
+          <a:p>
+            <a:pPr indent="0" marL="0">
+              <a:buNone/>
+            </a:pPr>
+            <a:r>
+              <a:rPr lang="en-US" sz="1400" b="1" dirty="0">
+                <a:solidFill>
+                  <a:srgbClr val="1B1F3B"/>
+                </a:solidFill>
+                <a:latin typeface="Segoe UI" pitchFamily="34" charset="0"/>
+                <a:ea typeface="Segoe UI" pitchFamily="34" charset="-122"/>
+                <a:cs typeface="Segoe UI" pitchFamily="34" charset="-120"/>
+              </a:rPr>
+              <a:t>Alertes automatiques de dépassement / manque d'heures</a:t>
+            </a:r>
+            <a:endParaRPr lang="en-US" sz="1400" dirty="0"/>
+          </a:p>
+        </p:txBody>
+      </p:sp>
+      <p:sp>
+        <p:nvSpPr>
+          <p:cNvPr id="12" name="Text 10"/>
+          <p:cNvSpPr/>
+          <p:nvPr/>
+        </p:nvSpPr>
+        <p:spPr>
+          <a:xfrm>
+            <a:off x="914400" y="3383280"/>
+            <a:ext cx="10332720" cy="594360"/>
+          </a:xfrm>
+          <a:prstGeom prst="rect">
+            <a:avLst/>
+          </a:prstGeom>
+          <a:noFill/>
+          <a:ln/>
+        </p:spPr>
+        <p:txBody>
+          <a:bodyPr wrap="square" rtlCol="0" anchor="ctr"/>
+          <a:lstStyle/>
+          <a:p>
+            <a:pPr indent="0" marL="0">
+              <a:lnSpc>
+                <a:spcPts val="1400"/>
+              </a:lnSpc>
+              <a:buNone/>
+            </a:pPr>
+            <a:r>
+              <a:rPr lang="en-US" sz="1100" dirty="0">
+                <a:solidFill>
+                  <a:srgbClr val="8A7C68"/>
+                </a:solidFill>
+                <a:latin typeface="Segoe UI" pitchFamily="34" charset="0"/>
+                <a:ea typeface="Segoe UI" pitchFamily="34" charset="-122"/>
+                <a:cs typeface="Segoe UI" pitchFamily="34" charset="-120"/>
+              </a:rPr>
+              <a:t>À la fin de chaque semaine, si le total travaillé diffère du contrat de plus de 15 minutes, une notification est envoyée automatiquement à l'entreprise (une seule fois par semaine et par ouvrier).</a:t>
+            </a:r>
+            <a:endParaRPr lang="en-US" sz="1100" dirty="0"/>
+          </a:p>
+        </p:txBody>
+      </p:sp>
+      <p:sp>
+        <p:nvSpPr>
+          <p:cNvPr id="13" name="Shape 11"/>
+          <p:cNvSpPr/>
+          <p:nvPr/>
+        </p:nvSpPr>
+        <p:spPr>
+          <a:xfrm>
+            <a:off x="640080" y="4160520"/>
+            <a:ext cx="10881360" cy="1097280"/>
+          </a:xfrm>
+          <a:prstGeom prst="roundRect">
+            <a:avLst>
+              <a:gd name="adj" fmla="val 5000"/>
+            </a:avLst>
+          </a:prstGeom>
+          <a:solidFill>
+            <a:srgbClr val="FFFFFF"/>
+          </a:solidFill>
+          <a:ln w="12700">
+            <a:solidFill>
+              <a:srgbClr val="E4DCCB"/>
+            </a:solidFill>
+            <a:prstDash val="solid"/>
+          </a:ln>
+        </p:spPr>
+      </p:sp>
+      <p:sp>
+        <p:nvSpPr>
+          <p:cNvPr id="14" name="Shape 12"/>
+          <p:cNvSpPr/>
+          <p:nvPr/>
+        </p:nvSpPr>
+        <p:spPr>
+          <a:xfrm>
+            <a:off x="640080" y="4160520"/>
+            <a:ext cx="54864" cy="1097280"/>
+          </a:xfrm>
+          <a:prstGeom prst="rect">
+            <a:avLst/>
+          </a:prstGeom>
+          <a:solidFill>
+            <a:srgbClr val="9A4C1F"/>
+          </a:solidFill>
+          <a:ln/>
+        </p:spPr>
+      </p:sp>
+      <p:sp>
+        <p:nvSpPr>
+          <p:cNvPr id="15" name="Text 13"/>
+          <p:cNvSpPr/>
+          <p:nvPr/>
+        </p:nvSpPr>
+        <p:spPr>
+          <a:xfrm>
+            <a:off x="914400" y="4270248"/>
+            <a:ext cx="10332720" cy="365760"/>
+          </a:xfrm>
+          <a:prstGeom prst="rect">
+            <a:avLst/>
+          </a:prstGeom>
+          <a:noFill/>
+          <a:ln/>
+        </p:spPr>
+        <p:txBody>
+          <a:bodyPr wrap="square" rtlCol="0" anchor="ctr"/>
+          <a:lstStyle/>
+          <a:p>
+            <a:pPr indent="0" marL="0">
+              <a:buNone/>
+            </a:pPr>
+            <a:r>
+              <a:rPr lang="en-US" sz="1400" b="1" dirty="0">
+                <a:solidFill>
+                  <a:srgbClr val="1B1F3B"/>
+                </a:solidFill>
+                <a:latin typeface="Segoe UI" pitchFamily="34" charset="0"/>
+                <a:ea typeface="Segoe UI" pitchFamily="34" charset="-122"/>
+                <a:cs typeface="Segoe UI" pitchFamily="34" charset="-120"/>
+              </a:rPr>
+              <a:t>Export PDF du relevé d'heures</a:t>
+            </a:r>
+            <a:endParaRPr lang="en-US" sz="1400" dirty="0"/>
+          </a:p>
+        </p:txBody>
+      </p:sp>
+      <p:sp>
+        <p:nvSpPr>
+          <p:cNvPr id="16" name="Text 14"/>
+          <p:cNvSpPr/>
+          <p:nvPr/>
+        </p:nvSpPr>
+        <p:spPr>
+          <a:xfrm>
+            <a:off x="914400" y="4617720"/>
+            <a:ext cx="10332720" cy="594360"/>
+          </a:xfrm>
+          <a:prstGeom prst="rect">
+            <a:avLst/>
+          </a:prstGeom>
+          <a:noFill/>
+          <a:ln/>
+        </p:spPr>
+        <p:txBody>
+          <a:bodyPr wrap="square" rtlCol="0" anchor="ctr"/>
+          <a:lstStyle/>
+          <a:p>
+            <a:pPr indent="0" marL="0">
+              <a:lnSpc>
+                <a:spcPts val="1400"/>
+              </a:lnSpc>
+              <a:buNone/>
+            </a:pPr>
+            <a:r>
+              <a:rPr lang="en-US" sz="1100" dirty="0">
+                <a:solidFill>
+                  <a:srgbClr val="8A7C68"/>
+                </a:solidFill>
+                <a:latin typeface="Segoe UI" pitchFamily="34" charset="0"/>
+                <a:ea typeface="Segoe UI" pitchFamily="34" charset="-122"/>
+                <a:cs typeface="Segoe UI" pitchFamily="34" charset="-120"/>
+              </a:rPr>
+              <a:t>Génération d'un PDF mensuel par ouvrier : détail par journée/type de pointage, totaux hebdomadaires, total du mois en heures et en montant — pensé pour la comptabilité et la gestion de la paie.</a:t>
+            </a:r>
+            <a:endParaRPr lang="en-US" sz="1100" dirty="0"/>
+          </a:p>
+        </p:txBody>
+      </p:sp>
+      <p:sp>
+        <p:nvSpPr>
+          <p:cNvPr id="17" name="Text 15"/>
           <p:cNvSpPr/>
           <p:nvPr/>
         </p:nvSpPr>
@@ -10163,7 +10469,7 @@
       </p:sp>
       <p:sp>
         <p:nvSpPr>
-          <p:cNvPr id="10" name="Text 8"/>
+          <p:cNvPr id="18" name="Text 16"/>
           <p:cNvSpPr/>
           <p:nvPr/>
         </p:nvSpPr>
@@ -10326,7 +10632,7 @@
                 <a:ea typeface="Georgia" pitchFamily="34" charset="-122"/>
                 <a:cs typeface="Georgia" pitchFamily="34" charset="-120"/>
               </a:rPr>
-              <a:t>Signature &amp; portails</a:t>
+              <a:t>Notifications</a:t>
             </a:r>
             <a:endParaRPr lang="en-US" sz="2400" dirty="0"/>
           </a:p>
@@ -10412,7 +10718,7 @@
                 <a:ea typeface="Segoe UI" pitchFamily="34" charset="-122"/>
                 <a:cs typeface="Segoe UI" pitchFamily="34" charset="-120"/>
               </a:rPr>
-              <a:t>Signature client branchée sur Supabase</a:t>
+              <a:t>Envoi d'email réel à la signature du devis</a:t>
             </a:r>
             <a:endParaRPr lang="en-US" sz="1400" dirty="0"/>
           </a:p>
@@ -10454,7 +10760,7 @@
                 <a:ea typeface="Segoe UI" pitchFamily="34" charset="-122"/>
                 <a:cs typeface="Segoe UI" pitchFamily="34" charset="-120"/>
               </a:rPr>
-              <a:t>Le client qui signe un devis n'a pas de session Kôji : une clé technique dédiée (service_role) permet de retrouver et mettre à jour son devis directement dans la base partagée.</a:t>
+              <a:t>Le premier envoi des identifiants client déclenche désormais un vrai email (SMTP), et plus seulement une file d'attente locale.</a:t>
             </a:r>
             <a:endParaRPr lang="en-US" sz="1100" dirty="0"/>
           </a:p>
@@ -10462,263 +10768,7 @@
       </p:sp>
       <p:sp>
         <p:nvSpPr>
-          <p:cNvPr id="9" name="Shape 7"/>
-          <p:cNvSpPr/>
-          <p:nvPr/>
-        </p:nvSpPr>
-        <p:spPr>
-          <a:xfrm>
-            <a:off x="640080" y="2926080"/>
-            <a:ext cx="10881360" cy="1097280"/>
-          </a:xfrm>
-          <a:prstGeom prst="roundRect">
-            <a:avLst>
-              <a:gd name="adj" fmla="val 5000"/>
-            </a:avLst>
-          </a:prstGeom>
-          <a:solidFill>
-            <a:srgbClr val="FFFFFF"/>
-          </a:solidFill>
-          <a:ln w="12700">
-            <a:solidFill>
-              <a:srgbClr val="E4DCCB"/>
-            </a:solidFill>
-            <a:prstDash val="solid"/>
-          </a:ln>
-        </p:spPr>
-      </p:sp>
-      <p:sp>
-        <p:nvSpPr>
-          <p:cNvPr id="10" name="Shape 8"/>
-          <p:cNvSpPr/>
-          <p:nvPr/>
-        </p:nvSpPr>
-        <p:spPr>
-          <a:xfrm>
-            <a:off x="640080" y="2926080"/>
-            <a:ext cx="54864" cy="1097280"/>
-          </a:xfrm>
-          <a:prstGeom prst="rect">
-            <a:avLst/>
-          </a:prstGeom>
-          <a:solidFill>
-            <a:srgbClr val="9A4C1F"/>
-          </a:solidFill>
-          <a:ln/>
-        </p:spPr>
-      </p:sp>
-      <p:sp>
-        <p:nvSpPr>
-          <p:cNvPr id="11" name="Text 9"/>
-          <p:cNvSpPr/>
-          <p:nvPr/>
-        </p:nvSpPr>
-        <p:spPr>
-          <a:xfrm>
-            <a:off x="914400" y="3035808"/>
-            <a:ext cx="10332720" cy="365760"/>
-          </a:xfrm>
-          <a:prstGeom prst="rect">
-            <a:avLst/>
-          </a:prstGeom>
-          <a:noFill/>
-          <a:ln/>
-        </p:spPr>
-        <p:txBody>
-          <a:bodyPr wrap="square" rtlCol="0" anchor="ctr"/>
-          <a:lstStyle/>
-          <a:p>
-            <a:pPr indent="0" marL="0">
-              <a:buNone/>
-            </a:pPr>
-            <a:r>
-              <a:rPr lang="en-US" sz="1400" b="1" dirty="0">
-                <a:solidFill>
-                  <a:srgbClr val="1B1F3B"/>
-                </a:solidFill>
-                <a:latin typeface="Segoe UI" pitchFamily="34" charset="0"/>
-                <a:ea typeface="Segoe UI" pitchFamily="34" charset="-122"/>
-                <a:cs typeface="Segoe UI" pitchFamily="34" charset="-120"/>
-              </a:rPr>
-              <a:t>Audit complet du portail client</a:t>
-            </a:r>
-            <a:endParaRPr lang="en-US" sz="1400" dirty="0"/>
-          </a:p>
-        </p:txBody>
-      </p:sp>
-      <p:sp>
-        <p:nvSpPr>
-          <p:cNvPr id="12" name="Text 10"/>
-          <p:cNvSpPr/>
-          <p:nvPr/>
-        </p:nvSpPr>
-        <p:spPr>
-          <a:xfrm>
-            <a:off x="914400" y="3383280"/>
-            <a:ext cx="10332720" cy="594360"/>
-          </a:xfrm>
-          <a:prstGeom prst="rect">
-            <a:avLst/>
-          </a:prstGeom>
-          <a:noFill/>
-          <a:ln/>
-        </p:spPr>
-        <p:txBody>
-          <a:bodyPr wrap="square" rtlCol="0" anchor="ctr"/>
-          <a:lstStyle/>
-          <a:p>
-            <a:pPr indent="0" marL="0">
-              <a:lnSpc>
-                <a:spcPts val="1400"/>
-              </a:lnSpc>
-              <a:buNone/>
-            </a:pPr>
-            <a:r>
-              <a:rPr lang="en-US" sz="1100" dirty="0">
-                <a:solidFill>
-                  <a:srgbClr val="8A7C68"/>
-                </a:solidFill>
-                <a:latin typeface="Segoe UI" pitchFamily="34" charset="0"/>
-                <a:ea typeface="Segoe UI" pitchFamily="34" charset="-122"/>
-                <a:cs typeface="Segoe UI" pitchFamily="34" charset="-120"/>
-              </a:rPr>
-              <a:t>Plusieurs routes (connexion client, devis/tâches/notes du portail, création de factures) lisaient encore l'ancien fichier JSON local et ne trouvaient plus aucune donnée récente depuis la migration Supabase des devis — toutes corrigées.</a:t>
-            </a:r>
-            <a:endParaRPr lang="en-US" sz="1100" dirty="0"/>
-          </a:p>
-        </p:txBody>
-      </p:sp>
-      <p:sp>
-        <p:nvSpPr>
-          <p:cNvPr id="13" name="Shape 11"/>
-          <p:cNvSpPr/>
-          <p:nvPr/>
-        </p:nvSpPr>
-        <p:spPr>
-          <a:xfrm>
-            <a:off x="640080" y="4160520"/>
-            <a:ext cx="10881360" cy="1097280"/>
-          </a:xfrm>
-          <a:prstGeom prst="roundRect">
-            <a:avLst>
-              <a:gd name="adj" fmla="val 5000"/>
-            </a:avLst>
-          </a:prstGeom>
-          <a:solidFill>
-            <a:srgbClr val="FFFFFF"/>
-          </a:solidFill>
-          <a:ln w="12700">
-            <a:solidFill>
-              <a:srgbClr val="E4DCCB"/>
-            </a:solidFill>
-            <a:prstDash val="solid"/>
-          </a:ln>
-        </p:spPr>
-      </p:sp>
-      <p:sp>
-        <p:nvSpPr>
-          <p:cNvPr id="14" name="Shape 12"/>
-          <p:cNvSpPr/>
-          <p:nvPr/>
-        </p:nvSpPr>
-        <p:spPr>
-          <a:xfrm>
-            <a:off x="640080" y="4160520"/>
-            <a:ext cx="54864" cy="1097280"/>
-          </a:xfrm>
-          <a:prstGeom prst="rect">
-            <a:avLst/>
-          </a:prstGeom>
-          <a:solidFill>
-            <a:srgbClr val="9A4C1F"/>
-          </a:solidFill>
-          <a:ln/>
-        </p:spPr>
-      </p:sp>
-      <p:sp>
-        <p:nvSpPr>
-          <p:cNvPr id="15" name="Text 13"/>
-          <p:cNvSpPr/>
-          <p:nvPr/>
-        </p:nvSpPr>
-        <p:spPr>
-          <a:xfrm>
-            <a:off x="914400" y="4270248"/>
-            <a:ext cx="10332720" cy="365760"/>
-          </a:xfrm>
-          <a:prstGeom prst="rect">
-            <a:avLst/>
-          </a:prstGeom>
-          <a:noFill/>
-          <a:ln/>
-        </p:spPr>
-        <p:txBody>
-          <a:bodyPr wrap="square" rtlCol="0" anchor="ctr"/>
-          <a:lstStyle/>
-          <a:p>
-            <a:pPr indent="0" marL="0">
-              <a:buNone/>
-            </a:pPr>
-            <a:r>
-              <a:rPr lang="en-US" sz="1400" b="1" dirty="0">
-                <a:solidFill>
-                  <a:srgbClr val="1B1F3B"/>
-                </a:solidFill>
-                <a:latin typeface="Segoe UI" pitchFamily="34" charset="0"/>
-                <a:ea typeface="Segoe UI" pitchFamily="34" charset="-122"/>
-                <a:cs typeface="Segoe UI" pitchFamily="34" charset="-120"/>
-              </a:rPr>
-              <a:t>Suivi du temps par ouvrage</a:t>
-            </a:r>
-            <a:endParaRPr lang="en-US" sz="1400" dirty="0"/>
-          </a:p>
-        </p:txBody>
-      </p:sp>
-      <p:sp>
-        <p:nvSpPr>
-          <p:cNvPr id="16" name="Text 14"/>
-          <p:cNvSpPr/>
-          <p:nvPr/>
-        </p:nvSpPr>
-        <p:spPr>
-          <a:xfrm>
-            <a:off x="914400" y="4617720"/>
-            <a:ext cx="10332720" cy="594360"/>
-          </a:xfrm>
-          <a:prstGeom prst="rect">
-            <a:avLst/>
-          </a:prstGeom>
-          <a:noFill/>
-          <a:ln/>
-        </p:spPr>
-        <p:txBody>
-          <a:bodyPr wrap="square" rtlCol="0" anchor="ctr"/>
-          <a:lstStyle/>
-          <a:p>
-            <a:pPr indent="0" marL="0">
-              <a:lnSpc>
-                <a:spcPts val="1400"/>
-              </a:lnSpc>
-              <a:buNone/>
-            </a:pPr>
-            <a:r>
-              <a:rPr lang="en-US" sz="1100" dirty="0">
-                <a:solidFill>
-                  <a:srgbClr val="8A7C68"/>
-                </a:solidFill>
-                <a:latin typeface="Segoe UI" pitchFamily="34" charset="0"/>
-                <a:ea typeface="Segoe UI" pitchFamily="34" charset="-122"/>
-                <a:cs typeface="Segoe UI" pitchFamily="34" charset="-120"/>
-              </a:rPr>
-              <a:t>Boutons Démarrer / Pause / Reprendre / Terminer par tâche, avec calcul automatique du temps consommé et alerte en cas de dépassement du temps prévu.</a:t>
-            </a:r>
-            <a:endParaRPr lang="en-US" sz="1100" dirty="0"/>
-          </a:p>
-        </p:txBody>
-      </p:sp>
-      <p:sp>
-        <p:nvSpPr>
-          <p:cNvPr id="17" name="Text 15"/>
+          <p:cNvPr id="9" name="Text 7"/>
           <p:cNvSpPr/>
           <p:nvPr/>
         </p:nvSpPr>
@@ -10757,7 +10807,7 @@
       </p:sp>
       <p:sp>
         <p:nvSpPr>
-          <p:cNvPr id="18" name="Text 16"/>
+          <p:cNvPr id="10" name="Text 8"/>
           <p:cNvSpPr/>
           <p:nvPr/>
         </p:nvSpPr>
@@ -10920,7 +10970,7 @@
                 <a:ea typeface="Georgia" pitchFamily="34" charset="-122"/>
                 <a:cs typeface="Georgia" pitchFamily="34" charset="-120"/>
               </a:rPr>
-              <a:t>Accueil &amp; stabilité</a:t>
+              <a:t>Signature &amp; portails</a:t>
             </a:r>
             <a:endParaRPr lang="en-US" sz="2400" dirty="0"/>
           </a:p>
@@ -11006,7 +11056,7 @@
                 <a:ea typeface="Segoe UI" pitchFamily="34" charset="-122"/>
                 <a:cs typeface="Segoe UI" pitchFamily="34" charset="-120"/>
               </a:rPr>
-              <a:t>Reconnexion automatique de session</a:t>
+              <a:t>Signature client branchée sur Supabase</a:t>
             </a:r>
             <a:endParaRPr lang="en-US" sz="1400" dirty="0"/>
           </a:p>
@@ -11048,7 +11098,7 @@
                 <a:ea typeface="Segoe UI" pitchFamily="34" charset="-122"/>
                 <a:cs typeface="Segoe UI" pitchFamily="34" charset="-120"/>
               </a:rPr>
-              <a:t>Une session expirée (~1h) provoquait des échecs silencieux à l'enregistrement (profil, IBAN, devis) sans reconnexion automatique ; la détection couvre désormais tous les cas d'expiration.</a:t>
+              <a:t>Le client qui signe un devis n'a pas de session Kôji : une clé technique dédiée (service_role) permet de retrouver et mettre à jour son devis directement dans la base partagée.</a:t>
             </a:r>
             <a:endParaRPr lang="en-US" sz="1100" dirty="0"/>
           </a:p>
@@ -11134,7 +11184,7 @@
                 <a:ea typeface="Segoe UI" pitchFamily="34" charset="-122"/>
                 <a:cs typeface="Segoe UI" pitchFamily="34" charset="-120"/>
               </a:rPr>
-              <a:t>Corrections de plantages ponctuels</a:t>
+              <a:t>Audit complet du portail client</a:t>
             </a:r>
             <a:endParaRPr lang="en-US" sz="1400" dirty="0"/>
           </a:p>
@@ -11176,7 +11226,7 @@
                 <a:ea typeface="Segoe UI" pitchFamily="34" charset="-122"/>
                 <a:cs typeface="Segoe UI" pitchFamily="34" charset="-120"/>
               </a:rPr>
-              <a:t>Plusieurs erreurs bloquantes corrigées au fil des tests (références de code manquantes, composants mal placés).</a:t>
+              <a:t>Plusieurs routes (connexion client, devis/tâches/notes du portail, création de factures) lisaient encore l'ancien fichier JSON local et ne trouvaient plus aucune donnée récente depuis la migration Supabase des devis — toutes corrigées.</a:t>
             </a:r>
             <a:endParaRPr lang="en-US" sz="1100" dirty="0"/>
           </a:p>
@@ -11184,7 +11234,135 @@
       </p:sp>
       <p:sp>
         <p:nvSpPr>
-          <p:cNvPr id="13" name="Text 11"/>
+          <p:cNvPr id="13" name="Shape 11"/>
+          <p:cNvSpPr/>
+          <p:nvPr/>
+        </p:nvSpPr>
+        <p:spPr>
+          <a:xfrm>
+            <a:off x="640080" y="4160520"/>
+            <a:ext cx="10881360" cy="1097280"/>
+          </a:xfrm>
+          <a:prstGeom prst="roundRect">
+            <a:avLst>
+              <a:gd name="adj" fmla="val 5000"/>
+            </a:avLst>
+          </a:prstGeom>
+          <a:solidFill>
+            <a:srgbClr val="FFFFFF"/>
+          </a:solidFill>
+          <a:ln w="12700">
+            <a:solidFill>
+              <a:srgbClr val="E4DCCB"/>
+            </a:solidFill>
+            <a:prstDash val="solid"/>
+          </a:ln>
+        </p:spPr>
+      </p:sp>
+      <p:sp>
+        <p:nvSpPr>
+          <p:cNvPr id="14" name="Shape 12"/>
+          <p:cNvSpPr/>
+          <p:nvPr/>
+        </p:nvSpPr>
+        <p:spPr>
+          <a:xfrm>
+            <a:off x="640080" y="4160520"/>
+            <a:ext cx="54864" cy="1097280"/>
+          </a:xfrm>
+          <a:prstGeom prst="rect">
+            <a:avLst/>
+          </a:prstGeom>
+          <a:solidFill>
+            <a:srgbClr val="9A4C1F"/>
+          </a:solidFill>
+          <a:ln/>
+        </p:spPr>
+      </p:sp>
+      <p:sp>
+        <p:nvSpPr>
+          <p:cNvPr id="15" name="Text 13"/>
+          <p:cNvSpPr/>
+          <p:nvPr/>
+        </p:nvSpPr>
+        <p:spPr>
+          <a:xfrm>
+            <a:off x="914400" y="4270248"/>
+            <a:ext cx="10332720" cy="365760"/>
+          </a:xfrm>
+          <a:prstGeom prst="rect">
+            <a:avLst/>
+          </a:prstGeom>
+          <a:noFill/>
+          <a:ln/>
+        </p:spPr>
+        <p:txBody>
+          <a:bodyPr wrap="square" rtlCol="0" anchor="ctr"/>
+          <a:lstStyle/>
+          <a:p>
+            <a:pPr indent="0" marL="0">
+              <a:buNone/>
+            </a:pPr>
+            <a:r>
+              <a:rPr lang="en-US" sz="1400" b="1" dirty="0">
+                <a:solidFill>
+                  <a:srgbClr val="1B1F3B"/>
+                </a:solidFill>
+                <a:latin typeface="Segoe UI" pitchFamily="34" charset="0"/>
+                <a:ea typeface="Segoe UI" pitchFamily="34" charset="-122"/>
+                <a:cs typeface="Segoe UI" pitchFamily="34" charset="-120"/>
+              </a:rPr>
+              <a:t>Suivi du temps par ouvrage</a:t>
+            </a:r>
+            <a:endParaRPr lang="en-US" sz="1400" dirty="0"/>
+          </a:p>
+        </p:txBody>
+      </p:sp>
+      <p:sp>
+        <p:nvSpPr>
+          <p:cNvPr id="16" name="Text 14"/>
+          <p:cNvSpPr/>
+          <p:nvPr/>
+        </p:nvSpPr>
+        <p:spPr>
+          <a:xfrm>
+            <a:off x="914400" y="4617720"/>
+            <a:ext cx="10332720" cy="594360"/>
+          </a:xfrm>
+          <a:prstGeom prst="rect">
+            <a:avLst/>
+          </a:prstGeom>
+          <a:noFill/>
+          <a:ln/>
+        </p:spPr>
+        <p:txBody>
+          <a:bodyPr wrap="square" rtlCol="0" anchor="ctr"/>
+          <a:lstStyle/>
+          <a:p>
+            <a:pPr indent="0" marL="0">
+              <a:lnSpc>
+                <a:spcPts val="1400"/>
+              </a:lnSpc>
+              <a:buNone/>
+            </a:pPr>
+            <a:r>
+              <a:rPr lang="en-US" sz="1100" dirty="0">
+                <a:solidFill>
+                  <a:srgbClr val="8A7C68"/>
+                </a:solidFill>
+                <a:latin typeface="Segoe UI" pitchFamily="34" charset="0"/>
+                <a:ea typeface="Segoe UI" pitchFamily="34" charset="-122"/>
+                <a:cs typeface="Segoe UI" pitchFamily="34" charset="-120"/>
+              </a:rPr>
+              <a:t>Boutons Démarrer / Pause / Reprendre / Terminer par tâche, avec calcul automatique du temps consommé et alerte en cas de dépassement du temps prévu.</a:t>
+            </a:r>
+            <a:endParaRPr lang="en-US" sz="1100" dirty="0"/>
+          </a:p>
+        </p:txBody>
+      </p:sp>
+      <p:sp>
+        <p:nvSpPr>
+          <p:cNvPr id="17" name="Text 15"/>
           <p:cNvSpPr/>
           <p:nvPr/>
         </p:nvSpPr>
@@ -11223,7 +11401,7 @@
       </p:sp>
       <p:sp>
         <p:nvSpPr>
-          <p:cNvPr id="14" name="Text 12"/>
+          <p:cNvPr id="18" name="Text 16"/>
           <p:cNvSpPr/>
           <p:nvPr/>
         </p:nvSpPr>
@@ -11386,7 +11564,7 @@
                 <a:ea typeface="Georgia" pitchFamily="34" charset="-122"/>
                 <a:cs typeface="Georgia" pitchFamily="34" charset="-120"/>
               </a:rPr>
-              <a:t>Rapports d'intervention</a:t>
+              <a:t>Accueil &amp; stabilité</a:t>
             </a:r>
             <a:endParaRPr lang="en-US" sz="2400" dirty="0"/>
           </a:p>
@@ -11472,7 +11650,7 @@
                 <a:ea typeface="Segoe UI" pitchFamily="34" charset="-122"/>
                 <a:cs typeface="Segoe UI" pitchFamily="34" charset="-120"/>
               </a:rPr>
-              <a:t>Nouvelle entité 'interventions'</a:t>
+              <a:t>Reconnexion automatique de session</a:t>
             </a:r>
             <a:endParaRPr lang="en-US" sz="1400" dirty="0"/>
           </a:p>
@@ -11514,7 +11692,7 @@
                 <a:ea typeface="Segoe UI" pitchFamily="34" charset="-122"/>
                 <a:cs typeface="Segoe UI" pitchFamily="34" charset="-120"/>
               </a:rPr>
-              <a:t>API dédiée (creation, consultation, suppression) pour stocker les rapports d'intervention, avec historique des actions comme pour les autres modules.</a:t>
+              <a:t>Une session expirée (~1h) provoquait des échecs silencieux à l'enregistrement (profil, IBAN, devis) sans reconnexion automatique ; la détection couvre désormais tous les cas d'expiration.</a:t>
             </a:r>
             <a:endParaRPr lang="en-US" sz="1100" dirty="0"/>
           </a:p>
@@ -11600,7 +11778,7 @@
                 <a:ea typeface="Segoe UI" pitchFamily="34" charset="-122"/>
                 <a:cs typeface="Segoe UI" pitchFamily="34" charset="-120"/>
               </a:rPr>
-              <a:t>Génération PDF du rapport d'intervention</a:t>
+              <a:t>Corrections de plantages ponctuels</a:t>
             </a:r>
             <a:endParaRPr lang="en-US" sz="1400" dirty="0"/>
           </a:p>
@@ -11642,7 +11820,7 @@
                 <a:ea typeface="Segoe UI" pitchFamily="34" charset="-122"/>
                 <a:cs typeface="Segoe UI" pitchFamily="34" charset="-120"/>
               </a:rPr>
-              <a:t>Chaque rapport peut être téléchargé en PDF avec le logo de l'entreprise en en-tête, dans une mise en page reprenant celle des rapports d'intervention papier existants.</a:t>
+              <a:t>Plusieurs erreurs bloquantes corrigées au fil des tests (références de code manquantes, composants mal placés).</a:t>
             </a:r>
             <a:endParaRPr lang="en-US" sz="1100" dirty="0"/>
           </a:p>
@@ -11650,263 +11828,7 @@
       </p:sp>
       <p:sp>
         <p:nvSpPr>
-          <p:cNvPr id="13" name="Shape 11"/>
-          <p:cNvSpPr/>
-          <p:nvPr/>
-        </p:nvSpPr>
-        <p:spPr>
-          <a:xfrm>
-            <a:off x="640080" y="4160520"/>
-            <a:ext cx="10881360" cy="1097280"/>
-          </a:xfrm>
-          <a:prstGeom prst="roundRect">
-            <a:avLst>
-              <a:gd name="adj" fmla="val 5000"/>
-            </a:avLst>
-          </a:prstGeom>
-          <a:solidFill>
-            <a:srgbClr val="FFFFFF"/>
-          </a:solidFill>
-          <a:ln w="12700">
-            <a:solidFill>
-              <a:srgbClr val="E4DCCB"/>
-            </a:solidFill>
-            <a:prstDash val="solid"/>
-          </a:ln>
-        </p:spPr>
-      </p:sp>
-      <p:sp>
-        <p:nvSpPr>
-          <p:cNvPr id="14" name="Shape 12"/>
-          <p:cNvSpPr/>
-          <p:nvPr/>
-        </p:nvSpPr>
-        <p:spPr>
-          <a:xfrm>
-            <a:off x="640080" y="4160520"/>
-            <a:ext cx="54864" cy="1097280"/>
-          </a:xfrm>
-          <a:prstGeom prst="rect">
-            <a:avLst/>
-          </a:prstGeom>
-          <a:solidFill>
-            <a:srgbClr val="9A4C1F"/>
-          </a:solidFill>
-          <a:ln/>
-        </p:spPr>
-      </p:sp>
-      <p:sp>
-        <p:nvSpPr>
-          <p:cNvPr id="15" name="Text 13"/>
-          <p:cNvSpPr/>
-          <p:nvPr/>
-        </p:nvSpPr>
-        <p:spPr>
-          <a:xfrm>
-            <a:off x="914400" y="4270248"/>
-            <a:ext cx="10332720" cy="365760"/>
-          </a:xfrm>
-          <a:prstGeom prst="rect">
-            <a:avLst/>
-          </a:prstGeom>
-          <a:noFill/>
-          <a:ln/>
-        </p:spPr>
-        <p:txBody>
-          <a:bodyPr wrap="square" rtlCol="0" anchor="ctr"/>
-          <a:lstStyle/>
-          <a:p>
-            <a:pPr indent="0" marL="0">
-              <a:buNone/>
-            </a:pPr>
-            <a:r>
-              <a:rPr lang="en-US" sz="1400" b="1" dirty="0">
-                <a:solidFill>
-                  <a:srgbClr val="1B1F3B"/>
-                </a:solidFill>
-                <a:latin typeface="Segoe UI" pitchFamily="34" charset="0"/>
-                <a:ea typeface="Segoe UI" pitchFamily="34" charset="-122"/>
-                <a:cs typeface="Segoe UI" pitchFamily="34" charset="-120"/>
-              </a:rPr>
-              <a:t>Facturation directe d'une intervention</a:t>
-            </a:r>
-            <a:endParaRPr lang="en-US" sz="1400" dirty="0"/>
-          </a:p>
-        </p:txBody>
-      </p:sp>
-      <p:sp>
-        <p:nvSpPr>
-          <p:cNvPr id="16" name="Text 14"/>
-          <p:cNvSpPr/>
-          <p:nvPr/>
-        </p:nvSpPr>
-        <p:spPr>
-          <a:xfrm>
-            <a:off x="914400" y="4617720"/>
-            <a:ext cx="10332720" cy="594360"/>
-          </a:xfrm>
-          <a:prstGeom prst="rect">
-            <a:avLst/>
-          </a:prstGeom>
-          <a:noFill/>
-          <a:ln/>
-        </p:spPr>
-        <p:txBody>
-          <a:bodyPr wrap="square" rtlCol="0" anchor="ctr"/>
-          <a:lstStyle/>
-          <a:p>
-            <a:pPr indent="0" marL="0">
-              <a:lnSpc>
-                <a:spcPts val="1400"/>
-              </a:lnSpc>
-              <a:buNone/>
-            </a:pPr>
-            <a:r>
-              <a:rPr lang="en-US" sz="1100" dirty="0">
-                <a:solidFill>
-                  <a:srgbClr val="8A7C68"/>
-                </a:solidFill>
-                <a:latin typeface="Segoe UI" pitchFamily="34" charset="0"/>
-                <a:ea typeface="Segoe UI" pitchFamily="34" charset="-122"/>
-                <a:cs typeface="Segoe UI" pitchFamily="34" charset="-120"/>
-              </a:rPr>
-              <a:t>Une facture peut être créée directement à partir d'une intervention (sans passer par un devis signé), avec un montant saisi manuellement ; l'intervention passe alors automatiquement au statut 'Facturée'.</a:t>
-            </a:r>
-            <a:endParaRPr lang="en-US" sz="1100" dirty="0"/>
-          </a:p>
-        </p:txBody>
-      </p:sp>
-      <p:sp>
-        <p:nvSpPr>
-          <p:cNvPr id="17" name="Shape 15"/>
-          <p:cNvSpPr/>
-          <p:nvPr/>
-        </p:nvSpPr>
-        <p:spPr>
-          <a:xfrm>
-            <a:off x="640080" y="5394960"/>
-            <a:ext cx="10881360" cy="1097280"/>
-          </a:xfrm>
-          <a:prstGeom prst="roundRect">
-            <a:avLst>
-              <a:gd name="adj" fmla="val 5000"/>
-            </a:avLst>
-          </a:prstGeom>
-          <a:solidFill>
-            <a:srgbClr val="FFFFFF"/>
-          </a:solidFill>
-          <a:ln w="12700">
-            <a:solidFill>
-              <a:srgbClr val="E4DCCB"/>
-            </a:solidFill>
-            <a:prstDash val="solid"/>
-          </a:ln>
-        </p:spPr>
-      </p:sp>
-      <p:sp>
-        <p:nvSpPr>
-          <p:cNvPr id="18" name="Shape 16"/>
-          <p:cNvSpPr/>
-          <p:nvPr/>
-        </p:nvSpPr>
-        <p:spPr>
-          <a:xfrm>
-            <a:off x="640080" y="5394960"/>
-            <a:ext cx="54864" cy="1097280"/>
-          </a:xfrm>
-          <a:prstGeom prst="rect">
-            <a:avLst/>
-          </a:prstGeom>
-          <a:solidFill>
-            <a:srgbClr val="9A4C1F"/>
-          </a:solidFill>
-          <a:ln/>
-        </p:spPr>
-      </p:sp>
-      <p:sp>
-        <p:nvSpPr>
-          <p:cNvPr id="19" name="Text 17"/>
-          <p:cNvSpPr/>
-          <p:nvPr/>
-        </p:nvSpPr>
-        <p:spPr>
-          <a:xfrm>
-            <a:off x="914400" y="5504688"/>
-            <a:ext cx="10332720" cy="365760"/>
-          </a:xfrm>
-          <a:prstGeom prst="rect">
-            <a:avLst/>
-          </a:prstGeom>
-          <a:noFill/>
-          <a:ln/>
-        </p:spPr>
-        <p:txBody>
-          <a:bodyPr wrap="square" rtlCol="0" anchor="ctr"/>
-          <a:lstStyle/>
-          <a:p>
-            <a:pPr indent="0" marL="0">
-              <a:buNone/>
-            </a:pPr>
-            <a:r>
-              <a:rPr lang="en-US" sz="1400" b="1" dirty="0">
-                <a:solidFill>
-                  <a:srgbClr val="1B1F3B"/>
-                </a:solidFill>
-                <a:latin typeface="Segoe UI" pitchFamily="34" charset="0"/>
-                <a:ea typeface="Segoe UI" pitchFamily="34" charset="-122"/>
-                <a:cs typeface="Segoe UI" pitchFamily="34" charset="-120"/>
-              </a:rPr>
-              <a:t>En-tête d'entreprise propre à chaque rapport</a:t>
-            </a:r>
-            <a:endParaRPr lang="en-US" sz="1400" dirty="0"/>
-          </a:p>
-        </p:txBody>
-      </p:sp>
-      <p:sp>
-        <p:nvSpPr>
-          <p:cNvPr id="20" name="Text 18"/>
-          <p:cNvSpPr/>
-          <p:nvPr/>
-        </p:nvSpPr>
-        <p:spPr>
-          <a:xfrm>
-            <a:off x="914400" y="5852160"/>
-            <a:ext cx="10332720" cy="594360"/>
-          </a:xfrm>
-          <a:prstGeom prst="rect">
-            <a:avLst/>
-          </a:prstGeom>
-          <a:noFill/>
-          <a:ln/>
-        </p:spPr>
-        <p:txBody>
-          <a:bodyPr wrap="square" rtlCol="0" anchor="ctr"/>
-          <a:lstStyle/>
-          <a:p>
-            <a:pPr indent="0" marL="0">
-              <a:lnSpc>
-                <a:spcPts val="1400"/>
-              </a:lnSpc>
-              <a:buNone/>
-            </a:pPr>
-            <a:r>
-              <a:rPr lang="en-US" sz="1100" dirty="0">
-                <a:solidFill>
-                  <a:srgbClr val="8A7C68"/>
-                </a:solidFill>
-                <a:latin typeface="Segoe UI" pitchFamily="34" charset="0"/>
-                <a:ea typeface="Segoe UI" pitchFamily="34" charset="-122"/>
-                <a:cs typeface="Segoe UI" pitchFamily="34" charset="-120"/>
-              </a:rPr>
-              <a:t>Chaque intervention conserve son propre instantané des informations d'entreprise (comme les devis), pour que le PDF reste fidèle même si le profil change ensuite.</a:t>
-            </a:r>
-            <a:endParaRPr lang="en-US" sz="1100" dirty="0"/>
-          </a:p>
-        </p:txBody>
-      </p:sp>
-      <p:sp>
-        <p:nvSpPr>
-          <p:cNvPr id="21" name="Text 19"/>
+          <p:cNvPr id="13" name="Text 11"/>
           <p:cNvSpPr/>
           <p:nvPr/>
         </p:nvSpPr>
@@ -11945,7 +11867,7 @@
       </p:sp>
       <p:sp>
         <p:nvSpPr>
-          <p:cNvPr id="22" name="Text 20"/>
+          <p:cNvPr id="14" name="Text 12"/>
           <p:cNvSpPr/>
           <p:nvPr/>
         </p:nvSpPr>
@@ -12108,7 +12030,7 @@
                 <a:ea typeface="Georgia" pitchFamily="34" charset="-122"/>
                 <a:cs typeface="Georgia" pitchFamily="34" charset="-120"/>
               </a:rPr>
-              <a:t>Rapports d'intervention (suite)</a:t>
+              <a:t>Rapports d'intervention</a:t>
             </a:r>
             <a:endParaRPr lang="en-US" sz="2400" dirty="0"/>
           </a:p>
@@ -12194,7 +12116,7 @@
                 <a:ea typeface="Segoe UI" pitchFamily="34" charset="-122"/>
                 <a:cs typeface="Segoe UI" pitchFamily="34" charset="-120"/>
               </a:rPr>
-              <a:t>Statut de suivi automatique (À faire / En cours / Terminée)</a:t>
+              <a:t>Nouvelle entité 'interventions'</a:t>
             </a:r>
             <a:endParaRPr lang="en-US" sz="1400" dirty="0"/>
           </a:p>
@@ -12236,7 +12158,7 @@
                 <a:ea typeface="Segoe UI" pitchFamily="34" charset="-122"/>
                 <a:cs typeface="Segoe UI" pitchFamily="34" charset="-120"/>
               </a:rPr>
-              <a:t>Le statut d'une intervention évolue automatiquement selon sa date (À faire tant que la date n'est pas arrivée, En cours le jour J), jusqu'à être marquée Terminée manuellement puis, si besoin, archivée.</a:t>
+              <a:t>API dédiée (creation, consultation, suppression) pour stocker les rapports d'intervention, avec historique des actions comme pour les autres modules.</a:t>
             </a:r>
             <a:endParaRPr lang="en-US" sz="1100" dirty="0"/>
           </a:p>
@@ -12322,7 +12244,7 @@
                 <a:ea typeface="Segoe UI" pitchFamily="34" charset="-122"/>
                 <a:cs typeface="Segoe UI" pitchFamily="34" charset="-120"/>
               </a:rPr>
-              <a:t>Numéro de rapport automatique</a:t>
+              <a:t>Génération PDF du rapport d'intervention</a:t>
             </a:r>
             <a:endParaRPr lang="en-US" sz="1400" dirty="0"/>
           </a:p>
@@ -12364,7 +12286,7 @@
                 <a:ea typeface="Segoe UI" pitchFamily="34" charset="-122"/>
                 <a:cs typeface="Segoe UI" pitchFamily="34" charset="-120"/>
               </a:rPr>
-              <a:t>Chaque rapport reçoit un numéro unique généré automatiquement (ex. INT-2026-0003), affiché en en-tête avec la date de création, sur le même principe que la numérotation des devis et factures.</a:t>
+              <a:t>Chaque rapport peut être téléchargé en PDF avec le logo de l'entreprise en en-tête, dans une mise en page reprenant celle des rapports d'intervention papier existants.</a:t>
             </a:r>
             <a:endParaRPr lang="en-US" sz="1100" dirty="0"/>
           </a:p>
@@ -12372,7 +12294,263 @@
       </p:sp>
       <p:sp>
         <p:nvSpPr>
-          <p:cNvPr id="13" name="Text 11"/>
+          <p:cNvPr id="13" name="Shape 11"/>
+          <p:cNvSpPr/>
+          <p:nvPr/>
+        </p:nvSpPr>
+        <p:spPr>
+          <a:xfrm>
+            <a:off x="640080" y="4160520"/>
+            <a:ext cx="10881360" cy="1097280"/>
+          </a:xfrm>
+          <a:prstGeom prst="roundRect">
+            <a:avLst>
+              <a:gd name="adj" fmla="val 5000"/>
+            </a:avLst>
+          </a:prstGeom>
+          <a:solidFill>
+            <a:srgbClr val="FFFFFF"/>
+          </a:solidFill>
+          <a:ln w="12700">
+            <a:solidFill>
+              <a:srgbClr val="E4DCCB"/>
+            </a:solidFill>
+            <a:prstDash val="solid"/>
+          </a:ln>
+        </p:spPr>
+      </p:sp>
+      <p:sp>
+        <p:nvSpPr>
+          <p:cNvPr id="14" name="Shape 12"/>
+          <p:cNvSpPr/>
+          <p:nvPr/>
+        </p:nvSpPr>
+        <p:spPr>
+          <a:xfrm>
+            <a:off x="640080" y="4160520"/>
+            <a:ext cx="54864" cy="1097280"/>
+          </a:xfrm>
+          <a:prstGeom prst="rect">
+            <a:avLst/>
+          </a:prstGeom>
+          <a:solidFill>
+            <a:srgbClr val="9A4C1F"/>
+          </a:solidFill>
+          <a:ln/>
+        </p:spPr>
+      </p:sp>
+      <p:sp>
+        <p:nvSpPr>
+          <p:cNvPr id="15" name="Text 13"/>
+          <p:cNvSpPr/>
+          <p:nvPr/>
+        </p:nvSpPr>
+        <p:spPr>
+          <a:xfrm>
+            <a:off x="914400" y="4270248"/>
+            <a:ext cx="10332720" cy="365760"/>
+          </a:xfrm>
+          <a:prstGeom prst="rect">
+            <a:avLst/>
+          </a:prstGeom>
+          <a:noFill/>
+          <a:ln/>
+        </p:spPr>
+        <p:txBody>
+          <a:bodyPr wrap="square" rtlCol="0" anchor="ctr"/>
+          <a:lstStyle/>
+          <a:p>
+            <a:pPr indent="0" marL="0">
+              <a:buNone/>
+            </a:pPr>
+            <a:r>
+              <a:rPr lang="en-US" sz="1400" b="1" dirty="0">
+                <a:solidFill>
+                  <a:srgbClr val="1B1F3B"/>
+                </a:solidFill>
+                <a:latin typeface="Segoe UI" pitchFamily="34" charset="0"/>
+                <a:ea typeface="Segoe UI" pitchFamily="34" charset="-122"/>
+                <a:cs typeface="Segoe UI" pitchFamily="34" charset="-120"/>
+              </a:rPr>
+              <a:t>Facturation directe d'une intervention</a:t>
+            </a:r>
+            <a:endParaRPr lang="en-US" sz="1400" dirty="0"/>
+          </a:p>
+        </p:txBody>
+      </p:sp>
+      <p:sp>
+        <p:nvSpPr>
+          <p:cNvPr id="16" name="Text 14"/>
+          <p:cNvSpPr/>
+          <p:nvPr/>
+        </p:nvSpPr>
+        <p:spPr>
+          <a:xfrm>
+            <a:off x="914400" y="4617720"/>
+            <a:ext cx="10332720" cy="594360"/>
+          </a:xfrm>
+          <a:prstGeom prst="rect">
+            <a:avLst/>
+          </a:prstGeom>
+          <a:noFill/>
+          <a:ln/>
+        </p:spPr>
+        <p:txBody>
+          <a:bodyPr wrap="square" rtlCol="0" anchor="ctr"/>
+          <a:lstStyle/>
+          <a:p>
+            <a:pPr indent="0" marL="0">
+              <a:lnSpc>
+                <a:spcPts val="1400"/>
+              </a:lnSpc>
+              <a:buNone/>
+            </a:pPr>
+            <a:r>
+              <a:rPr lang="en-US" sz="1100" dirty="0">
+                <a:solidFill>
+                  <a:srgbClr val="8A7C68"/>
+                </a:solidFill>
+                <a:latin typeface="Segoe UI" pitchFamily="34" charset="0"/>
+                <a:ea typeface="Segoe UI" pitchFamily="34" charset="-122"/>
+                <a:cs typeface="Segoe UI" pitchFamily="34" charset="-120"/>
+              </a:rPr>
+              <a:t>Une facture peut être créée directement à partir d'une intervention (sans passer par un devis signé), avec un montant saisi manuellement ; l'intervention passe alors automatiquement au statut 'Facturée'.</a:t>
+            </a:r>
+            <a:endParaRPr lang="en-US" sz="1100" dirty="0"/>
+          </a:p>
+        </p:txBody>
+      </p:sp>
+      <p:sp>
+        <p:nvSpPr>
+          <p:cNvPr id="17" name="Shape 15"/>
+          <p:cNvSpPr/>
+          <p:nvPr/>
+        </p:nvSpPr>
+        <p:spPr>
+          <a:xfrm>
+            <a:off x="640080" y="5394960"/>
+            <a:ext cx="10881360" cy="1097280"/>
+          </a:xfrm>
+          <a:prstGeom prst="roundRect">
+            <a:avLst>
+              <a:gd name="adj" fmla="val 5000"/>
+            </a:avLst>
+          </a:prstGeom>
+          <a:solidFill>
+            <a:srgbClr val="FFFFFF"/>
+          </a:solidFill>
+          <a:ln w="12700">
+            <a:solidFill>
+              <a:srgbClr val="E4DCCB"/>
+            </a:solidFill>
+            <a:prstDash val="solid"/>
+          </a:ln>
+        </p:spPr>
+      </p:sp>
+      <p:sp>
+        <p:nvSpPr>
+          <p:cNvPr id="18" name="Shape 16"/>
+          <p:cNvSpPr/>
+          <p:nvPr/>
+        </p:nvSpPr>
+        <p:spPr>
+          <a:xfrm>
+            <a:off x="640080" y="5394960"/>
+            <a:ext cx="54864" cy="1097280"/>
+          </a:xfrm>
+          <a:prstGeom prst="rect">
+            <a:avLst/>
+          </a:prstGeom>
+          <a:solidFill>
+            <a:srgbClr val="9A4C1F"/>
+          </a:solidFill>
+          <a:ln/>
+        </p:spPr>
+      </p:sp>
+      <p:sp>
+        <p:nvSpPr>
+          <p:cNvPr id="19" name="Text 17"/>
+          <p:cNvSpPr/>
+          <p:nvPr/>
+        </p:nvSpPr>
+        <p:spPr>
+          <a:xfrm>
+            <a:off x="914400" y="5504688"/>
+            <a:ext cx="10332720" cy="365760"/>
+          </a:xfrm>
+          <a:prstGeom prst="rect">
+            <a:avLst/>
+          </a:prstGeom>
+          <a:noFill/>
+          <a:ln/>
+        </p:spPr>
+        <p:txBody>
+          <a:bodyPr wrap="square" rtlCol="0" anchor="ctr"/>
+          <a:lstStyle/>
+          <a:p>
+            <a:pPr indent="0" marL="0">
+              <a:buNone/>
+            </a:pPr>
+            <a:r>
+              <a:rPr lang="en-US" sz="1400" b="1" dirty="0">
+                <a:solidFill>
+                  <a:srgbClr val="1B1F3B"/>
+                </a:solidFill>
+                <a:latin typeface="Segoe UI" pitchFamily="34" charset="0"/>
+                <a:ea typeface="Segoe UI" pitchFamily="34" charset="-122"/>
+                <a:cs typeface="Segoe UI" pitchFamily="34" charset="-120"/>
+              </a:rPr>
+              <a:t>En-tête d'entreprise propre à chaque rapport</a:t>
+            </a:r>
+            <a:endParaRPr lang="en-US" sz="1400" dirty="0"/>
+          </a:p>
+        </p:txBody>
+      </p:sp>
+      <p:sp>
+        <p:nvSpPr>
+          <p:cNvPr id="20" name="Text 18"/>
+          <p:cNvSpPr/>
+          <p:nvPr/>
+        </p:nvSpPr>
+        <p:spPr>
+          <a:xfrm>
+            <a:off x="914400" y="5852160"/>
+            <a:ext cx="10332720" cy="594360"/>
+          </a:xfrm>
+          <a:prstGeom prst="rect">
+            <a:avLst/>
+          </a:prstGeom>
+          <a:noFill/>
+          <a:ln/>
+        </p:spPr>
+        <p:txBody>
+          <a:bodyPr wrap="square" rtlCol="0" anchor="ctr"/>
+          <a:lstStyle/>
+          <a:p>
+            <a:pPr indent="0" marL="0">
+              <a:lnSpc>
+                <a:spcPts val="1400"/>
+              </a:lnSpc>
+              <a:buNone/>
+            </a:pPr>
+            <a:r>
+              <a:rPr lang="en-US" sz="1100" dirty="0">
+                <a:solidFill>
+                  <a:srgbClr val="8A7C68"/>
+                </a:solidFill>
+                <a:latin typeface="Segoe UI" pitchFamily="34" charset="0"/>
+                <a:ea typeface="Segoe UI" pitchFamily="34" charset="-122"/>
+                <a:cs typeface="Segoe UI" pitchFamily="34" charset="-120"/>
+              </a:rPr>
+              <a:t>Chaque intervention conserve son propre instantané des informations d'entreprise (comme les devis), pour que le PDF reste fidèle même si le profil change ensuite.</a:t>
+            </a:r>
+            <a:endParaRPr lang="en-US" sz="1100" dirty="0"/>
+          </a:p>
+        </p:txBody>
+      </p:sp>
+      <p:sp>
+        <p:nvSpPr>
+          <p:cNvPr id="21" name="Text 19"/>
           <p:cNvSpPr/>
           <p:nvPr/>
         </p:nvSpPr>
@@ -12411,7 +12589,7 @@
       </p:sp>
       <p:sp>
         <p:nvSpPr>
-          <p:cNvPr id="14" name="Text 12"/>
+          <p:cNvPr id="22" name="Text 20"/>
           <p:cNvSpPr/>
           <p:nvPr/>
         </p:nvSpPr>
@@ -12574,7 +12752,7 @@
                 <a:ea typeface="Georgia" pitchFamily="34" charset="-122"/>
                 <a:cs typeface="Georgia" pitchFamily="34" charset="-120"/>
               </a:rPr>
-              <a:t>Facturation</a:t>
+              <a:t>Rapports d'intervention (suite)</a:t>
             </a:r>
             <a:endParaRPr lang="en-US" sz="2400" dirty="0"/>
           </a:p>
@@ -12660,7 +12838,7 @@
                 <a:ea typeface="Segoe UI" pitchFamily="34" charset="-122"/>
                 <a:cs typeface="Segoe UI" pitchFamily="34" charset="-120"/>
               </a:rPr>
-              <a:t>Export PDF des factures</a:t>
+              <a:t>Statut de suivi automatique (À faire / En cours / Terminée)</a:t>
             </a:r>
             <a:endParaRPr lang="en-US" sz="1400" dirty="0"/>
           </a:p>
@@ -12702,7 +12880,7 @@
                 <a:ea typeface="Segoe UI" pitchFamily="34" charset="-122"/>
                 <a:cs typeface="Segoe UI" pitchFamily="34" charset="-120"/>
               </a:rPr>
-              <a:t>Chaque facture (issue d'un devis signé ou d'une intervention) peut désormais être téléchargée en PDF avec les informations de l'entreprise, du client et du montant — bouton ajouté dans la page Facturation et dans la fiche d'une intervention.</a:t>
+              <a:t>Le statut d'une intervention évolue automatiquement selon sa date (À faire tant que la date n'est pas arrivée, En cours le jour J), jusqu'à être marquée Terminée manuellement puis, si besoin, archivée.</a:t>
             </a:r>
             <a:endParaRPr lang="en-US" sz="1100" dirty="0"/>
           </a:p>
@@ -12710,7 +12888,135 @@
       </p:sp>
       <p:sp>
         <p:nvSpPr>
-          <p:cNvPr id="9" name="Text 7"/>
+          <p:cNvPr id="9" name="Shape 7"/>
+          <p:cNvSpPr/>
+          <p:nvPr/>
+        </p:nvSpPr>
+        <p:spPr>
+          <a:xfrm>
+            <a:off x="640080" y="2926080"/>
+            <a:ext cx="10881360" cy="1097280"/>
+          </a:xfrm>
+          <a:prstGeom prst="roundRect">
+            <a:avLst>
+              <a:gd name="adj" fmla="val 5000"/>
+            </a:avLst>
+          </a:prstGeom>
+          <a:solidFill>
+            <a:srgbClr val="FFFFFF"/>
+          </a:solidFill>
+          <a:ln w="12700">
+            <a:solidFill>
+              <a:srgbClr val="E4DCCB"/>
+            </a:solidFill>
+            <a:prstDash val="solid"/>
+          </a:ln>
+        </p:spPr>
+      </p:sp>
+      <p:sp>
+        <p:nvSpPr>
+          <p:cNvPr id="10" name="Shape 8"/>
+          <p:cNvSpPr/>
+          <p:nvPr/>
+        </p:nvSpPr>
+        <p:spPr>
+          <a:xfrm>
+            <a:off x="640080" y="2926080"/>
+            <a:ext cx="54864" cy="1097280"/>
+          </a:xfrm>
+          <a:prstGeom prst="rect">
+            <a:avLst/>
+          </a:prstGeom>
+          <a:solidFill>
+            <a:srgbClr val="9A4C1F"/>
+          </a:solidFill>
+          <a:ln/>
+        </p:spPr>
+      </p:sp>
+      <p:sp>
+        <p:nvSpPr>
+          <p:cNvPr id="11" name="Text 9"/>
+          <p:cNvSpPr/>
+          <p:nvPr/>
+        </p:nvSpPr>
+        <p:spPr>
+          <a:xfrm>
+            <a:off x="914400" y="3035808"/>
+            <a:ext cx="10332720" cy="365760"/>
+          </a:xfrm>
+          <a:prstGeom prst="rect">
+            <a:avLst/>
+          </a:prstGeom>
+          <a:noFill/>
+          <a:ln/>
+        </p:spPr>
+        <p:txBody>
+          <a:bodyPr wrap="square" rtlCol="0" anchor="ctr"/>
+          <a:lstStyle/>
+          <a:p>
+            <a:pPr indent="0" marL="0">
+              <a:buNone/>
+            </a:pPr>
+            <a:r>
+              <a:rPr lang="en-US" sz="1400" b="1" dirty="0">
+                <a:solidFill>
+                  <a:srgbClr val="1B1F3B"/>
+                </a:solidFill>
+                <a:latin typeface="Segoe UI" pitchFamily="34" charset="0"/>
+                <a:ea typeface="Segoe UI" pitchFamily="34" charset="-122"/>
+                <a:cs typeface="Segoe UI" pitchFamily="34" charset="-120"/>
+              </a:rPr>
+              <a:t>Numéro de rapport automatique</a:t>
+            </a:r>
+            <a:endParaRPr lang="en-US" sz="1400" dirty="0"/>
+          </a:p>
+        </p:txBody>
+      </p:sp>
+      <p:sp>
+        <p:nvSpPr>
+          <p:cNvPr id="12" name="Text 10"/>
+          <p:cNvSpPr/>
+          <p:nvPr/>
+        </p:nvSpPr>
+        <p:spPr>
+          <a:xfrm>
+            <a:off x="914400" y="3383280"/>
+            <a:ext cx="10332720" cy="594360"/>
+          </a:xfrm>
+          <a:prstGeom prst="rect">
+            <a:avLst/>
+          </a:prstGeom>
+          <a:noFill/>
+          <a:ln/>
+        </p:spPr>
+        <p:txBody>
+          <a:bodyPr wrap="square" rtlCol="0" anchor="ctr"/>
+          <a:lstStyle/>
+          <a:p>
+            <a:pPr indent="0" marL="0">
+              <a:lnSpc>
+                <a:spcPts val="1400"/>
+              </a:lnSpc>
+              <a:buNone/>
+            </a:pPr>
+            <a:r>
+              <a:rPr lang="en-US" sz="1100" dirty="0">
+                <a:solidFill>
+                  <a:srgbClr val="8A7C68"/>
+                </a:solidFill>
+                <a:latin typeface="Segoe UI" pitchFamily="34" charset="0"/>
+                <a:ea typeface="Segoe UI" pitchFamily="34" charset="-122"/>
+                <a:cs typeface="Segoe UI" pitchFamily="34" charset="-120"/>
+              </a:rPr>
+              <a:t>Chaque rapport reçoit un numéro unique généré automatiquement (ex. INT-2026-0003), affiché en en-tête avec la date de création, sur le même principe que la numérotation des devis et factures.</a:t>
+            </a:r>
+            <a:endParaRPr lang="en-US" sz="1100" dirty="0"/>
+          </a:p>
+        </p:txBody>
+      </p:sp>
+      <p:sp>
+        <p:nvSpPr>
+          <p:cNvPr id="13" name="Text 11"/>
           <p:cNvSpPr/>
           <p:nvPr/>
         </p:nvSpPr>
@@ -12749,7 +13055,7 @@
       </p:sp>
       <p:sp>
         <p:nvSpPr>
-          <p:cNvPr id="10" name="Text 8"/>
+          <p:cNvPr id="14" name="Text 12"/>
           <p:cNvSpPr/>
           <p:nvPr/>
         </p:nvSpPr>
@@ -12797,6 +13103,344 @@
 <file path=ppt/slides/slide26.xml><?xml version="1.0" encoding="utf-8"?>
 <p:sld xmlns:a="http://schemas.openxmlformats.org/drawingml/2006/main" xmlns:r="http://schemas.openxmlformats.org/officeDocument/2006/relationships" xmlns:p="http://schemas.openxmlformats.org/presentationml/2006/main">
   <p:cSld name="Slide 26">
+    <p:bg>
+      <p:bgPr>
+        <a:solidFill>
+          <a:srgbClr val="F3EEE3"/>
+        </a:solidFill>
+      </p:bgPr>
+    </p:bg>
+    <p:spTree>
+      <p:nvGrpSpPr>
+        <p:cNvPr id="1" name=""/>
+        <p:cNvGrpSpPr/>
+        <p:nvPr/>
+      </p:nvGrpSpPr>
+      <p:grpSpPr>
+        <a:xfrm>
+          <a:off x="0" y="0"/>
+          <a:ext cx="0" cy="0"/>
+          <a:chOff x="0" y="0"/>
+          <a:chExt cx="0" cy="0"/>
+        </a:xfrm>
+      </p:grpSpPr>
+      <p:sp>
+        <p:nvSpPr>
+          <p:cNvPr id="2" name="Shape 0"/>
+          <p:cNvSpPr/>
+          <p:nvPr/>
+        </p:nvSpPr>
+        <p:spPr>
+          <a:xfrm>
+            <a:off x="640080" y="411480"/>
+            <a:ext cx="2377440" cy="365760"/>
+          </a:xfrm>
+          <a:prstGeom prst="roundRect">
+            <a:avLst>
+              <a:gd name="adj" fmla="val 50000"/>
+            </a:avLst>
+          </a:prstGeom>
+          <a:solidFill>
+            <a:srgbClr val="F5E6DA"/>
+          </a:solidFill>
+          <a:ln/>
+        </p:spPr>
+      </p:sp>
+      <p:sp>
+        <p:nvSpPr>
+          <p:cNvPr id="3" name="Text 1"/>
+          <p:cNvSpPr/>
+          <p:nvPr/>
+        </p:nvSpPr>
+        <p:spPr>
+          <a:xfrm>
+            <a:off x="640080" y="411480"/>
+            <a:ext cx="2377440" cy="365760"/>
+          </a:xfrm>
+          <a:prstGeom prst="rect">
+            <a:avLst/>
+          </a:prstGeom>
+          <a:noFill/>
+          <a:ln/>
+        </p:spPr>
+        <p:txBody>
+          <a:bodyPr wrap="square" rtlCol="0" anchor="ctr"/>
+          <a:lstStyle/>
+          <a:p>
+            <a:pPr algn="ctr" indent="0" marL="0">
+              <a:buNone/>
+            </a:pPr>
+            <a:r>
+              <a:rPr lang="en-US" sz="1000" b="1" spc="100" kern="0" dirty="0">
+                <a:solidFill>
+                  <a:srgbClr val="9A4C1F"/>
+                </a:solidFill>
+                <a:latin typeface="Segoe UI" pitchFamily="34" charset="0"/>
+                <a:ea typeface="Segoe UI" pitchFamily="34" charset="-122"/>
+                <a:cs typeface="Segoe UI" pitchFamily="34" charset="-120"/>
+              </a:rPr>
+              <a:t>BACKEND</a:t>
+            </a:r>
+            <a:endParaRPr lang="en-US" sz="1000" dirty="0"/>
+          </a:p>
+        </p:txBody>
+      </p:sp>
+      <p:sp>
+        <p:nvSpPr>
+          <p:cNvPr id="4" name="Text 2"/>
+          <p:cNvSpPr/>
+          <p:nvPr/>
+        </p:nvSpPr>
+        <p:spPr>
+          <a:xfrm>
+            <a:off x="640080" y="868680"/>
+            <a:ext cx="10515600" cy="548640"/>
+          </a:xfrm>
+          <a:prstGeom prst="rect">
+            <a:avLst/>
+          </a:prstGeom>
+          <a:noFill/>
+          <a:ln/>
+        </p:spPr>
+        <p:txBody>
+          <a:bodyPr wrap="square" rtlCol="0" anchor="ctr"/>
+          <a:lstStyle/>
+          <a:p>
+            <a:pPr indent="0" marL="0">
+              <a:buNone/>
+            </a:pPr>
+            <a:r>
+              <a:rPr lang="en-US" sz="2400" b="1" dirty="0">
+                <a:solidFill>
+                  <a:srgbClr val="1B1F3B"/>
+                </a:solidFill>
+                <a:latin typeface="Georgia" pitchFamily="34" charset="0"/>
+                <a:ea typeface="Georgia" pitchFamily="34" charset="-122"/>
+                <a:cs typeface="Georgia" pitchFamily="34" charset="-120"/>
+              </a:rPr>
+              <a:t>Facturation</a:t>
+            </a:r>
+            <a:endParaRPr lang="en-US" sz="2400" dirty="0"/>
+          </a:p>
+        </p:txBody>
+      </p:sp>
+      <p:sp>
+        <p:nvSpPr>
+          <p:cNvPr id="5" name="Shape 3"/>
+          <p:cNvSpPr/>
+          <p:nvPr/>
+        </p:nvSpPr>
+        <p:spPr>
+          <a:xfrm>
+            <a:off x="640080" y="1691640"/>
+            <a:ext cx="10881360" cy="1097280"/>
+          </a:xfrm>
+          <a:prstGeom prst="roundRect">
+            <a:avLst>
+              <a:gd name="adj" fmla="val 5000"/>
+            </a:avLst>
+          </a:prstGeom>
+          <a:solidFill>
+            <a:srgbClr val="FFFFFF"/>
+          </a:solidFill>
+          <a:ln w="12700">
+            <a:solidFill>
+              <a:srgbClr val="E4DCCB"/>
+            </a:solidFill>
+            <a:prstDash val="solid"/>
+          </a:ln>
+        </p:spPr>
+      </p:sp>
+      <p:sp>
+        <p:nvSpPr>
+          <p:cNvPr id="6" name="Shape 4"/>
+          <p:cNvSpPr/>
+          <p:nvPr/>
+        </p:nvSpPr>
+        <p:spPr>
+          <a:xfrm>
+            <a:off x="640080" y="1691640"/>
+            <a:ext cx="54864" cy="1097280"/>
+          </a:xfrm>
+          <a:prstGeom prst="rect">
+            <a:avLst/>
+          </a:prstGeom>
+          <a:solidFill>
+            <a:srgbClr val="9A4C1F"/>
+          </a:solidFill>
+          <a:ln/>
+        </p:spPr>
+      </p:sp>
+      <p:sp>
+        <p:nvSpPr>
+          <p:cNvPr id="7" name="Text 5"/>
+          <p:cNvSpPr/>
+          <p:nvPr/>
+        </p:nvSpPr>
+        <p:spPr>
+          <a:xfrm>
+            <a:off x="914400" y="1801368"/>
+            <a:ext cx="10332720" cy="365760"/>
+          </a:xfrm>
+          <a:prstGeom prst="rect">
+            <a:avLst/>
+          </a:prstGeom>
+          <a:noFill/>
+          <a:ln/>
+        </p:spPr>
+        <p:txBody>
+          <a:bodyPr wrap="square" rtlCol="0" anchor="ctr"/>
+          <a:lstStyle/>
+          <a:p>
+            <a:pPr indent="0" marL="0">
+              <a:buNone/>
+            </a:pPr>
+            <a:r>
+              <a:rPr lang="en-US" sz="1400" b="1" dirty="0">
+                <a:solidFill>
+                  <a:srgbClr val="1B1F3B"/>
+                </a:solidFill>
+                <a:latin typeface="Segoe UI" pitchFamily="34" charset="0"/>
+                <a:ea typeface="Segoe UI" pitchFamily="34" charset="-122"/>
+                <a:cs typeface="Segoe UI" pitchFamily="34" charset="-120"/>
+              </a:rPr>
+              <a:t>Export PDF des factures</a:t>
+            </a:r>
+            <a:endParaRPr lang="en-US" sz="1400" dirty="0"/>
+          </a:p>
+        </p:txBody>
+      </p:sp>
+      <p:sp>
+        <p:nvSpPr>
+          <p:cNvPr id="8" name="Text 6"/>
+          <p:cNvSpPr/>
+          <p:nvPr/>
+        </p:nvSpPr>
+        <p:spPr>
+          <a:xfrm>
+            <a:off x="914400" y="2148840"/>
+            <a:ext cx="10332720" cy="594360"/>
+          </a:xfrm>
+          <a:prstGeom prst="rect">
+            <a:avLst/>
+          </a:prstGeom>
+          <a:noFill/>
+          <a:ln/>
+        </p:spPr>
+        <p:txBody>
+          <a:bodyPr wrap="square" rtlCol="0" anchor="ctr"/>
+          <a:lstStyle/>
+          <a:p>
+            <a:pPr indent="0" marL="0">
+              <a:lnSpc>
+                <a:spcPts val="1400"/>
+              </a:lnSpc>
+              <a:buNone/>
+            </a:pPr>
+            <a:r>
+              <a:rPr lang="en-US" sz="1100" dirty="0">
+                <a:solidFill>
+                  <a:srgbClr val="8A7C68"/>
+                </a:solidFill>
+                <a:latin typeface="Segoe UI" pitchFamily="34" charset="0"/>
+                <a:ea typeface="Segoe UI" pitchFamily="34" charset="-122"/>
+                <a:cs typeface="Segoe UI" pitchFamily="34" charset="-120"/>
+              </a:rPr>
+              <a:t>Chaque facture (issue d'un devis signé ou d'une intervention) peut désormais être téléchargée en PDF avec les informations de l'entreprise, du client et du montant — bouton ajouté dans la page Facturation et dans la fiche d'une intervention.</a:t>
+            </a:r>
+            <a:endParaRPr lang="en-US" sz="1100" dirty="0"/>
+          </a:p>
+        </p:txBody>
+      </p:sp>
+      <p:sp>
+        <p:nvSpPr>
+          <p:cNvPr id="9" name="Text 7"/>
+          <p:cNvSpPr/>
+          <p:nvPr/>
+        </p:nvSpPr>
+        <p:spPr>
+          <a:xfrm>
+            <a:off x="365760" y="6510528"/>
+            <a:ext cx="5486400" cy="274320"/>
+          </a:xfrm>
+          <a:prstGeom prst="rect">
+            <a:avLst/>
+          </a:prstGeom>
+          <a:noFill/>
+          <a:ln/>
+        </p:spPr>
+        <p:txBody>
+          <a:bodyPr wrap="square" rtlCol="0" anchor="ctr"/>
+          <a:lstStyle/>
+          <a:p>
+            <a:pPr indent="0" marL="0">
+              <a:buNone/>
+            </a:pPr>
+            <a:r>
+              <a:rPr lang="en-US" sz="900" dirty="0">
+                <a:solidFill>
+                  <a:srgbClr val="8A7C68"/>
+                </a:solidFill>
+                <a:latin typeface="Segoe UI" pitchFamily="34" charset="0"/>
+                <a:ea typeface="Segoe UI" pitchFamily="34" charset="-122"/>
+                <a:cs typeface="Segoe UI" pitchFamily="34" charset="-120"/>
+              </a:rPr>
+              <a:t>Kôji Web — Récapitulatif technique</a:t>
+            </a:r>
+            <a:endParaRPr lang="en-US" sz="900" dirty="0"/>
+          </a:p>
+        </p:txBody>
+      </p:sp>
+      <p:sp>
+        <p:nvSpPr>
+          <p:cNvPr id="10" name="Text 8"/>
+          <p:cNvSpPr/>
+          <p:nvPr/>
+        </p:nvSpPr>
+        <p:spPr>
+          <a:xfrm>
+            <a:off x="9601200" y="6510528"/>
+            <a:ext cx="2194560" cy="274320"/>
+          </a:xfrm>
+          <a:prstGeom prst="rect">
+            <a:avLst/>
+          </a:prstGeom>
+          <a:noFill/>
+          <a:ln/>
+        </p:spPr>
+        <p:txBody>
+          <a:bodyPr wrap="square" rtlCol="0" anchor="ctr"/>
+          <a:lstStyle/>
+          <a:p>
+            <a:pPr algn="r" indent="0" marL="0">
+              <a:buNone/>
+            </a:pPr>
+            <a:r>
+              <a:rPr lang="en-US" sz="900" dirty="0">
+                <a:solidFill>
+                  <a:srgbClr val="8A7C68"/>
+                </a:solidFill>
+                <a:latin typeface="Segoe UI" pitchFamily="34" charset="0"/>
+                <a:ea typeface="Segoe UI" pitchFamily="34" charset="-122"/>
+                <a:cs typeface="Segoe UI" pitchFamily="34" charset="-120"/>
+              </a:rPr>
+              <a:t>26</a:t>
+            </a:r>
+            <a:endParaRPr lang="en-US" sz="900" dirty="0"/>
+          </a:p>
+        </p:txBody>
+      </p:sp>
+    </p:spTree>
+  </p:cSld>
+  <p:clrMapOvr>
+    <a:masterClrMapping/>
+  </p:clrMapOvr>
+</p:sld>
+</file>
+
+<file path=ppt/slides/slide27.xml><?xml version="1.0" encoding="utf-8"?>
+<p:sld xmlns:a="http://schemas.openxmlformats.org/drawingml/2006/main" xmlns:r="http://schemas.openxmlformats.org/officeDocument/2006/relationships" xmlns:p="http://schemas.openxmlformats.org/presentationml/2006/main">
+  <p:cSld name="Slide 27">
     <p:bg>
       <p:bgPr>
         <a:solidFill>
@@ -12949,7 +13593,7 @@
                 <a:ea typeface="Segoe UI" pitchFamily="34" charset="-122"/>
                 <a:cs typeface="Segoe UI" pitchFamily="34" charset="-120"/>
               </a:rPr>
-              <a:t>5 mise(s) à jour</a:t>
+              <a:t>7 mise(s) à jour</a:t>
             </a:r>
             <a:endParaRPr lang="en-US" sz="1200" dirty="0"/>
           </a:p>
@@ -12997,344 +13641,6 @@
       <p:sp>
         <p:nvSpPr>
           <p:cNvPr id="7" name="Text 5"/>
-          <p:cNvSpPr/>
-          <p:nvPr/>
-        </p:nvSpPr>
-        <p:spPr>
-          <a:xfrm>
-            <a:off x="9601200" y="6510528"/>
-            <a:ext cx="2194560" cy="274320"/>
-          </a:xfrm>
-          <a:prstGeom prst="rect">
-            <a:avLst/>
-          </a:prstGeom>
-          <a:noFill/>
-          <a:ln/>
-        </p:spPr>
-        <p:txBody>
-          <a:bodyPr wrap="square" rtlCol="0" anchor="ctr"/>
-          <a:lstStyle/>
-          <a:p>
-            <a:pPr algn="r" indent="0" marL="0">
-              <a:buNone/>
-            </a:pPr>
-            <a:r>
-              <a:rPr lang="en-US" sz="900" dirty="0">
-                <a:solidFill>
-                  <a:srgbClr val="8A7C68"/>
-                </a:solidFill>
-                <a:latin typeface="Segoe UI" pitchFamily="34" charset="0"/>
-                <a:ea typeface="Segoe UI" pitchFamily="34" charset="-122"/>
-                <a:cs typeface="Segoe UI" pitchFamily="34" charset="-120"/>
-              </a:rPr>
-              <a:t>26</a:t>
-            </a:r>
-            <a:endParaRPr lang="en-US" sz="900" dirty="0"/>
-          </a:p>
-        </p:txBody>
-      </p:sp>
-    </p:spTree>
-  </p:cSld>
-  <p:clrMapOvr>
-    <a:masterClrMapping/>
-  </p:clrMapOvr>
-</p:sld>
-</file>
-
-<file path=ppt/slides/slide27.xml><?xml version="1.0" encoding="utf-8"?>
-<p:sld xmlns:a="http://schemas.openxmlformats.org/drawingml/2006/main" xmlns:r="http://schemas.openxmlformats.org/officeDocument/2006/relationships" xmlns:p="http://schemas.openxmlformats.org/presentationml/2006/main">
-  <p:cSld name="Slide 27">
-    <p:bg>
-      <p:bgPr>
-        <a:solidFill>
-          <a:srgbClr val="F3EEE3"/>
-        </a:solidFill>
-      </p:bgPr>
-    </p:bg>
-    <p:spTree>
-      <p:nvGrpSpPr>
-        <p:cNvPr id="1" name=""/>
-        <p:cNvGrpSpPr/>
-        <p:nvPr/>
-      </p:nvGrpSpPr>
-      <p:grpSpPr>
-        <a:xfrm>
-          <a:off x="0" y="0"/>
-          <a:ext cx="0" cy="0"/>
-          <a:chOff x="0" y="0"/>
-          <a:chExt cx="0" cy="0"/>
-        </a:xfrm>
-      </p:grpSpPr>
-      <p:sp>
-        <p:nvSpPr>
-          <p:cNvPr id="2" name="Shape 0"/>
-          <p:cNvSpPr/>
-          <p:nvPr/>
-        </p:nvSpPr>
-        <p:spPr>
-          <a:xfrm>
-            <a:off x="640080" y="411480"/>
-            <a:ext cx="2377440" cy="365760"/>
-          </a:xfrm>
-          <a:prstGeom prst="roundRect">
-            <a:avLst>
-              <a:gd name="adj" fmla="val 50000"/>
-            </a:avLst>
-          </a:prstGeom>
-          <a:solidFill>
-            <a:srgbClr val="E6EFE4"/>
-          </a:solidFill>
-          <a:ln/>
-        </p:spPr>
-      </p:sp>
-      <p:sp>
-        <p:nvSpPr>
-          <p:cNvPr id="3" name="Text 1"/>
-          <p:cNvSpPr/>
-          <p:nvPr/>
-        </p:nvSpPr>
-        <p:spPr>
-          <a:xfrm>
-            <a:off x="640080" y="411480"/>
-            <a:ext cx="2377440" cy="365760"/>
-          </a:xfrm>
-          <a:prstGeom prst="rect">
-            <a:avLst/>
-          </a:prstGeom>
-          <a:noFill/>
-          <a:ln/>
-        </p:spPr>
-        <p:txBody>
-          <a:bodyPr wrap="square" rtlCol="0" anchor="ctr"/>
-          <a:lstStyle/>
-          <a:p>
-            <a:pPr algn="ctr" indent="0" marL="0">
-              <a:buNone/>
-            </a:pPr>
-            <a:r>
-              <a:rPr lang="en-US" sz="1000" b="1" spc="100" kern="0" dirty="0">
-                <a:solidFill>
-                  <a:srgbClr val="386641"/>
-                </a:solidFill>
-                <a:latin typeface="Segoe UI" pitchFamily="34" charset="0"/>
-                <a:ea typeface="Segoe UI" pitchFamily="34" charset="-122"/>
-                <a:cs typeface="Segoe UI" pitchFamily="34" charset="-120"/>
-              </a:rPr>
-              <a:t>BASE DE DONNÉES</a:t>
-            </a:r>
-            <a:endParaRPr lang="en-US" sz="1000" dirty="0"/>
-          </a:p>
-        </p:txBody>
-      </p:sp>
-      <p:sp>
-        <p:nvSpPr>
-          <p:cNvPr id="4" name="Text 2"/>
-          <p:cNvSpPr/>
-          <p:nvPr/>
-        </p:nvSpPr>
-        <p:spPr>
-          <a:xfrm>
-            <a:off x="640080" y="868680"/>
-            <a:ext cx="10515600" cy="548640"/>
-          </a:xfrm>
-          <a:prstGeom prst="rect">
-            <a:avLst/>
-          </a:prstGeom>
-          <a:noFill/>
-          <a:ln/>
-        </p:spPr>
-        <p:txBody>
-          <a:bodyPr wrap="square" rtlCol="0" anchor="ctr"/>
-          <a:lstStyle/>
-          <a:p>
-            <a:pPr indent="0" marL="0">
-              <a:buNone/>
-            </a:pPr>
-            <a:r>
-              <a:rPr lang="en-US" sz="2400" b="1" dirty="0">
-                <a:solidFill>
-                  <a:srgbClr val="1B1F3B"/>
-                </a:solidFill>
-                <a:latin typeface="Georgia" pitchFamily="34" charset="0"/>
-                <a:ea typeface="Georgia" pitchFamily="34" charset="-122"/>
-                <a:cs typeface="Georgia" pitchFamily="34" charset="-120"/>
-              </a:rPr>
-              <a:t>Fondations</a:t>
-            </a:r>
-            <a:endParaRPr lang="en-US" sz="2400" dirty="0"/>
-          </a:p>
-        </p:txBody>
-      </p:sp>
-      <p:sp>
-        <p:nvSpPr>
-          <p:cNvPr id="5" name="Shape 3"/>
-          <p:cNvSpPr/>
-          <p:nvPr/>
-        </p:nvSpPr>
-        <p:spPr>
-          <a:xfrm>
-            <a:off x="640080" y="1691640"/>
-            <a:ext cx="10881360" cy="1097280"/>
-          </a:xfrm>
-          <a:prstGeom prst="roundRect">
-            <a:avLst>
-              <a:gd name="adj" fmla="val 5000"/>
-            </a:avLst>
-          </a:prstGeom>
-          <a:solidFill>
-            <a:srgbClr val="FFFFFF"/>
-          </a:solidFill>
-          <a:ln w="12700">
-            <a:solidFill>
-              <a:srgbClr val="E4DCCB"/>
-            </a:solidFill>
-            <a:prstDash val="solid"/>
-          </a:ln>
-        </p:spPr>
-      </p:sp>
-      <p:sp>
-        <p:nvSpPr>
-          <p:cNvPr id="6" name="Shape 4"/>
-          <p:cNvSpPr/>
-          <p:nvPr/>
-        </p:nvSpPr>
-        <p:spPr>
-          <a:xfrm>
-            <a:off x="640080" y="1691640"/>
-            <a:ext cx="54864" cy="1097280"/>
-          </a:xfrm>
-          <a:prstGeom prst="rect">
-            <a:avLst/>
-          </a:prstGeom>
-          <a:solidFill>
-            <a:srgbClr val="386641"/>
-          </a:solidFill>
-          <a:ln/>
-        </p:spPr>
-      </p:sp>
-      <p:sp>
-        <p:nvSpPr>
-          <p:cNvPr id="7" name="Text 5"/>
-          <p:cNvSpPr/>
-          <p:nvPr/>
-        </p:nvSpPr>
-        <p:spPr>
-          <a:xfrm>
-            <a:off x="914400" y="1801368"/>
-            <a:ext cx="10332720" cy="365760"/>
-          </a:xfrm>
-          <a:prstGeom prst="rect">
-            <a:avLst/>
-          </a:prstGeom>
-          <a:noFill/>
-          <a:ln/>
-        </p:spPr>
-        <p:txBody>
-          <a:bodyPr wrap="square" rtlCol="0" anchor="ctr"/>
-          <a:lstStyle/>
-          <a:p>
-            <a:pPr indent="0" marL="0">
-              <a:buNone/>
-            </a:pPr>
-            <a:r>
-              <a:rPr lang="en-US" sz="1400" b="1" dirty="0">
-                <a:solidFill>
-                  <a:srgbClr val="1B1F3B"/>
-                </a:solidFill>
-                <a:latin typeface="Segoe UI" pitchFamily="34" charset="0"/>
-                <a:ea typeface="Segoe UI" pitchFamily="34" charset="-122"/>
-                <a:cs typeface="Segoe UI" pitchFamily="34" charset="-120"/>
-              </a:rPr>
-              <a:t>Connexion Vercel / configuration environnement</a:t>
-            </a:r>
-            <a:endParaRPr lang="en-US" sz="1400" dirty="0"/>
-          </a:p>
-        </p:txBody>
-      </p:sp>
-      <p:sp>
-        <p:nvSpPr>
-          <p:cNvPr id="8" name="Text 6"/>
-          <p:cNvSpPr/>
-          <p:nvPr/>
-        </p:nvSpPr>
-        <p:spPr>
-          <a:xfrm>
-            <a:off x="914400" y="2148840"/>
-            <a:ext cx="10332720" cy="594360"/>
-          </a:xfrm>
-          <a:prstGeom prst="rect">
-            <a:avLst/>
-          </a:prstGeom>
-          <a:noFill/>
-          <a:ln/>
-        </p:spPr>
-        <p:txBody>
-          <a:bodyPr wrap="square" rtlCol="0" anchor="ctr"/>
-          <a:lstStyle/>
-          <a:p>
-            <a:pPr indent="0" marL="0">
-              <a:lnSpc>
-                <a:spcPts val="1400"/>
-              </a:lnSpc>
-              <a:buNone/>
-            </a:pPr>
-            <a:r>
-              <a:rPr lang="en-US" sz="1100" dirty="0">
-                <a:solidFill>
-                  <a:srgbClr val="8A7C68"/>
-                </a:solidFill>
-                <a:latin typeface="Segoe UI" pitchFamily="34" charset="0"/>
-                <a:ea typeface="Segoe UI" pitchFamily="34" charset="-122"/>
-                <a:cs typeface="Segoe UI" pitchFamily="34" charset="-120"/>
-              </a:rPr>
-              <a:t>Correction de la configuration d'authentification et du SMTP sur l'environnement de production Vercel.</a:t>
-            </a:r>
-            <a:endParaRPr lang="en-US" sz="1100" dirty="0"/>
-          </a:p>
-        </p:txBody>
-      </p:sp>
-      <p:sp>
-        <p:nvSpPr>
-          <p:cNvPr id="9" name="Text 7"/>
-          <p:cNvSpPr/>
-          <p:nvPr/>
-        </p:nvSpPr>
-        <p:spPr>
-          <a:xfrm>
-            <a:off x="365760" y="6510528"/>
-            <a:ext cx="5486400" cy="274320"/>
-          </a:xfrm>
-          <a:prstGeom prst="rect">
-            <a:avLst/>
-          </a:prstGeom>
-          <a:noFill/>
-          <a:ln/>
-        </p:spPr>
-        <p:txBody>
-          <a:bodyPr wrap="square" rtlCol="0" anchor="ctr"/>
-          <a:lstStyle/>
-          <a:p>
-            <a:pPr indent="0" marL="0">
-              <a:buNone/>
-            </a:pPr>
-            <a:r>
-              <a:rPr lang="en-US" sz="900" dirty="0">
-                <a:solidFill>
-                  <a:srgbClr val="8A7C68"/>
-                </a:solidFill>
-                <a:latin typeface="Segoe UI" pitchFamily="34" charset="0"/>
-                <a:ea typeface="Segoe UI" pitchFamily="34" charset="-122"/>
-                <a:cs typeface="Segoe UI" pitchFamily="34" charset="-120"/>
-              </a:rPr>
-              <a:t>Kôji Web — Récapitulatif technique</a:t>
-            </a:r>
-            <a:endParaRPr lang="en-US" sz="900" dirty="0"/>
-          </a:p>
-        </p:txBody>
-      </p:sp>
-      <p:sp>
-        <p:nvSpPr>
-          <p:cNvPr id="10" name="Text 8"/>
           <p:cNvSpPr/>
           <p:nvPr/>
         </p:nvSpPr>
@@ -13497,7 +13803,7 @@
                 <a:ea typeface="Georgia" pitchFamily="34" charset="-122"/>
                 <a:cs typeface="Georgia" pitchFamily="34" charset="-120"/>
               </a:rPr>
-              <a:t>Devis</a:t>
+              <a:t>Fondations</a:t>
             </a:r>
             <a:endParaRPr lang="en-US" sz="2400" dirty="0"/>
           </a:p>
@@ -13583,7 +13889,7 @@
                 <a:ea typeface="Segoe UI" pitchFamily="34" charset="-122"/>
                 <a:cs typeface="Segoe UI" pitchFamily="34" charset="-120"/>
               </a:rPr>
-              <a:t>Migration des devis vers Supabase (table partagée)</a:t>
+              <a:t>Connexion Vercel / configuration environnement</a:t>
             </a:r>
             <a:endParaRPr lang="en-US" sz="1400" dirty="0"/>
           </a:p>
@@ -13625,7 +13931,7 @@
                 <a:ea typeface="Segoe UI" pitchFamily="34" charset="-122"/>
                 <a:cs typeface="Segoe UI" pitchFamily="34" charset="-120"/>
               </a:rPr>
-              <a:t>Les devis créés sur le site web et sur l'application mobile (Firas) vivent désormais dans la même table Supabase 'quotes', avec un mapping bidirectionnel dédié (lib/quote-mapping.js).</a:t>
+              <a:t>Correction de la configuration d'authentification et du SMTP sur l'environnement de production Vercel.</a:t>
             </a:r>
             <a:endParaRPr lang="en-US" sz="1100" dirty="0"/>
           </a:p>
@@ -13835,7 +14141,7 @@
                 <a:ea typeface="Georgia" pitchFamily="34" charset="-122"/>
                 <a:cs typeface="Georgia" pitchFamily="34" charset="-120"/>
               </a:rPr>
-              <a:t>Chantiers</a:t>
+              <a:t>Devis</a:t>
             </a:r>
             <a:endParaRPr lang="en-US" sz="2400" dirty="0"/>
           </a:p>
@@ -13921,7 +14227,7 @@
                 <a:ea typeface="Segoe UI" pitchFamily="34" charset="-122"/>
                 <a:cs typeface="Segoe UI" pitchFamily="34" charset="-120"/>
               </a:rPr>
-              <a:t>Connexion Supabase : chantiers, planning, fournitures</a:t>
+              <a:t>Migration des devis vers Supabase (table partagée)</a:t>
             </a:r>
             <a:endParaRPr lang="en-US" sz="1400" dirty="0"/>
           </a:p>
@@ -13963,7 +14269,7 @@
                 <a:ea typeface="Segoe UI" pitchFamily="34" charset="-122"/>
                 <a:cs typeface="Segoe UI" pitchFamily="34" charset="-120"/>
               </a:rPr>
-              <a:t>Ces trois modules sont branchés sur la base partagée avec l'application mobile ; les comptes utilisateurs sont également partagés entre les deux plateformes.</a:t>
+              <a:t>Les devis créés sur le site web et sur l'application mobile (Firas) vivent désormais dans la même table Supabase 'quotes', avec un mapping bidirectionnel dédié (lib/quote-mapping.js).</a:t>
             </a:r>
             <a:endParaRPr lang="en-US" sz="1100" dirty="0"/>
           </a:p>
@@ -14210,7 +14516,7 @@
                 <a:ea typeface="Segoe UI" pitchFamily="34" charset="-122"/>
                 <a:cs typeface="Segoe UI" pitchFamily="34" charset="-120"/>
               </a:rPr>
-              <a:t>33 mise(s) à jour</a:t>
+              <a:t>35 mise(s) à jour</a:t>
             </a:r>
             <a:endParaRPr lang="en-US" sz="1200" dirty="0"/>
           </a:p>
@@ -14420,7 +14726,7 @@
                 <a:ea typeface="Georgia" pitchFamily="34" charset="-122"/>
                 <a:cs typeface="Georgia" pitchFamily="34" charset="-120"/>
               </a:rPr>
-              <a:t>Équipe</a:t>
+              <a:t>Chantiers</a:t>
             </a:r>
             <a:endParaRPr lang="en-US" sz="2400" dirty="0"/>
           </a:p>
@@ -14506,7 +14812,7 @@
                 <a:ea typeface="Segoe UI" pitchFamily="34" charset="-122"/>
                 <a:cs typeface="Segoe UI" pitchFamily="34" charset="-120"/>
               </a:rPr>
-              <a:t>Nouvelle donnée : heures contractuelles par ouvrier</a:t>
+              <a:t>Connexion Supabase : chantiers, planning, fournitures</a:t>
             </a:r>
             <a:endParaRPr lang="en-US" sz="1400" dirty="0"/>
           </a:p>
@@ -14548,7 +14854,7 @@
                 <a:ea typeface="Segoe UI" pitchFamily="34" charset="-122"/>
                 <a:cs typeface="Segoe UI" pitchFamily="34" charset="-120"/>
               </a:rPr>
-              <a:t>Ajout d'un paramètre 'heures contractuelles / semaine' (35h par défaut) sur chaque fiche ouvrier, utilisé pour le calcul des écarts.</a:t>
+              <a:t>Ces trois modules sont branchés sur la base partagée avec l'application mobile ; les comptes utilisateurs sont également partagés entre les deux plateformes.</a:t>
             </a:r>
             <a:endParaRPr lang="en-US" sz="1100" dirty="0"/>
           </a:p>
@@ -14758,7 +15064,7 @@
                 <a:ea typeface="Georgia" pitchFamily="34" charset="-122"/>
                 <a:cs typeface="Georgia" pitchFamily="34" charset="-120"/>
               </a:rPr>
-              <a:t>Accueil &amp; stabilité</a:t>
+              <a:t>Équipe</a:t>
             </a:r>
             <a:endParaRPr lang="en-US" sz="2400" dirty="0"/>
           </a:p>
@@ -14844,7 +15150,7 @@
                 <a:ea typeface="Segoe UI" pitchFamily="34" charset="-122"/>
                 <a:cs typeface="Segoe UI" pitchFamily="34" charset="-120"/>
               </a:rPr>
-              <a:t>Nettoyage du backend</a:t>
+              <a:t>Nouvelle donnée : heures contractuelles par ouvrier</a:t>
             </a:r>
             <a:endParaRPr lang="en-US" sz="1400" dirty="0"/>
           </a:p>
@@ -14886,7 +15192,7 @@
                 <a:ea typeface="Segoe UI" pitchFamily="34" charset="-122"/>
                 <a:cs typeface="Segoe UI" pitchFamily="34" charset="-120"/>
               </a:rPr>
-              <a:t>Audit complet des routes serveur : suppression du code mort (module Marketplace), vérification de la cohérence entre données locales et données Supabase sur l'ensemble de l'application.</a:t>
+              <a:t>Ajout d'un paramètre 'heures contractuelles / semaine' (35h par défaut) sur chaque fiche ouvrier, utilisé pour le calcul des écarts.</a:t>
             </a:r>
             <a:endParaRPr lang="en-US" sz="1100" dirty="0"/>
           </a:p>
@@ -14981,6 +15287,810 @@
 <file path=ppt/slides/slide32.xml><?xml version="1.0" encoding="utf-8"?>
 <p:sld xmlns:a="http://schemas.openxmlformats.org/drawingml/2006/main" xmlns:r="http://schemas.openxmlformats.org/officeDocument/2006/relationships" xmlns:p="http://schemas.openxmlformats.org/presentationml/2006/main">
   <p:cSld name="Slide 32">
+    <p:bg>
+      <p:bgPr>
+        <a:solidFill>
+          <a:srgbClr val="F3EEE3"/>
+        </a:solidFill>
+      </p:bgPr>
+    </p:bg>
+    <p:spTree>
+      <p:nvGrpSpPr>
+        <p:cNvPr id="1" name=""/>
+        <p:cNvGrpSpPr/>
+        <p:nvPr/>
+      </p:nvGrpSpPr>
+      <p:grpSpPr>
+        <a:xfrm>
+          <a:off x="0" y="0"/>
+          <a:ext cx="0" cy="0"/>
+          <a:chOff x="0" y="0"/>
+          <a:chExt cx="0" cy="0"/>
+        </a:xfrm>
+      </p:grpSpPr>
+      <p:sp>
+        <p:nvSpPr>
+          <p:cNvPr id="2" name="Shape 0"/>
+          <p:cNvSpPr/>
+          <p:nvPr/>
+        </p:nvSpPr>
+        <p:spPr>
+          <a:xfrm>
+            <a:off x="640080" y="411480"/>
+            <a:ext cx="2377440" cy="365760"/>
+          </a:xfrm>
+          <a:prstGeom prst="roundRect">
+            <a:avLst>
+              <a:gd name="adj" fmla="val 50000"/>
+            </a:avLst>
+          </a:prstGeom>
+          <a:solidFill>
+            <a:srgbClr val="E6EFE4"/>
+          </a:solidFill>
+          <a:ln/>
+        </p:spPr>
+      </p:sp>
+      <p:sp>
+        <p:nvSpPr>
+          <p:cNvPr id="3" name="Text 1"/>
+          <p:cNvSpPr/>
+          <p:nvPr/>
+        </p:nvSpPr>
+        <p:spPr>
+          <a:xfrm>
+            <a:off x="640080" y="411480"/>
+            <a:ext cx="2377440" cy="365760"/>
+          </a:xfrm>
+          <a:prstGeom prst="rect">
+            <a:avLst/>
+          </a:prstGeom>
+          <a:noFill/>
+          <a:ln/>
+        </p:spPr>
+        <p:txBody>
+          <a:bodyPr wrap="square" rtlCol="0" anchor="ctr"/>
+          <a:lstStyle/>
+          <a:p>
+            <a:pPr algn="ctr" indent="0" marL="0">
+              <a:buNone/>
+            </a:pPr>
+            <a:r>
+              <a:rPr lang="en-US" sz="1000" b="1" spc="100" kern="0" dirty="0">
+                <a:solidFill>
+                  <a:srgbClr val="386641"/>
+                </a:solidFill>
+                <a:latin typeface="Segoe UI" pitchFamily="34" charset="0"/>
+                <a:ea typeface="Segoe UI" pitchFamily="34" charset="-122"/>
+                <a:cs typeface="Segoe UI" pitchFamily="34" charset="-120"/>
+              </a:rPr>
+              <a:t>BASE DE DONNÉES</a:t>
+            </a:r>
+            <a:endParaRPr lang="en-US" sz="1000" dirty="0"/>
+          </a:p>
+        </p:txBody>
+      </p:sp>
+      <p:sp>
+        <p:nvSpPr>
+          <p:cNvPr id="4" name="Text 2"/>
+          <p:cNvSpPr/>
+          <p:nvPr/>
+        </p:nvSpPr>
+        <p:spPr>
+          <a:xfrm>
+            <a:off x="640080" y="868680"/>
+            <a:ext cx="10515600" cy="548640"/>
+          </a:xfrm>
+          <a:prstGeom prst="rect">
+            <a:avLst/>
+          </a:prstGeom>
+          <a:noFill/>
+          <a:ln/>
+        </p:spPr>
+        <p:txBody>
+          <a:bodyPr wrap="square" rtlCol="0" anchor="ctr"/>
+          <a:lstStyle/>
+          <a:p>
+            <a:pPr indent="0" marL="0">
+              <a:buNone/>
+            </a:pPr>
+            <a:r>
+              <a:rPr lang="en-US" sz="2400" b="1" dirty="0">
+                <a:solidFill>
+                  <a:srgbClr val="1B1F3B"/>
+                </a:solidFill>
+                <a:latin typeface="Georgia" pitchFamily="34" charset="0"/>
+                <a:ea typeface="Georgia" pitchFamily="34" charset="-122"/>
+                <a:cs typeface="Georgia" pitchFamily="34" charset="-120"/>
+              </a:rPr>
+              <a:t>Accueil &amp; stabilité</a:t>
+            </a:r>
+            <a:endParaRPr lang="en-US" sz="2400" dirty="0"/>
+          </a:p>
+        </p:txBody>
+      </p:sp>
+      <p:sp>
+        <p:nvSpPr>
+          <p:cNvPr id="5" name="Shape 3"/>
+          <p:cNvSpPr/>
+          <p:nvPr/>
+        </p:nvSpPr>
+        <p:spPr>
+          <a:xfrm>
+            <a:off x="640080" y="1691640"/>
+            <a:ext cx="10881360" cy="1097280"/>
+          </a:xfrm>
+          <a:prstGeom prst="roundRect">
+            <a:avLst>
+              <a:gd name="adj" fmla="val 5000"/>
+            </a:avLst>
+          </a:prstGeom>
+          <a:solidFill>
+            <a:srgbClr val="FFFFFF"/>
+          </a:solidFill>
+          <a:ln w="12700">
+            <a:solidFill>
+              <a:srgbClr val="E4DCCB"/>
+            </a:solidFill>
+            <a:prstDash val="solid"/>
+          </a:ln>
+        </p:spPr>
+      </p:sp>
+      <p:sp>
+        <p:nvSpPr>
+          <p:cNvPr id="6" name="Shape 4"/>
+          <p:cNvSpPr/>
+          <p:nvPr/>
+        </p:nvSpPr>
+        <p:spPr>
+          <a:xfrm>
+            <a:off x="640080" y="1691640"/>
+            <a:ext cx="54864" cy="1097280"/>
+          </a:xfrm>
+          <a:prstGeom prst="rect">
+            <a:avLst/>
+          </a:prstGeom>
+          <a:solidFill>
+            <a:srgbClr val="386641"/>
+          </a:solidFill>
+          <a:ln/>
+        </p:spPr>
+      </p:sp>
+      <p:sp>
+        <p:nvSpPr>
+          <p:cNvPr id="7" name="Text 5"/>
+          <p:cNvSpPr/>
+          <p:nvPr/>
+        </p:nvSpPr>
+        <p:spPr>
+          <a:xfrm>
+            <a:off x="914400" y="1801368"/>
+            <a:ext cx="10332720" cy="365760"/>
+          </a:xfrm>
+          <a:prstGeom prst="rect">
+            <a:avLst/>
+          </a:prstGeom>
+          <a:noFill/>
+          <a:ln/>
+        </p:spPr>
+        <p:txBody>
+          <a:bodyPr wrap="square" rtlCol="0" anchor="ctr"/>
+          <a:lstStyle/>
+          <a:p>
+            <a:pPr indent="0" marL="0">
+              <a:buNone/>
+            </a:pPr>
+            <a:r>
+              <a:rPr lang="en-US" sz="1400" b="1" dirty="0">
+                <a:solidFill>
+                  <a:srgbClr val="1B1F3B"/>
+                </a:solidFill>
+                <a:latin typeface="Segoe UI" pitchFamily="34" charset="0"/>
+                <a:ea typeface="Segoe UI" pitchFamily="34" charset="-122"/>
+                <a:cs typeface="Segoe UI" pitchFamily="34" charset="-120"/>
+              </a:rPr>
+              <a:t>Nettoyage du backend</a:t>
+            </a:r>
+            <a:endParaRPr lang="en-US" sz="1400" dirty="0"/>
+          </a:p>
+        </p:txBody>
+      </p:sp>
+      <p:sp>
+        <p:nvSpPr>
+          <p:cNvPr id="8" name="Text 6"/>
+          <p:cNvSpPr/>
+          <p:nvPr/>
+        </p:nvSpPr>
+        <p:spPr>
+          <a:xfrm>
+            <a:off x="914400" y="2148840"/>
+            <a:ext cx="10332720" cy="594360"/>
+          </a:xfrm>
+          <a:prstGeom prst="rect">
+            <a:avLst/>
+          </a:prstGeom>
+          <a:noFill/>
+          <a:ln/>
+        </p:spPr>
+        <p:txBody>
+          <a:bodyPr wrap="square" rtlCol="0" anchor="ctr"/>
+          <a:lstStyle/>
+          <a:p>
+            <a:pPr indent="0" marL="0">
+              <a:lnSpc>
+                <a:spcPts val="1400"/>
+              </a:lnSpc>
+              <a:buNone/>
+            </a:pPr>
+            <a:r>
+              <a:rPr lang="en-US" sz="1100" dirty="0">
+                <a:solidFill>
+                  <a:srgbClr val="8A7C68"/>
+                </a:solidFill>
+                <a:latin typeface="Segoe UI" pitchFamily="34" charset="0"/>
+                <a:ea typeface="Segoe UI" pitchFamily="34" charset="-122"/>
+                <a:cs typeface="Segoe UI" pitchFamily="34" charset="-120"/>
+              </a:rPr>
+              <a:t>Audit complet des routes serveur : suppression du code mort (module Marketplace), vérification de la cohérence entre données locales et données Supabase sur l'ensemble de l'application.</a:t>
+            </a:r>
+            <a:endParaRPr lang="en-US" sz="1100" dirty="0"/>
+          </a:p>
+        </p:txBody>
+      </p:sp>
+      <p:sp>
+        <p:nvSpPr>
+          <p:cNvPr id="9" name="Text 7"/>
+          <p:cNvSpPr/>
+          <p:nvPr/>
+        </p:nvSpPr>
+        <p:spPr>
+          <a:xfrm>
+            <a:off x="365760" y="6510528"/>
+            <a:ext cx="5486400" cy="274320"/>
+          </a:xfrm>
+          <a:prstGeom prst="rect">
+            <a:avLst/>
+          </a:prstGeom>
+          <a:noFill/>
+          <a:ln/>
+        </p:spPr>
+        <p:txBody>
+          <a:bodyPr wrap="square" rtlCol="0" anchor="ctr"/>
+          <a:lstStyle/>
+          <a:p>
+            <a:pPr indent="0" marL="0">
+              <a:buNone/>
+            </a:pPr>
+            <a:r>
+              <a:rPr lang="en-US" sz="900" dirty="0">
+                <a:solidFill>
+                  <a:srgbClr val="8A7C68"/>
+                </a:solidFill>
+                <a:latin typeface="Segoe UI" pitchFamily="34" charset="0"/>
+                <a:ea typeface="Segoe UI" pitchFamily="34" charset="-122"/>
+                <a:cs typeface="Segoe UI" pitchFamily="34" charset="-120"/>
+              </a:rPr>
+              <a:t>Kôji Web — Récapitulatif technique</a:t>
+            </a:r>
+            <a:endParaRPr lang="en-US" sz="900" dirty="0"/>
+          </a:p>
+        </p:txBody>
+      </p:sp>
+      <p:sp>
+        <p:nvSpPr>
+          <p:cNvPr id="10" name="Text 8"/>
+          <p:cNvSpPr/>
+          <p:nvPr/>
+        </p:nvSpPr>
+        <p:spPr>
+          <a:xfrm>
+            <a:off x="9601200" y="6510528"/>
+            <a:ext cx="2194560" cy="274320"/>
+          </a:xfrm>
+          <a:prstGeom prst="rect">
+            <a:avLst/>
+          </a:prstGeom>
+          <a:noFill/>
+          <a:ln/>
+        </p:spPr>
+        <p:txBody>
+          <a:bodyPr wrap="square" rtlCol="0" anchor="ctr"/>
+          <a:lstStyle/>
+          <a:p>
+            <a:pPr algn="r" indent="0" marL="0">
+              <a:buNone/>
+            </a:pPr>
+            <a:r>
+              <a:rPr lang="en-US" sz="900" dirty="0">
+                <a:solidFill>
+                  <a:srgbClr val="8A7C68"/>
+                </a:solidFill>
+                <a:latin typeface="Segoe UI" pitchFamily="34" charset="0"/>
+                <a:ea typeface="Segoe UI" pitchFamily="34" charset="-122"/>
+                <a:cs typeface="Segoe UI" pitchFamily="34" charset="-120"/>
+              </a:rPr>
+              <a:t>32</a:t>
+            </a:r>
+            <a:endParaRPr lang="en-US" sz="900" dirty="0"/>
+          </a:p>
+        </p:txBody>
+      </p:sp>
+    </p:spTree>
+  </p:cSld>
+  <p:clrMapOvr>
+    <a:masterClrMapping/>
+  </p:clrMapOvr>
+</p:sld>
+</file>
+
+<file path=ppt/slides/slide33.xml><?xml version="1.0" encoding="utf-8"?>
+<p:sld xmlns:a="http://schemas.openxmlformats.org/drawingml/2006/main" xmlns:r="http://schemas.openxmlformats.org/officeDocument/2006/relationships" xmlns:p="http://schemas.openxmlformats.org/presentationml/2006/main">
+  <p:cSld name="Slide 33">
+    <p:bg>
+      <p:bgPr>
+        <a:solidFill>
+          <a:srgbClr val="F3EEE3"/>
+        </a:solidFill>
+      </p:bgPr>
+    </p:bg>
+    <p:spTree>
+      <p:nvGrpSpPr>
+        <p:cNvPr id="1" name=""/>
+        <p:cNvGrpSpPr/>
+        <p:nvPr/>
+      </p:nvGrpSpPr>
+      <p:grpSpPr>
+        <a:xfrm>
+          <a:off x="0" y="0"/>
+          <a:ext cx="0" cy="0"/>
+          <a:chOff x="0" y="0"/>
+          <a:chExt cx="0" cy="0"/>
+        </a:xfrm>
+      </p:grpSpPr>
+      <p:sp>
+        <p:nvSpPr>
+          <p:cNvPr id="2" name="Shape 0"/>
+          <p:cNvSpPr/>
+          <p:nvPr/>
+        </p:nvSpPr>
+        <p:spPr>
+          <a:xfrm>
+            <a:off x="640080" y="411480"/>
+            <a:ext cx="2377440" cy="365760"/>
+          </a:xfrm>
+          <a:prstGeom prst="roundRect">
+            <a:avLst>
+              <a:gd name="adj" fmla="val 50000"/>
+            </a:avLst>
+          </a:prstGeom>
+          <a:solidFill>
+            <a:srgbClr val="E6EFE4"/>
+          </a:solidFill>
+          <a:ln/>
+        </p:spPr>
+      </p:sp>
+      <p:sp>
+        <p:nvSpPr>
+          <p:cNvPr id="3" name="Text 1"/>
+          <p:cNvSpPr/>
+          <p:nvPr/>
+        </p:nvSpPr>
+        <p:spPr>
+          <a:xfrm>
+            <a:off x="640080" y="411480"/>
+            <a:ext cx="2377440" cy="365760"/>
+          </a:xfrm>
+          <a:prstGeom prst="rect">
+            <a:avLst/>
+          </a:prstGeom>
+          <a:noFill/>
+          <a:ln/>
+        </p:spPr>
+        <p:txBody>
+          <a:bodyPr wrap="square" rtlCol="0" anchor="ctr"/>
+          <a:lstStyle/>
+          <a:p>
+            <a:pPr algn="ctr" indent="0" marL="0">
+              <a:buNone/>
+            </a:pPr>
+            <a:r>
+              <a:rPr lang="en-US" sz="1000" b="1" spc="100" kern="0" dirty="0">
+                <a:solidFill>
+                  <a:srgbClr val="386641"/>
+                </a:solidFill>
+                <a:latin typeface="Segoe UI" pitchFamily="34" charset="0"/>
+                <a:ea typeface="Segoe UI" pitchFamily="34" charset="-122"/>
+                <a:cs typeface="Segoe UI" pitchFamily="34" charset="-120"/>
+              </a:rPr>
+              <a:t>BASE DE DONNÉES</a:t>
+            </a:r>
+            <a:endParaRPr lang="en-US" sz="1000" dirty="0"/>
+          </a:p>
+        </p:txBody>
+      </p:sp>
+      <p:sp>
+        <p:nvSpPr>
+          <p:cNvPr id="4" name="Text 2"/>
+          <p:cNvSpPr/>
+          <p:nvPr/>
+        </p:nvSpPr>
+        <p:spPr>
+          <a:xfrm>
+            <a:off x="640080" y="868680"/>
+            <a:ext cx="10515600" cy="548640"/>
+          </a:xfrm>
+          <a:prstGeom prst="rect">
+            <a:avLst/>
+          </a:prstGeom>
+          <a:noFill/>
+          <a:ln/>
+        </p:spPr>
+        <p:txBody>
+          <a:bodyPr wrap="square" rtlCol="0" anchor="ctr"/>
+          <a:lstStyle/>
+          <a:p>
+            <a:pPr indent="0" marL="0">
+              <a:buNone/>
+            </a:pPr>
+            <a:r>
+              <a:rPr lang="en-US" sz="2400" b="1" dirty="0">
+                <a:solidFill>
+                  <a:srgbClr val="1B1F3B"/>
+                </a:solidFill>
+                <a:latin typeface="Georgia" pitchFamily="34" charset="0"/>
+                <a:ea typeface="Georgia" pitchFamily="34" charset="-122"/>
+                <a:cs typeface="Georgia" pitchFamily="34" charset="-120"/>
+              </a:rPr>
+              <a:t>Maintenance technique</a:t>
+            </a:r>
+            <a:endParaRPr lang="en-US" sz="2400" dirty="0"/>
+          </a:p>
+        </p:txBody>
+      </p:sp>
+      <p:sp>
+        <p:nvSpPr>
+          <p:cNvPr id="5" name="Shape 3"/>
+          <p:cNvSpPr/>
+          <p:nvPr/>
+        </p:nvSpPr>
+        <p:spPr>
+          <a:xfrm>
+            <a:off x="640080" y="1691640"/>
+            <a:ext cx="10881360" cy="1097280"/>
+          </a:xfrm>
+          <a:prstGeom prst="roundRect">
+            <a:avLst>
+              <a:gd name="adj" fmla="val 5000"/>
+            </a:avLst>
+          </a:prstGeom>
+          <a:solidFill>
+            <a:srgbClr val="FFFFFF"/>
+          </a:solidFill>
+          <a:ln w="12700">
+            <a:solidFill>
+              <a:srgbClr val="E4DCCB"/>
+            </a:solidFill>
+            <a:prstDash val="solid"/>
+          </a:ln>
+        </p:spPr>
+      </p:sp>
+      <p:sp>
+        <p:nvSpPr>
+          <p:cNvPr id="6" name="Shape 4"/>
+          <p:cNvSpPr/>
+          <p:nvPr/>
+        </p:nvSpPr>
+        <p:spPr>
+          <a:xfrm>
+            <a:off x="640080" y="1691640"/>
+            <a:ext cx="54864" cy="1097280"/>
+          </a:xfrm>
+          <a:prstGeom prst="rect">
+            <a:avLst/>
+          </a:prstGeom>
+          <a:solidFill>
+            <a:srgbClr val="386641"/>
+          </a:solidFill>
+          <a:ln/>
+        </p:spPr>
+      </p:sp>
+      <p:sp>
+        <p:nvSpPr>
+          <p:cNvPr id="7" name="Text 5"/>
+          <p:cNvSpPr/>
+          <p:nvPr/>
+        </p:nvSpPr>
+        <p:spPr>
+          <a:xfrm>
+            <a:off x="914400" y="1801368"/>
+            <a:ext cx="10332720" cy="365760"/>
+          </a:xfrm>
+          <a:prstGeom prst="rect">
+            <a:avLst/>
+          </a:prstGeom>
+          <a:noFill/>
+          <a:ln/>
+        </p:spPr>
+        <p:txBody>
+          <a:bodyPr wrap="square" rtlCol="0" anchor="ctr"/>
+          <a:lstStyle/>
+          <a:p>
+            <a:pPr indent="0" marL="0">
+              <a:buNone/>
+            </a:pPr>
+            <a:r>
+              <a:rPr lang="en-US" sz="1400" b="1" dirty="0">
+                <a:solidFill>
+                  <a:srgbClr val="1B1F3B"/>
+                </a:solidFill>
+                <a:latin typeface="Segoe UI" pitchFamily="34" charset="0"/>
+                <a:ea typeface="Segoe UI" pitchFamily="34" charset="-122"/>
+                <a:cs typeface="Segoe UI" pitchFamily="34" charset="-120"/>
+              </a:rPr>
+              <a:t>Nettoyage approfondi du code</a:t>
+            </a:r>
+            <a:endParaRPr lang="en-US" sz="1400" dirty="0"/>
+          </a:p>
+        </p:txBody>
+      </p:sp>
+      <p:sp>
+        <p:nvSpPr>
+          <p:cNvPr id="8" name="Text 6"/>
+          <p:cNvSpPr/>
+          <p:nvPr/>
+        </p:nvSpPr>
+        <p:spPr>
+          <a:xfrm>
+            <a:off x="914400" y="2148840"/>
+            <a:ext cx="10332720" cy="594360"/>
+          </a:xfrm>
+          <a:prstGeom prst="rect">
+            <a:avLst/>
+          </a:prstGeom>
+          <a:noFill/>
+          <a:ln/>
+        </p:spPr>
+        <p:txBody>
+          <a:bodyPr wrap="square" rtlCol="0" anchor="ctr"/>
+          <a:lstStyle/>
+          <a:p>
+            <a:pPr indent="0" marL="0">
+              <a:lnSpc>
+                <a:spcPts val="1400"/>
+              </a:lnSpc>
+              <a:buNone/>
+            </a:pPr>
+            <a:r>
+              <a:rPr lang="en-US" sz="1100" dirty="0">
+                <a:solidFill>
+                  <a:srgbClr val="8A7C68"/>
+                </a:solidFill>
+                <a:latin typeface="Segoe UI" pitchFamily="34" charset="0"/>
+                <a:ea typeface="Segoe UI" pitchFamily="34" charset="-122"/>
+                <a:cs typeface="Segoe UI" pitchFamily="34" charset="-120"/>
+              </a:rPr>
+              <a:t>Audit complet du projet (pages, routes, fonctions, dépendances) pour repérer tout ce qui n'était plus utilisé ; suppression de 6 pages orphelines (onboarding, welcome, compte, anciennes pages devis en 3 étapes), d'une route de connexion de démonstration, d'un dossier de composants dupliqué obsolète, de plusieurs fonctions inutilisées et d'une dépendance logicielle non utilisée — sans toucher aux fonctionnalités actives.</a:t>
+            </a:r>
+            <a:endParaRPr lang="en-US" sz="1100" dirty="0"/>
+          </a:p>
+        </p:txBody>
+      </p:sp>
+      <p:sp>
+        <p:nvSpPr>
+          <p:cNvPr id="9" name="Shape 7"/>
+          <p:cNvSpPr/>
+          <p:nvPr/>
+        </p:nvSpPr>
+        <p:spPr>
+          <a:xfrm>
+            <a:off x="640080" y="2926080"/>
+            <a:ext cx="10881360" cy="1097280"/>
+          </a:xfrm>
+          <a:prstGeom prst="roundRect">
+            <a:avLst>
+              <a:gd name="adj" fmla="val 5000"/>
+            </a:avLst>
+          </a:prstGeom>
+          <a:solidFill>
+            <a:srgbClr val="FFFFFF"/>
+          </a:solidFill>
+          <a:ln w="12700">
+            <a:solidFill>
+              <a:srgbClr val="E4DCCB"/>
+            </a:solidFill>
+            <a:prstDash val="solid"/>
+          </a:ln>
+        </p:spPr>
+      </p:sp>
+      <p:sp>
+        <p:nvSpPr>
+          <p:cNvPr id="10" name="Shape 8"/>
+          <p:cNvSpPr/>
+          <p:nvPr/>
+        </p:nvSpPr>
+        <p:spPr>
+          <a:xfrm>
+            <a:off x="640080" y="2926080"/>
+            <a:ext cx="54864" cy="1097280"/>
+          </a:xfrm>
+          <a:prstGeom prst="rect">
+            <a:avLst/>
+          </a:prstGeom>
+          <a:solidFill>
+            <a:srgbClr val="386641"/>
+          </a:solidFill>
+          <a:ln/>
+        </p:spPr>
+      </p:sp>
+      <p:sp>
+        <p:nvSpPr>
+          <p:cNvPr id="11" name="Text 9"/>
+          <p:cNvSpPr/>
+          <p:nvPr/>
+        </p:nvSpPr>
+        <p:spPr>
+          <a:xfrm>
+            <a:off x="914400" y="3035808"/>
+            <a:ext cx="10332720" cy="365760"/>
+          </a:xfrm>
+          <a:prstGeom prst="rect">
+            <a:avLst/>
+          </a:prstGeom>
+          <a:noFill/>
+          <a:ln/>
+        </p:spPr>
+        <p:txBody>
+          <a:bodyPr wrap="square" rtlCol="0" anchor="ctr"/>
+          <a:lstStyle/>
+          <a:p>
+            <a:pPr indent="0" marL="0">
+              <a:buNone/>
+            </a:pPr>
+            <a:r>
+              <a:rPr lang="en-US" sz="1400" b="1" dirty="0">
+                <a:solidFill>
+                  <a:srgbClr val="1B1F3B"/>
+                </a:solidFill>
+                <a:latin typeface="Segoe UI" pitchFamily="34" charset="0"/>
+                <a:ea typeface="Segoe UI" pitchFamily="34" charset="-122"/>
+                <a:cs typeface="Segoe UI" pitchFamily="34" charset="-120"/>
+              </a:rPr>
+              <a:t>Suppression de code mort dans la génération de devis</a:t>
+            </a:r>
+            <a:endParaRPr lang="en-US" sz="1400" dirty="0"/>
+          </a:p>
+        </p:txBody>
+      </p:sp>
+      <p:sp>
+        <p:nvSpPr>
+          <p:cNvPr id="12" name="Text 10"/>
+          <p:cNvSpPr/>
+          <p:nvPr/>
+        </p:nvSpPr>
+        <p:spPr>
+          <a:xfrm>
+            <a:off x="914400" y="3383280"/>
+            <a:ext cx="10332720" cy="594360"/>
+          </a:xfrm>
+          <a:prstGeom prst="rect">
+            <a:avLst/>
+          </a:prstGeom>
+          <a:noFill/>
+          <a:ln/>
+        </p:spPr>
+        <p:txBody>
+          <a:bodyPr wrap="square" rtlCol="0" anchor="ctr"/>
+          <a:lstStyle/>
+          <a:p>
+            <a:pPr indent="0" marL="0">
+              <a:lnSpc>
+                <a:spcPts val="1400"/>
+              </a:lnSpc>
+              <a:buNone/>
+            </a:pPr>
+            <a:r>
+              <a:rPr lang="en-US" sz="1100" dirty="0">
+                <a:solidFill>
+                  <a:srgbClr val="8A7C68"/>
+                </a:solidFill>
+                <a:latin typeface="Segoe UI" pitchFamily="34" charset="0"/>
+                <a:ea typeface="Segoe UI" pitchFamily="34" charset="-122"/>
+                <a:cs typeface="Segoe UI" pitchFamily="34" charset="-120"/>
+              </a:rPr>
+              <a:t>Un ancien générateur de devis PDF, devenu inaccessible après une précédente refonte (code jamais exécuté), a été retiré du fichier technique de génération de documents.</a:t>
+            </a:r>
+            <a:endParaRPr lang="en-US" sz="1100" dirty="0"/>
+          </a:p>
+        </p:txBody>
+      </p:sp>
+      <p:sp>
+        <p:nvSpPr>
+          <p:cNvPr id="13" name="Text 11"/>
+          <p:cNvSpPr/>
+          <p:nvPr/>
+        </p:nvSpPr>
+        <p:spPr>
+          <a:xfrm>
+            <a:off x="365760" y="6510528"/>
+            <a:ext cx="5486400" cy="274320"/>
+          </a:xfrm>
+          <a:prstGeom prst="rect">
+            <a:avLst/>
+          </a:prstGeom>
+          <a:noFill/>
+          <a:ln/>
+        </p:spPr>
+        <p:txBody>
+          <a:bodyPr wrap="square" rtlCol="0" anchor="ctr"/>
+          <a:lstStyle/>
+          <a:p>
+            <a:pPr indent="0" marL="0">
+              <a:buNone/>
+            </a:pPr>
+            <a:r>
+              <a:rPr lang="en-US" sz="900" dirty="0">
+                <a:solidFill>
+                  <a:srgbClr val="8A7C68"/>
+                </a:solidFill>
+                <a:latin typeface="Segoe UI" pitchFamily="34" charset="0"/>
+                <a:ea typeface="Segoe UI" pitchFamily="34" charset="-122"/>
+                <a:cs typeface="Segoe UI" pitchFamily="34" charset="-120"/>
+              </a:rPr>
+              <a:t>Kôji Web — Récapitulatif technique</a:t>
+            </a:r>
+            <a:endParaRPr lang="en-US" sz="900" dirty="0"/>
+          </a:p>
+        </p:txBody>
+      </p:sp>
+      <p:sp>
+        <p:nvSpPr>
+          <p:cNvPr id="14" name="Text 12"/>
+          <p:cNvSpPr/>
+          <p:nvPr/>
+        </p:nvSpPr>
+        <p:spPr>
+          <a:xfrm>
+            <a:off x="9601200" y="6510528"/>
+            <a:ext cx="2194560" cy="274320"/>
+          </a:xfrm>
+          <a:prstGeom prst="rect">
+            <a:avLst/>
+          </a:prstGeom>
+          <a:noFill/>
+          <a:ln/>
+        </p:spPr>
+        <p:txBody>
+          <a:bodyPr wrap="square" rtlCol="0" anchor="ctr"/>
+          <a:lstStyle/>
+          <a:p>
+            <a:pPr algn="r" indent="0" marL="0">
+              <a:buNone/>
+            </a:pPr>
+            <a:r>
+              <a:rPr lang="en-US" sz="900" dirty="0">
+                <a:solidFill>
+                  <a:srgbClr val="8A7C68"/>
+                </a:solidFill>
+                <a:latin typeface="Segoe UI" pitchFamily="34" charset="0"/>
+                <a:ea typeface="Segoe UI" pitchFamily="34" charset="-122"/>
+                <a:cs typeface="Segoe UI" pitchFamily="34" charset="-120"/>
+              </a:rPr>
+              <a:t>33</a:t>
+            </a:r>
+            <a:endParaRPr lang="en-US" sz="900" dirty="0"/>
+          </a:p>
+        </p:txBody>
+      </p:sp>
+    </p:spTree>
+  </p:cSld>
+  <p:clrMapOvr>
+    <a:masterClrMapping/>
+  </p:clrMapOvr>
+</p:sld>
+</file>
+
+<file path=ppt/slides/slide34.xml><?xml version="1.0" encoding="utf-8"?>
+<p:sld xmlns:a="http://schemas.openxmlformats.org/drawingml/2006/main" xmlns:r="http://schemas.openxmlformats.org/officeDocument/2006/relationships" xmlns:p="http://schemas.openxmlformats.org/presentationml/2006/main">
+  <p:cSld name="Slide 34">
     <p:bg>
       <p:bgPr>
         <a:solidFill>
@@ -16192,7 +17302,263 @@
       </p:sp>
       <p:sp>
         <p:nvSpPr>
-          <p:cNvPr id="13" name="Text 11"/>
+          <p:cNvPr id="13" name="Shape 11"/>
+          <p:cNvSpPr/>
+          <p:nvPr/>
+        </p:nvSpPr>
+        <p:spPr>
+          <a:xfrm>
+            <a:off x="640080" y="4160520"/>
+            <a:ext cx="10881360" cy="1097280"/>
+          </a:xfrm>
+          <a:prstGeom prst="roundRect">
+            <a:avLst>
+              <a:gd name="adj" fmla="val 5000"/>
+            </a:avLst>
+          </a:prstGeom>
+          <a:solidFill>
+            <a:srgbClr val="FFFFFF"/>
+          </a:solidFill>
+          <a:ln w="12700">
+            <a:solidFill>
+              <a:srgbClr val="E4DCCB"/>
+            </a:solidFill>
+            <a:prstDash val="solid"/>
+          </a:ln>
+        </p:spPr>
+      </p:sp>
+      <p:sp>
+        <p:nvSpPr>
+          <p:cNvPr id="14" name="Shape 12"/>
+          <p:cNvSpPr/>
+          <p:nvPr/>
+        </p:nvSpPr>
+        <p:spPr>
+          <a:xfrm>
+            <a:off x="640080" y="4160520"/>
+            <a:ext cx="54864" cy="1097280"/>
+          </a:xfrm>
+          <a:prstGeom prst="rect">
+            <a:avLst/>
+          </a:prstGeom>
+          <a:solidFill>
+            <a:srgbClr val="1D6FE0"/>
+          </a:solidFill>
+          <a:ln/>
+        </p:spPr>
+      </p:sp>
+      <p:sp>
+        <p:nvSpPr>
+          <p:cNvPr id="15" name="Text 13"/>
+          <p:cNvSpPr/>
+          <p:nvPr/>
+        </p:nvSpPr>
+        <p:spPr>
+          <a:xfrm>
+            <a:off x="914400" y="4270248"/>
+            <a:ext cx="10332720" cy="365760"/>
+          </a:xfrm>
+          <a:prstGeom prst="rect">
+            <a:avLst/>
+          </a:prstGeom>
+          <a:noFill/>
+          <a:ln/>
+        </p:spPr>
+        <p:txBody>
+          <a:bodyPr wrap="square" rtlCol="0" anchor="ctr"/>
+          <a:lstStyle/>
+          <a:p>
+            <a:pPr indent="0" marL="0">
+              <a:buNone/>
+            </a:pPr>
+            <a:r>
+              <a:rPr lang="en-US" sz="1400" b="1" dirty="0">
+                <a:solidFill>
+                  <a:srgbClr val="1B1F3B"/>
+                </a:solidFill>
+                <a:latin typeface="Segoe UI" pitchFamily="34" charset="0"/>
+                <a:ea typeface="Segoe UI" pitchFamily="34" charset="-122"/>
+                <a:cs typeface="Segoe UI" pitchFamily="34" charset="-120"/>
+              </a:rPr>
+              <a:t>Description de l'ouvrage (titre + sous-titre)</a:t>
+            </a:r>
+            <a:endParaRPr lang="en-US" sz="1400" dirty="0"/>
+          </a:p>
+        </p:txBody>
+      </p:sp>
+      <p:sp>
+        <p:nvSpPr>
+          <p:cNvPr id="16" name="Text 14"/>
+          <p:cNvSpPr/>
+          <p:nvPr/>
+        </p:nvSpPr>
+        <p:spPr>
+          <a:xfrm>
+            <a:off x="914400" y="4617720"/>
+            <a:ext cx="10332720" cy="594360"/>
+          </a:xfrm>
+          <a:prstGeom prst="rect">
+            <a:avLst/>
+          </a:prstGeom>
+          <a:noFill/>
+          <a:ln/>
+        </p:spPr>
+        <p:txBody>
+          <a:bodyPr wrap="square" rtlCol="0" anchor="ctr"/>
+          <a:lstStyle/>
+          <a:p>
+            <a:pPr indent="0" marL="0">
+              <a:lnSpc>
+                <a:spcPts val="1400"/>
+              </a:lnSpc>
+              <a:buNone/>
+            </a:pPr>
+            <a:r>
+              <a:rPr lang="en-US" sz="1100" dirty="0">
+                <a:solidFill>
+                  <a:srgbClr val="8A7C68"/>
+                </a:solidFill>
+                <a:latin typeface="Segoe UI" pitchFamily="34" charset="0"/>
+                <a:ea typeface="Segoe UI" pitchFamily="34" charset="-122"/>
+                <a:cs typeface="Segoe UI" pitchFamily="34" charset="-120"/>
+              </a:rPr>
+              <a:t>Chaque ligne d'un devis (ouvrage ou fourniture) peut désormais recevoir une description libre, affichée sous forme de sous-titre grisé sous la désignation en gras dans le devis généré (PDF et Word) — le même principe que sur les devis modèles.</a:t>
+            </a:r>
+            <a:endParaRPr lang="en-US" sz="1100" dirty="0"/>
+          </a:p>
+        </p:txBody>
+      </p:sp>
+      <p:sp>
+        <p:nvSpPr>
+          <p:cNvPr id="17" name="Shape 15"/>
+          <p:cNvSpPr/>
+          <p:nvPr/>
+        </p:nvSpPr>
+        <p:spPr>
+          <a:xfrm>
+            <a:off x="640080" y="5394960"/>
+            <a:ext cx="10881360" cy="1097280"/>
+          </a:xfrm>
+          <a:prstGeom prst="roundRect">
+            <a:avLst>
+              <a:gd name="adj" fmla="val 5000"/>
+            </a:avLst>
+          </a:prstGeom>
+          <a:solidFill>
+            <a:srgbClr val="FFFFFF"/>
+          </a:solidFill>
+          <a:ln w="12700">
+            <a:solidFill>
+              <a:srgbClr val="E4DCCB"/>
+            </a:solidFill>
+            <a:prstDash val="solid"/>
+          </a:ln>
+        </p:spPr>
+      </p:sp>
+      <p:sp>
+        <p:nvSpPr>
+          <p:cNvPr id="18" name="Shape 16"/>
+          <p:cNvSpPr/>
+          <p:nvPr/>
+        </p:nvSpPr>
+        <p:spPr>
+          <a:xfrm>
+            <a:off x="640080" y="5394960"/>
+            <a:ext cx="54864" cy="1097280"/>
+          </a:xfrm>
+          <a:prstGeom prst="rect">
+            <a:avLst/>
+          </a:prstGeom>
+          <a:solidFill>
+            <a:srgbClr val="1D6FE0"/>
+          </a:solidFill>
+          <a:ln/>
+        </p:spPr>
+      </p:sp>
+      <p:sp>
+        <p:nvSpPr>
+          <p:cNvPr id="19" name="Text 17"/>
+          <p:cNvSpPr/>
+          <p:nvPr/>
+        </p:nvSpPr>
+        <p:spPr>
+          <a:xfrm>
+            <a:off x="914400" y="5504688"/>
+            <a:ext cx="10332720" cy="365760"/>
+          </a:xfrm>
+          <a:prstGeom prst="rect">
+            <a:avLst/>
+          </a:prstGeom>
+          <a:noFill/>
+          <a:ln/>
+        </p:spPr>
+        <p:txBody>
+          <a:bodyPr wrap="square" rtlCol="0" anchor="ctr"/>
+          <a:lstStyle/>
+          <a:p>
+            <a:pPr indent="0" marL="0">
+              <a:buNone/>
+            </a:pPr>
+            <a:r>
+              <a:rPr lang="en-US" sz="1400" b="1" dirty="0">
+                <a:solidFill>
+                  <a:srgbClr val="1B1F3B"/>
+                </a:solidFill>
+                <a:latin typeface="Segoe UI" pitchFamily="34" charset="0"/>
+                <a:ea typeface="Segoe UI" pitchFamily="34" charset="-122"/>
+                <a:cs typeface="Segoe UI" pitchFamily="34" charset="-120"/>
+              </a:rPr>
+              <a:t>Réorganisation de la fiche Client et chantier</a:t>
+            </a:r>
+            <a:endParaRPr lang="en-US" sz="1400" dirty="0"/>
+          </a:p>
+        </p:txBody>
+      </p:sp>
+      <p:sp>
+        <p:nvSpPr>
+          <p:cNvPr id="20" name="Text 18"/>
+          <p:cNvSpPr/>
+          <p:nvPr/>
+        </p:nvSpPr>
+        <p:spPr>
+          <a:xfrm>
+            <a:off x="914400" y="5852160"/>
+            <a:ext cx="10332720" cy="594360"/>
+          </a:xfrm>
+          <a:prstGeom prst="rect">
+            <a:avLst/>
+          </a:prstGeom>
+          <a:noFill/>
+          <a:ln/>
+        </p:spPr>
+        <p:txBody>
+          <a:bodyPr wrap="square" rtlCol="0" anchor="ctr"/>
+          <a:lstStyle/>
+          <a:p>
+            <a:pPr indent="0" marL="0">
+              <a:lnSpc>
+                <a:spcPts val="1400"/>
+              </a:lnSpc>
+              <a:buNone/>
+            </a:pPr>
+            <a:r>
+              <a:rPr lang="en-US" sz="1100" dirty="0">
+                <a:solidFill>
+                  <a:srgbClr val="8A7C68"/>
+                </a:solidFill>
+                <a:latin typeface="Segoe UI" pitchFamily="34" charset="0"/>
+                <a:ea typeface="Segoe UI" pitchFamily="34" charset="-122"/>
+                <a:cs typeface="Segoe UI" pitchFamily="34" charset="-120"/>
+              </a:rPr>
+              <a:t>Champs réorganisés pour plus de clarté : référence et client sur une même ligne, téléphone et email sur une même ligne, adresse sur sa propre ligne, puis le reste des informations (chantier, dates, durée, type de bien) en dessous.</a:t>
+            </a:r>
+            <a:endParaRPr lang="en-US" sz="1100" dirty="0"/>
+          </a:p>
+        </p:txBody>
+      </p:sp>
+      <p:sp>
+        <p:nvSpPr>
+          <p:cNvPr id="21" name="Text 19"/>
           <p:cNvSpPr/>
           <p:nvPr/>
         </p:nvSpPr>
@@ -16231,7 +17597,7 @@
       </p:sp>
       <p:sp>
         <p:nvSpPr>
-          <p:cNvPr id="14" name="Text 12"/>
+          <p:cNvPr id="22" name="Text 20"/>
           <p:cNvSpPr/>
           <p:nvPr/>
         </p:nvSpPr>

</xml_diff>

<commit_message>
Devis: le total serveur retombait a 0 sur chaque enregistrement, corrige
computeQuoteItem() recalculait chaque ligne a partir de zero au lieu de
faire confiance au totalHt deja correctement calcule par DevisEditor,
et se trompait deux fois : un champ fixedAmountHt a 0 (present sur
toute ligne facturee au temps) etait lu comme "prix fixe de 0e" via
firstDefined, et materialLines n'etait pas une cle de fournitures
reconnue. Les deux bugs combines annulaient systematiquement le total
HT/TTC persiste des que le devis contenait des lignes au temps -
exactement le cas du devis 2026_1050 signale par le manager. Corrige
en faisant confiance au montant deja calcule par ligne, avec l'ancien
recalcul en repli uniquement si aucun total n'est fourni.
</commit_message>
<xml_diff>
--- a/docs/manager-recap/Recap-Koji-Manager.pptx
+++ b/docs/manager-recap/Recap-Koji-Manager.pptx
@@ -7882,7 +7882,7 @@
                 <a:ea typeface="Segoe UI" pitchFamily="34" charset="-122"/>
                 <a:cs typeface="Segoe UI" pitchFamily="34" charset="-120"/>
               </a:rPr>
-              <a:t>27 mise(s) à jour</a:t>
+              <a:t>28 mise(s) à jour</a:t>
             </a:r>
             <a:endParaRPr lang="en-US" sz="1200" dirty="0"/>
           </a:p>
@@ -9622,7 +9622,7 @@
                 <a:ea typeface="Segoe UI" pitchFamily="34" charset="-122"/>
                 <a:cs typeface="Segoe UI" pitchFamily="34" charset="-120"/>
               </a:rPr>
-              <a:t>Taux de TVA de chaque ligne aligné sur le devis</a:t>
+              <a:t>Deuxième cause trouvée : le total serveur retombait à 0</a:t>
             </a:r>
             <a:endParaRPr lang="en-US" sz="1400" dirty="0"/>
           </a:p>
@@ -9664,6 +9664,134 @@
                 <a:ea typeface="Segoe UI" pitchFamily="34" charset="-122"/>
                 <a:cs typeface="Segoe UI" pitchFamily="34" charset="-120"/>
               </a:rPr>
+              <a:t>Le calcul serveur recalculait chaque ligne à partir de zéro au lieu de faire confiance au montant déjà calculé correctement par l'éditeur, et se trompait sur deux points (un champ technique à 0 mal interprété comme 'prix fixe', une liste de fournitures non reconnue), ramenant le total à 0€ à chaque enregistrement. Corrigé : le serveur fait maintenant confiance au montant de chaque ligne tel qu'il apparaît dans l'éditeur.</a:t>
+            </a:r>
+            <a:endParaRPr lang="en-US" sz="1100" dirty="0"/>
+          </a:p>
+        </p:txBody>
+      </p:sp>
+      <p:sp>
+        <p:nvSpPr>
+          <p:cNvPr id="17" name="Shape 15"/>
+          <p:cNvSpPr/>
+          <p:nvPr/>
+        </p:nvSpPr>
+        <p:spPr>
+          <a:xfrm>
+            <a:off x="640080" y="5394960"/>
+            <a:ext cx="10881360" cy="1097280"/>
+          </a:xfrm>
+          <a:prstGeom prst="roundRect">
+            <a:avLst>
+              <a:gd name="adj" fmla="val 5000"/>
+            </a:avLst>
+          </a:prstGeom>
+          <a:solidFill>
+            <a:srgbClr val="FFFFFF"/>
+          </a:solidFill>
+          <a:ln w="12700">
+            <a:solidFill>
+              <a:srgbClr val="E4DCCB"/>
+            </a:solidFill>
+            <a:prstDash val="solid"/>
+          </a:ln>
+        </p:spPr>
+      </p:sp>
+      <p:sp>
+        <p:nvSpPr>
+          <p:cNvPr id="18" name="Shape 16"/>
+          <p:cNvSpPr/>
+          <p:nvPr/>
+        </p:nvSpPr>
+        <p:spPr>
+          <a:xfrm>
+            <a:off x="640080" y="5394960"/>
+            <a:ext cx="54864" cy="1097280"/>
+          </a:xfrm>
+          <a:prstGeom prst="rect">
+            <a:avLst/>
+          </a:prstGeom>
+          <a:solidFill>
+            <a:srgbClr val="9A4C1F"/>
+          </a:solidFill>
+          <a:ln/>
+        </p:spPr>
+      </p:sp>
+      <p:sp>
+        <p:nvSpPr>
+          <p:cNvPr id="19" name="Text 17"/>
+          <p:cNvSpPr/>
+          <p:nvPr/>
+        </p:nvSpPr>
+        <p:spPr>
+          <a:xfrm>
+            <a:off x="914400" y="5504688"/>
+            <a:ext cx="10332720" cy="365760"/>
+          </a:xfrm>
+          <a:prstGeom prst="rect">
+            <a:avLst/>
+          </a:prstGeom>
+          <a:noFill/>
+          <a:ln/>
+        </p:spPr>
+        <p:txBody>
+          <a:bodyPr wrap="square" rtlCol="0" anchor="ctr"/>
+          <a:lstStyle/>
+          <a:p>
+            <a:pPr indent="0" marL="0">
+              <a:buNone/>
+            </a:pPr>
+            <a:r>
+              <a:rPr lang="en-US" sz="1400" b="1" dirty="0">
+                <a:solidFill>
+                  <a:srgbClr val="1B1F3B"/>
+                </a:solidFill>
+                <a:latin typeface="Segoe UI" pitchFamily="34" charset="0"/>
+                <a:ea typeface="Segoe UI" pitchFamily="34" charset="-122"/>
+                <a:cs typeface="Segoe UI" pitchFamily="34" charset="-120"/>
+              </a:rPr>
+              <a:t>Taux de TVA de chaque ligne aligné sur le devis</a:t>
+            </a:r>
+            <a:endParaRPr lang="en-US" sz="1400" dirty="0"/>
+          </a:p>
+        </p:txBody>
+      </p:sp>
+      <p:sp>
+        <p:nvSpPr>
+          <p:cNvPr id="20" name="Text 18"/>
+          <p:cNvSpPr/>
+          <p:nvPr/>
+        </p:nvSpPr>
+        <p:spPr>
+          <a:xfrm>
+            <a:off x="914400" y="5852160"/>
+            <a:ext cx="10332720" cy="594360"/>
+          </a:xfrm>
+          <a:prstGeom prst="rect">
+            <a:avLst/>
+          </a:prstGeom>
+          <a:noFill/>
+          <a:ln/>
+        </p:spPr>
+        <p:txBody>
+          <a:bodyPr wrap="square" rtlCol="0" anchor="ctr"/>
+          <a:lstStyle/>
+          <a:p>
+            <a:pPr indent="0" marL="0">
+              <a:lnSpc>
+                <a:spcPts val="1400"/>
+              </a:lnSpc>
+              <a:buNone/>
+            </a:pPr>
+            <a:r>
+              <a:rPr lang="en-US" sz="1100" dirty="0">
+                <a:solidFill>
+                  <a:srgbClr val="8A7C68"/>
+                </a:solidFill>
+                <a:latin typeface="Segoe UI" pitchFamily="34" charset="0"/>
+                <a:ea typeface="Segoe UI" pitchFamily="34" charset="-122"/>
+                <a:cs typeface="Segoe UI" pitchFamily="34" charset="-120"/>
+              </a:rPr>
               <a:t>Chaque ligne de devis calculait sa propre TVA à 20% par défaut, sans tenir compte du taux choisi pour le devis (ex. 10%) — corrigé pour utiliser le taux réellement sélectionné.</a:t>
             </a:r>
             <a:endParaRPr lang="en-US" sz="1100" dirty="0"/>
@@ -9672,7 +9800,7 @@
       </p:sp>
       <p:sp>
         <p:nvSpPr>
-          <p:cNvPr id="17" name="Text 15"/>
+          <p:cNvPr id="21" name="Text 19"/>
           <p:cNvSpPr/>
           <p:nvPr/>
         </p:nvSpPr>
@@ -9711,7 +9839,7 @@
       </p:sp>
       <p:sp>
         <p:nvSpPr>
-          <p:cNvPr id="18" name="Text 16"/>
+          <p:cNvPr id="22" name="Text 20"/>
           <p:cNvSpPr/>
           <p:nvPr/>
         </p:nvSpPr>
@@ -9918,7 +10046,7 @@
                 <a:ea typeface="Georgia" pitchFamily="34" charset="-122"/>
                 <a:cs typeface="Georgia" pitchFamily="34" charset="-120"/>
               </a:rPr>
-              <a:t>71</a:t>
+              <a:t>72</a:t>
             </a:r>
             <a:endParaRPr lang="en-US" sz="3200" dirty="0"/>
           </a:p>
@@ -10128,7 +10256,7 @@
                 <a:ea typeface="Georgia" pitchFamily="34" charset="-122"/>
                 <a:cs typeface="Georgia" pitchFamily="34" charset="-120"/>
               </a:rPr>
-              <a:t>27</a:t>
+              <a:t>28</a:t>
             </a:r>
             <a:endParaRPr lang="en-US" sz="3200" dirty="0"/>
           </a:p>

</xml_diff>

<commit_message>
Devis: empeche un double-clic sur Enregistrer de creer deux devis
Un clic rapide en double (ou une sauvegarde automatique qui se
declenchait en meme temps qu'un enregistrement manuel) partait avant
que le premier appel n'ait recu l'id du devis, donc les deux passaient
par une creation au lieu d'une mise a jour : deux devis identiques se
retrouvaient enregistres pour le meme chantier. persistQuote() partage
desormais un enregistrement deja en cours au lieu d'en relancer un.
</commit_message>
<xml_diff>
--- a/docs/manager-recap/Recap-Koji-Manager.pptx
+++ b/docs/manager-recap/Recap-Koji-Manager.pptx
@@ -10046,7 +10046,7 @@
                 <a:ea typeface="Georgia" pitchFamily="34" charset="-122"/>
                 <a:cs typeface="Georgia" pitchFamily="34" charset="-120"/>
               </a:rPr>
-              <a:t>72</a:t>
+              <a:t>73</a:t>
             </a:r>
             <a:endParaRPr lang="en-US" sz="3200" dirty="0"/>
           </a:p>
@@ -10151,7 +10151,7 @@
                 <a:ea typeface="Georgia" pitchFamily="34" charset="-122"/>
                 <a:cs typeface="Georgia" pitchFamily="34" charset="-120"/>
               </a:rPr>
-              <a:t>36</a:t>
+              <a:t>37</a:t>
             </a:r>
             <a:endParaRPr lang="en-US" sz="3200" dirty="0"/>
           </a:p>
@@ -15373,7 +15373,7 @@
                 <a:ea typeface="Segoe UI" pitchFamily="34" charset="-122"/>
                 <a:cs typeface="Segoe UI" pitchFamily="34" charset="-120"/>
               </a:rPr>
-              <a:t>36 mise(s) à jour</a:t>
+              <a:t>37 mise(s) à jour</a:t>
             </a:r>
             <a:endParaRPr lang="en-US" sz="1200" dirty="0"/>
           </a:p>
@@ -19169,7 +19169,7 @@
                 <a:ea typeface="Segoe UI" pitchFamily="34" charset="-122"/>
                 <a:cs typeface="Segoe UI" pitchFamily="34" charset="-120"/>
               </a:rPr>
-              <a:t>Tableau du devis : colonne Total HT (au lieu de Total TTC)</a:t>
+              <a:t>Double-clic sur Enregistrer : un seul devis créé au lieu de deux</a:t>
             </a:r>
             <a:endParaRPr lang="en-US" sz="1400" dirty="0"/>
           </a:p>
@@ -19211,6 +19211,134 @@
                 <a:ea typeface="Segoe UI" pitchFamily="34" charset="-122"/>
                 <a:cs typeface="Segoe UI" pitchFamily="34" charset="-120"/>
               </a:rPr>
+              <a:t>Un double-clic (ou un enregistrement automatique déclenché en même temps qu'un enregistrement manuel) pouvait créer deux devis identiques pour le même chantier au lieu de mettre à jour le même. Corrigé : un enregistrement déjà en cours est désormais partagé au lieu d'en déclencher un second.</a:t>
+            </a:r>
+            <a:endParaRPr lang="en-US" sz="1100" dirty="0"/>
+          </a:p>
+        </p:txBody>
+      </p:sp>
+      <p:sp>
+        <p:nvSpPr>
+          <p:cNvPr id="9" name="Shape 7"/>
+          <p:cNvSpPr/>
+          <p:nvPr/>
+        </p:nvSpPr>
+        <p:spPr>
+          <a:xfrm>
+            <a:off x="640080" y="2926080"/>
+            <a:ext cx="10881360" cy="1097280"/>
+          </a:xfrm>
+          <a:prstGeom prst="roundRect">
+            <a:avLst>
+              <a:gd name="adj" fmla="val 5000"/>
+            </a:avLst>
+          </a:prstGeom>
+          <a:solidFill>
+            <a:srgbClr val="FFFFFF"/>
+          </a:solidFill>
+          <a:ln w="12700">
+            <a:solidFill>
+              <a:srgbClr val="E4DCCB"/>
+            </a:solidFill>
+            <a:prstDash val="solid"/>
+          </a:ln>
+        </p:spPr>
+      </p:sp>
+      <p:sp>
+        <p:nvSpPr>
+          <p:cNvPr id="10" name="Shape 8"/>
+          <p:cNvSpPr/>
+          <p:nvPr/>
+        </p:nvSpPr>
+        <p:spPr>
+          <a:xfrm>
+            <a:off x="640080" y="2926080"/>
+            <a:ext cx="54864" cy="1097280"/>
+          </a:xfrm>
+          <a:prstGeom prst="rect">
+            <a:avLst/>
+          </a:prstGeom>
+          <a:solidFill>
+            <a:srgbClr val="1D6FE0"/>
+          </a:solidFill>
+          <a:ln/>
+        </p:spPr>
+      </p:sp>
+      <p:sp>
+        <p:nvSpPr>
+          <p:cNvPr id="11" name="Text 9"/>
+          <p:cNvSpPr/>
+          <p:nvPr/>
+        </p:nvSpPr>
+        <p:spPr>
+          <a:xfrm>
+            <a:off x="914400" y="3035808"/>
+            <a:ext cx="10332720" cy="365760"/>
+          </a:xfrm>
+          <a:prstGeom prst="rect">
+            <a:avLst/>
+          </a:prstGeom>
+          <a:noFill/>
+          <a:ln/>
+        </p:spPr>
+        <p:txBody>
+          <a:bodyPr wrap="square" rtlCol="0" anchor="ctr"/>
+          <a:lstStyle/>
+          <a:p>
+            <a:pPr indent="0" marL="0">
+              <a:buNone/>
+            </a:pPr>
+            <a:r>
+              <a:rPr lang="en-US" sz="1400" b="1" dirty="0">
+                <a:solidFill>
+                  <a:srgbClr val="1B1F3B"/>
+                </a:solidFill>
+                <a:latin typeface="Segoe UI" pitchFamily="34" charset="0"/>
+                <a:ea typeface="Segoe UI" pitchFamily="34" charset="-122"/>
+                <a:cs typeface="Segoe UI" pitchFamily="34" charset="-120"/>
+              </a:rPr>
+              <a:t>Tableau du devis : colonne Total HT (au lieu de Total TTC)</a:t>
+            </a:r>
+            <a:endParaRPr lang="en-US" sz="1400" dirty="0"/>
+          </a:p>
+        </p:txBody>
+      </p:sp>
+      <p:sp>
+        <p:nvSpPr>
+          <p:cNvPr id="12" name="Text 10"/>
+          <p:cNvSpPr/>
+          <p:nvPr/>
+        </p:nvSpPr>
+        <p:spPr>
+          <a:xfrm>
+            <a:off x="914400" y="3383280"/>
+            <a:ext cx="10332720" cy="594360"/>
+          </a:xfrm>
+          <a:prstGeom prst="rect">
+            <a:avLst/>
+          </a:prstGeom>
+          <a:noFill/>
+          <a:ln/>
+        </p:spPr>
+        <p:txBody>
+          <a:bodyPr wrap="square" rtlCol="0" anchor="ctr"/>
+          <a:lstStyle/>
+          <a:p>
+            <a:pPr indent="0" marL="0">
+              <a:lnSpc>
+                <a:spcPts val="1400"/>
+              </a:lnSpc>
+              <a:buNone/>
+            </a:pPr>
+            <a:r>
+              <a:rPr lang="en-US" sz="1100" dirty="0">
+                <a:solidFill>
+                  <a:srgbClr val="8A7C68"/>
+                </a:solidFill>
+                <a:latin typeface="Segoe UI" pitchFamily="34" charset="0"/>
+                <a:ea typeface="Segoe UI" pitchFamily="34" charset="-122"/>
+                <a:cs typeface="Segoe UI" pitchFamily="34" charset="-120"/>
+              </a:rPr>
               <a:t>La colonne de droite du tableau d'ouvrages, sur le PDF et le Word générés, affiche maintenant le Total HT de chaque ligne plutôt que le Total TTC, comme demandé pour la lecture par les clients/partenaires.</a:t>
             </a:r>
             <a:endParaRPr lang="en-US" sz="1100" dirty="0"/>
@@ -19219,7 +19347,7 @@
       </p:sp>
       <p:sp>
         <p:nvSpPr>
-          <p:cNvPr id="9" name="Text 7"/>
+          <p:cNvPr id="13" name="Text 11"/>
           <p:cNvSpPr/>
           <p:nvPr/>
         </p:nvSpPr>
@@ -19258,7 +19386,7 @@
       </p:sp>
       <p:sp>
         <p:nvSpPr>
-          <p:cNvPr id="10" name="Text 8"/>
+          <p:cNvPr id="14" name="Text 12"/>
           <p:cNvSpPr/>
           <p:nvPr/>
         </p:nvSpPr>

</xml_diff>

<commit_message>
Devis: bouton Ouvrir sur les ouvrages lies a la Bibliotheque
Comme pour les fournitures, chaque ligne de devis rattachee a un
ouvrage de la Bibliotheque affiche desormais un bouton "Ouvrir" a
cote de son titre, montrant sa fiche (code, famille, unite, temps
normatif, taux horaire, description) avec un lien vers la
Bibliotheque d'ouvrages pour la modifier.
</commit_message>
<xml_diff>
--- a/docs/manager-recap/Recap-Koji-Manager.pptx
+++ b/docs/manager-recap/Recap-Koji-Manager.pptx
@@ -10046,7 +10046,7 @@
                 <a:ea typeface="Georgia" pitchFamily="34" charset="-122"/>
                 <a:cs typeface="Georgia" pitchFamily="34" charset="-120"/>
               </a:rPr>
-              <a:t>73</a:t>
+              <a:t>74</a:t>
             </a:r>
             <a:endParaRPr lang="en-US" sz="3200" dirty="0"/>
           </a:p>
@@ -10151,7 +10151,7 @@
                 <a:ea typeface="Georgia" pitchFamily="34" charset="-122"/>
                 <a:cs typeface="Georgia" pitchFamily="34" charset="-120"/>
               </a:rPr>
-              <a:t>37</a:t>
+              <a:t>38</a:t>
             </a:r>
             <a:endParaRPr lang="en-US" sz="3200" dirty="0"/>
           </a:p>
@@ -15373,7 +15373,7 @@
                 <a:ea typeface="Segoe UI" pitchFamily="34" charset="-122"/>
                 <a:cs typeface="Segoe UI" pitchFamily="34" charset="-120"/>
               </a:rPr>
-              <a:t>37 mise(s) à jour</a:t>
+              <a:t>38 mise(s) à jour</a:t>
             </a:r>
             <a:endParaRPr lang="en-US" sz="1200" dirty="0"/>
           </a:p>
@@ -19347,7 +19347,135 @@
       </p:sp>
       <p:sp>
         <p:nvSpPr>
-          <p:cNvPr id="13" name="Text 11"/>
+          <p:cNvPr id="13" name="Shape 11"/>
+          <p:cNvSpPr/>
+          <p:nvPr/>
+        </p:nvSpPr>
+        <p:spPr>
+          <a:xfrm>
+            <a:off x="640080" y="4160520"/>
+            <a:ext cx="10881360" cy="1097280"/>
+          </a:xfrm>
+          <a:prstGeom prst="roundRect">
+            <a:avLst>
+              <a:gd name="adj" fmla="val 5000"/>
+            </a:avLst>
+          </a:prstGeom>
+          <a:solidFill>
+            <a:srgbClr val="FFFFFF"/>
+          </a:solidFill>
+          <a:ln w="12700">
+            <a:solidFill>
+              <a:srgbClr val="E4DCCB"/>
+            </a:solidFill>
+            <a:prstDash val="solid"/>
+          </a:ln>
+        </p:spPr>
+      </p:sp>
+      <p:sp>
+        <p:nvSpPr>
+          <p:cNvPr id="14" name="Shape 12"/>
+          <p:cNvSpPr/>
+          <p:nvPr/>
+        </p:nvSpPr>
+        <p:spPr>
+          <a:xfrm>
+            <a:off x="640080" y="4160520"/>
+            <a:ext cx="54864" cy="1097280"/>
+          </a:xfrm>
+          <a:prstGeom prst="rect">
+            <a:avLst/>
+          </a:prstGeom>
+          <a:solidFill>
+            <a:srgbClr val="1D6FE0"/>
+          </a:solidFill>
+          <a:ln/>
+        </p:spPr>
+      </p:sp>
+      <p:sp>
+        <p:nvSpPr>
+          <p:cNvPr id="15" name="Text 13"/>
+          <p:cNvSpPr/>
+          <p:nvPr/>
+        </p:nvSpPr>
+        <p:spPr>
+          <a:xfrm>
+            <a:off x="914400" y="4270248"/>
+            <a:ext cx="10332720" cy="365760"/>
+          </a:xfrm>
+          <a:prstGeom prst="rect">
+            <a:avLst/>
+          </a:prstGeom>
+          <a:noFill/>
+          <a:ln/>
+        </p:spPr>
+        <p:txBody>
+          <a:bodyPr wrap="square" rtlCol="0" anchor="ctr"/>
+          <a:lstStyle/>
+          <a:p>
+            <a:pPr indent="0" marL="0">
+              <a:buNone/>
+            </a:pPr>
+            <a:r>
+              <a:rPr lang="en-US" sz="1400" b="1" dirty="0">
+                <a:solidFill>
+                  <a:srgbClr val="1B1F3B"/>
+                </a:solidFill>
+                <a:latin typeface="Segoe UI" pitchFamily="34" charset="0"/>
+                <a:ea typeface="Segoe UI" pitchFamily="34" charset="-122"/>
+                <a:cs typeface="Segoe UI" pitchFamily="34" charset="-120"/>
+              </a:rPr>
+              <a:t>Bouton Ouvrir sur chaque ouvrage lié à la bibliothèque</a:t>
+            </a:r>
+            <a:endParaRPr lang="en-US" sz="1400" dirty="0"/>
+          </a:p>
+        </p:txBody>
+      </p:sp>
+      <p:sp>
+        <p:nvSpPr>
+          <p:cNvPr id="16" name="Text 14"/>
+          <p:cNvSpPr/>
+          <p:nvPr/>
+        </p:nvSpPr>
+        <p:spPr>
+          <a:xfrm>
+            <a:off x="914400" y="4617720"/>
+            <a:ext cx="10332720" cy="594360"/>
+          </a:xfrm>
+          <a:prstGeom prst="rect">
+            <a:avLst/>
+          </a:prstGeom>
+          <a:noFill/>
+          <a:ln/>
+        </p:spPr>
+        <p:txBody>
+          <a:bodyPr wrap="square" rtlCol="0" anchor="ctr"/>
+          <a:lstStyle/>
+          <a:p>
+            <a:pPr indent="0" marL="0">
+              <a:lnSpc>
+                <a:spcPts val="1400"/>
+              </a:lnSpc>
+              <a:buNone/>
+            </a:pPr>
+            <a:r>
+              <a:rPr lang="en-US" sz="1100" dirty="0">
+                <a:solidFill>
+                  <a:srgbClr val="8A7C68"/>
+                </a:solidFill>
+                <a:latin typeface="Segoe UI" pitchFamily="34" charset="0"/>
+                <a:ea typeface="Segoe UI" pitchFamily="34" charset="-122"/>
+                <a:cs typeface="Segoe UI" pitchFamily="34" charset="-120"/>
+              </a:rPr>
+              <a:t>Comme pour les fournitures, chaque ouvrage d'un devis relié à la Bibliothèque d'ouvrages affiche désormais un bouton 'Ouvrir' qui montre sa fiche (code, famille, unité, temps normatif, taux horaire, description) et permet d'aller la modifier dans la Bibliothèque.</a:t>
+            </a:r>
+            <a:endParaRPr lang="en-US" sz="1100" dirty="0"/>
+          </a:p>
+        </p:txBody>
+      </p:sp>
+      <p:sp>
+        <p:nvSpPr>
+          <p:cNvPr id="17" name="Text 15"/>
           <p:cNvSpPr/>
           <p:nvPr/>
         </p:nvSpPr>
@@ -19386,7 +19514,7 @@
       </p:sp>
       <p:sp>
         <p:nvSpPr>
-          <p:cNvPr id="14" name="Text 12"/>
+          <p:cNvPr id="18" name="Text 16"/>
           <p:cNvSpPr/>
           <p:nvPr/>
         </p:nvSpPr>

</xml_diff>

<commit_message>
Devis PDF/Word: masque les cadres Date de debut / Duree des travaux si vides
Egalement: retire le bloc "Bon pour accord / signature" du PDF genere
via "Transformer ce devis en facture" - non pertinent sur une facture,
le devis original le garde.
</commit_message>
<xml_diff>
--- a/docs/manager-recap/Recap-Koji-Manager.pptx
+++ b/docs/manager-recap/Recap-Koji-Manager.pptx
@@ -9901,7 +9901,7 @@
                 <a:ea typeface="Georgia" pitchFamily="34" charset="-122"/>
                 <a:cs typeface="Georgia" pitchFamily="34" charset="-120"/>
               </a:rPr>
-              <a:t>90</a:t>
+              <a:t>91</a:t>
             </a:r>
             <a:endParaRPr lang="en-US" sz="3200" dirty="0"/>
           </a:p>
@@ -10006,7 +10006,7 @@
                 <a:ea typeface="Georgia" pitchFamily="34" charset="-122"/>
                 <a:cs typeface="Georgia" pitchFamily="34" charset="-120"/>
               </a:rPr>
-              <a:t>41</a:t>
+              <a:t>42</a:t>
             </a:r>
             <a:endParaRPr lang="en-US" sz="3200" dirty="0"/>
           </a:p>
@@ -16087,7 +16087,7 @@
                 <a:ea typeface="Segoe UI" pitchFamily="34" charset="-122"/>
                 <a:cs typeface="Segoe UI" pitchFamily="34" charset="-120"/>
               </a:rPr>
-              <a:t>41 mise(s) à jour</a:t>
+              <a:t>42 mise(s) à jour</a:t>
             </a:r>
             <a:endParaRPr lang="en-US" sz="1200" dirty="0"/>
           </a:p>
@@ -23954,7 +23954,135 @@
       </p:sp>
       <p:sp>
         <p:nvSpPr>
-          <p:cNvPr id="9" name="Text 7"/>
+          <p:cNvPr id="9" name="Shape 7"/>
+          <p:cNvSpPr/>
+          <p:nvPr/>
+        </p:nvSpPr>
+        <p:spPr>
+          <a:xfrm>
+            <a:off x="640080" y="2926080"/>
+            <a:ext cx="10881360" cy="1097280"/>
+          </a:xfrm>
+          <a:prstGeom prst="roundRect">
+            <a:avLst>
+              <a:gd name="adj" fmla="val 5000"/>
+            </a:avLst>
+          </a:prstGeom>
+          <a:solidFill>
+            <a:srgbClr val="FFFFFF"/>
+          </a:solidFill>
+          <a:ln w="12700">
+            <a:solidFill>
+              <a:srgbClr val="E4DCCB"/>
+            </a:solidFill>
+            <a:prstDash val="solid"/>
+          </a:ln>
+        </p:spPr>
+      </p:sp>
+      <p:sp>
+        <p:nvSpPr>
+          <p:cNvPr id="10" name="Shape 8"/>
+          <p:cNvSpPr/>
+          <p:nvPr/>
+        </p:nvSpPr>
+        <p:spPr>
+          <a:xfrm>
+            <a:off x="640080" y="2926080"/>
+            <a:ext cx="54864" cy="1097280"/>
+          </a:xfrm>
+          <a:prstGeom prst="rect">
+            <a:avLst/>
+          </a:prstGeom>
+          <a:solidFill>
+            <a:srgbClr val="1D6FE0"/>
+          </a:solidFill>
+          <a:ln/>
+        </p:spPr>
+      </p:sp>
+      <p:sp>
+        <p:nvSpPr>
+          <p:cNvPr id="11" name="Text 9"/>
+          <p:cNvSpPr/>
+          <p:nvPr/>
+        </p:nvSpPr>
+        <p:spPr>
+          <a:xfrm>
+            <a:off x="914400" y="3035808"/>
+            <a:ext cx="10332720" cy="365760"/>
+          </a:xfrm>
+          <a:prstGeom prst="rect">
+            <a:avLst/>
+          </a:prstGeom>
+          <a:noFill/>
+          <a:ln/>
+        </p:spPr>
+        <p:txBody>
+          <a:bodyPr wrap="square" rtlCol="0" anchor="ctr"/>
+          <a:lstStyle/>
+          <a:p>
+            <a:pPr indent="0" marL="0">
+              <a:buNone/>
+            </a:pPr>
+            <a:r>
+              <a:rPr lang="en-US" sz="1400" b="1" dirty="0">
+                <a:solidFill>
+                  <a:srgbClr val="1B1F3B"/>
+                </a:solidFill>
+                <a:latin typeface="Segoe UI" pitchFamily="34" charset="0"/>
+                <a:ea typeface="Segoe UI" pitchFamily="34" charset="-122"/>
+                <a:cs typeface="Segoe UI" pitchFamily="34" charset="-120"/>
+              </a:rPr>
+              <a:t>Pas de bloc signature sur une facture</a:t>
+            </a:r>
+            <a:endParaRPr lang="en-US" sz="1400" dirty="0"/>
+          </a:p>
+        </p:txBody>
+      </p:sp>
+      <p:sp>
+        <p:nvSpPr>
+          <p:cNvPr id="12" name="Text 10"/>
+          <p:cNvSpPr/>
+          <p:nvPr/>
+        </p:nvSpPr>
+        <p:spPr>
+          <a:xfrm>
+            <a:off x="914400" y="3383280"/>
+            <a:ext cx="10332720" cy="594360"/>
+          </a:xfrm>
+          <a:prstGeom prst="rect">
+            <a:avLst/>
+          </a:prstGeom>
+          <a:noFill/>
+          <a:ln/>
+        </p:spPr>
+        <p:txBody>
+          <a:bodyPr wrap="square" rtlCol="0" anchor="ctr"/>
+          <a:lstStyle/>
+          <a:p>
+            <a:pPr indent="0" marL="0">
+              <a:lnSpc>
+                <a:spcPts val="1400"/>
+              </a:lnSpc>
+              <a:buNone/>
+            </a:pPr>
+            <a:r>
+              <a:rPr lang="en-US" sz="1100" dirty="0">
+                <a:solidFill>
+                  <a:srgbClr val="8A7C68"/>
+                </a:solidFill>
+                <a:latin typeface="Segoe UI" pitchFamily="34" charset="0"/>
+                <a:ea typeface="Segoe UI" pitchFamily="34" charset="-122"/>
+                <a:cs typeface="Segoe UI" pitchFamily="34" charset="-120"/>
+              </a:rPr>
+              <a:t>Le PDF généré via 'Transformer ce devis en facture' affichait encore le cadre 'Bon pour accord / Date et signature du client', qui n'a pas lieu d'être sur une facture. Retiré uniquement pour ce cas ; le devis original le garde.</a:t>
+            </a:r>
+            <a:endParaRPr lang="en-US" sz="1100" dirty="0"/>
+          </a:p>
+        </p:txBody>
+      </p:sp>
+      <p:sp>
+        <p:nvSpPr>
+          <p:cNvPr id="13" name="Text 11"/>
           <p:cNvSpPr/>
           <p:nvPr/>
         </p:nvSpPr>
@@ -23993,7 +24121,7 @@
       </p:sp>
       <p:sp>
         <p:nvSpPr>
-          <p:cNvPr id="10" name="Text 8"/>
+          <p:cNvPr id="14" name="Text 12"/>
           <p:cNvSpPr/>
           <p:nvPr/>
         </p:nvSpPr>

</xml_diff>

<commit_message>
Devis: acceptation manuelle sans e-signature + creation de chantier plus visible
Ajoute une action pour marquer un devis comme accepte par le client
sans passer par Koji Signature (accord oral, email, papier) : le
devis passe en statut Signe, devient eligible a la facturation et
debloque l'acces normal au chantier lie, comme une vraie signature.
Un bouton "Creer un chantier pour ce devis" rend aussi plus visible
un parcours qui existait deja mais etait cache dans un menu deroulant.

Co-Authored-By: Claude Sonnet 5 <noreply@anthropic.com>
</commit_message>
<xml_diff>
--- a/docs/manager-recap/Recap-Koji-Manager.pptx
+++ b/docs/manager-recap/Recap-Koji-Manager.pptx
@@ -10081,7 +10081,7 @@
                 <a:ea typeface="Segoe UI" pitchFamily="34" charset="-122"/>
                 <a:cs typeface="Segoe UI" pitchFamily="34" charset="-120"/>
               </a:rPr>
-              <a:t>39 mise(s) à jour</a:t>
+              <a:t>40 mise(s) à jour</a:t>
             </a:r>
             <a:endParaRPr lang="en-US" sz="1200" dirty="0"/>
           </a:p>
@@ -10335,7 +10335,7 @@
                 <a:ea typeface="Georgia" pitchFamily="34" charset="-122"/>
                 <a:cs typeface="Georgia" pitchFamily="34" charset="-120"/>
               </a:rPr>
-              <a:t>96</a:t>
+              <a:t>98</a:t>
             </a:r>
             <a:endParaRPr lang="en-US" sz="3200" dirty="0"/>
           </a:p>
@@ -10440,7 +10440,7 @@
                 <a:ea typeface="Georgia" pitchFamily="34" charset="-122"/>
                 <a:cs typeface="Georgia" pitchFamily="34" charset="-120"/>
               </a:rPr>
-              <a:t>46</a:t>
+              <a:t>47</a:t>
             </a:r>
             <a:endParaRPr lang="en-US" sz="3200" dirty="0"/>
           </a:p>
@@ -10545,7 +10545,7 @@
                 <a:ea typeface="Georgia" pitchFamily="34" charset="-122"/>
                 <a:cs typeface="Georgia" pitchFamily="34" charset="-120"/>
               </a:rPr>
-              <a:t>39</a:t>
+              <a:t>40</a:t>
             </a:r>
             <a:endParaRPr lang="en-US" sz="3200" dirty="0"/>
           </a:p>
@@ -13102,7 +13102,135 @@
       </p:sp>
       <p:sp>
         <p:nvSpPr>
-          <p:cNvPr id="9" name="Text 7"/>
+          <p:cNvPr id="9" name="Shape 7"/>
+          <p:cNvSpPr/>
+          <p:nvPr/>
+        </p:nvSpPr>
+        <p:spPr>
+          <a:xfrm>
+            <a:off x="640080" y="2926080"/>
+            <a:ext cx="10881360" cy="1097280"/>
+          </a:xfrm>
+          <a:prstGeom prst="roundRect">
+            <a:avLst>
+              <a:gd name="adj" fmla="val 5000"/>
+            </a:avLst>
+          </a:prstGeom>
+          <a:solidFill>
+            <a:srgbClr val="FFFFFF"/>
+          </a:solidFill>
+          <a:ln w="12700">
+            <a:solidFill>
+              <a:srgbClr val="E4DCCB"/>
+            </a:solidFill>
+            <a:prstDash val="solid"/>
+          </a:ln>
+        </p:spPr>
+      </p:sp>
+      <p:sp>
+        <p:nvSpPr>
+          <p:cNvPr id="10" name="Shape 8"/>
+          <p:cNvSpPr/>
+          <p:nvPr/>
+        </p:nvSpPr>
+        <p:spPr>
+          <a:xfrm>
+            <a:off x="640080" y="2926080"/>
+            <a:ext cx="54864" cy="1097280"/>
+          </a:xfrm>
+          <a:prstGeom prst="rect">
+            <a:avLst/>
+          </a:prstGeom>
+          <a:solidFill>
+            <a:srgbClr val="9A4C1F"/>
+          </a:solidFill>
+          <a:ln/>
+        </p:spPr>
+      </p:sp>
+      <p:sp>
+        <p:nvSpPr>
+          <p:cNvPr id="11" name="Text 9"/>
+          <p:cNvSpPr/>
+          <p:nvPr/>
+        </p:nvSpPr>
+        <p:spPr>
+          <a:xfrm>
+            <a:off x="914400" y="3035808"/>
+            <a:ext cx="10332720" cy="365760"/>
+          </a:xfrm>
+          <a:prstGeom prst="rect">
+            <a:avLst/>
+          </a:prstGeom>
+          <a:noFill/>
+          <a:ln/>
+        </p:spPr>
+        <p:txBody>
+          <a:bodyPr wrap="square" rtlCol="0" anchor="ctr"/>
+          <a:lstStyle/>
+          <a:p>
+            <a:pPr indent="0" marL="0">
+              <a:buNone/>
+            </a:pPr>
+            <a:r>
+              <a:rPr lang="en-US" sz="1400" b="1" dirty="0">
+                <a:solidFill>
+                  <a:srgbClr val="1B1F3B"/>
+                </a:solidFill>
+                <a:latin typeface="Segoe UI" pitchFamily="34" charset="0"/>
+                <a:ea typeface="Segoe UI" pitchFamily="34" charset="-122"/>
+                <a:cs typeface="Segoe UI" pitchFamily="34" charset="-120"/>
+              </a:rPr>
+              <a:t>Acceptation manuelle d'un devis, sans passer par la signature électronique</a:t>
+            </a:r>
+            <a:endParaRPr lang="en-US" sz="1400" dirty="0"/>
+          </a:p>
+        </p:txBody>
+      </p:sp>
+      <p:sp>
+        <p:nvSpPr>
+          <p:cNvPr id="12" name="Text 10"/>
+          <p:cNvSpPr/>
+          <p:nvPr/>
+        </p:nvSpPr>
+        <p:spPr>
+          <a:xfrm>
+            <a:off x="914400" y="3383280"/>
+            <a:ext cx="10332720" cy="594360"/>
+          </a:xfrm>
+          <a:prstGeom prst="rect">
+            <a:avLst/>
+          </a:prstGeom>
+          <a:noFill/>
+          <a:ln/>
+        </p:spPr>
+        <p:txBody>
+          <a:bodyPr wrap="square" rtlCol="0" anchor="ctr"/>
+          <a:lstStyle/>
+          <a:p>
+            <a:pPr indent="0" marL="0">
+              <a:lnSpc>
+                <a:spcPts val="1400"/>
+              </a:lnSpc>
+              <a:buNone/>
+            </a:pPr>
+            <a:r>
+              <a:rPr lang="en-US" sz="1100" dirty="0">
+                <a:solidFill>
+                  <a:srgbClr val="8A7C68"/>
+                </a:solidFill>
+                <a:latin typeface="Segoe UI" pitchFamily="34" charset="0"/>
+                <a:ea typeface="Segoe UI" pitchFamily="34" charset="-122"/>
+                <a:cs typeface="Segoe UI" pitchFamily="34" charset="-120"/>
+              </a:rPr>
+              <a:t>Nouvelle action pour marquer un devis comme accepté par le client (statut 'Signé') directement depuis l'éditeur, sans passer par Kôji Signature — utile quand l'accord a été donné oralement, par email ou sur papier. Le devis devient alors immédiatement éligible à la facturation et débloque l'accès normal au chantier lié, exactement comme une signature électronique. Un repère '(manuel)' distingue ce cas d'une vraie signature dans la liste des devis.</a:t>
+            </a:r>
+            <a:endParaRPr lang="en-US" sz="1100" dirty="0"/>
+          </a:p>
+        </p:txBody>
+      </p:sp>
+      <p:sp>
+        <p:nvSpPr>
+          <p:cNvPr id="13" name="Text 11"/>
           <p:cNvSpPr/>
           <p:nvPr/>
         </p:nvSpPr>
@@ -13141,7 +13269,7 @@
       </p:sp>
       <p:sp>
         <p:nvSpPr>
-          <p:cNvPr id="10" name="Text 8"/>
+          <p:cNvPr id="14" name="Text 12"/>
           <p:cNvSpPr/>
           <p:nvPr/>
         </p:nvSpPr>
@@ -16521,7 +16649,7 @@
                 <a:ea typeface="Segoe UI" pitchFamily="34" charset="-122"/>
                 <a:cs typeface="Segoe UI" pitchFamily="34" charset="-120"/>
               </a:rPr>
-              <a:t>46 mise(s) à jour</a:t>
+              <a:t>47 mise(s) à jour</a:t>
             </a:r>
             <a:endParaRPr lang="en-US" sz="1200" dirty="0"/>
           </a:p>
@@ -25320,7 +25448,135 @@
       </p:sp>
       <p:sp>
         <p:nvSpPr>
-          <p:cNvPr id="13" name="Text 11"/>
+          <p:cNvPr id="13" name="Shape 11"/>
+          <p:cNvSpPr/>
+          <p:nvPr/>
+        </p:nvSpPr>
+        <p:spPr>
+          <a:xfrm>
+            <a:off x="640080" y="4160520"/>
+            <a:ext cx="10881360" cy="1097280"/>
+          </a:xfrm>
+          <a:prstGeom prst="roundRect">
+            <a:avLst>
+              <a:gd name="adj" fmla="val 5000"/>
+            </a:avLst>
+          </a:prstGeom>
+          <a:solidFill>
+            <a:srgbClr val="FFFFFF"/>
+          </a:solidFill>
+          <a:ln w="12700">
+            <a:solidFill>
+              <a:srgbClr val="E4DCCB"/>
+            </a:solidFill>
+            <a:prstDash val="solid"/>
+          </a:ln>
+        </p:spPr>
+      </p:sp>
+      <p:sp>
+        <p:nvSpPr>
+          <p:cNvPr id="14" name="Shape 12"/>
+          <p:cNvSpPr/>
+          <p:nvPr/>
+        </p:nvSpPr>
+        <p:spPr>
+          <a:xfrm>
+            <a:off x="640080" y="4160520"/>
+            <a:ext cx="54864" cy="1097280"/>
+          </a:xfrm>
+          <a:prstGeom prst="rect">
+            <a:avLst/>
+          </a:prstGeom>
+          <a:solidFill>
+            <a:srgbClr val="1D6FE0"/>
+          </a:solidFill>
+          <a:ln/>
+        </p:spPr>
+      </p:sp>
+      <p:sp>
+        <p:nvSpPr>
+          <p:cNvPr id="15" name="Text 13"/>
+          <p:cNvSpPr/>
+          <p:nvPr/>
+        </p:nvSpPr>
+        <p:spPr>
+          <a:xfrm>
+            <a:off x="914400" y="4270248"/>
+            <a:ext cx="10332720" cy="365760"/>
+          </a:xfrm>
+          <a:prstGeom prst="rect">
+            <a:avLst/>
+          </a:prstGeom>
+          <a:noFill/>
+          <a:ln/>
+        </p:spPr>
+        <p:txBody>
+          <a:bodyPr wrap="square" rtlCol="0" anchor="ctr"/>
+          <a:lstStyle/>
+          <a:p>
+            <a:pPr indent="0" marL="0">
+              <a:buNone/>
+            </a:pPr>
+            <a:r>
+              <a:rPr lang="en-US" sz="1400" b="1" dirty="0">
+                <a:solidFill>
+                  <a:srgbClr val="1B1F3B"/>
+                </a:solidFill>
+                <a:latin typeface="Segoe UI" pitchFamily="34" charset="0"/>
+                <a:ea typeface="Segoe UI" pitchFamily="34" charset="-122"/>
+                <a:cs typeface="Segoe UI" pitchFamily="34" charset="-120"/>
+              </a:rPr>
+              <a:t>Création d'un chantier depuis un devis existant rendue plus visible</a:t>
+            </a:r>
+            <a:endParaRPr lang="en-US" sz="1400" dirty="0"/>
+          </a:p>
+        </p:txBody>
+      </p:sp>
+      <p:sp>
+        <p:nvSpPr>
+          <p:cNvPr id="16" name="Text 14"/>
+          <p:cNvSpPr/>
+          <p:nvPr/>
+        </p:nvSpPr>
+        <p:spPr>
+          <a:xfrm>
+            <a:off x="914400" y="4617720"/>
+            <a:ext cx="10332720" cy="594360"/>
+          </a:xfrm>
+          <a:prstGeom prst="rect">
+            <a:avLst/>
+          </a:prstGeom>
+          <a:noFill/>
+          <a:ln/>
+        </p:spPr>
+        <p:txBody>
+          <a:bodyPr wrap="square" rtlCol="0" anchor="ctr"/>
+          <a:lstStyle/>
+          <a:p>
+            <a:pPr indent="0" marL="0">
+              <a:lnSpc>
+                <a:spcPts val="1400"/>
+              </a:lnSpc>
+              <a:buNone/>
+            </a:pPr>
+            <a:r>
+              <a:rPr lang="en-US" sz="1100" dirty="0">
+                <a:solidFill>
+                  <a:srgbClr val="8A7C68"/>
+                </a:solidFill>
+                <a:latin typeface="Segoe UI" pitchFamily="34" charset="0"/>
+                <a:ea typeface="Segoe UI" pitchFamily="34" charset="-122"/>
+                <a:cs typeface="Segoe UI" pitchFamily="34" charset="-120"/>
+              </a:rPr>
+              <a:t>Un bouton explicite 'Créer un chantier pour ce devis' apparaît désormais quand un devis déjà enregistré n'a pas de chantier lié — possible à tout moment, même si le client n'a pas encore validé le devis.</a:t>
+            </a:r>
+            <a:endParaRPr lang="en-US" sz="1100" dirty="0"/>
+          </a:p>
+        </p:txBody>
+      </p:sp>
+      <p:sp>
+        <p:nvSpPr>
+          <p:cNvPr id="17" name="Text 15"/>
           <p:cNvSpPr/>
           <p:nvPr/>
         </p:nvSpPr>
@@ -25359,7 +25615,7 @@
       </p:sp>
       <p:sp>
         <p:nvSpPr>
-          <p:cNvPr id="14" name="Text 12"/>
+          <p:cNvPr id="18" name="Text 16"/>
           <p:cNvSpPr/>
           <p:nvPr/>
         </p:nvSpPr>

</xml_diff>

<commit_message>
Accueil: le devis devient le point d'entree principal
Le bouton d'action principal de l'accueil cree desormais un devis
(au lieu d'un chantier), et l'ordre des sections passe a Devis en
cours, Chantiers, puis Interventions.

Co-Authored-By: Claude Sonnet 5 <noreply@anthropic.com>
</commit_message>
<xml_diff>
--- a/docs/manager-recap/Recap-Koji-Manager.pptx
+++ b/docs/manager-recap/Recap-Koji-Manager.pptx
@@ -7000,7 +7000,135 @@
       </p:sp>
       <p:sp>
         <p:nvSpPr>
-          <p:cNvPr id="17" name="Text 15"/>
+          <p:cNvPr id="17" name="Shape 15"/>
+          <p:cNvSpPr/>
+          <p:nvPr/>
+        </p:nvSpPr>
+        <p:spPr>
+          <a:xfrm>
+            <a:off x="640080" y="5394960"/>
+            <a:ext cx="10881360" cy="1097280"/>
+          </a:xfrm>
+          <a:prstGeom prst="roundRect">
+            <a:avLst>
+              <a:gd name="adj" fmla="val 5000"/>
+            </a:avLst>
+          </a:prstGeom>
+          <a:solidFill>
+            <a:srgbClr val="FFFFFF"/>
+          </a:solidFill>
+          <a:ln w="12700">
+            <a:solidFill>
+              <a:srgbClr val="E4DCCB"/>
+            </a:solidFill>
+            <a:prstDash val="solid"/>
+          </a:ln>
+        </p:spPr>
+      </p:sp>
+      <p:sp>
+        <p:nvSpPr>
+          <p:cNvPr id="18" name="Shape 16"/>
+          <p:cNvSpPr/>
+          <p:nvPr/>
+        </p:nvSpPr>
+        <p:spPr>
+          <a:xfrm>
+            <a:off x="640080" y="5394960"/>
+            <a:ext cx="54864" cy="1097280"/>
+          </a:xfrm>
+          <a:prstGeom prst="rect">
+            <a:avLst/>
+          </a:prstGeom>
+          <a:solidFill>
+            <a:srgbClr val="1D6FE0"/>
+          </a:solidFill>
+          <a:ln/>
+        </p:spPr>
+      </p:sp>
+      <p:sp>
+        <p:nvSpPr>
+          <p:cNvPr id="19" name="Text 17"/>
+          <p:cNvSpPr/>
+          <p:nvPr/>
+        </p:nvSpPr>
+        <p:spPr>
+          <a:xfrm>
+            <a:off x="914400" y="5504688"/>
+            <a:ext cx="10332720" cy="365760"/>
+          </a:xfrm>
+          <a:prstGeom prst="rect">
+            <a:avLst/>
+          </a:prstGeom>
+          <a:noFill/>
+          <a:ln/>
+        </p:spPr>
+        <p:txBody>
+          <a:bodyPr wrap="square" rtlCol="0" anchor="ctr"/>
+          <a:lstStyle/>
+          <a:p>
+            <a:pPr indent="0" marL="0">
+              <a:buNone/>
+            </a:pPr>
+            <a:r>
+              <a:rPr lang="en-US" sz="1400" b="1" dirty="0">
+                <a:solidFill>
+                  <a:srgbClr val="1B1F3B"/>
+                </a:solidFill>
+                <a:latin typeface="Segoe UI" pitchFamily="34" charset="0"/>
+                <a:ea typeface="Segoe UI" pitchFamily="34" charset="-122"/>
+                <a:cs typeface="Segoe UI" pitchFamily="34" charset="-120"/>
+              </a:rPr>
+              <a:t>Le devis devient le point d'entrée de l'accueil</a:t>
+            </a:r>
+            <a:endParaRPr lang="en-US" sz="1400" dirty="0"/>
+          </a:p>
+        </p:txBody>
+      </p:sp>
+      <p:sp>
+        <p:nvSpPr>
+          <p:cNvPr id="20" name="Text 18"/>
+          <p:cNvSpPr/>
+          <p:nvPr/>
+        </p:nvSpPr>
+        <p:spPr>
+          <a:xfrm>
+            <a:off x="914400" y="5852160"/>
+            <a:ext cx="10332720" cy="594360"/>
+          </a:xfrm>
+          <a:prstGeom prst="rect">
+            <a:avLst/>
+          </a:prstGeom>
+          <a:noFill/>
+          <a:ln/>
+        </p:spPr>
+        <p:txBody>
+          <a:bodyPr wrap="square" rtlCol="0" anchor="ctr"/>
+          <a:lstStyle/>
+          <a:p>
+            <a:pPr indent="0" marL="0">
+              <a:lnSpc>
+                <a:spcPts val="1400"/>
+              </a:lnSpc>
+              <a:buNone/>
+            </a:pPr>
+            <a:r>
+              <a:rPr lang="en-US" sz="1100" dirty="0">
+                <a:solidFill>
+                  <a:srgbClr val="8A7C68"/>
+                </a:solidFill>
+                <a:latin typeface="Segoe UI" pitchFamily="34" charset="0"/>
+                <a:ea typeface="Segoe UI" pitchFamily="34" charset="-122"/>
+                <a:cs typeface="Segoe UI" pitchFamily="34" charset="-120"/>
+              </a:rPr>
+              <a:t>Le gros bouton d'action de la page d'accueil ('+') pointe maintenant vers la création d'un devis au lieu d'un chantier, et l'ordre des sections a été inversé : Devis en cours avant Chantiers, Interventions en dernier.</a:t>
+            </a:r>
+            <a:endParaRPr lang="en-US" sz="1100" dirty="0"/>
+          </a:p>
+        </p:txBody>
+      </p:sp>
+      <p:sp>
+        <p:nvSpPr>
+          <p:cNvPr id="21" name="Text 19"/>
           <p:cNvSpPr/>
           <p:nvPr/>
         </p:nvSpPr>
@@ -7039,7 +7167,7 @@
       </p:sp>
       <p:sp>
         <p:nvSpPr>
-          <p:cNvPr id="18" name="Text 16"/>
+          <p:cNvPr id="22" name="Text 20"/>
           <p:cNvSpPr/>
           <p:nvPr/>
         </p:nvSpPr>
@@ -10335,7 +10463,7 @@
                 <a:ea typeface="Georgia" pitchFamily="34" charset="-122"/>
                 <a:cs typeface="Georgia" pitchFamily="34" charset="-120"/>
               </a:rPr>
-              <a:t>98</a:t>
+              <a:t>99</a:t>
             </a:r>
             <a:endParaRPr lang="en-US" sz="3200" dirty="0"/>
           </a:p>
@@ -10440,7 +10568,7 @@
                 <a:ea typeface="Georgia" pitchFamily="34" charset="-122"/>
                 <a:cs typeface="Georgia" pitchFamily="34" charset="-120"/>
               </a:rPr>
-              <a:t>47</a:t>
+              <a:t>48</a:t>
             </a:r>
             <a:endParaRPr lang="en-US" sz="3200" dirty="0"/>
           </a:p>
@@ -16649,7 +16777,7 @@
                 <a:ea typeface="Segoe UI" pitchFamily="34" charset="-122"/>
                 <a:cs typeface="Segoe UI" pitchFamily="34" charset="-120"/>
               </a:rPr>
-              <a:t>47 mise(s) à jour</a:t>
+              <a:t>48 mise(s) à jour</a:t>
             </a:r>
             <a:endParaRPr lang="en-US" sz="1200" dirty="0"/>
           </a:p>

</xml_diff>

<commit_message>
Devis: base de calcul cumulative pour les majorations (assurance)
Coordination de chantier et provision pour aleas restent calculees
sur le total des lots uniquement. L'assurance decennale, elle,
doit porter sur le chiffrage total de l'affaire HT (lots +
coordination + provision alea + lignes precedentes), pas sur les
seuls lots -- une case a cocher "Cumule" par ligne de majoration
permet de le choisir, activee par defaut sur l'assurance decennale.

Extrait la logique dans un helper partage (computeSurchargeBreakdown)
repris par le calcul du devis, le PDF et l'export Word, qui
recalculaient chacun le meme montant de facon independante et
desynchronisee.

Co-Authored-By: Claude Sonnet 5 <noreply@anthropic.com>
</commit_message>
<xml_diff>
--- a/docs/manager-recap/Recap-Koji-Manager.pptx
+++ b/docs/manager-recap/Recap-Koji-Manager.pptx
@@ -10209,7 +10209,7 @@
                 <a:ea typeface="Segoe UI" pitchFamily="34" charset="-122"/>
                 <a:cs typeface="Segoe UI" pitchFamily="34" charset="-120"/>
               </a:rPr>
-              <a:t>40 mise(s) à jour</a:t>
+              <a:t>41 mise(s) à jour</a:t>
             </a:r>
             <a:endParaRPr lang="en-US" sz="1200" dirty="0"/>
           </a:p>
@@ -10463,7 +10463,7 @@
                 <a:ea typeface="Georgia" pitchFamily="34" charset="-122"/>
                 <a:cs typeface="Georgia" pitchFamily="34" charset="-120"/>
               </a:rPr>
-              <a:t>99</a:t>
+              <a:t>100</a:t>
             </a:r>
             <a:endParaRPr lang="en-US" sz="3200" dirty="0"/>
           </a:p>
@@ -10673,7 +10673,7 @@
                 <a:ea typeface="Georgia" pitchFamily="34" charset="-122"/>
                 <a:cs typeface="Georgia" pitchFamily="34" charset="-120"/>
               </a:rPr>
-              <a:t>40</a:t>
+              <a:t>41</a:t>
             </a:r>
             <a:endParaRPr lang="en-US" sz="3200" dirty="0"/>
           </a:p>
@@ -13358,7 +13358,135 @@
       </p:sp>
       <p:sp>
         <p:nvSpPr>
-          <p:cNvPr id="13" name="Text 11"/>
+          <p:cNvPr id="13" name="Shape 11"/>
+          <p:cNvSpPr/>
+          <p:nvPr/>
+        </p:nvSpPr>
+        <p:spPr>
+          <a:xfrm>
+            <a:off x="640080" y="4160520"/>
+            <a:ext cx="10881360" cy="1097280"/>
+          </a:xfrm>
+          <a:prstGeom prst="roundRect">
+            <a:avLst>
+              <a:gd name="adj" fmla="val 5000"/>
+            </a:avLst>
+          </a:prstGeom>
+          <a:solidFill>
+            <a:srgbClr val="FFFFFF"/>
+          </a:solidFill>
+          <a:ln w="12700">
+            <a:solidFill>
+              <a:srgbClr val="E4DCCB"/>
+            </a:solidFill>
+            <a:prstDash val="solid"/>
+          </a:ln>
+        </p:spPr>
+      </p:sp>
+      <p:sp>
+        <p:nvSpPr>
+          <p:cNvPr id="14" name="Shape 12"/>
+          <p:cNvSpPr/>
+          <p:nvPr/>
+        </p:nvSpPr>
+        <p:spPr>
+          <a:xfrm>
+            <a:off x="640080" y="4160520"/>
+            <a:ext cx="54864" cy="1097280"/>
+          </a:xfrm>
+          <a:prstGeom prst="rect">
+            <a:avLst/>
+          </a:prstGeom>
+          <a:solidFill>
+            <a:srgbClr val="9A4C1F"/>
+          </a:solidFill>
+          <a:ln/>
+        </p:spPr>
+      </p:sp>
+      <p:sp>
+        <p:nvSpPr>
+          <p:cNvPr id="15" name="Text 13"/>
+          <p:cNvSpPr/>
+          <p:nvPr/>
+        </p:nvSpPr>
+        <p:spPr>
+          <a:xfrm>
+            <a:off x="914400" y="4270248"/>
+            <a:ext cx="10332720" cy="365760"/>
+          </a:xfrm>
+          <a:prstGeom prst="rect">
+            <a:avLst/>
+          </a:prstGeom>
+          <a:noFill/>
+          <a:ln/>
+        </p:spPr>
+        <p:txBody>
+          <a:bodyPr wrap="square" rtlCol="0" anchor="ctr"/>
+          <a:lstStyle/>
+          <a:p>
+            <a:pPr indent="0" marL="0">
+              <a:buNone/>
+            </a:pPr>
+            <a:r>
+              <a:rPr lang="en-US" sz="1400" b="1" dirty="0">
+                <a:solidFill>
+                  <a:srgbClr val="1B1F3B"/>
+                </a:solidFill>
+                <a:latin typeface="Segoe UI" pitchFamily="34" charset="0"/>
+                <a:ea typeface="Segoe UI" pitchFamily="34" charset="-122"/>
+                <a:cs typeface="Segoe UI" pitchFamily="34" charset="-120"/>
+              </a:rPr>
+              <a:t>Base de calcul correcte pour les majorations (coordination, aléas, assurance)</a:t>
+            </a:r>
+            <a:endParaRPr lang="en-US" sz="1400" dirty="0"/>
+          </a:p>
+        </p:txBody>
+      </p:sp>
+      <p:sp>
+        <p:nvSpPr>
+          <p:cNvPr id="16" name="Text 14"/>
+          <p:cNvSpPr/>
+          <p:nvPr/>
+        </p:nvSpPr>
+        <p:spPr>
+          <a:xfrm>
+            <a:off x="914400" y="4617720"/>
+            <a:ext cx="10332720" cy="594360"/>
+          </a:xfrm>
+          <a:prstGeom prst="rect">
+            <a:avLst/>
+          </a:prstGeom>
+          <a:noFill/>
+          <a:ln/>
+        </p:spPr>
+        <p:txBody>
+          <a:bodyPr wrap="square" rtlCol="0" anchor="ctr"/>
+          <a:lstStyle/>
+          <a:p>
+            <a:pPr indent="0" marL="0">
+              <a:lnSpc>
+                <a:spcPts val="1400"/>
+              </a:lnSpc>
+              <a:buNone/>
+            </a:pPr>
+            <a:r>
+              <a:rPr lang="en-US" sz="1100" dirty="0">
+                <a:solidFill>
+                  <a:srgbClr val="8A7C68"/>
+                </a:solidFill>
+                <a:latin typeface="Segoe UI" pitchFamily="34" charset="0"/>
+                <a:ea typeface="Segoe UI" pitchFamily="34" charset="-122"/>
+                <a:cs typeface="Segoe UI" pitchFamily="34" charset="-120"/>
+              </a:rPr>
+              <a:t>La coordination de chantier et la provision pour aléas se calculaient déjà, comme il se doit, uniquement sur le total des lots. L'assurance décennale utilisait à tort la même base, alors qu'elle doit porter sur le chiffrage total de l'affaire HT (lots + coordination + provision aléas + toute ligne précédente). Une case 'Cumulé' sur chaque ligne de majoration permet désormais de choisir sa base de calcul ; cochée par défaut sur l'assurance décennale. Corrigé dans le calcul du devis, le PDF et l'export Word, qui utilisaient chacun leur propre logique.</a:t>
+            </a:r>
+            <a:endParaRPr lang="en-US" sz="1100" dirty="0"/>
+          </a:p>
+        </p:txBody>
+      </p:sp>
+      <p:sp>
+        <p:nvSpPr>
+          <p:cNvPr id="17" name="Text 15"/>
           <p:cNvSpPr/>
           <p:nvPr/>
         </p:nvSpPr>
@@ -13397,7 +13525,7 @@
       </p:sp>
       <p:sp>
         <p:nvSpPr>
-          <p:cNvPr id="14" name="Text 12"/>
+          <p:cNvPr id="18" name="Text 16"/>
           <p:cNvSpPr/>
           <p:nvPr/>
         </p:nvSpPr>

</xml_diff>

<commit_message>
Facturation: retour vers la page Factures apres transformation d'un devis
"Transformer ce devis en facture" ouvrait directement le PDF dans un
nouvel onglet. Redirige maintenant vers /facturation avec la facture
nouvellement creee deja selectionnee (parametre ?quoteId=), pour la
telecharger ou l'envoyer depuis la page plutot que depuis un PDF isole.

Co-Authored-By: Claude Sonnet 5 <noreply@anthropic.com>
</commit_message>
<xml_diff>
--- a/docs/manager-recap/Recap-Koji-Manager.pptx
+++ b/docs/manager-recap/Recap-Koji-Manager.pptx
@@ -9426,7 +9426,135 @@
       </p:sp>
       <p:sp>
         <p:nvSpPr>
-          <p:cNvPr id="9" name="Text 7"/>
+          <p:cNvPr id="9" name="Shape 7"/>
+          <p:cNvSpPr/>
+          <p:nvPr/>
+        </p:nvSpPr>
+        <p:spPr>
+          <a:xfrm>
+            <a:off x="640080" y="2926080"/>
+            <a:ext cx="10881360" cy="1097280"/>
+          </a:xfrm>
+          <a:prstGeom prst="roundRect">
+            <a:avLst>
+              <a:gd name="adj" fmla="val 5000"/>
+            </a:avLst>
+          </a:prstGeom>
+          <a:solidFill>
+            <a:srgbClr val="FFFFFF"/>
+          </a:solidFill>
+          <a:ln w="12700">
+            <a:solidFill>
+              <a:srgbClr val="E4DCCB"/>
+            </a:solidFill>
+            <a:prstDash val="solid"/>
+          </a:ln>
+        </p:spPr>
+      </p:sp>
+      <p:sp>
+        <p:nvSpPr>
+          <p:cNvPr id="10" name="Shape 8"/>
+          <p:cNvSpPr/>
+          <p:nvPr/>
+        </p:nvSpPr>
+        <p:spPr>
+          <a:xfrm>
+            <a:off x="640080" y="2926080"/>
+            <a:ext cx="54864" cy="1097280"/>
+          </a:xfrm>
+          <a:prstGeom prst="rect">
+            <a:avLst/>
+          </a:prstGeom>
+          <a:solidFill>
+            <a:srgbClr val="1D6FE0"/>
+          </a:solidFill>
+          <a:ln/>
+        </p:spPr>
+      </p:sp>
+      <p:sp>
+        <p:nvSpPr>
+          <p:cNvPr id="11" name="Text 9"/>
+          <p:cNvSpPr/>
+          <p:nvPr/>
+        </p:nvSpPr>
+        <p:spPr>
+          <a:xfrm>
+            <a:off x="914400" y="3035808"/>
+            <a:ext cx="10332720" cy="365760"/>
+          </a:xfrm>
+          <a:prstGeom prst="rect">
+            <a:avLst/>
+          </a:prstGeom>
+          <a:noFill/>
+          <a:ln/>
+        </p:spPr>
+        <p:txBody>
+          <a:bodyPr wrap="square" rtlCol="0" anchor="ctr"/>
+          <a:lstStyle/>
+          <a:p>
+            <a:pPr indent="0" marL="0">
+              <a:buNone/>
+            </a:pPr>
+            <a:r>
+              <a:rPr lang="en-US" sz="1400" b="1" dirty="0">
+                <a:solidFill>
+                  <a:srgbClr val="1B1F3B"/>
+                </a:solidFill>
+                <a:latin typeface="Segoe UI" pitchFamily="34" charset="0"/>
+                <a:ea typeface="Segoe UI" pitchFamily="34" charset="-122"/>
+                <a:cs typeface="Segoe UI" pitchFamily="34" charset="-120"/>
+              </a:rPr>
+              <a:t>Retour vers Factures apres transformation d'un devis</a:t>
+            </a:r>
+            <a:endParaRPr lang="en-US" sz="1400" dirty="0"/>
+          </a:p>
+        </p:txBody>
+      </p:sp>
+      <p:sp>
+        <p:nvSpPr>
+          <p:cNvPr id="12" name="Text 10"/>
+          <p:cNvSpPr/>
+          <p:nvPr/>
+        </p:nvSpPr>
+        <p:spPr>
+          <a:xfrm>
+            <a:off x="914400" y="3383280"/>
+            <a:ext cx="10332720" cy="594360"/>
+          </a:xfrm>
+          <a:prstGeom prst="rect">
+            <a:avLst/>
+          </a:prstGeom>
+          <a:noFill/>
+          <a:ln/>
+        </p:spPr>
+        <p:txBody>
+          <a:bodyPr wrap="square" rtlCol="0" anchor="ctr"/>
+          <a:lstStyle/>
+          <a:p>
+            <a:pPr indent="0" marL="0">
+              <a:lnSpc>
+                <a:spcPts val="1400"/>
+              </a:lnSpc>
+              <a:buNone/>
+            </a:pPr>
+            <a:r>
+              <a:rPr lang="en-US" sz="1100" dirty="0">
+                <a:solidFill>
+                  <a:srgbClr val="8A7C68"/>
+                </a:solidFill>
+                <a:latin typeface="Segoe UI" pitchFamily="34" charset="0"/>
+                <a:ea typeface="Segoe UI" pitchFamily="34" charset="-122"/>
+                <a:cs typeface="Segoe UI" pitchFamily="34" charset="-120"/>
+              </a:rPr>
+              <a:t>Le bouton 'Transformer ce devis en facture' ouvrait directement le PDF dans un nouvel onglet. Il renvoie maintenant vers la page Factures, avec la facture nouvellement créée déjà sélectionnée, pour la télécharger ou l'envoyer depuis cette page plutôt que depuis un PDF isolé.</a:t>
+            </a:r>
+            <a:endParaRPr lang="en-US" sz="1100" dirty="0"/>
+          </a:p>
+        </p:txBody>
+      </p:sp>
+      <p:sp>
+        <p:nvSpPr>
+          <p:cNvPr id="13" name="Text 11"/>
           <p:cNvSpPr/>
           <p:nvPr/>
         </p:nvSpPr>
@@ -9465,7 +9593,7 @@
       </p:sp>
       <p:sp>
         <p:nvSpPr>
-          <p:cNvPr id="10" name="Text 8"/>
+          <p:cNvPr id="14" name="Text 12"/>
           <p:cNvSpPr/>
           <p:nvPr/>
         </p:nvSpPr>
@@ -10732,7 +10860,7 @@
                 <a:ea typeface="Georgia" pitchFamily="34" charset="-122"/>
                 <a:cs typeface="Georgia" pitchFamily="34" charset="-120"/>
               </a:rPr>
-              <a:t>102</a:t>
+              <a:t>103</a:t>
             </a:r>
             <a:endParaRPr lang="en-US" sz="3200" dirty="0"/>
           </a:p>
@@ -10837,7 +10965,7 @@
                 <a:ea typeface="Georgia" pitchFamily="34" charset="-122"/>
                 <a:cs typeface="Georgia" pitchFamily="34" charset="-120"/>
               </a:rPr>
-              <a:t>49</a:t>
+              <a:t>50</a:t>
             </a:r>
             <a:endParaRPr lang="en-US" sz="3200" dirty="0"/>
           </a:p>
@@ -16699,7 +16827,7 @@
                 <a:ea typeface="Segoe UI" pitchFamily="34" charset="-122"/>
                 <a:cs typeface="Segoe UI" pitchFamily="34" charset="-120"/>
               </a:rPr>
-              <a:t>49 mise(s) à jour</a:t>
+              <a:t>50 mise(s) à jour</a:t>
             </a:r>
             <a:endParaRPr lang="en-US" sz="1200" dirty="0"/>
           </a:p>

</xml_diff>

<commit_message>
Connexion: fusion Client + Ouvrier en un seul onglet "Particulier"
Nouvelle route app/api/auth/particulier-login qui cherche d'abord un
compte client (portail), puis un compte ouvrier si aucun ne
correspond, et verifie le mot de passe uniquement contre le compte
trouve -- reutilise telles quelles la logique de recherche et de
verification de client-portal-login et worker-auth (conservees
inchangees, toujours actives independamment). Message d'erreur
generique dans tous les cas, pour ne jamais reveler le type de
compte associe a un identifiant.

Cote page de connexion, un seul formulaire "Particulier" remplace les
deux anciens onglets Client/Ouvrier ; la redirection (/client ou
/worker) et le stockage de session suivent le type de compte renvoye
par l'API. ?type=ouvrier reste supporte pour compatibilite avec le
lien deja envoye aux ouvriers depuis la fiche Equipe.

Co-Authored-By: Claude Sonnet 5 <noreply@anthropic.com>
</commit_message>
<xml_diff>
--- a/docs/manager-recap/Recap-Koji-Manager.pptx
+++ b/docs/manager-recap/Recap-Koji-Manager.pptx
@@ -51,9 +51,10 @@
     <p:sldId id="299" r:id="rId45"/>
     <p:sldId id="300" r:id="rId46"/>
     <p:sldId id="301" r:id="rId47"/>
+    <p:sldId id="302" r:id="rId48"/>
   </p:sldIdLst>
   <p:notesMasterIdLst>
-    <p:notesMasterId r:id="rId48"/>
+    <p:notesMasterId r:id="rId49"/>
   </p:notesMasterIdLst>
   <p:sldSz cx="12191695" cy="6858000"/>
   <p:notesSz cx="6858000" cy="12191695"/>
@@ -4091,6 +4092,94 @@
             <a:fld id="{F7021451-1387-4CA6-816F-3879F97B5CBC}" type="slidenum">
               <a:rPr lang="en-US"/>
               <a:t>46</a:t>
+            </a:fld>
+            <a:endParaRPr lang="en-US"/>
+          </a:p>
+        </p:txBody>
+      </p:sp>
+    </p:spTree>
+    <p:extLst>
+      <p:ext uri="{BB962C8B-B14F-4D97-AF65-F5344CB8AC3E}">
+        <p14:creationId xmlns:p14="http://schemas.microsoft.com/office/powerpoint/2010/main" val="1024086991"/>
+      </p:ext>
+    </p:extLst>
+  </p:cSld>
+  <p:clrMapOvr>
+    <a:masterClrMapping/>
+  </p:clrMapOvr>
+</p:notes>
+</file>
+
+<file path=ppt/notesSlides/notesSlide47.xml><?xml version="1.0" encoding="utf-8"?>
+<p:notes xmlns:a="http://schemas.openxmlformats.org/drawingml/2006/main" xmlns:r="http://schemas.openxmlformats.org/officeDocument/2006/relationships" xmlns:p="http://schemas.openxmlformats.org/presentationml/2006/main">
+  <p:cSld>
+    <p:spTree>
+      <p:nvGrpSpPr>
+        <p:cNvPr id="1" name=""/>
+        <p:cNvGrpSpPr/>
+        <p:nvPr/>
+      </p:nvGrpSpPr>
+      <p:grpSpPr>
+        <a:xfrm>
+          <a:off x="0" y="0"/>
+          <a:ext cx="0" cy="0"/>
+          <a:chOff x="0" y="0"/>
+          <a:chExt cx="0" cy="0"/>
+        </a:xfrm>
+      </p:grpSpPr>
+      <p:sp>
+        <p:nvSpPr>
+          <p:cNvPr id="2" name="Slide Image Placeholder 1"/>
+          <p:cNvSpPr>
+            <a:spLocks noGrp="1" noRot="1" noChangeAspect="1"/>
+          </p:cNvSpPr>
+          <p:nvPr>
+            <p:ph type="sldImg"/>
+          </p:nvPr>
+        </p:nvSpPr>
+        <p:spPr/>
+      </p:sp>
+      <p:sp>
+        <p:nvSpPr>
+          <p:cNvPr id="3" name="Notes Placeholder 2"/>
+          <p:cNvSpPr>
+            <a:spLocks noGrp="1"/>
+          </p:cNvSpPr>
+          <p:nvPr>
+            <p:ph type="body" idx="1"/>
+          </p:nvPr>
+        </p:nvSpPr>
+        <p:spPr/>
+        <p:txBody>
+          <a:bodyPr/>
+          <a:lstStyle/>
+          <a:p>
+            <a:r>
+              <a:rPr lang="en-US" dirty="0"/>
+              <a:t/>
+            </a:r>
+            <a:endParaRPr lang="en-US" dirty="0"/>
+          </a:p>
+        </p:txBody>
+      </p:sp>
+      <p:sp>
+        <p:nvSpPr>
+          <p:cNvPr id="4" name="Slide Number Placeholder 3"/>
+          <p:cNvSpPr>
+            <a:spLocks noGrp="1"/>
+          </p:cNvSpPr>
+          <p:nvPr>
+            <p:ph type="sldNum" sz="quarter" idx="10"/>
+          </p:nvPr>
+        </p:nvSpPr>
+        <p:spPr/>
+        <p:txBody>
+          <a:bodyPr/>
+          <a:lstStyle/>
+          <a:p>
+            <a:fld id="{F7021451-1387-4CA6-816F-3879F97B5CBC}" type="slidenum">
+              <a:rPr lang="en-US"/>
+              <a:t>47</a:t>
             </a:fld>
             <a:endParaRPr lang="en-US"/>
           </a:p>
@@ -9554,7 +9643,135 @@
       </p:sp>
       <p:sp>
         <p:nvSpPr>
-          <p:cNvPr id="13" name="Text 11"/>
+          <p:cNvPr id="13" name="Shape 11"/>
+          <p:cNvSpPr/>
+          <p:nvPr/>
+        </p:nvSpPr>
+        <p:spPr>
+          <a:xfrm>
+            <a:off x="640080" y="4160520"/>
+            <a:ext cx="10881360" cy="1097280"/>
+          </a:xfrm>
+          <a:prstGeom prst="roundRect">
+            <a:avLst>
+              <a:gd name="adj" fmla="val 5000"/>
+            </a:avLst>
+          </a:prstGeom>
+          <a:solidFill>
+            <a:srgbClr val="FFFFFF"/>
+          </a:solidFill>
+          <a:ln w="12700">
+            <a:solidFill>
+              <a:srgbClr val="E4DCCB"/>
+            </a:solidFill>
+            <a:prstDash val="solid"/>
+          </a:ln>
+        </p:spPr>
+      </p:sp>
+      <p:sp>
+        <p:nvSpPr>
+          <p:cNvPr id="14" name="Shape 12"/>
+          <p:cNvSpPr/>
+          <p:nvPr/>
+        </p:nvSpPr>
+        <p:spPr>
+          <a:xfrm>
+            <a:off x="640080" y="4160520"/>
+            <a:ext cx="54864" cy="1097280"/>
+          </a:xfrm>
+          <a:prstGeom prst="rect">
+            <a:avLst/>
+          </a:prstGeom>
+          <a:solidFill>
+            <a:srgbClr val="1D6FE0"/>
+          </a:solidFill>
+          <a:ln/>
+        </p:spPr>
+      </p:sp>
+      <p:sp>
+        <p:nvSpPr>
+          <p:cNvPr id="15" name="Text 13"/>
+          <p:cNvSpPr/>
+          <p:nvPr/>
+        </p:nvSpPr>
+        <p:spPr>
+          <a:xfrm>
+            <a:off x="914400" y="4270248"/>
+            <a:ext cx="10332720" cy="365760"/>
+          </a:xfrm>
+          <a:prstGeom prst="rect">
+            <a:avLst/>
+          </a:prstGeom>
+          <a:noFill/>
+          <a:ln/>
+        </p:spPr>
+        <p:txBody>
+          <a:bodyPr wrap="square" rtlCol="0" anchor="ctr"/>
+          <a:lstStyle/>
+          <a:p>
+            <a:pPr indent="0" marL="0">
+              <a:buNone/>
+            </a:pPr>
+            <a:r>
+              <a:rPr lang="en-US" sz="1400" b="1" dirty="0">
+                <a:solidFill>
+                  <a:srgbClr val="1B1F3B"/>
+                </a:solidFill>
+                <a:latin typeface="Segoe UI" pitchFamily="34" charset="0"/>
+                <a:ea typeface="Segoe UI" pitchFamily="34" charset="-122"/>
+                <a:cs typeface="Segoe UI" pitchFamily="34" charset="-120"/>
+              </a:rPr>
+              <a:t>'Devis signés' devient 'Mes factures'</a:t>
+            </a:r>
+            <a:endParaRPr lang="en-US" sz="1400" dirty="0"/>
+          </a:p>
+        </p:txBody>
+      </p:sp>
+      <p:sp>
+        <p:nvSpPr>
+          <p:cNvPr id="16" name="Text 14"/>
+          <p:cNvSpPr/>
+          <p:nvPr/>
+        </p:nvSpPr>
+        <p:spPr>
+          <a:xfrm>
+            <a:off x="914400" y="4617720"/>
+            <a:ext cx="10332720" cy="594360"/>
+          </a:xfrm>
+          <a:prstGeom prst="rect">
+            <a:avLst/>
+          </a:prstGeom>
+          <a:noFill/>
+          <a:ln/>
+        </p:spPr>
+        <p:txBody>
+          <a:bodyPr wrap="square" rtlCol="0" anchor="ctr"/>
+          <a:lstStyle/>
+          <a:p>
+            <a:pPr indent="0" marL="0">
+              <a:lnSpc>
+                <a:spcPts val="1400"/>
+              </a:lnSpc>
+              <a:buNone/>
+            </a:pPr>
+            <a:r>
+              <a:rPr lang="en-US" sz="1100" dirty="0">
+                <a:solidFill>
+                  <a:srgbClr val="8A7C68"/>
+                </a:solidFill>
+                <a:latin typeface="Segoe UI" pitchFamily="34" charset="0"/>
+                <a:ea typeface="Segoe UI" pitchFamily="34" charset="-122"/>
+                <a:cs typeface="Segoe UI" pitchFamily="34" charset="-120"/>
+              </a:rPr>
+              <a:t>Renommage du titre de section et du message d'état vide sur la page Factures pour parler de factures plutôt que de devis.</a:t>
+            </a:r>
+            <a:endParaRPr lang="en-US" sz="1100" dirty="0"/>
+          </a:p>
+        </p:txBody>
+      </p:sp>
+      <p:sp>
+        <p:nvSpPr>
+          <p:cNvPr id="17" name="Text 15"/>
           <p:cNvSpPr/>
           <p:nvPr/>
         </p:nvSpPr>
@@ -9593,7 +9810,7 @@
       </p:sp>
       <p:sp>
         <p:nvSpPr>
-          <p:cNvPr id="14" name="Text 12"/>
+          <p:cNvPr id="18" name="Text 16"/>
           <p:cNvSpPr/>
           <p:nvPr/>
         </p:nvSpPr>
@@ -10860,7 +11077,7 @@
                 <a:ea typeface="Georgia" pitchFamily="34" charset="-122"/>
                 <a:cs typeface="Georgia" pitchFamily="34" charset="-120"/>
               </a:rPr>
-              <a:t>103</a:t>
+              <a:t>106</a:t>
             </a:r>
             <a:endParaRPr lang="en-US" sz="3200" dirty="0"/>
           </a:p>
@@ -10965,7 +11182,7 @@
                 <a:ea typeface="Georgia" pitchFamily="34" charset="-122"/>
                 <a:cs typeface="Georgia" pitchFamily="34" charset="-120"/>
               </a:rPr>
-              <a:t>50</a:t>
+              <a:t>51</a:t>
             </a:r>
             <a:endParaRPr lang="en-US" sz="3200" dirty="0"/>
           </a:p>
@@ -11070,7 +11287,7 @@
                 <a:ea typeface="Georgia" pitchFamily="34" charset="-122"/>
                 <a:cs typeface="Georgia" pitchFamily="34" charset="-120"/>
               </a:rPr>
-              <a:t>42</a:t>
+              <a:t>44</a:t>
             </a:r>
             <a:endParaRPr lang="en-US" sz="3200" dirty="0"/>
           </a:p>
@@ -11618,7 +11835,7 @@
                 <a:ea typeface="Segoe UI" pitchFamily="34" charset="-122"/>
                 <a:cs typeface="Segoe UI" pitchFamily="34" charset="-120"/>
               </a:rPr>
-              <a:t>42 mise(s) à jour</a:t>
+              <a:t>44 mise(s) à jour</a:t>
             </a:r>
             <a:endParaRPr lang="en-US" sz="1200" dirty="0"/>
           </a:p>
@@ -16827,7 +17044,7 @@
                 <a:ea typeface="Segoe UI" pitchFamily="34" charset="-122"/>
                 <a:cs typeface="Segoe UI" pitchFamily="34" charset="-120"/>
               </a:rPr>
-              <a:t>50 mise(s) à jour</a:t>
+              <a:t>51 mise(s) à jour</a:t>
             </a:r>
             <a:endParaRPr lang="en-US" sz="1200" dirty="0"/>
           </a:p>
@@ -20143,7 +20360,135 @@
       </p:sp>
       <p:sp>
         <p:nvSpPr>
-          <p:cNvPr id="9" name="Text 7"/>
+          <p:cNvPr id="9" name="Shape 7"/>
+          <p:cNvSpPr/>
+          <p:nvPr/>
+        </p:nvSpPr>
+        <p:spPr>
+          <a:xfrm>
+            <a:off x="640080" y="2926080"/>
+            <a:ext cx="10881360" cy="1097280"/>
+          </a:xfrm>
+          <a:prstGeom prst="roundRect">
+            <a:avLst>
+              <a:gd name="adj" fmla="val 5000"/>
+            </a:avLst>
+          </a:prstGeom>
+          <a:solidFill>
+            <a:srgbClr val="FFFFFF"/>
+          </a:solidFill>
+          <a:ln w="12700">
+            <a:solidFill>
+              <a:srgbClr val="E4DCCB"/>
+            </a:solidFill>
+            <a:prstDash val="solid"/>
+          </a:ln>
+        </p:spPr>
+      </p:sp>
+      <p:sp>
+        <p:nvSpPr>
+          <p:cNvPr id="10" name="Shape 8"/>
+          <p:cNvSpPr/>
+          <p:nvPr/>
+        </p:nvSpPr>
+        <p:spPr>
+          <a:xfrm>
+            <a:off x="640080" y="2926080"/>
+            <a:ext cx="54864" cy="1097280"/>
+          </a:xfrm>
+          <a:prstGeom prst="rect">
+            <a:avLst/>
+          </a:prstGeom>
+          <a:solidFill>
+            <a:srgbClr val="9A4C1F"/>
+          </a:solidFill>
+          <a:ln/>
+        </p:spPr>
+      </p:sp>
+      <p:sp>
+        <p:nvSpPr>
+          <p:cNvPr id="11" name="Text 9"/>
+          <p:cNvSpPr/>
+          <p:nvPr/>
+        </p:nvSpPr>
+        <p:spPr>
+          <a:xfrm>
+            <a:off x="914400" y="3035808"/>
+            <a:ext cx="10332720" cy="365760"/>
+          </a:xfrm>
+          <a:prstGeom prst="rect">
+            <a:avLst/>
+          </a:prstGeom>
+          <a:noFill/>
+          <a:ln/>
+        </p:spPr>
+        <p:txBody>
+          <a:bodyPr wrap="square" rtlCol="0" anchor="ctr"/>
+          <a:lstStyle/>
+          <a:p>
+            <a:pPr indent="0" marL="0">
+              <a:buNone/>
+            </a:pPr>
+            <a:r>
+              <a:rPr lang="en-US" sz="1400" b="1" dirty="0">
+                <a:solidFill>
+                  <a:srgbClr val="1B1F3B"/>
+                </a:solidFill>
+                <a:latin typeface="Segoe UI" pitchFamily="34" charset="0"/>
+                <a:ea typeface="Segoe UI" pitchFamily="34" charset="-122"/>
+                <a:cs typeface="Segoe UI" pitchFamily="34" charset="-120"/>
+              </a:rPr>
+              <a:t>Fusion des connexions Client et Ouvrier en un seul onglet 'Particulier'</a:t>
+            </a:r>
+            <a:endParaRPr lang="en-US" sz="1400" dirty="0"/>
+          </a:p>
+        </p:txBody>
+      </p:sp>
+      <p:sp>
+        <p:nvSpPr>
+          <p:cNvPr id="12" name="Text 10"/>
+          <p:cNvSpPr/>
+          <p:nvPr/>
+        </p:nvSpPr>
+        <p:spPr>
+          <a:xfrm>
+            <a:off x="914400" y="3383280"/>
+            <a:ext cx="10332720" cy="594360"/>
+          </a:xfrm>
+          <a:prstGeom prst="rect">
+            <a:avLst/>
+          </a:prstGeom>
+          <a:noFill/>
+          <a:ln/>
+        </p:spPr>
+        <p:txBody>
+          <a:bodyPr wrap="square" rtlCol="0" anchor="ctr"/>
+          <a:lstStyle/>
+          <a:p>
+            <a:pPr indent="0" marL="0">
+              <a:lnSpc>
+                <a:spcPts val="1400"/>
+              </a:lnSpc>
+              <a:buNone/>
+            </a:pPr>
+            <a:r>
+              <a:rPr lang="en-US" sz="1100" dirty="0">
+                <a:solidFill>
+                  <a:srgbClr val="8A7C68"/>
+                </a:solidFill>
+                <a:latin typeface="Segoe UI" pitchFamily="34" charset="0"/>
+                <a:ea typeface="Segoe UI" pitchFamily="34" charset="-122"/>
+                <a:cs typeface="Segoe UI" pitchFamily="34" charset="-120"/>
+              </a:rPr>
+              <a:t>La page de connexion avait 3 onglets (Entreprise / Client / Ouvrier). Client et Ouvrier sont désormais réunis dans un seul onglet 'Particulier' : la personne saisit son identifiant une seule fois, et l'application détecte automatiquement s'il s'agit d'un compte client ou d'un compte ouvrier pour l'envoyer vers le bon espace. Les deux vérifications de mot de passe (avec leur limitation anti-force-brute respective) restent distinctes en coulisses, seul le point d'entrée est unifié.</a:t>
+            </a:r>
+            <a:endParaRPr lang="en-US" sz="1100" dirty="0"/>
+          </a:p>
+        </p:txBody>
+      </p:sp>
+      <p:sp>
+        <p:nvSpPr>
+          <p:cNvPr id="13" name="Text 11"/>
           <p:cNvSpPr/>
           <p:nvPr/>
         </p:nvSpPr>
@@ -20182,7 +20527,7 @@
       </p:sp>
       <p:sp>
         <p:nvSpPr>
-          <p:cNvPr id="10" name="Text 8"/>
+          <p:cNvPr id="14" name="Text 12"/>
           <p:cNvSpPr/>
           <p:nvPr/>
         </p:nvSpPr>
@@ -20909,6 +21254,344 @@
     <p:bg>
       <p:bgPr>
         <a:solidFill>
+          <a:srgbClr val="F3EEE3"/>
+        </a:solidFill>
+      </p:bgPr>
+    </p:bg>
+    <p:spTree>
+      <p:nvGrpSpPr>
+        <p:cNvPr id="1" name=""/>
+        <p:cNvGrpSpPr/>
+        <p:nvPr/>
+      </p:nvGrpSpPr>
+      <p:grpSpPr>
+        <a:xfrm>
+          <a:off x="0" y="0"/>
+          <a:ext cx="0" cy="0"/>
+          <a:chOff x="0" y="0"/>
+          <a:chExt cx="0" cy="0"/>
+        </a:xfrm>
+      </p:grpSpPr>
+      <p:sp>
+        <p:nvSpPr>
+          <p:cNvPr id="2" name="Shape 0"/>
+          <p:cNvSpPr/>
+          <p:nvPr/>
+        </p:nvSpPr>
+        <p:spPr>
+          <a:xfrm>
+            <a:off x="640080" y="411480"/>
+            <a:ext cx="2377440" cy="365760"/>
+          </a:xfrm>
+          <a:prstGeom prst="roundRect">
+            <a:avLst>
+              <a:gd name="adj" fmla="val 50000"/>
+            </a:avLst>
+          </a:prstGeom>
+          <a:solidFill>
+            <a:srgbClr val="F5E6DA"/>
+          </a:solidFill>
+          <a:ln/>
+        </p:spPr>
+      </p:sp>
+      <p:sp>
+        <p:nvSpPr>
+          <p:cNvPr id="3" name="Text 1"/>
+          <p:cNvSpPr/>
+          <p:nvPr/>
+        </p:nvSpPr>
+        <p:spPr>
+          <a:xfrm>
+            <a:off x="640080" y="411480"/>
+            <a:ext cx="2377440" cy="365760"/>
+          </a:xfrm>
+          <a:prstGeom prst="rect">
+            <a:avLst/>
+          </a:prstGeom>
+          <a:noFill/>
+          <a:ln/>
+        </p:spPr>
+        <p:txBody>
+          <a:bodyPr wrap="square" rtlCol="0" anchor="ctr"/>
+          <a:lstStyle/>
+          <a:p>
+            <a:pPr algn="ctr" indent="0" marL="0">
+              <a:buNone/>
+            </a:pPr>
+            <a:r>
+              <a:rPr lang="en-US" sz="1000" b="1" spc="100" kern="0" dirty="0">
+                <a:solidFill>
+                  <a:srgbClr val="9A4C1F"/>
+                </a:solidFill>
+                <a:latin typeface="Segoe UI" pitchFamily="34" charset="0"/>
+                <a:ea typeface="Segoe UI" pitchFamily="34" charset="-122"/>
+                <a:cs typeface="Segoe UI" pitchFamily="34" charset="-120"/>
+              </a:rPr>
+              <a:t>BACKEND</a:t>
+            </a:r>
+            <a:endParaRPr lang="en-US" sz="1000" dirty="0"/>
+          </a:p>
+        </p:txBody>
+      </p:sp>
+      <p:sp>
+        <p:nvSpPr>
+          <p:cNvPr id="4" name="Text 2"/>
+          <p:cNvSpPr/>
+          <p:nvPr/>
+        </p:nvSpPr>
+        <p:spPr>
+          <a:xfrm>
+            <a:off x="640080" y="868680"/>
+            <a:ext cx="10515600" cy="548640"/>
+          </a:xfrm>
+          <a:prstGeom prst="rect">
+            <a:avLst/>
+          </a:prstGeom>
+          <a:noFill/>
+          <a:ln/>
+        </p:spPr>
+        <p:txBody>
+          <a:bodyPr wrap="square" rtlCol="0" anchor="ctr"/>
+          <a:lstStyle/>
+          <a:p>
+            <a:pPr indent="0" marL="0">
+              <a:buNone/>
+            </a:pPr>
+            <a:r>
+              <a:rPr lang="en-US" sz="2400" b="1" dirty="0">
+                <a:solidFill>
+                  <a:srgbClr val="1B1F3B"/>
+                </a:solidFill>
+                <a:latin typeface="Georgia" pitchFamily="34" charset="0"/>
+                <a:ea typeface="Georgia" pitchFamily="34" charset="-122"/>
+                <a:cs typeface="Georgia" pitchFamily="34" charset="-120"/>
+              </a:rPr>
+              <a:t>Maintenance technique</a:t>
+            </a:r>
+            <a:endParaRPr lang="en-US" sz="2400" dirty="0"/>
+          </a:p>
+        </p:txBody>
+      </p:sp>
+      <p:sp>
+        <p:nvSpPr>
+          <p:cNvPr id="5" name="Shape 3"/>
+          <p:cNvSpPr/>
+          <p:nvPr/>
+        </p:nvSpPr>
+        <p:spPr>
+          <a:xfrm>
+            <a:off x="640080" y="1691640"/>
+            <a:ext cx="10881360" cy="1097280"/>
+          </a:xfrm>
+          <a:prstGeom prst="roundRect">
+            <a:avLst>
+              <a:gd name="adj" fmla="val 5000"/>
+            </a:avLst>
+          </a:prstGeom>
+          <a:solidFill>
+            <a:srgbClr val="FFFFFF"/>
+          </a:solidFill>
+          <a:ln w="12700">
+            <a:solidFill>
+              <a:srgbClr val="E4DCCB"/>
+            </a:solidFill>
+            <a:prstDash val="solid"/>
+          </a:ln>
+        </p:spPr>
+      </p:sp>
+      <p:sp>
+        <p:nvSpPr>
+          <p:cNvPr id="6" name="Shape 4"/>
+          <p:cNvSpPr/>
+          <p:nvPr/>
+        </p:nvSpPr>
+        <p:spPr>
+          <a:xfrm>
+            <a:off x="640080" y="1691640"/>
+            <a:ext cx="54864" cy="1097280"/>
+          </a:xfrm>
+          <a:prstGeom prst="rect">
+            <a:avLst/>
+          </a:prstGeom>
+          <a:solidFill>
+            <a:srgbClr val="9A4C1F"/>
+          </a:solidFill>
+          <a:ln/>
+        </p:spPr>
+      </p:sp>
+      <p:sp>
+        <p:nvSpPr>
+          <p:cNvPr id="7" name="Text 5"/>
+          <p:cNvSpPr/>
+          <p:nvPr/>
+        </p:nvSpPr>
+        <p:spPr>
+          <a:xfrm>
+            <a:off x="914400" y="1801368"/>
+            <a:ext cx="10332720" cy="365760"/>
+          </a:xfrm>
+          <a:prstGeom prst="rect">
+            <a:avLst/>
+          </a:prstGeom>
+          <a:noFill/>
+          <a:ln/>
+        </p:spPr>
+        <p:txBody>
+          <a:bodyPr wrap="square" rtlCol="0" anchor="ctr"/>
+          <a:lstStyle/>
+          <a:p>
+            <a:pPr indent="0" marL="0">
+              <a:buNone/>
+            </a:pPr>
+            <a:r>
+              <a:rPr lang="en-US" sz="1400" b="1" dirty="0">
+                <a:solidFill>
+                  <a:srgbClr val="1B1F3B"/>
+                </a:solidFill>
+                <a:latin typeface="Segoe UI" pitchFamily="34" charset="0"/>
+                <a:ea typeface="Segoe UI" pitchFamily="34" charset="-122"/>
+                <a:cs typeface="Segoe UI" pitchFamily="34" charset="-120"/>
+              </a:rPr>
+              <a:t>Correction d'une erreur console en développement</a:t>
+            </a:r>
+            <a:endParaRPr lang="en-US" sz="1400" dirty="0"/>
+          </a:p>
+        </p:txBody>
+      </p:sp>
+      <p:sp>
+        <p:nvSpPr>
+          <p:cNvPr id="8" name="Text 6"/>
+          <p:cNvSpPr/>
+          <p:nvPr/>
+        </p:nvSpPr>
+        <p:spPr>
+          <a:xfrm>
+            <a:off x="914400" y="2148840"/>
+            <a:ext cx="10332720" cy="594360"/>
+          </a:xfrm>
+          <a:prstGeom prst="rect">
+            <a:avLst/>
+          </a:prstGeom>
+          <a:noFill/>
+          <a:ln/>
+        </p:spPr>
+        <p:txBody>
+          <a:bodyPr wrap="square" rtlCol="0" anchor="ctr"/>
+          <a:lstStyle/>
+          <a:p>
+            <a:pPr indent="0" marL="0">
+              <a:lnSpc>
+                <a:spcPts val="1400"/>
+              </a:lnSpc>
+              <a:buNone/>
+            </a:pPr>
+            <a:r>
+              <a:rPr lang="en-US" sz="1100" dirty="0">
+                <a:solidFill>
+                  <a:srgbClr val="8A7C68"/>
+                </a:solidFill>
+                <a:latin typeface="Segoe UI" pitchFamily="34" charset="0"/>
+                <a:ea typeface="Segoe UI" pitchFamily="34" charset="-122"/>
+                <a:cs typeface="Segoe UI" pitchFamily="34" charset="-120"/>
+              </a:rPr>
+              <a:t>Le serveur de développement (Turbopack) affichait une erreur liée a la politique de sécurité du contenu (CSP) durcie lors de l'audit sécurité — celle-ci bloquait une fonctionnalité de débogage propre au mode développement. Corrigé sans rien changer à la sécurité de la version en production.</a:t>
+            </a:r>
+            <a:endParaRPr lang="en-US" sz="1100" dirty="0"/>
+          </a:p>
+        </p:txBody>
+      </p:sp>
+      <p:sp>
+        <p:nvSpPr>
+          <p:cNvPr id="9" name="Text 7"/>
+          <p:cNvSpPr/>
+          <p:nvPr/>
+        </p:nvSpPr>
+        <p:spPr>
+          <a:xfrm>
+            <a:off x="365760" y="6510528"/>
+            <a:ext cx="5486400" cy="274320"/>
+          </a:xfrm>
+          <a:prstGeom prst="rect">
+            <a:avLst/>
+          </a:prstGeom>
+          <a:noFill/>
+          <a:ln/>
+        </p:spPr>
+        <p:txBody>
+          <a:bodyPr wrap="square" rtlCol="0" anchor="ctr"/>
+          <a:lstStyle/>
+          <a:p>
+            <a:pPr indent="0" marL="0">
+              <a:buNone/>
+            </a:pPr>
+            <a:r>
+              <a:rPr lang="en-US" sz="900" dirty="0">
+                <a:solidFill>
+                  <a:srgbClr val="8A7C68"/>
+                </a:solidFill>
+                <a:latin typeface="Segoe UI" pitchFamily="34" charset="0"/>
+                <a:ea typeface="Segoe UI" pitchFamily="34" charset="-122"/>
+                <a:cs typeface="Segoe UI" pitchFamily="34" charset="-120"/>
+              </a:rPr>
+              <a:t>Kôji Web — Récapitulatif technique</a:t>
+            </a:r>
+            <a:endParaRPr lang="en-US" sz="900" dirty="0"/>
+          </a:p>
+        </p:txBody>
+      </p:sp>
+      <p:sp>
+        <p:nvSpPr>
+          <p:cNvPr id="10" name="Text 8"/>
+          <p:cNvSpPr/>
+          <p:nvPr/>
+        </p:nvSpPr>
+        <p:spPr>
+          <a:xfrm>
+            <a:off x="9601200" y="6510528"/>
+            <a:ext cx="2194560" cy="274320"/>
+          </a:xfrm>
+          <a:prstGeom prst="rect">
+            <a:avLst/>
+          </a:prstGeom>
+          <a:noFill/>
+          <a:ln/>
+        </p:spPr>
+        <p:txBody>
+          <a:bodyPr wrap="square" rtlCol="0" anchor="ctr"/>
+          <a:lstStyle/>
+          <a:p>
+            <a:pPr algn="r" indent="0" marL="0">
+              <a:buNone/>
+            </a:pPr>
+            <a:r>
+              <a:rPr lang="en-US" sz="900" dirty="0">
+                <a:solidFill>
+                  <a:srgbClr val="8A7C68"/>
+                </a:solidFill>
+                <a:latin typeface="Segoe UI" pitchFamily="34" charset="0"/>
+                <a:ea typeface="Segoe UI" pitchFamily="34" charset="-122"/>
+                <a:cs typeface="Segoe UI" pitchFamily="34" charset="-120"/>
+              </a:rPr>
+              <a:t>38</a:t>
+            </a:r>
+            <a:endParaRPr lang="en-US" sz="900" dirty="0"/>
+          </a:p>
+        </p:txBody>
+      </p:sp>
+    </p:spTree>
+  </p:cSld>
+  <p:clrMapOvr>
+    <a:masterClrMapping/>
+  </p:clrMapOvr>
+</p:sld>
+</file>
+
+<file path=ppt/slides/slide39.xml><?xml version="1.0" encoding="utf-8"?>
+<p:sld xmlns:a="http://schemas.openxmlformats.org/drawingml/2006/main" xmlns:r="http://schemas.openxmlformats.org/officeDocument/2006/relationships" xmlns:p="http://schemas.openxmlformats.org/presentationml/2006/main">
+  <p:cSld name="Slide 39">
+    <p:bg>
+      <p:bgPr>
+        <a:solidFill>
           <a:srgbClr val="0B1030"/>
         </a:solidFill>
       </p:bgPr>
@@ -21106,344 +21789,6 @@
       <p:sp>
         <p:nvSpPr>
           <p:cNvPr id="7" name="Text 5"/>
-          <p:cNvSpPr/>
-          <p:nvPr/>
-        </p:nvSpPr>
-        <p:spPr>
-          <a:xfrm>
-            <a:off x="9601200" y="6510528"/>
-            <a:ext cx="2194560" cy="274320"/>
-          </a:xfrm>
-          <a:prstGeom prst="rect">
-            <a:avLst/>
-          </a:prstGeom>
-          <a:noFill/>
-          <a:ln/>
-        </p:spPr>
-        <p:txBody>
-          <a:bodyPr wrap="square" rtlCol="0" anchor="ctr"/>
-          <a:lstStyle/>
-          <a:p>
-            <a:pPr algn="r" indent="0" marL="0">
-              <a:buNone/>
-            </a:pPr>
-            <a:r>
-              <a:rPr lang="en-US" sz="900" dirty="0">
-                <a:solidFill>
-                  <a:srgbClr val="8A7C68"/>
-                </a:solidFill>
-                <a:latin typeface="Segoe UI" pitchFamily="34" charset="0"/>
-                <a:ea typeface="Segoe UI" pitchFamily="34" charset="-122"/>
-                <a:cs typeface="Segoe UI" pitchFamily="34" charset="-120"/>
-              </a:rPr>
-              <a:t>38</a:t>
-            </a:r>
-            <a:endParaRPr lang="en-US" sz="900" dirty="0"/>
-          </a:p>
-        </p:txBody>
-      </p:sp>
-    </p:spTree>
-  </p:cSld>
-  <p:clrMapOvr>
-    <a:masterClrMapping/>
-  </p:clrMapOvr>
-</p:sld>
-</file>
-
-<file path=ppt/slides/slide39.xml><?xml version="1.0" encoding="utf-8"?>
-<p:sld xmlns:a="http://schemas.openxmlformats.org/drawingml/2006/main" xmlns:r="http://schemas.openxmlformats.org/officeDocument/2006/relationships" xmlns:p="http://schemas.openxmlformats.org/presentationml/2006/main">
-  <p:cSld name="Slide 39">
-    <p:bg>
-      <p:bgPr>
-        <a:solidFill>
-          <a:srgbClr val="F3EEE3"/>
-        </a:solidFill>
-      </p:bgPr>
-    </p:bg>
-    <p:spTree>
-      <p:nvGrpSpPr>
-        <p:cNvPr id="1" name=""/>
-        <p:cNvGrpSpPr/>
-        <p:nvPr/>
-      </p:nvGrpSpPr>
-      <p:grpSpPr>
-        <a:xfrm>
-          <a:off x="0" y="0"/>
-          <a:ext cx="0" cy="0"/>
-          <a:chOff x="0" y="0"/>
-          <a:chExt cx="0" cy="0"/>
-        </a:xfrm>
-      </p:grpSpPr>
-      <p:sp>
-        <p:nvSpPr>
-          <p:cNvPr id="2" name="Shape 0"/>
-          <p:cNvSpPr/>
-          <p:nvPr/>
-        </p:nvSpPr>
-        <p:spPr>
-          <a:xfrm>
-            <a:off x="640080" y="411480"/>
-            <a:ext cx="2377440" cy="365760"/>
-          </a:xfrm>
-          <a:prstGeom prst="roundRect">
-            <a:avLst>
-              <a:gd name="adj" fmla="val 50000"/>
-            </a:avLst>
-          </a:prstGeom>
-          <a:solidFill>
-            <a:srgbClr val="E6EFE4"/>
-          </a:solidFill>
-          <a:ln/>
-        </p:spPr>
-      </p:sp>
-      <p:sp>
-        <p:nvSpPr>
-          <p:cNvPr id="3" name="Text 1"/>
-          <p:cNvSpPr/>
-          <p:nvPr/>
-        </p:nvSpPr>
-        <p:spPr>
-          <a:xfrm>
-            <a:off x="640080" y="411480"/>
-            <a:ext cx="2377440" cy="365760"/>
-          </a:xfrm>
-          <a:prstGeom prst="rect">
-            <a:avLst/>
-          </a:prstGeom>
-          <a:noFill/>
-          <a:ln/>
-        </p:spPr>
-        <p:txBody>
-          <a:bodyPr wrap="square" rtlCol="0" anchor="ctr"/>
-          <a:lstStyle/>
-          <a:p>
-            <a:pPr algn="ctr" indent="0" marL="0">
-              <a:buNone/>
-            </a:pPr>
-            <a:r>
-              <a:rPr lang="en-US" sz="1000" b="1" spc="100" kern="0" dirty="0">
-                <a:solidFill>
-                  <a:srgbClr val="386641"/>
-                </a:solidFill>
-                <a:latin typeface="Segoe UI" pitchFamily="34" charset="0"/>
-                <a:ea typeface="Segoe UI" pitchFamily="34" charset="-122"/>
-                <a:cs typeface="Segoe UI" pitchFamily="34" charset="-120"/>
-              </a:rPr>
-              <a:t>BASE DE DONNÉES</a:t>
-            </a:r>
-            <a:endParaRPr lang="en-US" sz="1000" dirty="0"/>
-          </a:p>
-        </p:txBody>
-      </p:sp>
-      <p:sp>
-        <p:nvSpPr>
-          <p:cNvPr id="4" name="Text 2"/>
-          <p:cNvSpPr/>
-          <p:nvPr/>
-        </p:nvSpPr>
-        <p:spPr>
-          <a:xfrm>
-            <a:off x="640080" y="868680"/>
-            <a:ext cx="10515600" cy="548640"/>
-          </a:xfrm>
-          <a:prstGeom prst="rect">
-            <a:avLst/>
-          </a:prstGeom>
-          <a:noFill/>
-          <a:ln/>
-        </p:spPr>
-        <p:txBody>
-          <a:bodyPr wrap="square" rtlCol="0" anchor="ctr"/>
-          <a:lstStyle/>
-          <a:p>
-            <a:pPr indent="0" marL="0">
-              <a:buNone/>
-            </a:pPr>
-            <a:r>
-              <a:rPr lang="en-US" sz="2400" b="1" dirty="0">
-                <a:solidFill>
-                  <a:srgbClr val="1B1F3B"/>
-                </a:solidFill>
-                <a:latin typeface="Georgia" pitchFamily="34" charset="0"/>
-                <a:ea typeface="Georgia" pitchFamily="34" charset="-122"/>
-                <a:cs typeface="Georgia" pitchFamily="34" charset="-120"/>
-              </a:rPr>
-              <a:t>Fondations</a:t>
-            </a:r>
-            <a:endParaRPr lang="en-US" sz="2400" dirty="0"/>
-          </a:p>
-        </p:txBody>
-      </p:sp>
-      <p:sp>
-        <p:nvSpPr>
-          <p:cNvPr id="5" name="Shape 3"/>
-          <p:cNvSpPr/>
-          <p:nvPr/>
-        </p:nvSpPr>
-        <p:spPr>
-          <a:xfrm>
-            <a:off x="640080" y="1691640"/>
-            <a:ext cx="10881360" cy="1097280"/>
-          </a:xfrm>
-          <a:prstGeom prst="roundRect">
-            <a:avLst>
-              <a:gd name="adj" fmla="val 5000"/>
-            </a:avLst>
-          </a:prstGeom>
-          <a:solidFill>
-            <a:srgbClr val="FFFFFF"/>
-          </a:solidFill>
-          <a:ln w="12700">
-            <a:solidFill>
-              <a:srgbClr val="E4DCCB"/>
-            </a:solidFill>
-            <a:prstDash val="solid"/>
-          </a:ln>
-        </p:spPr>
-      </p:sp>
-      <p:sp>
-        <p:nvSpPr>
-          <p:cNvPr id="6" name="Shape 4"/>
-          <p:cNvSpPr/>
-          <p:nvPr/>
-        </p:nvSpPr>
-        <p:spPr>
-          <a:xfrm>
-            <a:off x="640080" y="1691640"/>
-            <a:ext cx="54864" cy="1097280"/>
-          </a:xfrm>
-          <a:prstGeom prst="rect">
-            <a:avLst/>
-          </a:prstGeom>
-          <a:solidFill>
-            <a:srgbClr val="386641"/>
-          </a:solidFill>
-          <a:ln/>
-        </p:spPr>
-      </p:sp>
-      <p:sp>
-        <p:nvSpPr>
-          <p:cNvPr id="7" name="Text 5"/>
-          <p:cNvSpPr/>
-          <p:nvPr/>
-        </p:nvSpPr>
-        <p:spPr>
-          <a:xfrm>
-            <a:off x="914400" y="1801368"/>
-            <a:ext cx="10332720" cy="365760"/>
-          </a:xfrm>
-          <a:prstGeom prst="rect">
-            <a:avLst/>
-          </a:prstGeom>
-          <a:noFill/>
-          <a:ln/>
-        </p:spPr>
-        <p:txBody>
-          <a:bodyPr wrap="square" rtlCol="0" anchor="ctr"/>
-          <a:lstStyle/>
-          <a:p>
-            <a:pPr indent="0" marL="0">
-              <a:buNone/>
-            </a:pPr>
-            <a:r>
-              <a:rPr lang="en-US" sz="1400" b="1" dirty="0">
-                <a:solidFill>
-                  <a:srgbClr val="1B1F3B"/>
-                </a:solidFill>
-                <a:latin typeface="Segoe UI" pitchFamily="34" charset="0"/>
-                <a:ea typeface="Segoe UI" pitchFamily="34" charset="-122"/>
-                <a:cs typeface="Segoe UI" pitchFamily="34" charset="-120"/>
-              </a:rPr>
-              <a:t>Connexion Vercel / configuration environnement</a:t>
-            </a:r>
-            <a:endParaRPr lang="en-US" sz="1400" dirty="0"/>
-          </a:p>
-        </p:txBody>
-      </p:sp>
-      <p:sp>
-        <p:nvSpPr>
-          <p:cNvPr id="8" name="Text 6"/>
-          <p:cNvSpPr/>
-          <p:nvPr/>
-        </p:nvSpPr>
-        <p:spPr>
-          <a:xfrm>
-            <a:off x="914400" y="2148840"/>
-            <a:ext cx="10332720" cy="594360"/>
-          </a:xfrm>
-          <a:prstGeom prst="rect">
-            <a:avLst/>
-          </a:prstGeom>
-          <a:noFill/>
-          <a:ln/>
-        </p:spPr>
-        <p:txBody>
-          <a:bodyPr wrap="square" rtlCol="0" anchor="ctr"/>
-          <a:lstStyle/>
-          <a:p>
-            <a:pPr indent="0" marL="0">
-              <a:lnSpc>
-                <a:spcPts val="1400"/>
-              </a:lnSpc>
-              <a:buNone/>
-            </a:pPr>
-            <a:r>
-              <a:rPr lang="en-US" sz="1100" dirty="0">
-                <a:solidFill>
-                  <a:srgbClr val="8A7C68"/>
-                </a:solidFill>
-                <a:latin typeface="Segoe UI" pitchFamily="34" charset="0"/>
-                <a:ea typeface="Segoe UI" pitchFamily="34" charset="-122"/>
-                <a:cs typeface="Segoe UI" pitchFamily="34" charset="-120"/>
-              </a:rPr>
-              <a:t>Correction de la configuration d'authentification et du SMTP sur l'environnement de production Vercel.</a:t>
-            </a:r>
-            <a:endParaRPr lang="en-US" sz="1100" dirty="0"/>
-          </a:p>
-        </p:txBody>
-      </p:sp>
-      <p:sp>
-        <p:nvSpPr>
-          <p:cNvPr id="9" name="Text 7"/>
-          <p:cNvSpPr/>
-          <p:nvPr/>
-        </p:nvSpPr>
-        <p:spPr>
-          <a:xfrm>
-            <a:off x="365760" y="6510528"/>
-            <a:ext cx="5486400" cy="274320"/>
-          </a:xfrm>
-          <a:prstGeom prst="rect">
-            <a:avLst/>
-          </a:prstGeom>
-          <a:noFill/>
-          <a:ln/>
-        </p:spPr>
-        <p:txBody>
-          <a:bodyPr wrap="square" rtlCol="0" anchor="ctr"/>
-          <a:lstStyle/>
-          <a:p>
-            <a:pPr indent="0" marL="0">
-              <a:buNone/>
-            </a:pPr>
-            <a:r>
-              <a:rPr lang="en-US" sz="900" dirty="0">
-                <a:solidFill>
-                  <a:srgbClr val="8A7C68"/>
-                </a:solidFill>
-                <a:latin typeface="Segoe UI" pitchFamily="34" charset="0"/>
-                <a:ea typeface="Segoe UI" pitchFamily="34" charset="-122"/>
-                <a:cs typeface="Segoe UI" pitchFamily="34" charset="-120"/>
-              </a:rPr>
-              <a:t>Kôji Web — Récapitulatif technique</a:t>
-            </a:r>
-            <a:endParaRPr lang="en-US" sz="900" dirty="0"/>
-          </a:p>
-        </p:txBody>
-      </p:sp>
-      <p:sp>
-        <p:nvSpPr>
-          <p:cNvPr id="10" name="Text 8"/>
           <p:cNvSpPr/>
           <p:nvPr/>
         </p:nvSpPr>
@@ -22328,7 +22673,7 @@
                 <a:ea typeface="Georgia" pitchFamily="34" charset="-122"/>
                 <a:cs typeface="Georgia" pitchFamily="34" charset="-120"/>
               </a:rPr>
-              <a:t>Devis</a:t>
+              <a:t>Fondations</a:t>
             </a:r>
             <a:endParaRPr lang="en-US" sz="2400" dirty="0"/>
           </a:p>
@@ -22414,7 +22759,7 @@
                 <a:ea typeface="Segoe UI" pitchFamily="34" charset="-122"/>
                 <a:cs typeface="Segoe UI" pitchFamily="34" charset="-120"/>
               </a:rPr>
-              <a:t>Migration des devis vers Supabase (table partagée)</a:t>
+              <a:t>Connexion Vercel / configuration environnement</a:t>
             </a:r>
             <a:endParaRPr lang="en-US" sz="1400" dirty="0"/>
           </a:p>
@@ -22456,7 +22801,7 @@
                 <a:ea typeface="Segoe UI" pitchFamily="34" charset="-122"/>
                 <a:cs typeface="Segoe UI" pitchFamily="34" charset="-120"/>
               </a:rPr>
-              <a:t>Les devis créés sur le site web et sur l'application mobile (Firas) vivent désormais dans la même table Supabase 'quotes', avec un mapping bidirectionnel dédié (lib/quote-mapping.js).</a:t>
+              <a:t>Correction de la configuration d'authentification et du SMTP sur l'environnement de production Vercel.</a:t>
             </a:r>
             <a:endParaRPr lang="en-US" sz="1100" dirty="0"/>
           </a:p>
@@ -22666,7 +23011,7 @@
                 <a:ea typeface="Georgia" pitchFamily="34" charset="-122"/>
                 <a:cs typeface="Georgia" pitchFamily="34" charset="-120"/>
               </a:rPr>
-              <a:t>Chantiers</a:t>
+              <a:t>Devis</a:t>
             </a:r>
             <a:endParaRPr lang="en-US" sz="2400" dirty="0"/>
           </a:p>
@@ -22752,7 +23097,7 @@
                 <a:ea typeface="Segoe UI" pitchFamily="34" charset="-122"/>
                 <a:cs typeface="Segoe UI" pitchFamily="34" charset="-120"/>
               </a:rPr>
-              <a:t>Connexion Supabase : chantiers, planning, fournitures</a:t>
+              <a:t>Migration des devis vers Supabase (table partagée)</a:t>
             </a:r>
             <a:endParaRPr lang="en-US" sz="1400" dirty="0"/>
           </a:p>
@@ -22794,7 +23139,7 @@
                 <a:ea typeface="Segoe UI" pitchFamily="34" charset="-122"/>
                 <a:cs typeface="Segoe UI" pitchFamily="34" charset="-120"/>
               </a:rPr>
-              <a:t>Ces trois modules sont branchés sur la base partagée avec l'application mobile ; les comptes utilisateurs sont également partagés entre les deux plateformes.</a:t>
+              <a:t>Les devis créés sur le site web et sur l'application mobile (Firas) vivent désormais dans la même table Supabase 'quotes', avec un mapping bidirectionnel dédié (lib/quote-mapping.js).</a:t>
             </a:r>
             <a:endParaRPr lang="en-US" sz="1100" dirty="0"/>
           </a:p>
@@ -23004,7 +23349,7 @@
                 <a:ea typeface="Georgia" pitchFamily="34" charset="-122"/>
                 <a:cs typeface="Georgia" pitchFamily="34" charset="-120"/>
               </a:rPr>
-              <a:t>Équipe</a:t>
+              <a:t>Chantiers</a:t>
             </a:r>
             <a:endParaRPr lang="en-US" sz="2400" dirty="0"/>
           </a:p>
@@ -23090,7 +23435,7 @@
                 <a:ea typeface="Segoe UI" pitchFamily="34" charset="-122"/>
                 <a:cs typeface="Segoe UI" pitchFamily="34" charset="-120"/>
               </a:rPr>
-              <a:t>Nouvelle donnée : heures contractuelles par ouvrier</a:t>
+              <a:t>Connexion Supabase : chantiers, planning, fournitures</a:t>
             </a:r>
             <a:endParaRPr lang="en-US" sz="1400" dirty="0"/>
           </a:p>
@@ -23132,7 +23477,7 @@
                 <a:ea typeface="Segoe UI" pitchFamily="34" charset="-122"/>
                 <a:cs typeface="Segoe UI" pitchFamily="34" charset="-120"/>
               </a:rPr>
-              <a:t>Ajout d'un paramètre 'heures contractuelles / semaine' (35h par défaut) sur chaque fiche ouvrier, utilisé pour le calcul des écarts.</a:t>
+              <a:t>Ces trois modules sont branchés sur la base partagée avec l'application mobile ; les comptes utilisateurs sont également partagés entre les deux plateformes.</a:t>
             </a:r>
             <a:endParaRPr lang="en-US" sz="1100" dirty="0"/>
           </a:p>
@@ -23342,7 +23687,7 @@
                 <a:ea typeface="Georgia" pitchFamily="34" charset="-122"/>
                 <a:cs typeface="Georgia" pitchFamily="34" charset="-120"/>
               </a:rPr>
-              <a:t>Accueil &amp; stabilité</a:t>
+              <a:t>Équipe</a:t>
             </a:r>
             <a:endParaRPr lang="en-US" sz="2400" dirty="0"/>
           </a:p>
@@ -23428,7 +23773,7 @@
                 <a:ea typeface="Segoe UI" pitchFamily="34" charset="-122"/>
                 <a:cs typeface="Segoe UI" pitchFamily="34" charset="-120"/>
               </a:rPr>
-              <a:t>Nettoyage du backend</a:t>
+              <a:t>Nouvelle donnée : heures contractuelles par ouvrier</a:t>
             </a:r>
             <a:endParaRPr lang="en-US" sz="1400" dirty="0"/>
           </a:p>
@@ -23470,7 +23815,7 @@
                 <a:ea typeface="Segoe UI" pitchFamily="34" charset="-122"/>
                 <a:cs typeface="Segoe UI" pitchFamily="34" charset="-120"/>
               </a:rPr>
-              <a:t>Audit complet des routes serveur : suppression du code mort (module Marketplace), vérification de la cohérence entre données locales et données Supabase sur l'ensemble de l'application.</a:t>
+              <a:t>Ajout d'un paramètre 'heures contractuelles / semaine' (35h par défaut) sur chaque fiche ouvrier, utilisé pour le calcul des écarts.</a:t>
             </a:r>
             <a:endParaRPr lang="en-US" sz="1100" dirty="0"/>
           </a:p>
@@ -23680,7 +24025,7 @@
                 <a:ea typeface="Georgia" pitchFamily="34" charset="-122"/>
                 <a:cs typeface="Georgia" pitchFamily="34" charset="-120"/>
               </a:rPr>
-              <a:t>Maintenance technique</a:t>
+              <a:t>Accueil &amp; stabilité</a:t>
             </a:r>
             <a:endParaRPr lang="en-US" sz="2400" dirty="0"/>
           </a:p>
@@ -23766,7 +24111,7 @@
                 <a:ea typeface="Segoe UI" pitchFamily="34" charset="-122"/>
                 <a:cs typeface="Segoe UI" pitchFamily="34" charset="-120"/>
               </a:rPr>
-              <a:t>Nettoyage approfondi du code</a:t>
+              <a:t>Nettoyage du backend</a:t>
             </a:r>
             <a:endParaRPr lang="en-US" sz="1400" dirty="0"/>
           </a:p>
@@ -23808,7 +24153,7 @@
                 <a:ea typeface="Segoe UI" pitchFamily="34" charset="-122"/>
                 <a:cs typeface="Segoe UI" pitchFamily="34" charset="-120"/>
               </a:rPr>
-              <a:t>Audit complet du projet (pages, routes, fonctions, dépendances) pour repérer tout ce qui n'était plus utilisé ; suppression de 6 pages orphelines (onboarding, welcome, compte, anciennes pages devis en 3 étapes), d'une route de connexion de démonstration, d'un dossier de composants dupliqué obsolète, de plusieurs fonctions inutilisées et d'une dépendance logicielle non utilisée — sans toucher aux fonctionnalités actives.</a:t>
+              <a:t>Audit complet des routes serveur : suppression du code mort (module Marketplace), vérification de la cohérence entre données locales et données Supabase sur l'ensemble de l'application.</a:t>
             </a:r>
             <a:endParaRPr lang="en-US" sz="1100" dirty="0"/>
           </a:p>
@@ -23816,263 +24161,7 @@
       </p:sp>
       <p:sp>
         <p:nvSpPr>
-          <p:cNvPr id="9" name="Shape 7"/>
-          <p:cNvSpPr/>
-          <p:nvPr/>
-        </p:nvSpPr>
-        <p:spPr>
-          <a:xfrm>
-            <a:off x="640080" y="2926080"/>
-            <a:ext cx="10881360" cy="1097280"/>
-          </a:xfrm>
-          <a:prstGeom prst="roundRect">
-            <a:avLst>
-              <a:gd name="adj" fmla="val 5000"/>
-            </a:avLst>
-          </a:prstGeom>
-          <a:solidFill>
-            <a:srgbClr val="FFFFFF"/>
-          </a:solidFill>
-          <a:ln w="12700">
-            <a:solidFill>
-              <a:srgbClr val="E4DCCB"/>
-            </a:solidFill>
-            <a:prstDash val="solid"/>
-          </a:ln>
-        </p:spPr>
-      </p:sp>
-      <p:sp>
-        <p:nvSpPr>
-          <p:cNvPr id="10" name="Shape 8"/>
-          <p:cNvSpPr/>
-          <p:nvPr/>
-        </p:nvSpPr>
-        <p:spPr>
-          <a:xfrm>
-            <a:off x="640080" y="2926080"/>
-            <a:ext cx="54864" cy="1097280"/>
-          </a:xfrm>
-          <a:prstGeom prst="rect">
-            <a:avLst/>
-          </a:prstGeom>
-          <a:solidFill>
-            <a:srgbClr val="386641"/>
-          </a:solidFill>
-          <a:ln/>
-        </p:spPr>
-      </p:sp>
-      <p:sp>
-        <p:nvSpPr>
-          <p:cNvPr id="11" name="Text 9"/>
-          <p:cNvSpPr/>
-          <p:nvPr/>
-        </p:nvSpPr>
-        <p:spPr>
-          <a:xfrm>
-            <a:off x="914400" y="3035808"/>
-            <a:ext cx="10332720" cy="365760"/>
-          </a:xfrm>
-          <a:prstGeom prst="rect">
-            <a:avLst/>
-          </a:prstGeom>
-          <a:noFill/>
-          <a:ln/>
-        </p:spPr>
-        <p:txBody>
-          <a:bodyPr wrap="square" rtlCol="0" anchor="ctr"/>
-          <a:lstStyle/>
-          <a:p>
-            <a:pPr indent="0" marL="0">
-              <a:buNone/>
-            </a:pPr>
-            <a:r>
-              <a:rPr lang="en-US" sz="1400" b="1" dirty="0">
-                <a:solidFill>
-                  <a:srgbClr val="1B1F3B"/>
-                </a:solidFill>
-                <a:latin typeface="Segoe UI" pitchFamily="34" charset="0"/>
-                <a:ea typeface="Segoe UI" pitchFamily="34" charset="-122"/>
-                <a:cs typeface="Segoe UI" pitchFamily="34" charset="-120"/>
-              </a:rPr>
-              <a:t>Suppression de code mort dans la génération de devis</a:t>
-            </a:r>
-            <a:endParaRPr lang="en-US" sz="1400" dirty="0"/>
-          </a:p>
-        </p:txBody>
-      </p:sp>
-      <p:sp>
-        <p:nvSpPr>
-          <p:cNvPr id="12" name="Text 10"/>
-          <p:cNvSpPr/>
-          <p:nvPr/>
-        </p:nvSpPr>
-        <p:spPr>
-          <a:xfrm>
-            <a:off x="914400" y="3383280"/>
-            <a:ext cx="10332720" cy="594360"/>
-          </a:xfrm>
-          <a:prstGeom prst="rect">
-            <a:avLst/>
-          </a:prstGeom>
-          <a:noFill/>
-          <a:ln/>
-        </p:spPr>
-        <p:txBody>
-          <a:bodyPr wrap="square" rtlCol="0" anchor="ctr"/>
-          <a:lstStyle/>
-          <a:p>
-            <a:pPr indent="0" marL="0">
-              <a:lnSpc>
-                <a:spcPts val="1400"/>
-              </a:lnSpc>
-              <a:buNone/>
-            </a:pPr>
-            <a:r>
-              <a:rPr lang="en-US" sz="1100" dirty="0">
-                <a:solidFill>
-                  <a:srgbClr val="8A7C68"/>
-                </a:solidFill>
-                <a:latin typeface="Segoe UI" pitchFamily="34" charset="0"/>
-                <a:ea typeface="Segoe UI" pitchFamily="34" charset="-122"/>
-                <a:cs typeface="Segoe UI" pitchFamily="34" charset="-120"/>
-              </a:rPr>
-              <a:t>Un ancien générateur de devis PDF, devenu inaccessible après une précédente refonte (code jamais exécuté), a été retiré du fichier technique de génération de documents.</a:t>
-            </a:r>
-            <a:endParaRPr lang="en-US" sz="1100" dirty="0"/>
-          </a:p>
-        </p:txBody>
-      </p:sp>
-      <p:sp>
-        <p:nvSpPr>
-          <p:cNvPr id="13" name="Shape 11"/>
-          <p:cNvSpPr/>
-          <p:nvPr/>
-        </p:nvSpPr>
-        <p:spPr>
-          <a:xfrm>
-            <a:off x="640080" y="4160520"/>
-            <a:ext cx="10881360" cy="1097280"/>
-          </a:xfrm>
-          <a:prstGeom prst="roundRect">
-            <a:avLst>
-              <a:gd name="adj" fmla="val 5000"/>
-            </a:avLst>
-          </a:prstGeom>
-          <a:solidFill>
-            <a:srgbClr val="FFFFFF"/>
-          </a:solidFill>
-          <a:ln w="12700">
-            <a:solidFill>
-              <a:srgbClr val="E4DCCB"/>
-            </a:solidFill>
-            <a:prstDash val="solid"/>
-          </a:ln>
-        </p:spPr>
-      </p:sp>
-      <p:sp>
-        <p:nvSpPr>
-          <p:cNvPr id="14" name="Shape 12"/>
-          <p:cNvSpPr/>
-          <p:nvPr/>
-        </p:nvSpPr>
-        <p:spPr>
-          <a:xfrm>
-            <a:off x="640080" y="4160520"/>
-            <a:ext cx="54864" cy="1097280"/>
-          </a:xfrm>
-          <a:prstGeom prst="rect">
-            <a:avLst/>
-          </a:prstGeom>
-          <a:solidFill>
-            <a:srgbClr val="386641"/>
-          </a:solidFill>
-          <a:ln/>
-        </p:spPr>
-      </p:sp>
-      <p:sp>
-        <p:nvSpPr>
-          <p:cNvPr id="15" name="Text 13"/>
-          <p:cNvSpPr/>
-          <p:nvPr/>
-        </p:nvSpPr>
-        <p:spPr>
-          <a:xfrm>
-            <a:off x="914400" y="4270248"/>
-            <a:ext cx="10332720" cy="365760"/>
-          </a:xfrm>
-          <a:prstGeom prst="rect">
-            <a:avLst/>
-          </a:prstGeom>
-          <a:noFill/>
-          <a:ln/>
-        </p:spPr>
-        <p:txBody>
-          <a:bodyPr wrap="square" rtlCol="0" anchor="ctr"/>
-          <a:lstStyle/>
-          <a:p>
-            <a:pPr indent="0" marL="0">
-              <a:buNone/>
-            </a:pPr>
-            <a:r>
-              <a:rPr lang="en-US" sz="1400" b="1" dirty="0">
-                <a:solidFill>
-                  <a:srgbClr val="1B1F3B"/>
-                </a:solidFill>
-                <a:latin typeface="Segoe UI" pitchFamily="34" charset="0"/>
-                <a:ea typeface="Segoe UI" pitchFamily="34" charset="-122"/>
-                <a:cs typeface="Segoe UI" pitchFamily="34" charset="-120"/>
-              </a:rPr>
-              <a:t>Suppression de code mort dans l'export Word des devis</a:t>
-            </a:r>
-            <a:endParaRPr lang="en-US" sz="1400" dirty="0"/>
-          </a:p>
-        </p:txBody>
-      </p:sp>
-      <p:sp>
-        <p:nvSpPr>
-          <p:cNvPr id="16" name="Text 14"/>
-          <p:cNvSpPr/>
-          <p:nvPr/>
-        </p:nvSpPr>
-        <p:spPr>
-          <a:xfrm>
-            <a:off x="914400" y="4617720"/>
-            <a:ext cx="10332720" cy="594360"/>
-          </a:xfrm>
-          <a:prstGeom prst="rect">
-            <a:avLst/>
-          </a:prstGeom>
-          <a:noFill/>
-          <a:ln/>
-        </p:spPr>
-        <p:txBody>
-          <a:bodyPr wrap="square" rtlCol="0" anchor="ctr"/>
-          <a:lstStyle/>
-          <a:p>
-            <a:pPr indent="0" marL="0">
-              <a:lnSpc>
-                <a:spcPts val="1400"/>
-              </a:lnSpc>
-              <a:buNone/>
-            </a:pPr>
-            <a:r>
-              <a:rPr lang="en-US" sz="1100" dirty="0">
-                <a:solidFill>
-                  <a:srgbClr val="8A7C68"/>
-                </a:solidFill>
-                <a:latin typeface="Segoe UI" pitchFamily="34" charset="0"/>
-                <a:ea typeface="Segoe UI" pitchFamily="34" charset="-122"/>
-                <a:cs typeface="Segoe UI" pitchFamily="34" charset="-120"/>
-              </a:rPr>
-              <a:t>Un second bloc de génération de document, devenu inaccessible après une précédente refonte (jamais exécuté), a été retiré du fichier technique de génération de documents.</a:t>
-            </a:r>
-            <a:endParaRPr lang="en-US" sz="1100" dirty="0"/>
-          </a:p>
-        </p:txBody>
-      </p:sp>
-      <p:sp>
-        <p:nvSpPr>
-          <p:cNvPr id="17" name="Text 15"/>
+          <p:cNvPr id="9" name="Text 7"/>
           <p:cNvSpPr/>
           <p:nvPr/>
         </p:nvSpPr>
@@ -24111,7 +24200,7 @@
       </p:sp>
       <p:sp>
         <p:nvSpPr>
-          <p:cNvPr id="18" name="Text 16"/>
+          <p:cNvPr id="10" name="Text 8"/>
           <p:cNvSpPr/>
           <p:nvPr/>
         </p:nvSpPr>
@@ -24274,7 +24363,7 @@
                 <a:ea typeface="Georgia" pitchFamily="34" charset="-122"/>
                 <a:cs typeface="Georgia" pitchFamily="34" charset="-120"/>
               </a:rPr>
-              <a:t>Sécurité</a:t>
+              <a:t>Maintenance technique</a:t>
             </a:r>
             <a:endParaRPr lang="en-US" sz="2400" dirty="0"/>
           </a:p>
@@ -24360,7 +24449,7 @@
                 <a:ea typeface="Segoe UI" pitchFamily="34" charset="-122"/>
                 <a:cs typeface="Segoe UI" pitchFamily="34" charset="-120"/>
               </a:rPr>
-              <a:t>Base de données partagée verrouillée</a:t>
+              <a:t>Nettoyage approfondi du code</a:t>
             </a:r>
             <a:endParaRPr lang="en-US" sz="1400" dirty="0"/>
           </a:p>
@@ -24402,7 +24491,7 @@
                 <a:ea typeface="Segoe UI" pitchFamily="34" charset="-122"/>
                 <a:cs typeface="Segoe UI" pitchFamily="34" charset="-120"/>
               </a:rPr>
-              <a:t>La table contenant l'essentiel des données de l'application était lisible par n'importe qui sur internet avec la simple clé publique du site, sans connexion. L'application y accède désormais avec une clé privée réservée au serveur, ce qui permet de fermer complètement l'accès public sans rien casser.</a:t>
+              <a:t>Audit complet du projet (pages, routes, fonctions, dépendances) pour repérer tout ce qui n'était plus utilisé ; suppression de 6 pages orphelines (onboarding, welcome, compte, anciennes pages devis en 3 étapes), d'une route de connexion de démonstration, d'un dossier de composants dupliqué obsolète, de plusieurs fonctions inutilisées et d'une dépendance logicielle non utilisée — sans toucher aux fonctionnalités actives.</a:t>
             </a:r>
             <a:endParaRPr lang="en-US" sz="1100" dirty="0"/>
           </a:p>
@@ -24488,7 +24577,7 @@
                 <a:ea typeface="Segoe UI" pitchFamily="34" charset="-122"/>
                 <a:cs typeface="Segoe UI" pitchFamily="34" charset="-120"/>
               </a:rPr>
-              <a:t>Fichier de base de données retiré du dépôt Git</a:t>
+              <a:t>Suppression de code mort dans la génération de devis</a:t>
             </a:r>
             <a:endParaRPr lang="en-US" sz="1400" dirty="0"/>
           </a:p>
@@ -24530,7 +24619,7 @@
                 <a:ea typeface="Segoe UI" pitchFamily="34" charset="-122"/>
                 <a:cs typeface="Segoe UI" pitchFamily="34" charset="-120"/>
               </a:rPr>
-              <a:t>Un fichier contenant une copie complète de la base de données de développement, avec des mots de passe réels en clair, était suivi par Git depuis plusieurs mois. Retiré du suivi et exclu définitivement.</a:t>
+              <a:t>Un ancien générateur de devis PDF, devenu inaccessible après une précédente refonte (code jamais exécuté), a été retiré du fichier technique de génération de documents.</a:t>
             </a:r>
             <a:endParaRPr lang="en-US" sz="1100" dirty="0"/>
           </a:p>
@@ -24616,7 +24705,7 @@
                 <a:ea typeface="Segoe UI" pitchFamily="34" charset="-122"/>
                 <a:cs typeface="Segoe UI" pitchFamily="34" charset="-120"/>
               </a:rPr>
-              <a:t>Verrouillage de la base partagée écrit dans le script d'installation</a:t>
+              <a:t>Suppression de code mort dans l'export Word des devis</a:t>
             </a:r>
             <a:endParaRPr lang="en-US" sz="1400" dirty="0"/>
           </a:p>
@@ -24658,7 +24747,7 @@
                 <a:ea typeface="Segoe UI" pitchFamily="34" charset="-122"/>
                 <a:cs typeface="Segoe UI" pitchFamily="34" charset="-120"/>
               </a:rPr>
-              <a:t>La commande qui ferme complètement l'accès public à la table de données partagée a été ajoutée au script SQL du projet, prête à être exécutée dans le tableau de bord Supabase.</a:t>
+              <a:t>Un second bloc de génération de document, devenu inaccessible après une précédente refonte (jamais exécuté), a été retiré du fichier technique de génération de documents.</a:t>
             </a:r>
             <a:endParaRPr lang="en-US" sz="1100" dirty="0"/>
           </a:p>
@@ -24753,6 +24842,600 @@
 <file path=ppt/slides/slide46.xml><?xml version="1.0" encoding="utf-8"?>
 <p:sld xmlns:a="http://schemas.openxmlformats.org/drawingml/2006/main" xmlns:r="http://schemas.openxmlformats.org/officeDocument/2006/relationships" xmlns:p="http://schemas.openxmlformats.org/presentationml/2006/main">
   <p:cSld name="Slide 46">
+    <p:bg>
+      <p:bgPr>
+        <a:solidFill>
+          <a:srgbClr val="F3EEE3"/>
+        </a:solidFill>
+      </p:bgPr>
+    </p:bg>
+    <p:spTree>
+      <p:nvGrpSpPr>
+        <p:cNvPr id="1" name=""/>
+        <p:cNvGrpSpPr/>
+        <p:nvPr/>
+      </p:nvGrpSpPr>
+      <p:grpSpPr>
+        <a:xfrm>
+          <a:off x="0" y="0"/>
+          <a:ext cx="0" cy="0"/>
+          <a:chOff x="0" y="0"/>
+          <a:chExt cx="0" cy="0"/>
+        </a:xfrm>
+      </p:grpSpPr>
+      <p:sp>
+        <p:nvSpPr>
+          <p:cNvPr id="2" name="Shape 0"/>
+          <p:cNvSpPr/>
+          <p:nvPr/>
+        </p:nvSpPr>
+        <p:spPr>
+          <a:xfrm>
+            <a:off x="640080" y="411480"/>
+            <a:ext cx="2377440" cy="365760"/>
+          </a:xfrm>
+          <a:prstGeom prst="roundRect">
+            <a:avLst>
+              <a:gd name="adj" fmla="val 50000"/>
+            </a:avLst>
+          </a:prstGeom>
+          <a:solidFill>
+            <a:srgbClr val="E6EFE4"/>
+          </a:solidFill>
+          <a:ln/>
+        </p:spPr>
+      </p:sp>
+      <p:sp>
+        <p:nvSpPr>
+          <p:cNvPr id="3" name="Text 1"/>
+          <p:cNvSpPr/>
+          <p:nvPr/>
+        </p:nvSpPr>
+        <p:spPr>
+          <a:xfrm>
+            <a:off x="640080" y="411480"/>
+            <a:ext cx="2377440" cy="365760"/>
+          </a:xfrm>
+          <a:prstGeom prst="rect">
+            <a:avLst/>
+          </a:prstGeom>
+          <a:noFill/>
+          <a:ln/>
+        </p:spPr>
+        <p:txBody>
+          <a:bodyPr wrap="square" rtlCol="0" anchor="ctr"/>
+          <a:lstStyle/>
+          <a:p>
+            <a:pPr algn="ctr" indent="0" marL="0">
+              <a:buNone/>
+            </a:pPr>
+            <a:r>
+              <a:rPr lang="en-US" sz="1000" b="1" spc="100" kern="0" dirty="0">
+                <a:solidFill>
+                  <a:srgbClr val="386641"/>
+                </a:solidFill>
+                <a:latin typeface="Segoe UI" pitchFamily="34" charset="0"/>
+                <a:ea typeface="Segoe UI" pitchFamily="34" charset="-122"/>
+                <a:cs typeface="Segoe UI" pitchFamily="34" charset="-120"/>
+              </a:rPr>
+              <a:t>BASE DE DONNÉES</a:t>
+            </a:r>
+            <a:endParaRPr lang="en-US" sz="1000" dirty="0"/>
+          </a:p>
+        </p:txBody>
+      </p:sp>
+      <p:sp>
+        <p:nvSpPr>
+          <p:cNvPr id="4" name="Text 2"/>
+          <p:cNvSpPr/>
+          <p:nvPr/>
+        </p:nvSpPr>
+        <p:spPr>
+          <a:xfrm>
+            <a:off x="640080" y="868680"/>
+            <a:ext cx="10515600" cy="548640"/>
+          </a:xfrm>
+          <a:prstGeom prst="rect">
+            <a:avLst/>
+          </a:prstGeom>
+          <a:noFill/>
+          <a:ln/>
+        </p:spPr>
+        <p:txBody>
+          <a:bodyPr wrap="square" rtlCol="0" anchor="ctr"/>
+          <a:lstStyle/>
+          <a:p>
+            <a:pPr indent="0" marL="0">
+              <a:buNone/>
+            </a:pPr>
+            <a:r>
+              <a:rPr lang="en-US" sz="2400" b="1" dirty="0">
+                <a:solidFill>
+                  <a:srgbClr val="1B1F3B"/>
+                </a:solidFill>
+                <a:latin typeface="Georgia" pitchFamily="34" charset="0"/>
+                <a:ea typeface="Georgia" pitchFamily="34" charset="-122"/>
+                <a:cs typeface="Georgia" pitchFamily="34" charset="-120"/>
+              </a:rPr>
+              <a:t>Sécurité</a:t>
+            </a:r>
+            <a:endParaRPr lang="en-US" sz="2400" dirty="0"/>
+          </a:p>
+        </p:txBody>
+      </p:sp>
+      <p:sp>
+        <p:nvSpPr>
+          <p:cNvPr id="5" name="Shape 3"/>
+          <p:cNvSpPr/>
+          <p:nvPr/>
+        </p:nvSpPr>
+        <p:spPr>
+          <a:xfrm>
+            <a:off x="640080" y="1691640"/>
+            <a:ext cx="10881360" cy="1097280"/>
+          </a:xfrm>
+          <a:prstGeom prst="roundRect">
+            <a:avLst>
+              <a:gd name="adj" fmla="val 5000"/>
+            </a:avLst>
+          </a:prstGeom>
+          <a:solidFill>
+            <a:srgbClr val="FFFFFF"/>
+          </a:solidFill>
+          <a:ln w="12700">
+            <a:solidFill>
+              <a:srgbClr val="E4DCCB"/>
+            </a:solidFill>
+            <a:prstDash val="solid"/>
+          </a:ln>
+        </p:spPr>
+      </p:sp>
+      <p:sp>
+        <p:nvSpPr>
+          <p:cNvPr id="6" name="Shape 4"/>
+          <p:cNvSpPr/>
+          <p:nvPr/>
+        </p:nvSpPr>
+        <p:spPr>
+          <a:xfrm>
+            <a:off x="640080" y="1691640"/>
+            <a:ext cx="54864" cy="1097280"/>
+          </a:xfrm>
+          <a:prstGeom prst="rect">
+            <a:avLst/>
+          </a:prstGeom>
+          <a:solidFill>
+            <a:srgbClr val="386641"/>
+          </a:solidFill>
+          <a:ln/>
+        </p:spPr>
+      </p:sp>
+      <p:sp>
+        <p:nvSpPr>
+          <p:cNvPr id="7" name="Text 5"/>
+          <p:cNvSpPr/>
+          <p:nvPr/>
+        </p:nvSpPr>
+        <p:spPr>
+          <a:xfrm>
+            <a:off x="914400" y="1801368"/>
+            <a:ext cx="10332720" cy="365760"/>
+          </a:xfrm>
+          <a:prstGeom prst="rect">
+            <a:avLst/>
+          </a:prstGeom>
+          <a:noFill/>
+          <a:ln/>
+        </p:spPr>
+        <p:txBody>
+          <a:bodyPr wrap="square" rtlCol="0" anchor="ctr"/>
+          <a:lstStyle/>
+          <a:p>
+            <a:pPr indent="0" marL="0">
+              <a:buNone/>
+            </a:pPr>
+            <a:r>
+              <a:rPr lang="en-US" sz="1400" b="1" dirty="0">
+                <a:solidFill>
+                  <a:srgbClr val="1B1F3B"/>
+                </a:solidFill>
+                <a:latin typeface="Segoe UI" pitchFamily="34" charset="0"/>
+                <a:ea typeface="Segoe UI" pitchFamily="34" charset="-122"/>
+                <a:cs typeface="Segoe UI" pitchFamily="34" charset="-120"/>
+              </a:rPr>
+              <a:t>Base de données partagée verrouillée</a:t>
+            </a:r>
+            <a:endParaRPr lang="en-US" sz="1400" dirty="0"/>
+          </a:p>
+        </p:txBody>
+      </p:sp>
+      <p:sp>
+        <p:nvSpPr>
+          <p:cNvPr id="8" name="Text 6"/>
+          <p:cNvSpPr/>
+          <p:nvPr/>
+        </p:nvSpPr>
+        <p:spPr>
+          <a:xfrm>
+            <a:off x="914400" y="2148840"/>
+            <a:ext cx="10332720" cy="594360"/>
+          </a:xfrm>
+          <a:prstGeom prst="rect">
+            <a:avLst/>
+          </a:prstGeom>
+          <a:noFill/>
+          <a:ln/>
+        </p:spPr>
+        <p:txBody>
+          <a:bodyPr wrap="square" rtlCol="0" anchor="ctr"/>
+          <a:lstStyle/>
+          <a:p>
+            <a:pPr indent="0" marL="0">
+              <a:lnSpc>
+                <a:spcPts val="1400"/>
+              </a:lnSpc>
+              <a:buNone/>
+            </a:pPr>
+            <a:r>
+              <a:rPr lang="en-US" sz="1100" dirty="0">
+                <a:solidFill>
+                  <a:srgbClr val="8A7C68"/>
+                </a:solidFill>
+                <a:latin typeface="Segoe UI" pitchFamily="34" charset="0"/>
+                <a:ea typeface="Segoe UI" pitchFamily="34" charset="-122"/>
+                <a:cs typeface="Segoe UI" pitchFamily="34" charset="-120"/>
+              </a:rPr>
+              <a:t>La table contenant l'essentiel des données de l'application était lisible par n'importe qui sur internet avec la simple clé publique du site, sans connexion. L'application y accède désormais avec une clé privée réservée au serveur, ce qui permet de fermer complètement l'accès public sans rien casser.</a:t>
+            </a:r>
+            <a:endParaRPr lang="en-US" sz="1100" dirty="0"/>
+          </a:p>
+        </p:txBody>
+      </p:sp>
+      <p:sp>
+        <p:nvSpPr>
+          <p:cNvPr id="9" name="Shape 7"/>
+          <p:cNvSpPr/>
+          <p:nvPr/>
+        </p:nvSpPr>
+        <p:spPr>
+          <a:xfrm>
+            <a:off x="640080" y="2926080"/>
+            <a:ext cx="10881360" cy="1097280"/>
+          </a:xfrm>
+          <a:prstGeom prst="roundRect">
+            <a:avLst>
+              <a:gd name="adj" fmla="val 5000"/>
+            </a:avLst>
+          </a:prstGeom>
+          <a:solidFill>
+            <a:srgbClr val="FFFFFF"/>
+          </a:solidFill>
+          <a:ln w="12700">
+            <a:solidFill>
+              <a:srgbClr val="E4DCCB"/>
+            </a:solidFill>
+            <a:prstDash val="solid"/>
+          </a:ln>
+        </p:spPr>
+      </p:sp>
+      <p:sp>
+        <p:nvSpPr>
+          <p:cNvPr id="10" name="Shape 8"/>
+          <p:cNvSpPr/>
+          <p:nvPr/>
+        </p:nvSpPr>
+        <p:spPr>
+          <a:xfrm>
+            <a:off x="640080" y="2926080"/>
+            <a:ext cx="54864" cy="1097280"/>
+          </a:xfrm>
+          <a:prstGeom prst="rect">
+            <a:avLst/>
+          </a:prstGeom>
+          <a:solidFill>
+            <a:srgbClr val="386641"/>
+          </a:solidFill>
+          <a:ln/>
+        </p:spPr>
+      </p:sp>
+      <p:sp>
+        <p:nvSpPr>
+          <p:cNvPr id="11" name="Text 9"/>
+          <p:cNvSpPr/>
+          <p:nvPr/>
+        </p:nvSpPr>
+        <p:spPr>
+          <a:xfrm>
+            <a:off x="914400" y="3035808"/>
+            <a:ext cx="10332720" cy="365760"/>
+          </a:xfrm>
+          <a:prstGeom prst="rect">
+            <a:avLst/>
+          </a:prstGeom>
+          <a:noFill/>
+          <a:ln/>
+        </p:spPr>
+        <p:txBody>
+          <a:bodyPr wrap="square" rtlCol="0" anchor="ctr"/>
+          <a:lstStyle/>
+          <a:p>
+            <a:pPr indent="0" marL="0">
+              <a:buNone/>
+            </a:pPr>
+            <a:r>
+              <a:rPr lang="en-US" sz="1400" b="1" dirty="0">
+                <a:solidFill>
+                  <a:srgbClr val="1B1F3B"/>
+                </a:solidFill>
+                <a:latin typeface="Segoe UI" pitchFamily="34" charset="0"/>
+                <a:ea typeface="Segoe UI" pitchFamily="34" charset="-122"/>
+                <a:cs typeface="Segoe UI" pitchFamily="34" charset="-120"/>
+              </a:rPr>
+              <a:t>Fichier de base de données retiré du dépôt Git</a:t>
+            </a:r>
+            <a:endParaRPr lang="en-US" sz="1400" dirty="0"/>
+          </a:p>
+        </p:txBody>
+      </p:sp>
+      <p:sp>
+        <p:nvSpPr>
+          <p:cNvPr id="12" name="Text 10"/>
+          <p:cNvSpPr/>
+          <p:nvPr/>
+        </p:nvSpPr>
+        <p:spPr>
+          <a:xfrm>
+            <a:off x="914400" y="3383280"/>
+            <a:ext cx="10332720" cy="594360"/>
+          </a:xfrm>
+          <a:prstGeom prst="rect">
+            <a:avLst/>
+          </a:prstGeom>
+          <a:noFill/>
+          <a:ln/>
+        </p:spPr>
+        <p:txBody>
+          <a:bodyPr wrap="square" rtlCol="0" anchor="ctr"/>
+          <a:lstStyle/>
+          <a:p>
+            <a:pPr indent="0" marL="0">
+              <a:lnSpc>
+                <a:spcPts val="1400"/>
+              </a:lnSpc>
+              <a:buNone/>
+            </a:pPr>
+            <a:r>
+              <a:rPr lang="en-US" sz="1100" dirty="0">
+                <a:solidFill>
+                  <a:srgbClr val="8A7C68"/>
+                </a:solidFill>
+                <a:latin typeface="Segoe UI" pitchFamily="34" charset="0"/>
+                <a:ea typeface="Segoe UI" pitchFamily="34" charset="-122"/>
+                <a:cs typeface="Segoe UI" pitchFamily="34" charset="-120"/>
+              </a:rPr>
+              <a:t>Un fichier contenant une copie complète de la base de données de développement, avec des mots de passe réels en clair, était suivi par Git depuis plusieurs mois. Retiré du suivi et exclu définitivement.</a:t>
+            </a:r>
+            <a:endParaRPr lang="en-US" sz="1100" dirty="0"/>
+          </a:p>
+        </p:txBody>
+      </p:sp>
+      <p:sp>
+        <p:nvSpPr>
+          <p:cNvPr id="13" name="Shape 11"/>
+          <p:cNvSpPr/>
+          <p:nvPr/>
+        </p:nvSpPr>
+        <p:spPr>
+          <a:xfrm>
+            <a:off x="640080" y="4160520"/>
+            <a:ext cx="10881360" cy="1097280"/>
+          </a:xfrm>
+          <a:prstGeom prst="roundRect">
+            <a:avLst>
+              <a:gd name="adj" fmla="val 5000"/>
+            </a:avLst>
+          </a:prstGeom>
+          <a:solidFill>
+            <a:srgbClr val="FFFFFF"/>
+          </a:solidFill>
+          <a:ln w="12700">
+            <a:solidFill>
+              <a:srgbClr val="E4DCCB"/>
+            </a:solidFill>
+            <a:prstDash val="solid"/>
+          </a:ln>
+        </p:spPr>
+      </p:sp>
+      <p:sp>
+        <p:nvSpPr>
+          <p:cNvPr id="14" name="Shape 12"/>
+          <p:cNvSpPr/>
+          <p:nvPr/>
+        </p:nvSpPr>
+        <p:spPr>
+          <a:xfrm>
+            <a:off x="640080" y="4160520"/>
+            <a:ext cx="54864" cy="1097280"/>
+          </a:xfrm>
+          <a:prstGeom prst="rect">
+            <a:avLst/>
+          </a:prstGeom>
+          <a:solidFill>
+            <a:srgbClr val="386641"/>
+          </a:solidFill>
+          <a:ln/>
+        </p:spPr>
+      </p:sp>
+      <p:sp>
+        <p:nvSpPr>
+          <p:cNvPr id="15" name="Text 13"/>
+          <p:cNvSpPr/>
+          <p:nvPr/>
+        </p:nvSpPr>
+        <p:spPr>
+          <a:xfrm>
+            <a:off x="914400" y="4270248"/>
+            <a:ext cx="10332720" cy="365760"/>
+          </a:xfrm>
+          <a:prstGeom prst="rect">
+            <a:avLst/>
+          </a:prstGeom>
+          <a:noFill/>
+          <a:ln/>
+        </p:spPr>
+        <p:txBody>
+          <a:bodyPr wrap="square" rtlCol="0" anchor="ctr"/>
+          <a:lstStyle/>
+          <a:p>
+            <a:pPr indent="0" marL="0">
+              <a:buNone/>
+            </a:pPr>
+            <a:r>
+              <a:rPr lang="en-US" sz="1400" b="1" dirty="0">
+                <a:solidFill>
+                  <a:srgbClr val="1B1F3B"/>
+                </a:solidFill>
+                <a:latin typeface="Segoe UI" pitchFamily="34" charset="0"/>
+                <a:ea typeface="Segoe UI" pitchFamily="34" charset="-122"/>
+                <a:cs typeface="Segoe UI" pitchFamily="34" charset="-120"/>
+              </a:rPr>
+              <a:t>Verrouillage de la base partagée écrit dans le script d'installation</a:t>
+            </a:r>
+            <a:endParaRPr lang="en-US" sz="1400" dirty="0"/>
+          </a:p>
+        </p:txBody>
+      </p:sp>
+      <p:sp>
+        <p:nvSpPr>
+          <p:cNvPr id="16" name="Text 14"/>
+          <p:cNvSpPr/>
+          <p:nvPr/>
+        </p:nvSpPr>
+        <p:spPr>
+          <a:xfrm>
+            <a:off x="914400" y="4617720"/>
+            <a:ext cx="10332720" cy="594360"/>
+          </a:xfrm>
+          <a:prstGeom prst="rect">
+            <a:avLst/>
+          </a:prstGeom>
+          <a:noFill/>
+          <a:ln/>
+        </p:spPr>
+        <p:txBody>
+          <a:bodyPr wrap="square" rtlCol="0" anchor="ctr"/>
+          <a:lstStyle/>
+          <a:p>
+            <a:pPr indent="0" marL="0">
+              <a:lnSpc>
+                <a:spcPts val="1400"/>
+              </a:lnSpc>
+              <a:buNone/>
+            </a:pPr>
+            <a:r>
+              <a:rPr lang="en-US" sz="1100" dirty="0">
+                <a:solidFill>
+                  <a:srgbClr val="8A7C68"/>
+                </a:solidFill>
+                <a:latin typeface="Segoe UI" pitchFamily="34" charset="0"/>
+                <a:ea typeface="Segoe UI" pitchFamily="34" charset="-122"/>
+                <a:cs typeface="Segoe UI" pitchFamily="34" charset="-120"/>
+              </a:rPr>
+              <a:t>La commande qui ferme complètement l'accès public à la table de données partagée a été ajoutée au script SQL du projet, prête à être exécutée dans le tableau de bord Supabase.</a:t>
+            </a:r>
+            <a:endParaRPr lang="en-US" sz="1100" dirty="0"/>
+          </a:p>
+        </p:txBody>
+      </p:sp>
+      <p:sp>
+        <p:nvSpPr>
+          <p:cNvPr id="17" name="Text 15"/>
+          <p:cNvSpPr/>
+          <p:nvPr/>
+        </p:nvSpPr>
+        <p:spPr>
+          <a:xfrm>
+            <a:off x="365760" y="6510528"/>
+            <a:ext cx="5486400" cy="274320"/>
+          </a:xfrm>
+          <a:prstGeom prst="rect">
+            <a:avLst/>
+          </a:prstGeom>
+          <a:noFill/>
+          <a:ln/>
+        </p:spPr>
+        <p:txBody>
+          <a:bodyPr wrap="square" rtlCol="0" anchor="ctr"/>
+          <a:lstStyle/>
+          <a:p>
+            <a:pPr indent="0" marL="0">
+              <a:buNone/>
+            </a:pPr>
+            <a:r>
+              <a:rPr lang="en-US" sz="900" dirty="0">
+                <a:solidFill>
+                  <a:srgbClr val="8A7C68"/>
+                </a:solidFill>
+                <a:latin typeface="Segoe UI" pitchFamily="34" charset="0"/>
+                <a:ea typeface="Segoe UI" pitchFamily="34" charset="-122"/>
+                <a:cs typeface="Segoe UI" pitchFamily="34" charset="-120"/>
+              </a:rPr>
+              <a:t>Kôji Web — Récapitulatif technique</a:t>
+            </a:r>
+            <a:endParaRPr lang="en-US" sz="900" dirty="0"/>
+          </a:p>
+        </p:txBody>
+      </p:sp>
+      <p:sp>
+        <p:nvSpPr>
+          <p:cNvPr id="18" name="Text 16"/>
+          <p:cNvSpPr/>
+          <p:nvPr/>
+        </p:nvSpPr>
+        <p:spPr>
+          <a:xfrm>
+            <a:off x="9601200" y="6510528"/>
+            <a:ext cx="2194560" cy="274320"/>
+          </a:xfrm>
+          <a:prstGeom prst="rect">
+            <a:avLst/>
+          </a:prstGeom>
+          <a:noFill/>
+          <a:ln/>
+        </p:spPr>
+        <p:txBody>
+          <a:bodyPr wrap="square" rtlCol="0" anchor="ctr"/>
+          <a:lstStyle/>
+          <a:p>
+            <a:pPr algn="r" indent="0" marL="0">
+              <a:buNone/>
+            </a:pPr>
+            <a:r>
+              <a:rPr lang="en-US" sz="900" dirty="0">
+                <a:solidFill>
+                  <a:srgbClr val="8A7C68"/>
+                </a:solidFill>
+                <a:latin typeface="Segoe UI" pitchFamily="34" charset="0"/>
+                <a:ea typeface="Segoe UI" pitchFamily="34" charset="-122"/>
+                <a:cs typeface="Segoe UI" pitchFamily="34" charset="-120"/>
+              </a:rPr>
+              <a:t>46</a:t>
+            </a:r>
+            <a:endParaRPr lang="en-US" sz="900" dirty="0"/>
+          </a:p>
+        </p:txBody>
+      </p:sp>
+    </p:spTree>
+  </p:cSld>
+  <p:clrMapOvr>
+    <a:masterClrMapping/>
+  </p:clrMapOvr>
+</p:sld>
+</file>
+
+<file path=ppt/slides/slide47.xml><?xml version="1.0" encoding="utf-8"?>
+<p:sld xmlns:a="http://schemas.openxmlformats.org/drawingml/2006/main" xmlns:r="http://schemas.openxmlformats.org/officeDocument/2006/relationships" xmlns:p="http://schemas.openxmlformats.org/presentationml/2006/main">
+  <p:cSld name="Slide 47">
     <p:bg>
       <p:bgPr>
         <a:solidFill>

</xml_diff>

<commit_message>
Profil entreprise: email de connexion affiche avec l'email professionnel
Dans "Coordonnees de l'entreprise", un nouveau champ en lecture seule
affiche l'email avec lequel le compte est connecte, juste avant
l'email professionnel -- utile quand l'entreprise ne s'est pas
inscrite avec son email pro au depart et veut que ce soit celui-ci
qui figure sur les devis/factures/carte de visite plutot que l'email
de connexion.

Co-Authored-By: Claude Sonnet 5 <noreply@anthropic.com>
</commit_message>
<xml_diff>
--- a/docs/manager-recap/Recap-Koji-Manager.pptx
+++ b/docs/manager-recap/Recap-Koji-Manager.pptx
@@ -11048,7 +11048,135 @@
       </p:sp>
       <p:sp>
         <p:nvSpPr>
-          <p:cNvPr id="9" name="Text 7"/>
+          <p:cNvPr id="9" name="Shape 7"/>
+          <p:cNvSpPr/>
+          <p:nvPr/>
+        </p:nvSpPr>
+        <p:spPr>
+          <a:xfrm>
+            <a:off x="640080" y="2926080"/>
+            <a:ext cx="10881360" cy="1097280"/>
+          </a:xfrm>
+          <a:prstGeom prst="roundRect">
+            <a:avLst>
+              <a:gd name="adj" fmla="val 5000"/>
+            </a:avLst>
+          </a:prstGeom>
+          <a:solidFill>
+            <a:srgbClr val="FFFFFF"/>
+          </a:solidFill>
+          <a:ln w="12700">
+            <a:solidFill>
+              <a:srgbClr val="E4DCCB"/>
+            </a:solidFill>
+            <a:prstDash val="solid"/>
+          </a:ln>
+        </p:spPr>
+      </p:sp>
+      <p:sp>
+        <p:nvSpPr>
+          <p:cNvPr id="10" name="Shape 8"/>
+          <p:cNvSpPr/>
+          <p:nvPr/>
+        </p:nvSpPr>
+        <p:spPr>
+          <a:xfrm>
+            <a:off x="640080" y="2926080"/>
+            <a:ext cx="54864" cy="1097280"/>
+          </a:xfrm>
+          <a:prstGeom prst="rect">
+            <a:avLst/>
+          </a:prstGeom>
+          <a:solidFill>
+            <a:srgbClr val="1D6FE0"/>
+          </a:solidFill>
+          <a:ln/>
+        </p:spPr>
+      </p:sp>
+      <p:sp>
+        <p:nvSpPr>
+          <p:cNvPr id="11" name="Text 9"/>
+          <p:cNvSpPr/>
+          <p:nvPr/>
+        </p:nvSpPr>
+        <p:spPr>
+          <a:xfrm>
+            <a:off x="914400" y="3035808"/>
+            <a:ext cx="10332720" cy="365760"/>
+          </a:xfrm>
+          <a:prstGeom prst="rect">
+            <a:avLst/>
+          </a:prstGeom>
+          <a:noFill/>
+          <a:ln/>
+        </p:spPr>
+        <p:txBody>
+          <a:bodyPr wrap="square" rtlCol="0" anchor="ctr"/>
+          <a:lstStyle/>
+          <a:p>
+            <a:pPr indent="0" marL="0">
+              <a:buNone/>
+            </a:pPr>
+            <a:r>
+              <a:rPr lang="en-US" sz="1400" b="1" dirty="0">
+                <a:solidFill>
+                  <a:srgbClr val="1B1F3B"/>
+                </a:solidFill>
+                <a:latin typeface="Segoe UI" pitchFamily="34" charset="0"/>
+                <a:ea typeface="Segoe UI" pitchFamily="34" charset="-122"/>
+                <a:cs typeface="Segoe UI" pitchFamily="34" charset="-120"/>
+              </a:rPr>
+              <a:t>Email de connexion affiché à côté de l'email professionnel</a:t>
+            </a:r>
+            <a:endParaRPr lang="en-US" sz="1400" dirty="0"/>
+          </a:p>
+        </p:txBody>
+      </p:sp>
+      <p:sp>
+        <p:nvSpPr>
+          <p:cNvPr id="12" name="Text 10"/>
+          <p:cNvSpPr/>
+          <p:nvPr/>
+        </p:nvSpPr>
+        <p:spPr>
+          <a:xfrm>
+            <a:off x="914400" y="3383280"/>
+            <a:ext cx="10332720" cy="594360"/>
+          </a:xfrm>
+          <a:prstGeom prst="rect">
+            <a:avLst/>
+          </a:prstGeom>
+          <a:noFill/>
+          <a:ln/>
+        </p:spPr>
+        <p:txBody>
+          <a:bodyPr wrap="square" rtlCol="0" anchor="ctr"/>
+          <a:lstStyle/>
+          <a:p>
+            <a:pPr indent="0" marL="0">
+              <a:lnSpc>
+                <a:spcPts val="1400"/>
+              </a:lnSpc>
+              <a:buNone/>
+            </a:pPr>
+            <a:r>
+              <a:rPr lang="en-US" sz="1100" dirty="0">
+                <a:solidFill>
+                  <a:srgbClr val="8A7C68"/>
+                </a:solidFill>
+                <a:latin typeface="Segoe UI" pitchFamily="34" charset="0"/>
+                <a:ea typeface="Segoe UI" pitchFamily="34" charset="-122"/>
+                <a:cs typeface="Segoe UI" pitchFamily="34" charset="-120"/>
+              </a:rPr>
+              <a:t>Dans les coordonnées de l'entreprise, l'email de connexion au compte (lecture seule) apparaît désormais juste avant l'email professionnel, avec une explication : utile quand l'entreprise ne s'est pas inscrite au départ avec son email professionnel et veut que ce soit ce dernier qui figure sur les devis/factures/carte de visite.</a:t>
+            </a:r>
+            <a:endParaRPr lang="en-US" sz="1100" dirty="0"/>
+          </a:p>
+        </p:txBody>
+      </p:sp>
+      <p:sp>
+        <p:nvSpPr>
+          <p:cNvPr id="13" name="Text 11"/>
           <p:cNvSpPr/>
           <p:nvPr/>
         </p:nvSpPr>
@@ -11087,7 +11215,7 @@
       </p:sp>
       <p:sp>
         <p:nvSpPr>
-          <p:cNvPr id="10" name="Text 8"/>
+          <p:cNvPr id="14" name="Text 12"/>
           <p:cNvSpPr/>
           <p:nvPr/>
         </p:nvSpPr>
@@ -11294,7 +11422,7 @@
                 <a:ea typeface="Georgia" pitchFamily="34" charset="-122"/>
                 <a:cs typeface="Georgia" pitchFamily="34" charset="-120"/>
               </a:rPr>
-              <a:t>108</a:t>
+              <a:t>109</a:t>
             </a:r>
             <a:endParaRPr lang="en-US" sz="3200" dirty="0"/>
           </a:p>
@@ -11399,7 +11527,7 @@
                 <a:ea typeface="Georgia" pitchFamily="34" charset="-122"/>
                 <a:cs typeface="Georgia" pitchFamily="34" charset="-120"/>
               </a:rPr>
-              <a:t>53</a:t>
+              <a:t>54</a:t>
             </a:r>
             <a:endParaRPr lang="en-US" sz="3200" dirty="0"/>
           </a:p>
@@ -17133,7 +17261,7 @@
                 <a:ea typeface="Segoe UI" pitchFamily="34" charset="-122"/>
                 <a:cs typeface="Segoe UI" pitchFamily="34" charset="-120"/>
               </a:rPr>
-              <a:t>53 mise(s) à jour</a:t>
+              <a:t>54 mise(s) à jour</a:t>
             </a:r>
             <a:endParaRPr lang="en-US" sz="1200" dirty="0"/>
           </a:p>

</xml_diff>

<commit_message>
Parametres entreprise: le bloc Parametres reprend le style des cartes existantes
SettingsPanel accepte maintenant une prop variant. "cards" (utilisee
sur /parametres) rend Abonnement/Langue/Apparence/Securite comme
des .profile-block, identiques aux cartes Signatures/Carte de
visite/Tarification deja presentes sur la page, au lieu d'un style
de liste compact different. Le profil client et l'onglet Parametres
ouvrier gardent le style compact ("settings-row"), coherent avec
leurs pages respectives qui n'ont pas de convention .profile-block.

Co-Authored-By: Claude Sonnet 5 <noreply@anthropic.com>
</commit_message>
<xml_diff>
--- a/docs/manager-recap/Recap-Koji-Manager.pptx
+++ b/docs/manager-recap/Recap-Koji-Manager.pptx
@@ -11432,7 +11432,135 @@
       </p:sp>
       <p:sp>
         <p:nvSpPr>
-          <p:cNvPr id="17" name="Text 15"/>
+          <p:cNvPr id="17" name="Shape 15"/>
+          <p:cNvSpPr/>
+          <p:nvPr/>
+        </p:nvSpPr>
+        <p:spPr>
+          <a:xfrm>
+            <a:off x="640080" y="5394960"/>
+            <a:ext cx="10881360" cy="1097280"/>
+          </a:xfrm>
+          <a:prstGeom prst="roundRect">
+            <a:avLst>
+              <a:gd name="adj" fmla="val 5000"/>
+            </a:avLst>
+          </a:prstGeom>
+          <a:solidFill>
+            <a:srgbClr val="FFFFFF"/>
+          </a:solidFill>
+          <a:ln w="12700">
+            <a:solidFill>
+              <a:srgbClr val="E4DCCB"/>
+            </a:solidFill>
+            <a:prstDash val="solid"/>
+          </a:ln>
+        </p:spPr>
+      </p:sp>
+      <p:sp>
+        <p:nvSpPr>
+          <p:cNvPr id="18" name="Shape 16"/>
+          <p:cNvSpPr/>
+          <p:nvPr/>
+        </p:nvSpPr>
+        <p:spPr>
+          <a:xfrm>
+            <a:off x="640080" y="5394960"/>
+            <a:ext cx="54864" cy="1097280"/>
+          </a:xfrm>
+          <a:prstGeom prst="rect">
+            <a:avLst/>
+          </a:prstGeom>
+          <a:solidFill>
+            <a:srgbClr val="1D6FE0"/>
+          </a:solidFill>
+          <a:ln/>
+        </p:spPr>
+      </p:sp>
+      <p:sp>
+        <p:nvSpPr>
+          <p:cNvPr id="19" name="Text 17"/>
+          <p:cNvSpPr/>
+          <p:nvPr/>
+        </p:nvSpPr>
+        <p:spPr>
+          <a:xfrm>
+            <a:off x="914400" y="5504688"/>
+            <a:ext cx="10332720" cy="365760"/>
+          </a:xfrm>
+          <a:prstGeom prst="rect">
+            <a:avLst/>
+          </a:prstGeom>
+          <a:noFill/>
+          <a:ln/>
+        </p:spPr>
+        <p:txBody>
+          <a:bodyPr wrap="square" rtlCol="0" anchor="ctr"/>
+          <a:lstStyle/>
+          <a:p>
+            <a:pPr indent="0" marL="0">
+              <a:buNone/>
+            </a:pPr>
+            <a:r>
+              <a:rPr lang="en-US" sz="1400" b="1" dirty="0">
+                <a:solidFill>
+                  <a:srgbClr val="1B1F3B"/>
+                </a:solidFill>
+                <a:latin typeface="Segoe UI" pitchFamily="34" charset="0"/>
+                <a:ea typeface="Segoe UI" pitchFamily="34" charset="-122"/>
+                <a:cs typeface="Segoe UI" pitchFamily="34" charset="-120"/>
+              </a:rPr>
+              <a:t>Nouveau bloc Paramètres avec le même style de carte que le reste de la page entreprise</a:t>
+            </a:r>
+            <a:endParaRPr lang="en-US" sz="1400" dirty="0"/>
+          </a:p>
+        </p:txBody>
+      </p:sp>
+      <p:sp>
+        <p:nvSpPr>
+          <p:cNvPr id="20" name="Text 18"/>
+          <p:cNvSpPr/>
+          <p:nvPr/>
+        </p:nvSpPr>
+        <p:spPr>
+          <a:xfrm>
+            <a:off x="914400" y="5852160"/>
+            <a:ext cx="10332720" cy="594360"/>
+          </a:xfrm>
+          <a:prstGeom prst="rect">
+            <a:avLst/>
+          </a:prstGeom>
+          <a:noFill/>
+          <a:ln/>
+        </p:spPr>
+        <p:txBody>
+          <a:bodyPr wrap="square" rtlCol="0" anchor="ctr"/>
+          <a:lstStyle/>
+          <a:p>
+            <a:pPr indent="0" marL="0">
+              <a:lnSpc>
+                <a:spcPts val="1400"/>
+              </a:lnSpc>
+              <a:buNone/>
+            </a:pPr>
+            <a:r>
+              <a:rPr lang="en-US" sz="1100" dirty="0">
+                <a:solidFill>
+                  <a:srgbClr val="8A7C68"/>
+                </a:solidFill>
+                <a:latin typeface="Segoe UI" pitchFamily="34" charset="0"/>
+                <a:ea typeface="Segoe UI" pitchFamily="34" charset="-122"/>
+                <a:cs typeface="Segoe UI" pitchFamily="34" charset="-120"/>
+              </a:rPr>
+              <a:t>Côté profil entreprise, Abonnement / Langue / Apparence / Sécurité reprennent maintenant exactement le même style de carte (titre, description, bouton) que les sections déjà existantes (Signatures, Carte de visite, Tarification, Métiers...), au lieu d'une présentation différente — toute la page se lit comme une seule liste cohérente.</a:t>
+            </a:r>
+            <a:endParaRPr lang="en-US" sz="1100" dirty="0"/>
+          </a:p>
+        </p:txBody>
+      </p:sp>
+      <p:sp>
+        <p:nvSpPr>
+          <p:cNvPr id="21" name="Text 19"/>
           <p:cNvSpPr/>
           <p:nvPr/>
         </p:nvSpPr>
@@ -11471,7 +11599,7 @@
       </p:sp>
       <p:sp>
         <p:nvSpPr>
-          <p:cNvPr id="18" name="Text 16"/>
+          <p:cNvPr id="22" name="Text 20"/>
           <p:cNvSpPr/>
           <p:nvPr/>
         </p:nvSpPr>
@@ -11678,7 +11806,7 @@
                 <a:ea typeface="Georgia" pitchFamily="34" charset="-122"/>
                 <a:cs typeface="Georgia" pitchFamily="34" charset="-120"/>
               </a:rPr>
-              <a:t>111</a:t>
+              <a:t>112</a:t>
             </a:r>
             <a:endParaRPr lang="en-US" sz="3200" dirty="0"/>
           </a:p>
@@ -11783,7 +11911,7 @@
                 <a:ea typeface="Georgia" pitchFamily="34" charset="-122"/>
                 <a:cs typeface="Georgia" pitchFamily="34" charset="-120"/>
               </a:rPr>
-              <a:t>56</a:t>
+              <a:t>57</a:t>
             </a:r>
             <a:endParaRPr lang="en-US" sz="3200" dirty="0"/>
           </a:p>
@@ -17517,7 +17645,7 @@
                 <a:ea typeface="Segoe UI" pitchFamily="34" charset="-122"/>
                 <a:cs typeface="Segoe UI" pitchFamily="34" charset="-120"/>
               </a:rPr>
-              <a:t>56 mise(s) à jour</a:t>
+              <a:t>57 mise(s) à jour</a:t>
             </a:r>
             <a:endParaRPr lang="en-US" sz="1200" dirty="0"/>
           </a:p>

</xml_diff>

<commit_message>
Abonnement: carte depliable avec formule, IBAN et modalites de paiement
Cote entreprise, cliquer "Gerer" sur la carte Abonnement (Parametres)
l'ouvre en place au lieu de renvoyer vers /abonnement : affiche la
formule Koji actuelle (lib/plan.js PLAN_LIMITS), et reprend les
memes champs IBAN/BIC/titulaire + modalites de paiement que la page
Profil -- modifiables ici, enregistres via PATCH /api/auth/profile
sur le meme champ business, donc aucune duplication de source de
verite avec Profil. Un lien "Changer de formule" garde l'acces a
/abonnement pour comparer les 3 formules.

Cote client/ouvrier, la carte Abonnement reste un simple lien vers
/abonnement (IBAN et modalites de paiement ne les concernent pas).

Co-Authored-By: Claude Sonnet 5 <noreply@anthropic.com>
</commit_message>
<xml_diff>
--- a/docs/manager-recap/Recap-Koji-Manager.pptx
+++ b/docs/manager-recap/Recap-Koji-Manager.pptx
@@ -11895,7 +11895,7 @@
                 <a:ea typeface="Georgia" pitchFamily="34" charset="-122"/>
                 <a:cs typeface="Georgia" pitchFamily="34" charset="-120"/>
               </a:rPr>
-              <a:t>113</a:t>
+              <a:t>114</a:t>
             </a:r>
             <a:endParaRPr lang="en-US" sz="3200" dirty="0"/>
           </a:p>
@@ -12000,7 +12000,7 @@
                 <a:ea typeface="Georgia" pitchFamily="34" charset="-122"/>
                 <a:cs typeface="Georgia" pitchFamily="34" charset="-120"/>
               </a:rPr>
-              <a:t>58</a:t>
+              <a:t>59</a:t>
             </a:r>
             <a:endParaRPr lang="en-US" sz="3200" dirty="0"/>
           </a:p>
@@ -12752,7 +12752,135 @@
       </p:sp>
       <p:sp>
         <p:nvSpPr>
-          <p:cNvPr id="9" name="Text 7"/>
+          <p:cNvPr id="9" name="Shape 7"/>
+          <p:cNvSpPr/>
+          <p:nvPr/>
+        </p:nvSpPr>
+        <p:spPr>
+          <a:xfrm>
+            <a:off x="640080" y="2926080"/>
+            <a:ext cx="10881360" cy="1097280"/>
+          </a:xfrm>
+          <a:prstGeom prst="roundRect">
+            <a:avLst>
+              <a:gd name="adj" fmla="val 5000"/>
+            </a:avLst>
+          </a:prstGeom>
+          <a:solidFill>
+            <a:srgbClr val="FFFFFF"/>
+          </a:solidFill>
+          <a:ln w="12700">
+            <a:solidFill>
+              <a:srgbClr val="E4DCCB"/>
+            </a:solidFill>
+            <a:prstDash val="solid"/>
+          </a:ln>
+        </p:spPr>
+      </p:sp>
+      <p:sp>
+        <p:nvSpPr>
+          <p:cNvPr id="10" name="Shape 8"/>
+          <p:cNvSpPr/>
+          <p:nvPr/>
+        </p:nvSpPr>
+        <p:spPr>
+          <a:xfrm>
+            <a:off x="640080" y="2926080"/>
+            <a:ext cx="54864" cy="1097280"/>
+          </a:xfrm>
+          <a:prstGeom prst="rect">
+            <a:avLst/>
+          </a:prstGeom>
+          <a:solidFill>
+            <a:srgbClr val="1D6FE0"/>
+          </a:solidFill>
+          <a:ln/>
+        </p:spPr>
+      </p:sp>
+      <p:sp>
+        <p:nvSpPr>
+          <p:cNvPr id="11" name="Text 9"/>
+          <p:cNvSpPr/>
+          <p:nvPr/>
+        </p:nvSpPr>
+        <p:spPr>
+          <a:xfrm>
+            <a:off x="914400" y="3035808"/>
+            <a:ext cx="10332720" cy="365760"/>
+          </a:xfrm>
+          <a:prstGeom prst="rect">
+            <a:avLst/>
+          </a:prstGeom>
+          <a:noFill/>
+          <a:ln/>
+        </p:spPr>
+        <p:txBody>
+          <a:bodyPr wrap="square" rtlCol="0" anchor="ctr"/>
+          <a:lstStyle/>
+          <a:p>
+            <a:pPr indent="0" marL="0">
+              <a:buNone/>
+            </a:pPr>
+            <a:r>
+              <a:rPr lang="en-US" sz="1400" b="1" dirty="0">
+                <a:solidFill>
+                  <a:srgbClr val="1B1F3B"/>
+                </a:solidFill>
+                <a:latin typeface="Segoe UI" pitchFamily="34" charset="0"/>
+                <a:ea typeface="Segoe UI" pitchFamily="34" charset="-122"/>
+                <a:cs typeface="Segoe UI" pitchFamily="34" charset="-120"/>
+              </a:rPr>
+              <a:t>Carte Abonnement dépliable avec formule, mode de paiement et modalités</a:t>
+            </a:r>
+            <a:endParaRPr lang="en-US" sz="1400" dirty="0"/>
+          </a:p>
+        </p:txBody>
+      </p:sp>
+      <p:sp>
+        <p:nvSpPr>
+          <p:cNvPr id="12" name="Text 10"/>
+          <p:cNvSpPr/>
+          <p:nvPr/>
+        </p:nvSpPr>
+        <p:spPr>
+          <a:xfrm>
+            <a:off x="914400" y="3383280"/>
+            <a:ext cx="10332720" cy="594360"/>
+          </a:xfrm>
+          <a:prstGeom prst="rect">
+            <a:avLst/>
+          </a:prstGeom>
+          <a:noFill/>
+          <a:ln/>
+        </p:spPr>
+        <p:txBody>
+          <a:bodyPr wrap="square" rtlCol="0" anchor="ctr"/>
+          <a:lstStyle/>
+          <a:p>
+            <a:pPr indent="0" marL="0">
+              <a:lnSpc>
+                <a:spcPts val="1400"/>
+              </a:lnSpc>
+              <a:buNone/>
+            </a:pPr>
+            <a:r>
+              <a:rPr lang="en-US" sz="1100" dirty="0">
+                <a:solidFill>
+                  <a:srgbClr val="8A7C68"/>
+                </a:solidFill>
+                <a:latin typeface="Segoe UI" pitchFamily="34" charset="0"/>
+                <a:ea typeface="Segoe UI" pitchFamily="34" charset="-122"/>
+                <a:cs typeface="Segoe UI" pitchFamily="34" charset="-120"/>
+              </a:rPr>
+              <a:t>Côté entreprise, la carte 'Abonnement' des Paramètres s'ouvre maintenant au clic sur 'Gérer' pour afficher la formule Koji actuelle, ainsi que les coordonnées bancaires (IBAN/BIC/titulaire) et les modalités de paiement — les mêmes champs que ceux du Profil, modifiables directement depuis cette carte et enregistrés au même endroit (une seule source de vérité, pas de duplication de données). Un lien 'Changer de formule' reste disponible pour comparer les 3 formules sur /abonnement.</a:t>
+            </a:r>
+            <a:endParaRPr lang="en-US" sz="1100" dirty="0"/>
+          </a:p>
+        </p:txBody>
+      </p:sp>
+      <p:sp>
+        <p:nvSpPr>
+          <p:cNvPr id="13" name="Text 11"/>
           <p:cNvSpPr/>
           <p:nvPr/>
         </p:nvSpPr>
@@ -12791,7 +12919,7 @@
       </p:sp>
       <p:sp>
         <p:nvSpPr>
-          <p:cNvPr id="10" name="Text 8"/>
+          <p:cNvPr id="14" name="Text 12"/>
           <p:cNvSpPr/>
           <p:nvPr/>
         </p:nvSpPr>
@@ -17478,7 +17606,7 @@
                 <a:ea typeface="Segoe UI" pitchFamily="34" charset="-122"/>
                 <a:cs typeface="Segoe UI" pitchFamily="34" charset="-120"/>
               </a:rPr>
-              <a:t>58 mise(s) à jour</a:t>
+              <a:t>59 mise(s) à jour</a:t>
             </a:r>
             <a:endParaRPr lang="en-US" sz="1200" dirty="0"/>
           </a:p>

</xml_diff>

<commit_message>
Abonnement: page dediee au lieu d'une carte depliable sur place
"Gerer" sur la carte Abonnement (entreprise) menait vers un contenu
qui s'affichait sur la meme page. Remplace par une vraie navigation
vers /parametres/abonnement : coordonnees bancaires (IBAN/BIC/
titulaire) et modalites de paiement en haut -- memes champs que
Profil, enregistres au meme endroit -- puis la formule Koji actuelle
en bas avec un lien "Changer de formule" qui mene lui-meme vers une
page separee (/abonnement) pour comparer les 3 formules, plutot que
d'afficher la comparaison en place.

Cote client/ouvrier, "Gerer" continue de mener directement vers
/abonnement (pas de coordonnees bancaires les concernant).

Co-Authored-By: Claude Sonnet 5 <noreply@anthropic.com>
</commit_message>
<xml_diff>
--- a/docs/manager-recap/Recap-Koji-Manager.pptx
+++ b/docs/manager-recap/Recap-Koji-Manager.pptx
@@ -12830,7 +12830,7 @@
                 <a:ea typeface="Segoe UI" pitchFamily="34" charset="-122"/>
                 <a:cs typeface="Segoe UI" pitchFamily="34" charset="-120"/>
               </a:rPr>
-              <a:t>Carte Abonnement dépliable avec formule, mode de paiement et modalités</a:t>
+              <a:t>Nouvelle page Abonnement dédiée (coordonnées bancaires puis formule)</a:t>
             </a:r>
             <a:endParaRPr lang="en-US" sz="1400" dirty="0"/>
           </a:p>
@@ -12872,7 +12872,7 @@
                 <a:ea typeface="Segoe UI" pitchFamily="34" charset="-122"/>
                 <a:cs typeface="Segoe UI" pitchFamily="34" charset="-120"/>
               </a:rPr>
-              <a:t>Côté entreprise, la carte 'Abonnement' des Paramètres s'ouvre maintenant au clic sur 'Gérer' pour afficher la formule Koji actuelle, ainsi que les coordonnées bancaires (IBAN/BIC/titulaire) et les modalités de paiement — les mêmes champs que ceux du Profil, modifiables directement depuis cette carte et enregistrés au même endroit (une seule source de vérité, pas de duplication de données). Un lien 'Changer de formule' reste disponible pour comparer les 3 formules sur /abonnement.</a:t>
+              <a:t>Côté entreprise, 'Gérer' sur la carte Abonnement des Paramètres mène désormais vers une page dédiée /parametres/abonnement, plutôt que d'afficher le contenu sur la même page : coordonnées bancaires (IBAN/BIC/titulaire) et modalités de paiement en haut — les mêmes champs que le Profil, modifiables ici et enregistrés au même endroit, sans duplication — puis la formule Koji actuelle en bas, avec un lien 'Changer de formule' qui mène à son tour vers /abonnement pour comparer les 3 formules, sur une page séparée elle aussi.</a:t>
             </a:r>
             <a:endParaRPr lang="en-US" sz="1100" dirty="0"/>
           </a:p>

</xml_diff>

<commit_message>
Selecteur de langue deplace des topbars vers Parametres uniquement
Le selecteur de langue (FR/EN/AR/DE/IT) affiche en haut de chaque page
(entreprise, client, ouvrier) est retire au profit d'une carte "Langue"
dans Parametres qui affiche la langue actuelle sous forme de pastilles
cliquables. Reste present uniquement sur les ecrans de connexion, avant
que Parametres ne soit accessible.

Co-Authored-By: Claude Sonnet 5 <noreply@anthropic.com>
</commit_message>
<xml_diff>
--- a/docs/manager-recap/Recap-Koji-Manager.pptx
+++ b/docs/manager-recap/Recap-Koji-Manager.pptx
@@ -11895,7 +11895,7 @@
                 <a:ea typeface="Georgia" pitchFamily="34" charset="-122"/>
                 <a:cs typeface="Georgia" pitchFamily="34" charset="-120"/>
               </a:rPr>
-              <a:t>114</a:t>
+              <a:t>115</a:t>
             </a:r>
             <a:endParaRPr lang="en-US" sz="3200" dirty="0"/>
           </a:p>
@@ -12000,7 +12000,7 @@
                 <a:ea typeface="Georgia" pitchFamily="34" charset="-122"/>
                 <a:cs typeface="Georgia" pitchFamily="34" charset="-120"/>
               </a:rPr>
-              <a:t>59</a:t>
+              <a:t>60</a:t>
             </a:r>
             <a:endParaRPr lang="en-US" sz="3200" dirty="0"/>
           </a:p>
@@ -12880,7 +12880,135 @@
       </p:sp>
       <p:sp>
         <p:nvSpPr>
-          <p:cNvPr id="13" name="Text 11"/>
+          <p:cNvPr id="13" name="Shape 11"/>
+          <p:cNvSpPr/>
+          <p:nvPr/>
+        </p:nvSpPr>
+        <p:spPr>
+          <a:xfrm>
+            <a:off x="640080" y="4160520"/>
+            <a:ext cx="10881360" cy="1097280"/>
+          </a:xfrm>
+          <a:prstGeom prst="roundRect">
+            <a:avLst>
+              <a:gd name="adj" fmla="val 5000"/>
+            </a:avLst>
+          </a:prstGeom>
+          <a:solidFill>
+            <a:srgbClr val="FFFFFF"/>
+          </a:solidFill>
+          <a:ln w="12700">
+            <a:solidFill>
+              <a:srgbClr val="E4DCCB"/>
+            </a:solidFill>
+            <a:prstDash val="solid"/>
+          </a:ln>
+        </p:spPr>
+      </p:sp>
+      <p:sp>
+        <p:nvSpPr>
+          <p:cNvPr id="14" name="Shape 12"/>
+          <p:cNvSpPr/>
+          <p:nvPr/>
+        </p:nvSpPr>
+        <p:spPr>
+          <a:xfrm>
+            <a:off x="640080" y="4160520"/>
+            <a:ext cx="54864" cy="1097280"/>
+          </a:xfrm>
+          <a:prstGeom prst="rect">
+            <a:avLst/>
+          </a:prstGeom>
+          <a:solidFill>
+            <a:srgbClr val="1D6FE0"/>
+          </a:solidFill>
+          <a:ln/>
+        </p:spPr>
+      </p:sp>
+      <p:sp>
+        <p:nvSpPr>
+          <p:cNvPr id="15" name="Text 13"/>
+          <p:cNvSpPr/>
+          <p:nvPr/>
+        </p:nvSpPr>
+        <p:spPr>
+          <a:xfrm>
+            <a:off x="914400" y="4270248"/>
+            <a:ext cx="10332720" cy="365760"/>
+          </a:xfrm>
+          <a:prstGeom prst="rect">
+            <a:avLst/>
+          </a:prstGeom>
+          <a:noFill/>
+          <a:ln/>
+        </p:spPr>
+        <p:txBody>
+          <a:bodyPr wrap="square" rtlCol="0" anchor="ctr"/>
+          <a:lstStyle/>
+          <a:p>
+            <a:pPr indent="0" marL="0">
+              <a:buNone/>
+            </a:pPr>
+            <a:r>
+              <a:rPr lang="en-US" sz="1400" b="1" dirty="0">
+                <a:solidFill>
+                  <a:srgbClr val="1B1F3B"/>
+                </a:solidFill>
+                <a:latin typeface="Segoe UI" pitchFamily="34" charset="0"/>
+                <a:ea typeface="Segoe UI" pitchFamily="34" charset="-122"/>
+                <a:cs typeface="Segoe UI" pitchFamily="34" charset="-120"/>
+              </a:rPr>
+              <a:t>Sélecteur de langue déplacé des menus vers Paramètres uniquement</a:t>
+            </a:r>
+            <a:endParaRPr lang="en-US" sz="1400" dirty="0"/>
+          </a:p>
+        </p:txBody>
+      </p:sp>
+      <p:sp>
+        <p:nvSpPr>
+          <p:cNvPr id="16" name="Text 14"/>
+          <p:cNvSpPr/>
+          <p:nvPr/>
+        </p:nvSpPr>
+        <p:spPr>
+          <a:xfrm>
+            <a:off x="914400" y="4617720"/>
+            <a:ext cx="10332720" cy="594360"/>
+          </a:xfrm>
+          <a:prstGeom prst="rect">
+            <a:avLst/>
+          </a:prstGeom>
+          <a:noFill/>
+          <a:ln/>
+        </p:spPr>
+        <p:txBody>
+          <a:bodyPr wrap="square" rtlCol="0" anchor="ctr"/>
+          <a:lstStyle/>
+          <a:p>
+            <a:pPr indent="0" marL="0">
+              <a:lnSpc>
+                <a:spcPts val="1400"/>
+              </a:lnSpc>
+              <a:buNone/>
+            </a:pPr>
+            <a:r>
+              <a:rPr lang="en-US" sz="1100" dirty="0">
+                <a:solidFill>
+                  <a:srgbClr val="8A7C68"/>
+                </a:solidFill>
+                <a:latin typeface="Segoe UI" pitchFamily="34" charset="0"/>
+                <a:ea typeface="Segoe UI" pitchFamily="34" charset="-122"/>
+                <a:cs typeface="Segoe UI" pitchFamily="34" charset="-120"/>
+              </a:rPr>
+              <a:t>Le sélecteur de langue (FR/EN/AR/DE/IT) affiché en haut de chaque page (entreprise, client, ouvrier) est retiré : la langue se change désormais uniquement depuis la carte 'Langue' des Paramètres, qui affiche clairement la langue actuellement sélectionnée et permet de choisir parmi les langues disponibles en un clic (pastilles, plus de menu déroulant caché). Le sélecteur reste présent uniquement sur les écrans de connexion, avant que Paramètres ne soit accessible.</a:t>
+            </a:r>
+            <a:endParaRPr lang="en-US" sz="1100" dirty="0"/>
+          </a:p>
+        </p:txBody>
+      </p:sp>
+      <p:sp>
+        <p:nvSpPr>
+          <p:cNvPr id="17" name="Text 15"/>
           <p:cNvSpPr/>
           <p:nvPr/>
         </p:nvSpPr>
@@ -12919,7 +13047,7 @@
       </p:sp>
       <p:sp>
         <p:nvSpPr>
-          <p:cNvPr id="14" name="Text 12"/>
+          <p:cNvPr id="18" name="Text 16"/>
           <p:cNvSpPr/>
           <p:nvPr/>
         </p:nvSpPr>
@@ -17606,7 +17734,7 @@
                 <a:ea typeface="Segoe UI" pitchFamily="34" charset="-122"/>
                 <a:cs typeface="Segoe UI" pitchFamily="34" charset="-120"/>
               </a:rPr>
-              <a:t>59 mise(s) à jour</a:t>
+              <a:t>60 mise(s) à jour</a:t>
             </a:r>
             <a:endParaRPr lang="en-US" sz="1200" dirty="0"/>
           </a:p>

</xml_diff>

<commit_message>
Parametres: boutons Securite empiles verticalement
Les boutons "Signaler un probleme technique", "Aide" et "Mentions
legales & politiques" de la carte Securite (profil entreprise, variant
cards) etaient sur une seule ligne flex-wrap ; ajout d'un modificateur
profile-card-actions-column pour les empiler verticalement.

Co-Authored-By: Claude Sonnet 5 <noreply@anthropic.com>
</commit_message>
<xml_diff>
--- a/docs/manager-recap/Recap-Koji-Manager.pptx
+++ b/docs/manager-recap/Recap-Koji-Manager.pptx
@@ -11895,7 +11895,7 @@
                 <a:ea typeface="Georgia" pitchFamily="34" charset="-122"/>
                 <a:cs typeface="Georgia" pitchFamily="34" charset="-120"/>
               </a:rPr>
-              <a:t>115</a:t>
+              <a:t>116</a:t>
             </a:r>
             <a:endParaRPr lang="en-US" sz="3200" dirty="0"/>
           </a:p>
@@ -12000,7 +12000,7 @@
                 <a:ea typeface="Georgia" pitchFamily="34" charset="-122"/>
                 <a:cs typeface="Georgia" pitchFamily="34" charset="-120"/>
               </a:rPr>
-              <a:t>60</a:t>
+              <a:t>61</a:t>
             </a:r>
             <a:endParaRPr lang="en-US" sz="3200" dirty="0"/>
           </a:p>
@@ -13008,7 +13008,135 @@
       </p:sp>
       <p:sp>
         <p:nvSpPr>
-          <p:cNvPr id="17" name="Text 15"/>
+          <p:cNvPr id="17" name="Shape 15"/>
+          <p:cNvSpPr/>
+          <p:nvPr/>
+        </p:nvSpPr>
+        <p:spPr>
+          <a:xfrm>
+            <a:off x="640080" y="5394960"/>
+            <a:ext cx="10881360" cy="1097280"/>
+          </a:xfrm>
+          <a:prstGeom prst="roundRect">
+            <a:avLst>
+              <a:gd name="adj" fmla="val 5000"/>
+            </a:avLst>
+          </a:prstGeom>
+          <a:solidFill>
+            <a:srgbClr val="FFFFFF"/>
+          </a:solidFill>
+          <a:ln w="12700">
+            <a:solidFill>
+              <a:srgbClr val="E4DCCB"/>
+            </a:solidFill>
+            <a:prstDash val="solid"/>
+          </a:ln>
+        </p:spPr>
+      </p:sp>
+      <p:sp>
+        <p:nvSpPr>
+          <p:cNvPr id="18" name="Shape 16"/>
+          <p:cNvSpPr/>
+          <p:nvPr/>
+        </p:nvSpPr>
+        <p:spPr>
+          <a:xfrm>
+            <a:off x="640080" y="5394960"/>
+            <a:ext cx="54864" cy="1097280"/>
+          </a:xfrm>
+          <a:prstGeom prst="rect">
+            <a:avLst/>
+          </a:prstGeom>
+          <a:solidFill>
+            <a:srgbClr val="1D6FE0"/>
+          </a:solidFill>
+          <a:ln/>
+        </p:spPr>
+      </p:sp>
+      <p:sp>
+        <p:nvSpPr>
+          <p:cNvPr id="19" name="Text 17"/>
+          <p:cNvSpPr/>
+          <p:nvPr/>
+        </p:nvSpPr>
+        <p:spPr>
+          <a:xfrm>
+            <a:off x="914400" y="5504688"/>
+            <a:ext cx="10332720" cy="365760"/>
+          </a:xfrm>
+          <a:prstGeom prst="rect">
+            <a:avLst/>
+          </a:prstGeom>
+          <a:noFill/>
+          <a:ln/>
+        </p:spPr>
+        <p:txBody>
+          <a:bodyPr wrap="square" rtlCol="0" anchor="ctr"/>
+          <a:lstStyle/>
+          <a:p>
+            <a:pPr indent="0" marL="0">
+              <a:buNone/>
+            </a:pPr>
+            <a:r>
+              <a:rPr lang="en-US" sz="1400" b="1" dirty="0">
+                <a:solidFill>
+                  <a:srgbClr val="1B1F3B"/>
+                </a:solidFill>
+                <a:latin typeface="Segoe UI" pitchFamily="34" charset="0"/>
+                <a:ea typeface="Segoe UI" pitchFamily="34" charset="-122"/>
+                <a:cs typeface="Segoe UI" pitchFamily="34" charset="-120"/>
+              </a:rPr>
+              <a:t>Boutons Securite des Parametres empiles verticalement</a:t>
+            </a:r>
+            <a:endParaRPr lang="en-US" sz="1400" dirty="0"/>
+          </a:p>
+        </p:txBody>
+      </p:sp>
+      <p:sp>
+        <p:nvSpPr>
+          <p:cNvPr id="20" name="Text 18"/>
+          <p:cNvSpPr/>
+          <p:nvPr/>
+        </p:nvSpPr>
+        <p:spPr>
+          <a:xfrm>
+            <a:off x="914400" y="5852160"/>
+            <a:ext cx="10332720" cy="594360"/>
+          </a:xfrm>
+          <a:prstGeom prst="rect">
+            <a:avLst/>
+          </a:prstGeom>
+          <a:noFill/>
+          <a:ln/>
+        </p:spPr>
+        <p:txBody>
+          <a:bodyPr wrap="square" rtlCol="0" anchor="ctr"/>
+          <a:lstStyle/>
+          <a:p>
+            <a:pPr indent="0" marL="0">
+              <a:lnSpc>
+                <a:spcPts val="1400"/>
+              </a:lnSpc>
+              <a:buNone/>
+            </a:pPr>
+            <a:r>
+              <a:rPr lang="en-US" sz="1100" dirty="0">
+                <a:solidFill>
+                  <a:srgbClr val="8A7C68"/>
+                </a:solidFill>
+                <a:latin typeface="Segoe UI" pitchFamily="34" charset="0"/>
+                <a:ea typeface="Segoe UI" pitchFamily="34" charset="-122"/>
+                <a:cs typeface="Segoe UI" pitchFamily="34" charset="-120"/>
+              </a:rPr>
+              <a:t>Dans la carte 'Securite' des Parametres (profil entreprise), les trois boutons 'Signaler un probleme technique', 'Aide' et 'Mentions legales &amp; politiques' etaient cote a cote sur une meme ligne : ils sont desormais empiles verticalement, chacun sur sa propre ligne, pour rester lisibles quel que soit la largeur d'ecran.</a:t>
+            </a:r>
+            <a:endParaRPr lang="en-US" sz="1100" dirty="0"/>
+          </a:p>
+        </p:txBody>
+      </p:sp>
+      <p:sp>
+        <p:nvSpPr>
+          <p:cNvPr id="21" name="Text 19"/>
           <p:cNvSpPr/>
           <p:nvPr/>
         </p:nvSpPr>
@@ -13047,7 +13175,7 @@
       </p:sp>
       <p:sp>
         <p:nvSpPr>
-          <p:cNvPr id="18" name="Text 16"/>
+          <p:cNvPr id="22" name="Text 20"/>
           <p:cNvSpPr/>
           <p:nvPr/>
         </p:nvSpPr>
@@ -17734,7 +17862,7 @@
                 <a:ea typeface="Segoe UI" pitchFamily="34" charset="-122"/>
                 <a:cs typeface="Segoe UI" pitchFamily="34" charset="-120"/>
               </a:rPr>
-              <a:t>60 mise(s) à jour</a:t>
+              <a:t>61 mise(s) à jour</a:t>
             </a:r>
             <a:endParaRPr lang="en-US" sz="1200" dirty="0"/>
           </a:p>

</xml_diff>

<commit_message>
Signalement technique: notification par email a contact@kojibuild.com
contact@kojibuild.com est la boite dediee aux reclamations et demandes
d'aide. Le bouton "Signaler un probleme technique" (Parametres, les 3
profils) enregistrait deja le message en base sans jamais notifier
personne ; il envoie desormais aussi un email a cette adresse (best
effort, n'empeche pas l'enregistrement si l'envoi echoue).

Co-Authored-By: Claude Sonnet 5 <noreply@anthropic.com>
</commit_message>
<xml_diff>
--- a/docs/manager-recap/Recap-Koji-Manager.pptx
+++ b/docs/manager-recap/Recap-Koji-Manager.pptx
@@ -56,9 +56,10 @@
     <p:sldId id="304" r:id="rId50"/>
     <p:sldId id="305" r:id="rId51"/>
     <p:sldId id="306" r:id="rId52"/>
+    <p:sldId id="307" r:id="rId53"/>
   </p:sldIdLst>
   <p:notesMasterIdLst>
-    <p:notesMasterId r:id="rId53"/>
+    <p:notesMasterId r:id="rId54"/>
   </p:notesMasterIdLst>
   <p:sldSz cx="12191695" cy="6858000"/>
   <p:notesSz cx="6858000" cy="12191695"/>
@@ -4624,6 +4625,94 @@
             <a:fld id="{F7021451-1387-4CA6-816F-3879F97B5CBC}" type="slidenum">
               <a:rPr lang="en-US"/>
               <a:t>51</a:t>
+            </a:fld>
+            <a:endParaRPr lang="en-US"/>
+          </a:p>
+        </p:txBody>
+      </p:sp>
+    </p:spTree>
+    <p:extLst>
+      <p:ext uri="{BB962C8B-B14F-4D97-AF65-F5344CB8AC3E}">
+        <p14:creationId xmlns:p14="http://schemas.microsoft.com/office/powerpoint/2010/main" val="1024086991"/>
+      </p:ext>
+    </p:extLst>
+  </p:cSld>
+  <p:clrMapOvr>
+    <a:masterClrMapping/>
+  </p:clrMapOvr>
+</p:notes>
+</file>
+
+<file path=ppt/notesSlides/notesSlide52.xml><?xml version="1.0" encoding="utf-8"?>
+<p:notes xmlns:a="http://schemas.openxmlformats.org/drawingml/2006/main" xmlns:r="http://schemas.openxmlformats.org/officeDocument/2006/relationships" xmlns:p="http://schemas.openxmlformats.org/presentationml/2006/main">
+  <p:cSld>
+    <p:spTree>
+      <p:nvGrpSpPr>
+        <p:cNvPr id="1" name=""/>
+        <p:cNvGrpSpPr/>
+        <p:nvPr/>
+      </p:nvGrpSpPr>
+      <p:grpSpPr>
+        <a:xfrm>
+          <a:off x="0" y="0"/>
+          <a:ext cx="0" cy="0"/>
+          <a:chOff x="0" y="0"/>
+          <a:chExt cx="0" cy="0"/>
+        </a:xfrm>
+      </p:grpSpPr>
+      <p:sp>
+        <p:nvSpPr>
+          <p:cNvPr id="2" name="Slide Image Placeholder 1"/>
+          <p:cNvSpPr>
+            <a:spLocks noGrp="1" noRot="1" noChangeAspect="1"/>
+          </p:cNvSpPr>
+          <p:nvPr>
+            <p:ph type="sldImg"/>
+          </p:nvPr>
+        </p:nvSpPr>
+        <p:spPr/>
+      </p:sp>
+      <p:sp>
+        <p:nvSpPr>
+          <p:cNvPr id="3" name="Notes Placeholder 2"/>
+          <p:cNvSpPr>
+            <a:spLocks noGrp="1"/>
+          </p:cNvSpPr>
+          <p:nvPr>
+            <p:ph type="body" idx="1"/>
+          </p:nvPr>
+        </p:nvSpPr>
+        <p:spPr/>
+        <p:txBody>
+          <a:bodyPr/>
+          <a:lstStyle/>
+          <a:p>
+            <a:r>
+              <a:rPr lang="en-US" dirty="0"/>
+              <a:t/>
+            </a:r>
+            <a:endParaRPr lang="en-US" dirty="0"/>
+          </a:p>
+        </p:txBody>
+      </p:sp>
+      <p:sp>
+        <p:nvSpPr>
+          <p:cNvPr id="4" name="Slide Number Placeholder 3"/>
+          <p:cNvSpPr>
+            <a:spLocks noGrp="1"/>
+          </p:cNvSpPr>
+          <p:nvPr>
+            <p:ph type="sldNum" sz="quarter" idx="10"/>
+          </p:nvPr>
+        </p:nvSpPr>
+        <p:spPr/>
+        <p:txBody>
+          <a:bodyPr/>
+          <a:lstStyle/>
+          <a:p>
+            <a:fld id="{F7021451-1387-4CA6-816F-3879F97B5CBC}" type="slidenum">
+              <a:rPr lang="en-US"/>
+              <a:t>52</a:t>
             </a:fld>
             <a:endParaRPr lang="en-US"/>
           </a:p>
@@ -12073,7 +12162,7 @@
                 <a:ea typeface="Georgia" pitchFamily="34" charset="-122"/>
                 <a:cs typeface="Georgia" pitchFamily="34" charset="-120"/>
               </a:rPr>
-              <a:t>119</a:t>
+              <a:t>120</a:t>
             </a:r>
             <a:endParaRPr lang="en-US" sz="3200" dirty="0"/>
           </a:p>
@@ -12283,7 +12372,7 @@
                 <a:ea typeface="Georgia" pitchFamily="34" charset="-122"/>
                 <a:cs typeface="Georgia" pitchFamily="34" charset="-120"/>
               </a:rPr>
-              <a:t>46</a:t>
+              <a:t>47</a:t>
             </a:r>
             <a:endParaRPr lang="en-US" sz="3200" dirty="0"/>
           </a:p>
@@ -14229,7 +14318,7 @@
                 <a:ea typeface="Segoe UI" pitchFamily="34" charset="-122"/>
                 <a:cs typeface="Segoe UI" pitchFamily="34" charset="-120"/>
               </a:rPr>
-              <a:t>46 mise(s) à jour</a:t>
+              <a:t>47 mise(s) à jour</a:t>
             </a:r>
             <a:endParaRPr lang="en-US" sz="1200" dirty="0"/>
           </a:p>
@@ -25174,6 +25263,344 @@
     <p:bg>
       <p:bgPr>
         <a:solidFill>
+          <a:srgbClr val="F3EEE3"/>
+        </a:solidFill>
+      </p:bgPr>
+    </p:bg>
+    <p:spTree>
+      <p:nvGrpSpPr>
+        <p:cNvPr id="1" name=""/>
+        <p:cNvGrpSpPr/>
+        <p:nvPr/>
+      </p:nvGrpSpPr>
+      <p:grpSpPr>
+        <a:xfrm>
+          <a:off x="0" y="0"/>
+          <a:ext cx="0" cy="0"/>
+          <a:chOff x="0" y="0"/>
+          <a:chExt cx="0" cy="0"/>
+        </a:xfrm>
+      </p:grpSpPr>
+      <p:sp>
+        <p:nvSpPr>
+          <p:cNvPr id="2" name="Shape 0"/>
+          <p:cNvSpPr/>
+          <p:nvPr/>
+        </p:nvSpPr>
+        <p:spPr>
+          <a:xfrm>
+            <a:off x="640080" y="411480"/>
+            <a:ext cx="2377440" cy="365760"/>
+          </a:xfrm>
+          <a:prstGeom prst="roundRect">
+            <a:avLst>
+              <a:gd name="adj" fmla="val 50000"/>
+            </a:avLst>
+          </a:prstGeom>
+          <a:solidFill>
+            <a:srgbClr val="F5E6DA"/>
+          </a:solidFill>
+          <a:ln/>
+        </p:spPr>
+      </p:sp>
+      <p:sp>
+        <p:nvSpPr>
+          <p:cNvPr id="3" name="Text 1"/>
+          <p:cNvSpPr/>
+          <p:nvPr/>
+        </p:nvSpPr>
+        <p:spPr>
+          <a:xfrm>
+            <a:off x="640080" y="411480"/>
+            <a:ext cx="2377440" cy="365760"/>
+          </a:xfrm>
+          <a:prstGeom prst="rect">
+            <a:avLst/>
+          </a:prstGeom>
+          <a:noFill/>
+          <a:ln/>
+        </p:spPr>
+        <p:txBody>
+          <a:bodyPr wrap="square" rtlCol="0" anchor="ctr"/>
+          <a:lstStyle/>
+          <a:p>
+            <a:pPr algn="ctr" indent="0" marL="0">
+              <a:buNone/>
+            </a:pPr>
+            <a:r>
+              <a:rPr lang="en-US" sz="1000" b="1" spc="100" kern="0" dirty="0">
+                <a:solidFill>
+                  <a:srgbClr val="9A4C1F"/>
+                </a:solidFill>
+                <a:latin typeface="Segoe UI" pitchFamily="34" charset="0"/>
+                <a:ea typeface="Segoe UI" pitchFamily="34" charset="-122"/>
+                <a:cs typeface="Segoe UI" pitchFamily="34" charset="-120"/>
+              </a:rPr>
+              <a:t>BACKEND</a:t>
+            </a:r>
+            <a:endParaRPr lang="en-US" sz="1000" dirty="0"/>
+          </a:p>
+        </p:txBody>
+      </p:sp>
+      <p:sp>
+        <p:nvSpPr>
+          <p:cNvPr id="4" name="Text 2"/>
+          <p:cNvSpPr/>
+          <p:nvPr/>
+        </p:nvSpPr>
+        <p:spPr>
+          <a:xfrm>
+            <a:off x="640080" y="868680"/>
+            <a:ext cx="10515600" cy="548640"/>
+          </a:xfrm>
+          <a:prstGeom prst="rect">
+            <a:avLst/>
+          </a:prstGeom>
+          <a:noFill/>
+          <a:ln/>
+        </p:spPr>
+        <p:txBody>
+          <a:bodyPr wrap="square" rtlCol="0" anchor="ctr"/>
+          <a:lstStyle/>
+          <a:p>
+            <a:pPr indent="0" marL="0">
+              <a:buNone/>
+            </a:pPr>
+            <a:r>
+              <a:rPr lang="en-US" sz="2400" b="1" dirty="0">
+                <a:solidFill>
+                  <a:srgbClr val="1B1F3B"/>
+                </a:solidFill>
+                <a:latin typeface="Georgia" pitchFamily="34" charset="0"/>
+                <a:ea typeface="Georgia" pitchFamily="34" charset="-122"/>
+                <a:cs typeface="Georgia" pitchFamily="34" charset="-120"/>
+              </a:rPr>
+              <a:t>Support</a:t>
+            </a:r>
+            <a:endParaRPr lang="en-US" sz="2400" dirty="0"/>
+          </a:p>
+        </p:txBody>
+      </p:sp>
+      <p:sp>
+        <p:nvSpPr>
+          <p:cNvPr id="5" name="Shape 3"/>
+          <p:cNvSpPr/>
+          <p:nvPr/>
+        </p:nvSpPr>
+        <p:spPr>
+          <a:xfrm>
+            <a:off x="640080" y="1691640"/>
+            <a:ext cx="10881360" cy="1097280"/>
+          </a:xfrm>
+          <a:prstGeom prst="roundRect">
+            <a:avLst>
+              <a:gd name="adj" fmla="val 5000"/>
+            </a:avLst>
+          </a:prstGeom>
+          <a:solidFill>
+            <a:srgbClr val="FFFFFF"/>
+          </a:solidFill>
+          <a:ln w="12700">
+            <a:solidFill>
+              <a:srgbClr val="E4DCCB"/>
+            </a:solidFill>
+            <a:prstDash val="solid"/>
+          </a:ln>
+        </p:spPr>
+      </p:sp>
+      <p:sp>
+        <p:nvSpPr>
+          <p:cNvPr id="6" name="Shape 4"/>
+          <p:cNvSpPr/>
+          <p:nvPr/>
+        </p:nvSpPr>
+        <p:spPr>
+          <a:xfrm>
+            <a:off x="640080" y="1691640"/>
+            <a:ext cx="54864" cy="1097280"/>
+          </a:xfrm>
+          <a:prstGeom prst="rect">
+            <a:avLst/>
+          </a:prstGeom>
+          <a:solidFill>
+            <a:srgbClr val="9A4C1F"/>
+          </a:solidFill>
+          <a:ln/>
+        </p:spPr>
+      </p:sp>
+      <p:sp>
+        <p:nvSpPr>
+          <p:cNvPr id="7" name="Text 5"/>
+          <p:cNvSpPr/>
+          <p:nvPr/>
+        </p:nvSpPr>
+        <p:spPr>
+          <a:xfrm>
+            <a:off x="914400" y="1801368"/>
+            <a:ext cx="10332720" cy="365760"/>
+          </a:xfrm>
+          <a:prstGeom prst="rect">
+            <a:avLst/>
+          </a:prstGeom>
+          <a:noFill/>
+          <a:ln/>
+        </p:spPr>
+        <p:txBody>
+          <a:bodyPr wrap="square" rtlCol="0" anchor="ctr"/>
+          <a:lstStyle/>
+          <a:p>
+            <a:pPr indent="0" marL="0">
+              <a:buNone/>
+            </a:pPr>
+            <a:r>
+              <a:rPr lang="en-US" sz="1400" b="1" dirty="0">
+                <a:solidFill>
+                  <a:srgbClr val="1B1F3B"/>
+                </a:solidFill>
+                <a:latin typeface="Segoe UI" pitchFamily="34" charset="0"/>
+                <a:ea typeface="Segoe UI" pitchFamily="34" charset="-122"/>
+                <a:cs typeface="Segoe UI" pitchFamily="34" charset="-120"/>
+              </a:rPr>
+              <a:t>Adresse contact@kojibuild.com branchee sur Aide et les signalements techniques</a:t>
+            </a:r>
+            <a:endParaRPr lang="en-US" sz="1400" dirty="0"/>
+          </a:p>
+        </p:txBody>
+      </p:sp>
+      <p:sp>
+        <p:nvSpPr>
+          <p:cNvPr id="8" name="Text 6"/>
+          <p:cNvSpPr/>
+          <p:nvPr/>
+        </p:nvSpPr>
+        <p:spPr>
+          <a:xfrm>
+            <a:off x="914400" y="2148840"/>
+            <a:ext cx="10332720" cy="594360"/>
+          </a:xfrm>
+          <a:prstGeom prst="rect">
+            <a:avLst/>
+          </a:prstGeom>
+          <a:noFill/>
+          <a:ln/>
+        </p:spPr>
+        <p:txBody>
+          <a:bodyPr wrap="square" rtlCol="0" anchor="ctr"/>
+          <a:lstStyle/>
+          <a:p>
+            <a:pPr indent="0" marL="0">
+              <a:lnSpc>
+                <a:spcPts val="1400"/>
+              </a:lnSpc>
+              <a:buNone/>
+            </a:pPr>
+            <a:r>
+              <a:rPr lang="en-US" sz="1100" dirty="0">
+                <a:solidFill>
+                  <a:srgbClr val="8A7C68"/>
+                </a:solidFill>
+                <a:latin typeface="Segoe UI" pitchFamily="34" charset="0"/>
+                <a:ea typeface="Segoe UI" pitchFamily="34" charset="-122"/>
+                <a:cs typeface="Segoe UI" pitchFamily="34" charset="-120"/>
+              </a:rPr>
+              <a:t>L'adresse contact@kojibuild.com (destinee a recevoir les reclamations et demandes d'aide) remplace le placeholder contact@koji.app sur la page Aide et sur le bouton 'Contactez-nous' de l'abonnement (comptes particulier/ouvrier). Nouveaute : quand un utilisateur (entreprise, client ou ouvrier) utilise 'Signaler un probleme technique' dans Parametres, un email est desormais envoye automatiquement a contact@kojibuild.com avec le message, la page d'origine et le type de compte, en plus de l'enregistrement existant ; auparavant le signalement restait invisible tant que personne n'allait le consulter manuellement dans les donnees de l'application.</a:t>
+            </a:r>
+            <a:endParaRPr lang="en-US" sz="1100" dirty="0"/>
+          </a:p>
+        </p:txBody>
+      </p:sp>
+      <p:sp>
+        <p:nvSpPr>
+          <p:cNvPr id="9" name="Text 7"/>
+          <p:cNvSpPr/>
+          <p:nvPr/>
+        </p:nvSpPr>
+        <p:spPr>
+          <a:xfrm>
+            <a:off x="365760" y="6510528"/>
+            <a:ext cx="5486400" cy="274320"/>
+          </a:xfrm>
+          <a:prstGeom prst="rect">
+            <a:avLst/>
+          </a:prstGeom>
+          <a:noFill/>
+          <a:ln/>
+        </p:spPr>
+        <p:txBody>
+          <a:bodyPr wrap="square" rtlCol="0" anchor="ctr"/>
+          <a:lstStyle/>
+          <a:p>
+            <a:pPr indent="0" marL="0">
+              <a:buNone/>
+            </a:pPr>
+            <a:r>
+              <a:rPr lang="en-US" sz="900" dirty="0">
+                <a:solidFill>
+                  <a:srgbClr val="8A7C68"/>
+                </a:solidFill>
+                <a:latin typeface="Segoe UI" pitchFamily="34" charset="0"/>
+                <a:ea typeface="Segoe UI" pitchFamily="34" charset="-122"/>
+                <a:cs typeface="Segoe UI" pitchFamily="34" charset="-120"/>
+              </a:rPr>
+              <a:t>Koji Web — Récapitulatif technique</a:t>
+            </a:r>
+            <a:endParaRPr lang="en-US" sz="900" dirty="0"/>
+          </a:p>
+        </p:txBody>
+      </p:sp>
+      <p:sp>
+        <p:nvSpPr>
+          <p:cNvPr id="10" name="Text 8"/>
+          <p:cNvSpPr/>
+          <p:nvPr/>
+        </p:nvSpPr>
+        <p:spPr>
+          <a:xfrm>
+            <a:off x="9601200" y="6510528"/>
+            <a:ext cx="2194560" cy="274320"/>
+          </a:xfrm>
+          <a:prstGeom prst="rect">
+            <a:avLst/>
+          </a:prstGeom>
+          <a:noFill/>
+          <a:ln/>
+        </p:spPr>
+        <p:txBody>
+          <a:bodyPr wrap="square" rtlCol="0" anchor="ctr"/>
+          <a:lstStyle/>
+          <a:p>
+            <a:pPr algn="r" indent="0" marL="0">
+              <a:buNone/>
+            </a:pPr>
+            <a:r>
+              <a:rPr lang="en-US" sz="900" dirty="0">
+                <a:solidFill>
+                  <a:srgbClr val="8A7C68"/>
+                </a:solidFill>
+                <a:latin typeface="Segoe UI" pitchFamily="34" charset="0"/>
+                <a:ea typeface="Segoe UI" pitchFamily="34" charset="-122"/>
+                <a:cs typeface="Segoe UI" pitchFamily="34" charset="-120"/>
+              </a:rPr>
+              <a:t>43</a:t>
+            </a:r>
+            <a:endParaRPr lang="en-US" sz="900" dirty="0"/>
+          </a:p>
+        </p:txBody>
+      </p:sp>
+    </p:spTree>
+  </p:cSld>
+  <p:clrMapOvr>
+    <a:masterClrMapping/>
+  </p:clrMapOvr>
+</p:sld>
+</file>
+
+<file path=ppt/slides/slide44.xml><?xml version="1.0" encoding="utf-8"?>
+<p:sld xmlns:a="http://schemas.openxmlformats.org/drawingml/2006/main" xmlns:r="http://schemas.openxmlformats.org/officeDocument/2006/relationships" xmlns:p="http://schemas.openxmlformats.org/presentationml/2006/main">
+  <p:cSld name="Slide 44">
+    <p:bg>
+      <p:bgPr>
+        <a:solidFill>
           <a:srgbClr val="0B1030"/>
         </a:solidFill>
       </p:bgPr>
@@ -25371,344 +25798,6 @@
       <p:sp>
         <p:nvSpPr>
           <p:cNvPr id="7" name="Text 5"/>
-          <p:cNvSpPr/>
-          <p:nvPr/>
-        </p:nvSpPr>
-        <p:spPr>
-          <a:xfrm>
-            <a:off x="9601200" y="6510528"/>
-            <a:ext cx="2194560" cy="274320"/>
-          </a:xfrm>
-          <a:prstGeom prst="rect">
-            <a:avLst/>
-          </a:prstGeom>
-          <a:noFill/>
-          <a:ln/>
-        </p:spPr>
-        <p:txBody>
-          <a:bodyPr wrap="square" rtlCol="0" anchor="ctr"/>
-          <a:lstStyle/>
-          <a:p>
-            <a:pPr algn="r" indent="0" marL="0">
-              <a:buNone/>
-            </a:pPr>
-            <a:r>
-              <a:rPr lang="en-US" sz="900" dirty="0">
-                <a:solidFill>
-                  <a:srgbClr val="8A7C68"/>
-                </a:solidFill>
-                <a:latin typeface="Segoe UI" pitchFamily="34" charset="0"/>
-                <a:ea typeface="Segoe UI" pitchFamily="34" charset="-122"/>
-                <a:cs typeface="Segoe UI" pitchFamily="34" charset="-120"/>
-              </a:rPr>
-              <a:t>43</a:t>
-            </a:r>
-            <a:endParaRPr lang="en-US" sz="900" dirty="0"/>
-          </a:p>
-        </p:txBody>
-      </p:sp>
-    </p:spTree>
-  </p:cSld>
-  <p:clrMapOvr>
-    <a:masterClrMapping/>
-  </p:clrMapOvr>
-</p:sld>
-</file>
-
-<file path=ppt/slides/slide44.xml><?xml version="1.0" encoding="utf-8"?>
-<p:sld xmlns:a="http://schemas.openxmlformats.org/drawingml/2006/main" xmlns:r="http://schemas.openxmlformats.org/officeDocument/2006/relationships" xmlns:p="http://schemas.openxmlformats.org/presentationml/2006/main">
-  <p:cSld name="Slide 44">
-    <p:bg>
-      <p:bgPr>
-        <a:solidFill>
-          <a:srgbClr val="F3EEE3"/>
-        </a:solidFill>
-      </p:bgPr>
-    </p:bg>
-    <p:spTree>
-      <p:nvGrpSpPr>
-        <p:cNvPr id="1" name=""/>
-        <p:cNvGrpSpPr/>
-        <p:nvPr/>
-      </p:nvGrpSpPr>
-      <p:grpSpPr>
-        <a:xfrm>
-          <a:off x="0" y="0"/>
-          <a:ext cx="0" cy="0"/>
-          <a:chOff x="0" y="0"/>
-          <a:chExt cx="0" cy="0"/>
-        </a:xfrm>
-      </p:grpSpPr>
-      <p:sp>
-        <p:nvSpPr>
-          <p:cNvPr id="2" name="Shape 0"/>
-          <p:cNvSpPr/>
-          <p:nvPr/>
-        </p:nvSpPr>
-        <p:spPr>
-          <a:xfrm>
-            <a:off x="640080" y="411480"/>
-            <a:ext cx="2377440" cy="365760"/>
-          </a:xfrm>
-          <a:prstGeom prst="roundRect">
-            <a:avLst>
-              <a:gd name="adj" fmla="val 50000"/>
-            </a:avLst>
-          </a:prstGeom>
-          <a:solidFill>
-            <a:srgbClr val="E6EFE4"/>
-          </a:solidFill>
-          <a:ln/>
-        </p:spPr>
-      </p:sp>
-      <p:sp>
-        <p:nvSpPr>
-          <p:cNvPr id="3" name="Text 1"/>
-          <p:cNvSpPr/>
-          <p:nvPr/>
-        </p:nvSpPr>
-        <p:spPr>
-          <a:xfrm>
-            <a:off x="640080" y="411480"/>
-            <a:ext cx="2377440" cy="365760"/>
-          </a:xfrm>
-          <a:prstGeom prst="rect">
-            <a:avLst/>
-          </a:prstGeom>
-          <a:noFill/>
-          <a:ln/>
-        </p:spPr>
-        <p:txBody>
-          <a:bodyPr wrap="square" rtlCol="0" anchor="ctr"/>
-          <a:lstStyle/>
-          <a:p>
-            <a:pPr algn="ctr" indent="0" marL="0">
-              <a:buNone/>
-            </a:pPr>
-            <a:r>
-              <a:rPr lang="en-US" sz="1000" b="1" spc="100" kern="0" dirty="0">
-                <a:solidFill>
-                  <a:srgbClr val="386641"/>
-                </a:solidFill>
-                <a:latin typeface="Segoe UI" pitchFamily="34" charset="0"/>
-                <a:ea typeface="Segoe UI" pitchFamily="34" charset="-122"/>
-                <a:cs typeface="Segoe UI" pitchFamily="34" charset="-120"/>
-              </a:rPr>
-              <a:t>BASE DE DONNÉES</a:t>
-            </a:r>
-            <a:endParaRPr lang="en-US" sz="1000" dirty="0"/>
-          </a:p>
-        </p:txBody>
-      </p:sp>
-      <p:sp>
-        <p:nvSpPr>
-          <p:cNvPr id="4" name="Text 2"/>
-          <p:cNvSpPr/>
-          <p:nvPr/>
-        </p:nvSpPr>
-        <p:spPr>
-          <a:xfrm>
-            <a:off x="640080" y="868680"/>
-            <a:ext cx="10515600" cy="548640"/>
-          </a:xfrm>
-          <a:prstGeom prst="rect">
-            <a:avLst/>
-          </a:prstGeom>
-          <a:noFill/>
-          <a:ln/>
-        </p:spPr>
-        <p:txBody>
-          <a:bodyPr wrap="square" rtlCol="0" anchor="ctr"/>
-          <a:lstStyle/>
-          <a:p>
-            <a:pPr indent="0" marL="0">
-              <a:buNone/>
-            </a:pPr>
-            <a:r>
-              <a:rPr lang="en-US" sz="2400" b="1" dirty="0">
-                <a:solidFill>
-                  <a:srgbClr val="1B1F3B"/>
-                </a:solidFill>
-                <a:latin typeface="Georgia" pitchFamily="34" charset="0"/>
-                <a:ea typeface="Georgia" pitchFamily="34" charset="-122"/>
-                <a:cs typeface="Georgia" pitchFamily="34" charset="-120"/>
-              </a:rPr>
-              <a:t>Fondations</a:t>
-            </a:r>
-            <a:endParaRPr lang="en-US" sz="2400" dirty="0"/>
-          </a:p>
-        </p:txBody>
-      </p:sp>
-      <p:sp>
-        <p:nvSpPr>
-          <p:cNvPr id="5" name="Shape 3"/>
-          <p:cNvSpPr/>
-          <p:nvPr/>
-        </p:nvSpPr>
-        <p:spPr>
-          <a:xfrm>
-            <a:off x="640080" y="1691640"/>
-            <a:ext cx="10881360" cy="1097280"/>
-          </a:xfrm>
-          <a:prstGeom prst="roundRect">
-            <a:avLst>
-              <a:gd name="adj" fmla="val 5000"/>
-            </a:avLst>
-          </a:prstGeom>
-          <a:solidFill>
-            <a:srgbClr val="FFFFFF"/>
-          </a:solidFill>
-          <a:ln w="12700">
-            <a:solidFill>
-              <a:srgbClr val="E4DCCB"/>
-            </a:solidFill>
-            <a:prstDash val="solid"/>
-          </a:ln>
-        </p:spPr>
-      </p:sp>
-      <p:sp>
-        <p:nvSpPr>
-          <p:cNvPr id="6" name="Shape 4"/>
-          <p:cNvSpPr/>
-          <p:nvPr/>
-        </p:nvSpPr>
-        <p:spPr>
-          <a:xfrm>
-            <a:off x="640080" y="1691640"/>
-            <a:ext cx="54864" cy="1097280"/>
-          </a:xfrm>
-          <a:prstGeom prst="rect">
-            <a:avLst/>
-          </a:prstGeom>
-          <a:solidFill>
-            <a:srgbClr val="386641"/>
-          </a:solidFill>
-          <a:ln/>
-        </p:spPr>
-      </p:sp>
-      <p:sp>
-        <p:nvSpPr>
-          <p:cNvPr id="7" name="Text 5"/>
-          <p:cNvSpPr/>
-          <p:nvPr/>
-        </p:nvSpPr>
-        <p:spPr>
-          <a:xfrm>
-            <a:off x="914400" y="1801368"/>
-            <a:ext cx="10332720" cy="365760"/>
-          </a:xfrm>
-          <a:prstGeom prst="rect">
-            <a:avLst/>
-          </a:prstGeom>
-          <a:noFill/>
-          <a:ln/>
-        </p:spPr>
-        <p:txBody>
-          <a:bodyPr wrap="square" rtlCol="0" anchor="ctr"/>
-          <a:lstStyle/>
-          <a:p>
-            <a:pPr indent="0" marL="0">
-              <a:buNone/>
-            </a:pPr>
-            <a:r>
-              <a:rPr lang="en-US" sz="1400" b="1" dirty="0">
-                <a:solidFill>
-                  <a:srgbClr val="1B1F3B"/>
-                </a:solidFill>
-                <a:latin typeface="Segoe UI" pitchFamily="34" charset="0"/>
-                <a:ea typeface="Segoe UI" pitchFamily="34" charset="-122"/>
-                <a:cs typeface="Segoe UI" pitchFamily="34" charset="-120"/>
-              </a:rPr>
-              <a:t>Connexion Vercel / configuration environnement</a:t>
-            </a:r>
-            <a:endParaRPr lang="en-US" sz="1400" dirty="0"/>
-          </a:p>
-        </p:txBody>
-      </p:sp>
-      <p:sp>
-        <p:nvSpPr>
-          <p:cNvPr id="8" name="Text 6"/>
-          <p:cNvSpPr/>
-          <p:nvPr/>
-        </p:nvSpPr>
-        <p:spPr>
-          <a:xfrm>
-            <a:off x="914400" y="2148840"/>
-            <a:ext cx="10332720" cy="594360"/>
-          </a:xfrm>
-          <a:prstGeom prst="rect">
-            <a:avLst/>
-          </a:prstGeom>
-          <a:noFill/>
-          <a:ln/>
-        </p:spPr>
-        <p:txBody>
-          <a:bodyPr wrap="square" rtlCol="0" anchor="ctr"/>
-          <a:lstStyle/>
-          <a:p>
-            <a:pPr indent="0" marL="0">
-              <a:lnSpc>
-                <a:spcPts val="1400"/>
-              </a:lnSpc>
-              <a:buNone/>
-            </a:pPr>
-            <a:r>
-              <a:rPr lang="en-US" sz="1100" dirty="0">
-                <a:solidFill>
-                  <a:srgbClr val="8A7C68"/>
-                </a:solidFill>
-                <a:latin typeface="Segoe UI" pitchFamily="34" charset="0"/>
-                <a:ea typeface="Segoe UI" pitchFamily="34" charset="-122"/>
-                <a:cs typeface="Segoe UI" pitchFamily="34" charset="-120"/>
-              </a:rPr>
-              <a:t>Correction de la configuration d'authentification et du SMTP sur l'environnement de production Vercel.</a:t>
-            </a:r>
-            <a:endParaRPr lang="en-US" sz="1100" dirty="0"/>
-          </a:p>
-        </p:txBody>
-      </p:sp>
-      <p:sp>
-        <p:nvSpPr>
-          <p:cNvPr id="9" name="Text 7"/>
-          <p:cNvSpPr/>
-          <p:nvPr/>
-        </p:nvSpPr>
-        <p:spPr>
-          <a:xfrm>
-            <a:off x="365760" y="6510528"/>
-            <a:ext cx="5486400" cy="274320"/>
-          </a:xfrm>
-          <a:prstGeom prst="rect">
-            <a:avLst/>
-          </a:prstGeom>
-          <a:noFill/>
-          <a:ln/>
-        </p:spPr>
-        <p:txBody>
-          <a:bodyPr wrap="square" rtlCol="0" anchor="ctr"/>
-          <a:lstStyle/>
-          <a:p>
-            <a:pPr indent="0" marL="0">
-              <a:buNone/>
-            </a:pPr>
-            <a:r>
-              <a:rPr lang="en-US" sz="900" dirty="0">
-                <a:solidFill>
-                  <a:srgbClr val="8A7C68"/>
-                </a:solidFill>
-                <a:latin typeface="Segoe UI" pitchFamily="34" charset="0"/>
-                <a:ea typeface="Segoe UI" pitchFamily="34" charset="-122"/>
-                <a:cs typeface="Segoe UI" pitchFamily="34" charset="-120"/>
-              </a:rPr>
-              <a:t>Koji Web — Récapitulatif technique</a:t>
-            </a:r>
-            <a:endParaRPr lang="en-US" sz="900" dirty="0"/>
-          </a:p>
-        </p:txBody>
-      </p:sp>
-      <p:sp>
-        <p:nvSpPr>
-          <p:cNvPr id="10" name="Text 8"/>
           <p:cNvSpPr/>
           <p:nvPr/>
         </p:nvSpPr>
@@ -25871,7 +25960,7 @@
                 <a:ea typeface="Georgia" pitchFamily="34" charset="-122"/>
                 <a:cs typeface="Georgia" pitchFamily="34" charset="-120"/>
               </a:rPr>
-              <a:t>Devis</a:t>
+              <a:t>Fondations</a:t>
             </a:r>
             <a:endParaRPr lang="en-US" sz="2400" dirty="0"/>
           </a:p>
@@ -25957,7 +26046,7 @@
                 <a:ea typeface="Segoe UI" pitchFamily="34" charset="-122"/>
                 <a:cs typeface="Segoe UI" pitchFamily="34" charset="-120"/>
               </a:rPr>
-              <a:t>Migration des devis vers Supabase (table partagée)</a:t>
+              <a:t>Connexion Vercel / configuration environnement</a:t>
             </a:r>
             <a:endParaRPr lang="en-US" sz="1400" dirty="0"/>
           </a:p>
@@ -25999,7 +26088,7 @@
                 <a:ea typeface="Segoe UI" pitchFamily="34" charset="-122"/>
                 <a:cs typeface="Segoe UI" pitchFamily="34" charset="-120"/>
               </a:rPr>
-              <a:t>Les devis créés sur le site web et sur l'application mobile (Firas) vivent désormais dans la même table Supabase 'quotes', avec un mapping bidirectionnel dédié (lib/quote-mapping.js).</a:t>
+              <a:t>Correction de la configuration d'authentification et du SMTP sur l'environnement de production Vercel.</a:t>
             </a:r>
             <a:endParaRPr lang="en-US" sz="1100" dirty="0"/>
           </a:p>
@@ -26209,7 +26298,7 @@
                 <a:ea typeface="Georgia" pitchFamily="34" charset="-122"/>
                 <a:cs typeface="Georgia" pitchFamily="34" charset="-120"/>
               </a:rPr>
-              <a:t>Chantiers</a:t>
+              <a:t>Devis</a:t>
             </a:r>
             <a:endParaRPr lang="en-US" sz="2400" dirty="0"/>
           </a:p>
@@ -26295,7 +26384,7 @@
                 <a:ea typeface="Segoe UI" pitchFamily="34" charset="-122"/>
                 <a:cs typeface="Segoe UI" pitchFamily="34" charset="-120"/>
               </a:rPr>
-              <a:t>Connexion Supabase : chantiers, planning, fournitures</a:t>
+              <a:t>Migration des devis vers Supabase (table partagée)</a:t>
             </a:r>
             <a:endParaRPr lang="en-US" sz="1400" dirty="0"/>
           </a:p>
@@ -26337,7 +26426,7 @@
                 <a:ea typeface="Segoe UI" pitchFamily="34" charset="-122"/>
                 <a:cs typeface="Segoe UI" pitchFamily="34" charset="-120"/>
               </a:rPr>
-              <a:t>Ces trois modules sont branchés sur la base partagée avec l'application mobile ; les comptes utilisateurs sont également partagés entre les deux plateformes.</a:t>
+              <a:t>Les devis créés sur le site web et sur l'application mobile (Firas) vivent désormais dans la même table Supabase 'quotes', avec un mapping bidirectionnel dédié (lib/quote-mapping.js).</a:t>
             </a:r>
             <a:endParaRPr lang="en-US" sz="1100" dirty="0"/>
           </a:p>
@@ -26547,7 +26636,7 @@
                 <a:ea typeface="Georgia" pitchFamily="34" charset="-122"/>
                 <a:cs typeface="Georgia" pitchFamily="34" charset="-120"/>
               </a:rPr>
-              <a:t>Équipe</a:t>
+              <a:t>Chantiers</a:t>
             </a:r>
             <a:endParaRPr lang="en-US" sz="2400" dirty="0"/>
           </a:p>
@@ -26633,7 +26722,7 @@
                 <a:ea typeface="Segoe UI" pitchFamily="34" charset="-122"/>
                 <a:cs typeface="Segoe UI" pitchFamily="34" charset="-120"/>
               </a:rPr>
-              <a:t>Nouvelle donnée : heures contractuelles par ouvrier</a:t>
+              <a:t>Connexion Supabase : chantiers, planning, fournitures</a:t>
             </a:r>
             <a:endParaRPr lang="en-US" sz="1400" dirty="0"/>
           </a:p>
@@ -26675,7 +26764,7 @@
                 <a:ea typeface="Segoe UI" pitchFamily="34" charset="-122"/>
                 <a:cs typeface="Segoe UI" pitchFamily="34" charset="-120"/>
               </a:rPr>
-              <a:t>Ajout d'un paramètre 'heures contractuelles / semaine' (35h par défaut) sur chaque fiche ouvrier, utilisé pour le calcul des écarts.</a:t>
+              <a:t>Ces trois modules sont branchés sur la base partagée avec l'application mobile ; les comptes utilisateurs sont également partagés entre les deux plateformes.</a:t>
             </a:r>
             <a:endParaRPr lang="en-US" sz="1100" dirty="0"/>
           </a:p>
@@ -26885,7 +26974,7 @@
                 <a:ea typeface="Georgia" pitchFamily="34" charset="-122"/>
                 <a:cs typeface="Georgia" pitchFamily="34" charset="-120"/>
               </a:rPr>
-              <a:t>Accueil &amp; stabilité</a:t>
+              <a:t>Équipe</a:t>
             </a:r>
             <a:endParaRPr lang="en-US" sz="2400" dirty="0"/>
           </a:p>
@@ -26971,7 +27060,7 @@
                 <a:ea typeface="Segoe UI" pitchFamily="34" charset="-122"/>
                 <a:cs typeface="Segoe UI" pitchFamily="34" charset="-120"/>
               </a:rPr>
-              <a:t>Nettoyage du backend</a:t>
+              <a:t>Nouvelle donnée : heures contractuelles par ouvrier</a:t>
             </a:r>
             <a:endParaRPr lang="en-US" sz="1400" dirty="0"/>
           </a:p>
@@ -27013,7 +27102,7 @@
                 <a:ea typeface="Segoe UI" pitchFamily="34" charset="-122"/>
                 <a:cs typeface="Segoe UI" pitchFamily="34" charset="-120"/>
               </a:rPr>
-              <a:t>Audit complet des routes serveur : suppression du code mort (module Marketplace), vérification de la cohérence entre données locales et données Supabase sur l'ensemble de l'application.</a:t>
+              <a:t>Ajout d'un paramètre 'heures contractuelles / semaine' (35h par défaut) sur chaque fiche ouvrier, utilisé pour le calcul des écarts.</a:t>
             </a:r>
             <a:endParaRPr lang="en-US" sz="1100" dirty="0"/>
           </a:p>
@@ -27223,7 +27312,7 @@
                 <a:ea typeface="Georgia" pitchFamily="34" charset="-122"/>
                 <a:cs typeface="Georgia" pitchFamily="34" charset="-120"/>
               </a:rPr>
-              <a:t>Maintenance technique</a:t>
+              <a:t>Accueil &amp; stabilité</a:t>
             </a:r>
             <a:endParaRPr lang="en-US" sz="2400" dirty="0"/>
           </a:p>
@@ -27309,7 +27398,7 @@
                 <a:ea typeface="Segoe UI" pitchFamily="34" charset="-122"/>
                 <a:cs typeface="Segoe UI" pitchFamily="34" charset="-120"/>
               </a:rPr>
-              <a:t>Nettoyage approfondi du code</a:t>
+              <a:t>Nettoyage du backend</a:t>
             </a:r>
             <a:endParaRPr lang="en-US" sz="1400" dirty="0"/>
           </a:p>
@@ -27351,7 +27440,7 @@
                 <a:ea typeface="Segoe UI" pitchFamily="34" charset="-122"/>
                 <a:cs typeface="Segoe UI" pitchFamily="34" charset="-120"/>
               </a:rPr>
-              <a:t>Audit complet du projet (pages, routes, fonctions, dépendances) pour repérer tout ce qui n'était plus utilisé ; suppression de 6 pages orphelines (onboarding, welcome, compte, anciennes pages devis en 3 étapes), d'une route de connexion de démonstration, d'un dossier de composants dupliqué obsolète, de plusieurs fonctions inutilisées et d'une dépendance logicielle non utilisée — sans toucher aux fonctionnalités actives.</a:t>
+              <a:t>Audit complet des routes serveur : suppression du code mort (module Marketplace), vérification de la cohérence entre données locales et données Supabase sur l'ensemble de l'application.</a:t>
             </a:r>
             <a:endParaRPr lang="en-US" sz="1100" dirty="0"/>
           </a:p>
@@ -27359,263 +27448,7 @@
       </p:sp>
       <p:sp>
         <p:nvSpPr>
-          <p:cNvPr id="9" name="Shape 7"/>
-          <p:cNvSpPr/>
-          <p:nvPr/>
-        </p:nvSpPr>
-        <p:spPr>
-          <a:xfrm>
-            <a:off x="640080" y="2926080"/>
-            <a:ext cx="10881360" cy="1097280"/>
-          </a:xfrm>
-          <a:prstGeom prst="roundRect">
-            <a:avLst>
-              <a:gd name="adj" fmla="val 5000"/>
-            </a:avLst>
-          </a:prstGeom>
-          <a:solidFill>
-            <a:srgbClr val="FFFFFF"/>
-          </a:solidFill>
-          <a:ln w="12700">
-            <a:solidFill>
-              <a:srgbClr val="E4DCCB"/>
-            </a:solidFill>
-            <a:prstDash val="solid"/>
-          </a:ln>
-        </p:spPr>
-      </p:sp>
-      <p:sp>
-        <p:nvSpPr>
-          <p:cNvPr id="10" name="Shape 8"/>
-          <p:cNvSpPr/>
-          <p:nvPr/>
-        </p:nvSpPr>
-        <p:spPr>
-          <a:xfrm>
-            <a:off x="640080" y="2926080"/>
-            <a:ext cx="54864" cy="1097280"/>
-          </a:xfrm>
-          <a:prstGeom prst="rect">
-            <a:avLst/>
-          </a:prstGeom>
-          <a:solidFill>
-            <a:srgbClr val="386641"/>
-          </a:solidFill>
-          <a:ln/>
-        </p:spPr>
-      </p:sp>
-      <p:sp>
-        <p:nvSpPr>
-          <p:cNvPr id="11" name="Text 9"/>
-          <p:cNvSpPr/>
-          <p:nvPr/>
-        </p:nvSpPr>
-        <p:spPr>
-          <a:xfrm>
-            <a:off x="914400" y="3035808"/>
-            <a:ext cx="10332720" cy="365760"/>
-          </a:xfrm>
-          <a:prstGeom prst="rect">
-            <a:avLst/>
-          </a:prstGeom>
-          <a:noFill/>
-          <a:ln/>
-        </p:spPr>
-        <p:txBody>
-          <a:bodyPr wrap="square" rtlCol="0" anchor="ctr"/>
-          <a:lstStyle/>
-          <a:p>
-            <a:pPr indent="0" marL="0">
-              <a:buNone/>
-            </a:pPr>
-            <a:r>
-              <a:rPr lang="en-US" sz="1400" b="1" dirty="0">
-                <a:solidFill>
-                  <a:srgbClr val="1B1F3B"/>
-                </a:solidFill>
-                <a:latin typeface="Segoe UI" pitchFamily="34" charset="0"/>
-                <a:ea typeface="Segoe UI" pitchFamily="34" charset="-122"/>
-                <a:cs typeface="Segoe UI" pitchFamily="34" charset="-120"/>
-              </a:rPr>
-              <a:t>Suppression de code mort dans la génération de devis</a:t>
-            </a:r>
-            <a:endParaRPr lang="en-US" sz="1400" dirty="0"/>
-          </a:p>
-        </p:txBody>
-      </p:sp>
-      <p:sp>
-        <p:nvSpPr>
-          <p:cNvPr id="12" name="Text 10"/>
-          <p:cNvSpPr/>
-          <p:nvPr/>
-        </p:nvSpPr>
-        <p:spPr>
-          <a:xfrm>
-            <a:off x="914400" y="3383280"/>
-            <a:ext cx="10332720" cy="594360"/>
-          </a:xfrm>
-          <a:prstGeom prst="rect">
-            <a:avLst/>
-          </a:prstGeom>
-          <a:noFill/>
-          <a:ln/>
-        </p:spPr>
-        <p:txBody>
-          <a:bodyPr wrap="square" rtlCol="0" anchor="ctr"/>
-          <a:lstStyle/>
-          <a:p>
-            <a:pPr indent="0" marL="0">
-              <a:lnSpc>
-                <a:spcPts val="1400"/>
-              </a:lnSpc>
-              <a:buNone/>
-            </a:pPr>
-            <a:r>
-              <a:rPr lang="en-US" sz="1100" dirty="0">
-                <a:solidFill>
-                  <a:srgbClr val="8A7C68"/>
-                </a:solidFill>
-                <a:latin typeface="Segoe UI" pitchFamily="34" charset="0"/>
-                <a:ea typeface="Segoe UI" pitchFamily="34" charset="-122"/>
-                <a:cs typeface="Segoe UI" pitchFamily="34" charset="-120"/>
-              </a:rPr>
-              <a:t>Un ancien générateur de devis PDF, devenu inaccessible après une précédente refonte (code jamais exécuté), a été retiré du fichier technique de génération de documents.</a:t>
-            </a:r>
-            <a:endParaRPr lang="en-US" sz="1100" dirty="0"/>
-          </a:p>
-        </p:txBody>
-      </p:sp>
-      <p:sp>
-        <p:nvSpPr>
-          <p:cNvPr id="13" name="Shape 11"/>
-          <p:cNvSpPr/>
-          <p:nvPr/>
-        </p:nvSpPr>
-        <p:spPr>
-          <a:xfrm>
-            <a:off x="640080" y="4160520"/>
-            <a:ext cx="10881360" cy="1097280"/>
-          </a:xfrm>
-          <a:prstGeom prst="roundRect">
-            <a:avLst>
-              <a:gd name="adj" fmla="val 5000"/>
-            </a:avLst>
-          </a:prstGeom>
-          <a:solidFill>
-            <a:srgbClr val="FFFFFF"/>
-          </a:solidFill>
-          <a:ln w="12700">
-            <a:solidFill>
-              <a:srgbClr val="E4DCCB"/>
-            </a:solidFill>
-            <a:prstDash val="solid"/>
-          </a:ln>
-        </p:spPr>
-      </p:sp>
-      <p:sp>
-        <p:nvSpPr>
-          <p:cNvPr id="14" name="Shape 12"/>
-          <p:cNvSpPr/>
-          <p:nvPr/>
-        </p:nvSpPr>
-        <p:spPr>
-          <a:xfrm>
-            <a:off x="640080" y="4160520"/>
-            <a:ext cx="54864" cy="1097280"/>
-          </a:xfrm>
-          <a:prstGeom prst="rect">
-            <a:avLst/>
-          </a:prstGeom>
-          <a:solidFill>
-            <a:srgbClr val="386641"/>
-          </a:solidFill>
-          <a:ln/>
-        </p:spPr>
-      </p:sp>
-      <p:sp>
-        <p:nvSpPr>
-          <p:cNvPr id="15" name="Text 13"/>
-          <p:cNvSpPr/>
-          <p:nvPr/>
-        </p:nvSpPr>
-        <p:spPr>
-          <a:xfrm>
-            <a:off x="914400" y="4270248"/>
-            <a:ext cx="10332720" cy="365760"/>
-          </a:xfrm>
-          <a:prstGeom prst="rect">
-            <a:avLst/>
-          </a:prstGeom>
-          <a:noFill/>
-          <a:ln/>
-        </p:spPr>
-        <p:txBody>
-          <a:bodyPr wrap="square" rtlCol="0" anchor="ctr"/>
-          <a:lstStyle/>
-          <a:p>
-            <a:pPr indent="0" marL="0">
-              <a:buNone/>
-            </a:pPr>
-            <a:r>
-              <a:rPr lang="en-US" sz="1400" b="1" dirty="0">
-                <a:solidFill>
-                  <a:srgbClr val="1B1F3B"/>
-                </a:solidFill>
-                <a:latin typeface="Segoe UI" pitchFamily="34" charset="0"/>
-                <a:ea typeface="Segoe UI" pitchFamily="34" charset="-122"/>
-                <a:cs typeface="Segoe UI" pitchFamily="34" charset="-120"/>
-              </a:rPr>
-              <a:t>Suppression de code mort dans l'export Word des devis</a:t>
-            </a:r>
-            <a:endParaRPr lang="en-US" sz="1400" dirty="0"/>
-          </a:p>
-        </p:txBody>
-      </p:sp>
-      <p:sp>
-        <p:nvSpPr>
-          <p:cNvPr id="16" name="Text 14"/>
-          <p:cNvSpPr/>
-          <p:nvPr/>
-        </p:nvSpPr>
-        <p:spPr>
-          <a:xfrm>
-            <a:off x="914400" y="4617720"/>
-            <a:ext cx="10332720" cy="594360"/>
-          </a:xfrm>
-          <a:prstGeom prst="rect">
-            <a:avLst/>
-          </a:prstGeom>
-          <a:noFill/>
-          <a:ln/>
-        </p:spPr>
-        <p:txBody>
-          <a:bodyPr wrap="square" rtlCol="0" anchor="ctr"/>
-          <a:lstStyle/>
-          <a:p>
-            <a:pPr indent="0" marL="0">
-              <a:lnSpc>
-                <a:spcPts val="1400"/>
-              </a:lnSpc>
-              <a:buNone/>
-            </a:pPr>
-            <a:r>
-              <a:rPr lang="en-US" sz="1100" dirty="0">
-                <a:solidFill>
-                  <a:srgbClr val="8A7C68"/>
-                </a:solidFill>
-                <a:latin typeface="Segoe UI" pitchFamily="34" charset="0"/>
-                <a:ea typeface="Segoe UI" pitchFamily="34" charset="-122"/>
-                <a:cs typeface="Segoe UI" pitchFamily="34" charset="-120"/>
-              </a:rPr>
-              <a:t>Un second bloc de génération de document, devenu inaccessible après une précédente refonte (jamais exécuté), a été retiré du fichier technique de génération de documents.</a:t>
-            </a:r>
-            <a:endParaRPr lang="en-US" sz="1100" dirty="0"/>
-          </a:p>
-        </p:txBody>
-      </p:sp>
-      <p:sp>
-        <p:nvSpPr>
-          <p:cNvPr id="17" name="Text 15"/>
+          <p:cNvPr id="9" name="Text 7"/>
           <p:cNvSpPr/>
           <p:nvPr/>
         </p:nvSpPr>
@@ -27654,7 +27487,7 @@
       </p:sp>
       <p:sp>
         <p:nvSpPr>
-          <p:cNvPr id="18" name="Text 16"/>
+          <p:cNvPr id="10" name="Text 8"/>
           <p:cNvSpPr/>
           <p:nvPr/>
         </p:nvSpPr>
@@ -28539,7 +28372,7 @@
                 <a:ea typeface="Georgia" pitchFamily="34" charset="-122"/>
                 <a:cs typeface="Georgia" pitchFamily="34" charset="-120"/>
               </a:rPr>
-              <a:t>Sécurité</a:t>
+              <a:t>Maintenance technique</a:t>
             </a:r>
             <a:endParaRPr lang="en-US" sz="2400" dirty="0"/>
           </a:p>
@@ -28625,7 +28458,7 @@
                 <a:ea typeface="Segoe UI" pitchFamily="34" charset="-122"/>
                 <a:cs typeface="Segoe UI" pitchFamily="34" charset="-120"/>
               </a:rPr>
-              <a:t>Base de données partagée verrouillée</a:t>
+              <a:t>Nettoyage approfondi du code</a:t>
             </a:r>
             <a:endParaRPr lang="en-US" sz="1400" dirty="0"/>
           </a:p>
@@ -28667,7 +28500,7 @@
                 <a:ea typeface="Segoe UI" pitchFamily="34" charset="-122"/>
                 <a:cs typeface="Segoe UI" pitchFamily="34" charset="-120"/>
               </a:rPr>
-              <a:t>La table contenant l'essentiel des données de l'application était lisible par n'importe qui sur internet avec la simple clé publique du site, sans connexion. L'application y accède désormais avec une clé privée réservée au serveur, ce qui permet de fermer complètement l'accès public sans rien casser.</a:t>
+              <a:t>Audit complet du projet (pages, routes, fonctions, dépendances) pour repérer tout ce qui n'était plus utilisé ; suppression de 6 pages orphelines (onboarding, welcome, compte, anciennes pages devis en 3 étapes), d'une route de connexion de démonstration, d'un dossier de composants dupliqué obsolète, de plusieurs fonctions inutilisées et d'une dépendance logicielle non utilisée — sans toucher aux fonctionnalités actives.</a:t>
             </a:r>
             <a:endParaRPr lang="en-US" sz="1100" dirty="0"/>
           </a:p>
@@ -28753,7 +28586,7 @@
                 <a:ea typeface="Segoe UI" pitchFamily="34" charset="-122"/>
                 <a:cs typeface="Segoe UI" pitchFamily="34" charset="-120"/>
               </a:rPr>
-              <a:t>Fichier de base de données retiré du dépôt Git</a:t>
+              <a:t>Suppression de code mort dans la génération de devis</a:t>
             </a:r>
             <a:endParaRPr lang="en-US" sz="1400" dirty="0"/>
           </a:p>
@@ -28795,7 +28628,7 @@
                 <a:ea typeface="Segoe UI" pitchFamily="34" charset="-122"/>
                 <a:cs typeface="Segoe UI" pitchFamily="34" charset="-120"/>
               </a:rPr>
-              <a:t>Un fichier contenant une copie complète de la base de données de développement, avec des mots de passe réels en clair, était suivi par Git depuis plusieurs mois. Retiré du suivi et exclu définitivement.</a:t>
+              <a:t>Un ancien générateur de devis PDF, devenu inaccessible après une précédente refonte (code jamais exécuté), a été retiré du fichier technique de génération de documents.</a:t>
             </a:r>
             <a:endParaRPr lang="en-US" sz="1100" dirty="0"/>
           </a:p>
@@ -28881,7 +28714,7 @@
                 <a:ea typeface="Segoe UI" pitchFamily="34" charset="-122"/>
                 <a:cs typeface="Segoe UI" pitchFamily="34" charset="-120"/>
               </a:rPr>
-              <a:t>Verrouillage de la base partagée écrit dans le script d'installation</a:t>
+              <a:t>Suppression de code mort dans l'export Word des devis</a:t>
             </a:r>
             <a:endParaRPr lang="en-US" sz="1400" dirty="0"/>
           </a:p>
@@ -28923,7 +28756,7 @@
                 <a:ea typeface="Segoe UI" pitchFamily="34" charset="-122"/>
                 <a:cs typeface="Segoe UI" pitchFamily="34" charset="-120"/>
               </a:rPr>
-              <a:t>La commande qui ferme complètement l'accès public à la table de données partagée a été ajoutée au script SQL du projet, prête à être exécutée dans le tableau de bord Supabase.</a:t>
+              <a:t>Un second bloc de génération de document, devenu inaccessible après une précédente refonte (jamais exécuté), a été retiré du fichier technique de génération de documents.</a:t>
             </a:r>
             <a:endParaRPr lang="en-US" sz="1100" dirty="0"/>
           </a:p>
@@ -29018,6 +28851,600 @@
 <file path=ppt/slides/slide51.xml><?xml version="1.0" encoding="utf-8"?>
 <p:sld xmlns:a="http://schemas.openxmlformats.org/drawingml/2006/main" xmlns:r="http://schemas.openxmlformats.org/officeDocument/2006/relationships" xmlns:p="http://schemas.openxmlformats.org/presentationml/2006/main">
   <p:cSld name="Slide 51">
+    <p:bg>
+      <p:bgPr>
+        <a:solidFill>
+          <a:srgbClr val="F3EEE3"/>
+        </a:solidFill>
+      </p:bgPr>
+    </p:bg>
+    <p:spTree>
+      <p:nvGrpSpPr>
+        <p:cNvPr id="1" name=""/>
+        <p:cNvGrpSpPr/>
+        <p:nvPr/>
+      </p:nvGrpSpPr>
+      <p:grpSpPr>
+        <a:xfrm>
+          <a:off x="0" y="0"/>
+          <a:ext cx="0" cy="0"/>
+          <a:chOff x="0" y="0"/>
+          <a:chExt cx="0" cy="0"/>
+        </a:xfrm>
+      </p:grpSpPr>
+      <p:sp>
+        <p:nvSpPr>
+          <p:cNvPr id="2" name="Shape 0"/>
+          <p:cNvSpPr/>
+          <p:nvPr/>
+        </p:nvSpPr>
+        <p:spPr>
+          <a:xfrm>
+            <a:off x="640080" y="411480"/>
+            <a:ext cx="2377440" cy="365760"/>
+          </a:xfrm>
+          <a:prstGeom prst="roundRect">
+            <a:avLst>
+              <a:gd name="adj" fmla="val 50000"/>
+            </a:avLst>
+          </a:prstGeom>
+          <a:solidFill>
+            <a:srgbClr val="E6EFE4"/>
+          </a:solidFill>
+          <a:ln/>
+        </p:spPr>
+      </p:sp>
+      <p:sp>
+        <p:nvSpPr>
+          <p:cNvPr id="3" name="Text 1"/>
+          <p:cNvSpPr/>
+          <p:nvPr/>
+        </p:nvSpPr>
+        <p:spPr>
+          <a:xfrm>
+            <a:off x="640080" y="411480"/>
+            <a:ext cx="2377440" cy="365760"/>
+          </a:xfrm>
+          <a:prstGeom prst="rect">
+            <a:avLst/>
+          </a:prstGeom>
+          <a:noFill/>
+          <a:ln/>
+        </p:spPr>
+        <p:txBody>
+          <a:bodyPr wrap="square" rtlCol="0" anchor="ctr"/>
+          <a:lstStyle/>
+          <a:p>
+            <a:pPr algn="ctr" indent="0" marL="0">
+              <a:buNone/>
+            </a:pPr>
+            <a:r>
+              <a:rPr lang="en-US" sz="1000" b="1" spc="100" kern="0" dirty="0">
+                <a:solidFill>
+                  <a:srgbClr val="386641"/>
+                </a:solidFill>
+                <a:latin typeface="Segoe UI" pitchFamily="34" charset="0"/>
+                <a:ea typeface="Segoe UI" pitchFamily="34" charset="-122"/>
+                <a:cs typeface="Segoe UI" pitchFamily="34" charset="-120"/>
+              </a:rPr>
+              <a:t>BASE DE DONNÉES</a:t>
+            </a:r>
+            <a:endParaRPr lang="en-US" sz="1000" dirty="0"/>
+          </a:p>
+        </p:txBody>
+      </p:sp>
+      <p:sp>
+        <p:nvSpPr>
+          <p:cNvPr id="4" name="Text 2"/>
+          <p:cNvSpPr/>
+          <p:nvPr/>
+        </p:nvSpPr>
+        <p:spPr>
+          <a:xfrm>
+            <a:off x="640080" y="868680"/>
+            <a:ext cx="10515600" cy="548640"/>
+          </a:xfrm>
+          <a:prstGeom prst="rect">
+            <a:avLst/>
+          </a:prstGeom>
+          <a:noFill/>
+          <a:ln/>
+        </p:spPr>
+        <p:txBody>
+          <a:bodyPr wrap="square" rtlCol="0" anchor="ctr"/>
+          <a:lstStyle/>
+          <a:p>
+            <a:pPr indent="0" marL="0">
+              <a:buNone/>
+            </a:pPr>
+            <a:r>
+              <a:rPr lang="en-US" sz="2400" b="1" dirty="0">
+                <a:solidFill>
+                  <a:srgbClr val="1B1F3B"/>
+                </a:solidFill>
+                <a:latin typeface="Georgia" pitchFamily="34" charset="0"/>
+                <a:ea typeface="Georgia" pitchFamily="34" charset="-122"/>
+                <a:cs typeface="Georgia" pitchFamily="34" charset="-120"/>
+              </a:rPr>
+              <a:t>Sécurité</a:t>
+            </a:r>
+            <a:endParaRPr lang="en-US" sz="2400" dirty="0"/>
+          </a:p>
+        </p:txBody>
+      </p:sp>
+      <p:sp>
+        <p:nvSpPr>
+          <p:cNvPr id="5" name="Shape 3"/>
+          <p:cNvSpPr/>
+          <p:nvPr/>
+        </p:nvSpPr>
+        <p:spPr>
+          <a:xfrm>
+            <a:off x="640080" y="1691640"/>
+            <a:ext cx="10881360" cy="1097280"/>
+          </a:xfrm>
+          <a:prstGeom prst="roundRect">
+            <a:avLst>
+              <a:gd name="adj" fmla="val 5000"/>
+            </a:avLst>
+          </a:prstGeom>
+          <a:solidFill>
+            <a:srgbClr val="FFFFFF"/>
+          </a:solidFill>
+          <a:ln w="12700">
+            <a:solidFill>
+              <a:srgbClr val="E4DCCB"/>
+            </a:solidFill>
+            <a:prstDash val="solid"/>
+          </a:ln>
+        </p:spPr>
+      </p:sp>
+      <p:sp>
+        <p:nvSpPr>
+          <p:cNvPr id="6" name="Shape 4"/>
+          <p:cNvSpPr/>
+          <p:nvPr/>
+        </p:nvSpPr>
+        <p:spPr>
+          <a:xfrm>
+            <a:off x="640080" y="1691640"/>
+            <a:ext cx="54864" cy="1097280"/>
+          </a:xfrm>
+          <a:prstGeom prst="rect">
+            <a:avLst/>
+          </a:prstGeom>
+          <a:solidFill>
+            <a:srgbClr val="386641"/>
+          </a:solidFill>
+          <a:ln/>
+        </p:spPr>
+      </p:sp>
+      <p:sp>
+        <p:nvSpPr>
+          <p:cNvPr id="7" name="Text 5"/>
+          <p:cNvSpPr/>
+          <p:nvPr/>
+        </p:nvSpPr>
+        <p:spPr>
+          <a:xfrm>
+            <a:off x="914400" y="1801368"/>
+            <a:ext cx="10332720" cy="365760"/>
+          </a:xfrm>
+          <a:prstGeom prst="rect">
+            <a:avLst/>
+          </a:prstGeom>
+          <a:noFill/>
+          <a:ln/>
+        </p:spPr>
+        <p:txBody>
+          <a:bodyPr wrap="square" rtlCol="0" anchor="ctr"/>
+          <a:lstStyle/>
+          <a:p>
+            <a:pPr indent="0" marL="0">
+              <a:buNone/>
+            </a:pPr>
+            <a:r>
+              <a:rPr lang="en-US" sz="1400" b="1" dirty="0">
+                <a:solidFill>
+                  <a:srgbClr val="1B1F3B"/>
+                </a:solidFill>
+                <a:latin typeface="Segoe UI" pitchFamily="34" charset="0"/>
+                <a:ea typeface="Segoe UI" pitchFamily="34" charset="-122"/>
+                <a:cs typeface="Segoe UI" pitchFamily="34" charset="-120"/>
+              </a:rPr>
+              <a:t>Base de données partagée verrouillée</a:t>
+            </a:r>
+            <a:endParaRPr lang="en-US" sz="1400" dirty="0"/>
+          </a:p>
+        </p:txBody>
+      </p:sp>
+      <p:sp>
+        <p:nvSpPr>
+          <p:cNvPr id="8" name="Text 6"/>
+          <p:cNvSpPr/>
+          <p:nvPr/>
+        </p:nvSpPr>
+        <p:spPr>
+          <a:xfrm>
+            <a:off x="914400" y="2148840"/>
+            <a:ext cx="10332720" cy="594360"/>
+          </a:xfrm>
+          <a:prstGeom prst="rect">
+            <a:avLst/>
+          </a:prstGeom>
+          <a:noFill/>
+          <a:ln/>
+        </p:spPr>
+        <p:txBody>
+          <a:bodyPr wrap="square" rtlCol="0" anchor="ctr"/>
+          <a:lstStyle/>
+          <a:p>
+            <a:pPr indent="0" marL="0">
+              <a:lnSpc>
+                <a:spcPts val="1400"/>
+              </a:lnSpc>
+              <a:buNone/>
+            </a:pPr>
+            <a:r>
+              <a:rPr lang="en-US" sz="1100" dirty="0">
+                <a:solidFill>
+                  <a:srgbClr val="8A7C68"/>
+                </a:solidFill>
+                <a:latin typeface="Segoe UI" pitchFamily="34" charset="0"/>
+                <a:ea typeface="Segoe UI" pitchFamily="34" charset="-122"/>
+                <a:cs typeface="Segoe UI" pitchFamily="34" charset="-120"/>
+              </a:rPr>
+              <a:t>La table contenant l'essentiel des données de l'application était lisible par n'importe qui sur internet avec la simple clé publique du site, sans connexion. L'application y accède désormais avec une clé privée réservée au serveur, ce qui permet de fermer complètement l'accès public sans rien casser.</a:t>
+            </a:r>
+            <a:endParaRPr lang="en-US" sz="1100" dirty="0"/>
+          </a:p>
+        </p:txBody>
+      </p:sp>
+      <p:sp>
+        <p:nvSpPr>
+          <p:cNvPr id="9" name="Shape 7"/>
+          <p:cNvSpPr/>
+          <p:nvPr/>
+        </p:nvSpPr>
+        <p:spPr>
+          <a:xfrm>
+            <a:off x="640080" y="2926080"/>
+            <a:ext cx="10881360" cy="1097280"/>
+          </a:xfrm>
+          <a:prstGeom prst="roundRect">
+            <a:avLst>
+              <a:gd name="adj" fmla="val 5000"/>
+            </a:avLst>
+          </a:prstGeom>
+          <a:solidFill>
+            <a:srgbClr val="FFFFFF"/>
+          </a:solidFill>
+          <a:ln w="12700">
+            <a:solidFill>
+              <a:srgbClr val="E4DCCB"/>
+            </a:solidFill>
+            <a:prstDash val="solid"/>
+          </a:ln>
+        </p:spPr>
+      </p:sp>
+      <p:sp>
+        <p:nvSpPr>
+          <p:cNvPr id="10" name="Shape 8"/>
+          <p:cNvSpPr/>
+          <p:nvPr/>
+        </p:nvSpPr>
+        <p:spPr>
+          <a:xfrm>
+            <a:off x="640080" y="2926080"/>
+            <a:ext cx="54864" cy="1097280"/>
+          </a:xfrm>
+          <a:prstGeom prst="rect">
+            <a:avLst/>
+          </a:prstGeom>
+          <a:solidFill>
+            <a:srgbClr val="386641"/>
+          </a:solidFill>
+          <a:ln/>
+        </p:spPr>
+      </p:sp>
+      <p:sp>
+        <p:nvSpPr>
+          <p:cNvPr id="11" name="Text 9"/>
+          <p:cNvSpPr/>
+          <p:nvPr/>
+        </p:nvSpPr>
+        <p:spPr>
+          <a:xfrm>
+            <a:off x="914400" y="3035808"/>
+            <a:ext cx="10332720" cy="365760"/>
+          </a:xfrm>
+          <a:prstGeom prst="rect">
+            <a:avLst/>
+          </a:prstGeom>
+          <a:noFill/>
+          <a:ln/>
+        </p:spPr>
+        <p:txBody>
+          <a:bodyPr wrap="square" rtlCol="0" anchor="ctr"/>
+          <a:lstStyle/>
+          <a:p>
+            <a:pPr indent="0" marL="0">
+              <a:buNone/>
+            </a:pPr>
+            <a:r>
+              <a:rPr lang="en-US" sz="1400" b="1" dirty="0">
+                <a:solidFill>
+                  <a:srgbClr val="1B1F3B"/>
+                </a:solidFill>
+                <a:latin typeface="Segoe UI" pitchFamily="34" charset="0"/>
+                <a:ea typeface="Segoe UI" pitchFamily="34" charset="-122"/>
+                <a:cs typeface="Segoe UI" pitchFamily="34" charset="-120"/>
+              </a:rPr>
+              <a:t>Fichier de base de données retiré du dépôt Git</a:t>
+            </a:r>
+            <a:endParaRPr lang="en-US" sz="1400" dirty="0"/>
+          </a:p>
+        </p:txBody>
+      </p:sp>
+      <p:sp>
+        <p:nvSpPr>
+          <p:cNvPr id="12" name="Text 10"/>
+          <p:cNvSpPr/>
+          <p:nvPr/>
+        </p:nvSpPr>
+        <p:spPr>
+          <a:xfrm>
+            <a:off x="914400" y="3383280"/>
+            <a:ext cx="10332720" cy="594360"/>
+          </a:xfrm>
+          <a:prstGeom prst="rect">
+            <a:avLst/>
+          </a:prstGeom>
+          <a:noFill/>
+          <a:ln/>
+        </p:spPr>
+        <p:txBody>
+          <a:bodyPr wrap="square" rtlCol="0" anchor="ctr"/>
+          <a:lstStyle/>
+          <a:p>
+            <a:pPr indent="0" marL="0">
+              <a:lnSpc>
+                <a:spcPts val="1400"/>
+              </a:lnSpc>
+              <a:buNone/>
+            </a:pPr>
+            <a:r>
+              <a:rPr lang="en-US" sz="1100" dirty="0">
+                <a:solidFill>
+                  <a:srgbClr val="8A7C68"/>
+                </a:solidFill>
+                <a:latin typeface="Segoe UI" pitchFamily="34" charset="0"/>
+                <a:ea typeface="Segoe UI" pitchFamily="34" charset="-122"/>
+                <a:cs typeface="Segoe UI" pitchFamily="34" charset="-120"/>
+              </a:rPr>
+              <a:t>Un fichier contenant une copie complète de la base de données de développement, avec des mots de passe réels en clair, était suivi par Git depuis plusieurs mois. Retiré du suivi et exclu définitivement.</a:t>
+            </a:r>
+            <a:endParaRPr lang="en-US" sz="1100" dirty="0"/>
+          </a:p>
+        </p:txBody>
+      </p:sp>
+      <p:sp>
+        <p:nvSpPr>
+          <p:cNvPr id="13" name="Shape 11"/>
+          <p:cNvSpPr/>
+          <p:nvPr/>
+        </p:nvSpPr>
+        <p:spPr>
+          <a:xfrm>
+            <a:off x="640080" y="4160520"/>
+            <a:ext cx="10881360" cy="1097280"/>
+          </a:xfrm>
+          <a:prstGeom prst="roundRect">
+            <a:avLst>
+              <a:gd name="adj" fmla="val 5000"/>
+            </a:avLst>
+          </a:prstGeom>
+          <a:solidFill>
+            <a:srgbClr val="FFFFFF"/>
+          </a:solidFill>
+          <a:ln w="12700">
+            <a:solidFill>
+              <a:srgbClr val="E4DCCB"/>
+            </a:solidFill>
+            <a:prstDash val="solid"/>
+          </a:ln>
+        </p:spPr>
+      </p:sp>
+      <p:sp>
+        <p:nvSpPr>
+          <p:cNvPr id="14" name="Shape 12"/>
+          <p:cNvSpPr/>
+          <p:nvPr/>
+        </p:nvSpPr>
+        <p:spPr>
+          <a:xfrm>
+            <a:off x="640080" y="4160520"/>
+            <a:ext cx="54864" cy="1097280"/>
+          </a:xfrm>
+          <a:prstGeom prst="rect">
+            <a:avLst/>
+          </a:prstGeom>
+          <a:solidFill>
+            <a:srgbClr val="386641"/>
+          </a:solidFill>
+          <a:ln/>
+        </p:spPr>
+      </p:sp>
+      <p:sp>
+        <p:nvSpPr>
+          <p:cNvPr id="15" name="Text 13"/>
+          <p:cNvSpPr/>
+          <p:nvPr/>
+        </p:nvSpPr>
+        <p:spPr>
+          <a:xfrm>
+            <a:off x="914400" y="4270248"/>
+            <a:ext cx="10332720" cy="365760"/>
+          </a:xfrm>
+          <a:prstGeom prst="rect">
+            <a:avLst/>
+          </a:prstGeom>
+          <a:noFill/>
+          <a:ln/>
+        </p:spPr>
+        <p:txBody>
+          <a:bodyPr wrap="square" rtlCol="0" anchor="ctr"/>
+          <a:lstStyle/>
+          <a:p>
+            <a:pPr indent="0" marL="0">
+              <a:buNone/>
+            </a:pPr>
+            <a:r>
+              <a:rPr lang="en-US" sz="1400" b="1" dirty="0">
+                <a:solidFill>
+                  <a:srgbClr val="1B1F3B"/>
+                </a:solidFill>
+                <a:latin typeface="Segoe UI" pitchFamily="34" charset="0"/>
+                <a:ea typeface="Segoe UI" pitchFamily="34" charset="-122"/>
+                <a:cs typeface="Segoe UI" pitchFamily="34" charset="-120"/>
+              </a:rPr>
+              <a:t>Verrouillage de la base partagée écrit dans le script d'installation</a:t>
+            </a:r>
+            <a:endParaRPr lang="en-US" sz="1400" dirty="0"/>
+          </a:p>
+        </p:txBody>
+      </p:sp>
+      <p:sp>
+        <p:nvSpPr>
+          <p:cNvPr id="16" name="Text 14"/>
+          <p:cNvSpPr/>
+          <p:nvPr/>
+        </p:nvSpPr>
+        <p:spPr>
+          <a:xfrm>
+            <a:off x="914400" y="4617720"/>
+            <a:ext cx="10332720" cy="594360"/>
+          </a:xfrm>
+          <a:prstGeom prst="rect">
+            <a:avLst/>
+          </a:prstGeom>
+          <a:noFill/>
+          <a:ln/>
+        </p:spPr>
+        <p:txBody>
+          <a:bodyPr wrap="square" rtlCol="0" anchor="ctr"/>
+          <a:lstStyle/>
+          <a:p>
+            <a:pPr indent="0" marL="0">
+              <a:lnSpc>
+                <a:spcPts val="1400"/>
+              </a:lnSpc>
+              <a:buNone/>
+            </a:pPr>
+            <a:r>
+              <a:rPr lang="en-US" sz="1100" dirty="0">
+                <a:solidFill>
+                  <a:srgbClr val="8A7C68"/>
+                </a:solidFill>
+                <a:latin typeface="Segoe UI" pitchFamily="34" charset="0"/>
+                <a:ea typeface="Segoe UI" pitchFamily="34" charset="-122"/>
+                <a:cs typeface="Segoe UI" pitchFamily="34" charset="-120"/>
+              </a:rPr>
+              <a:t>La commande qui ferme complètement l'accès public à la table de données partagée a été ajoutée au script SQL du projet, prête à être exécutée dans le tableau de bord Supabase.</a:t>
+            </a:r>
+            <a:endParaRPr lang="en-US" sz="1100" dirty="0"/>
+          </a:p>
+        </p:txBody>
+      </p:sp>
+      <p:sp>
+        <p:nvSpPr>
+          <p:cNvPr id="17" name="Text 15"/>
+          <p:cNvSpPr/>
+          <p:nvPr/>
+        </p:nvSpPr>
+        <p:spPr>
+          <a:xfrm>
+            <a:off x="365760" y="6510528"/>
+            <a:ext cx="5486400" cy="274320"/>
+          </a:xfrm>
+          <a:prstGeom prst="rect">
+            <a:avLst/>
+          </a:prstGeom>
+          <a:noFill/>
+          <a:ln/>
+        </p:spPr>
+        <p:txBody>
+          <a:bodyPr wrap="square" rtlCol="0" anchor="ctr"/>
+          <a:lstStyle/>
+          <a:p>
+            <a:pPr indent="0" marL="0">
+              <a:buNone/>
+            </a:pPr>
+            <a:r>
+              <a:rPr lang="en-US" sz="900" dirty="0">
+                <a:solidFill>
+                  <a:srgbClr val="8A7C68"/>
+                </a:solidFill>
+                <a:latin typeface="Segoe UI" pitchFamily="34" charset="0"/>
+                <a:ea typeface="Segoe UI" pitchFamily="34" charset="-122"/>
+                <a:cs typeface="Segoe UI" pitchFamily="34" charset="-120"/>
+              </a:rPr>
+              <a:t>Koji Web — Récapitulatif technique</a:t>
+            </a:r>
+            <a:endParaRPr lang="en-US" sz="900" dirty="0"/>
+          </a:p>
+        </p:txBody>
+      </p:sp>
+      <p:sp>
+        <p:nvSpPr>
+          <p:cNvPr id="18" name="Text 16"/>
+          <p:cNvSpPr/>
+          <p:nvPr/>
+        </p:nvSpPr>
+        <p:spPr>
+          <a:xfrm>
+            <a:off x="9601200" y="6510528"/>
+            <a:ext cx="2194560" cy="274320"/>
+          </a:xfrm>
+          <a:prstGeom prst="rect">
+            <a:avLst/>
+          </a:prstGeom>
+          <a:noFill/>
+          <a:ln/>
+        </p:spPr>
+        <p:txBody>
+          <a:bodyPr wrap="square" rtlCol="0" anchor="ctr"/>
+          <a:lstStyle/>
+          <a:p>
+            <a:pPr algn="r" indent="0" marL="0">
+              <a:buNone/>
+            </a:pPr>
+            <a:r>
+              <a:rPr lang="en-US" sz="900" dirty="0">
+                <a:solidFill>
+                  <a:srgbClr val="8A7C68"/>
+                </a:solidFill>
+                <a:latin typeface="Segoe UI" pitchFamily="34" charset="0"/>
+                <a:ea typeface="Segoe UI" pitchFamily="34" charset="-122"/>
+                <a:cs typeface="Segoe UI" pitchFamily="34" charset="-120"/>
+              </a:rPr>
+              <a:t>51</a:t>
+            </a:r>
+            <a:endParaRPr lang="en-US" sz="900" dirty="0"/>
+          </a:p>
+        </p:txBody>
+      </p:sp>
+    </p:spTree>
+  </p:cSld>
+  <p:clrMapOvr>
+    <a:masterClrMapping/>
+  </p:clrMapOvr>
+</p:sld>
+</file>
+
+<file path=ppt/slides/slide52.xml><?xml version="1.0" encoding="utf-8"?>
+<p:sld xmlns:a="http://schemas.openxmlformats.org/drawingml/2006/main" xmlns:r="http://schemas.openxmlformats.org/officeDocument/2006/relationships" xmlns:p="http://schemas.openxmlformats.org/presentationml/2006/main">
+  <p:cSld name="Slide 52">
     <p:bg>
       <p:bgPr>
         <a:solidFill>

</xml_diff>

<commit_message>
Signalement technique: email avec l'identite du client et reply-to
Le mail envoye a contact@kojibuild.com precise desormais qui a envoye
le signalement : nom, email, entreprise (celle qui emploie l'ouvrier
le cas echeant), page d'origine, type de compte. L'email est envoye
avec Reply-To sur l'adresse du client, pour repondre directement sans
avoir a la rechercher ailleurs.

Retire aussi koji-texte-* (fichiers logo texte-seul supprimes localement).

Co-Authored-By: Claude Sonnet 5 <noreply@anthropic.com>
</commit_message>
<xml_diff>
--- a/docs/manager-recap/Recap-Koji-Manager.pptx
+++ b/docs/manager-recap/Recap-Koji-Manager.pptx
@@ -12162,7 +12162,7 @@
                 <a:ea typeface="Georgia" pitchFamily="34" charset="-122"/>
                 <a:cs typeface="Georgia" pitchFamily="34" charset="-120"/>
               </a:rPr>
-              <a:t>120</a:t>
+              <a:t>121</a:t>
             </a:r>
             <a:endParaRPr lang="en-US" sz="3200" dirty="0"/>
           </a:p>
@@ -12372,7 +12372,7 @@
                 <a:ea typeface="Georgia" pitchFamily="34" charset="-122"/>
                 <a:cs typeface="Georgia" pitchFamily="34" charset="-120"/>
               </a:rPr>
-              <a:t>47</a:t>
+              <a:t>48</a:t>
             </a:r>
             <a:endParaRPr lang="en-US" sz="3200" dirty="0"/>
           </a:p>
@@ -14318,7 +14318,7 @@
                 <a:ea typeface="Segoe UI" pitchFamily="34" charset="-122"/>
                 <a:cs typeface="Segoe UI" pitchFamily="34" charset="-120"/>
               </a:rPr>
-              <a:t>47 mise(s) à jour</a:t>
+              <a:t>48 mise(s) à jour</a:t>
             </a:r>
             <a:endParaRPr lang="en-US" sz="1200" dirty="0"/>
           </a:p>
@@ -25511,7 +25511,135 @@
       </p:sp>
       <p:sp>
         <p:nvSpPr>
-          <p:cNvPr id="9" name="Text 7"/>
+          <p:cNvPr id="9" name="Shape 7"/>
+          <p:cNvSpPr/>
+          <p:nvPr/>
+        </p:nvSpPr>
+        <p:spPr>
+          <a:xfrm>
+            <a:off x="640080" y="2926080"/>
+            <a:ext cx="10881360" cy="1097280"/>
+          </a:xfrm>
+          <a:prstGeom prst="roundRect">
+            <a:avLst>
+              <a:gd name="adj" fmla="val 5000"/>
+            </a:avLst>
+          </a:prstGeom>
+          <a:solidFill>
+            <a:srgbClr val="FFFFFF"/>
+          </a:solidFill>
+          <a:ln w="12700">
+            <a:solidFill>
+              <a:srgbClr val="E4DCCB"/>
+            </a:solidFill>
+            <a:prstDash val="solid"/>
+          </a:ln>
+        </p:spPr>
+      </p:sp>
+      <p:sp>
+        <p:nvSpPr>
+          <p:cNvPr id="10" name="Shape 8"/>
+          <p:cNvSpPr/>
+          <p:nvPr/>
+        </p:nvSpPr>
+        <p:spPr>
+          <a:xfrm>
+            <a:off x="640080" y="2926080"/>
+            <a:ext cx="54864" cy="1097280"/>
+          </a:xfrm>
+          <a:prstGeom prst="rect">
+            <a:avLst/>
+          </a:prstGeom>
+          <a:solidFill>
+            <a:srgbClr val="9A4C1F"/>
+          </a:solidFill>
+          <a:ln/>
+        </p:spPr>
+      </p:sp>
+      <p:sp>
+        <p:nvSpPr>
+          <p:cNvPr id="11" name="Text 9"/>
+          <p:cNvSpPr/>
+          <p:nvPr/>
+        </p:nvSpPr>
+        <p:spPr>
+          <a:xfrm>
+            <a:off x="914400" y="3035808"/>
+            <a:ext cx="10332720" cy="365760"/>
+          </a:xfrm>
+          <a:prstGeom prst="rect">
+            <a:avLst/>
+          </a:prstGeom>
+          <a:noFill/>
+          <a:ln/>
+        </p:spPr>
+        <p:txBody>
+          <a:bodyPr wrap="square" rtlCol="0" anchor="ctr"/>
+          <a:lstStyle/>
+          <a:p>
+            <a:pPr indent="0" marL="0">
+              <a:buNone/>
+            </a:pPr>
+            <a:r>
+              <a:rPr lang="en-US" sz="1400" b="1" dirty="0">
+                <a:solidFill>
+                  <a:srgbClr val="1B1F3B"/>
+                </a:solidFill>
+                <a:latin typeface="Segoe UI" pitchFamily="34" charset="0"/>
+                <a:ea typeface="Segoe UI" pitchFamily="34" charset="-122"/>
+                <a:cs typeface="Segoe UI" pitchFamily="34" charset="-120"/>
+              </a:rPr>
+              <a:t>Email de signalement technique enrichi (qui, quelle entreprise, reponse directe)</a:t>
+            </a:r>
+            <a:endParaRPr lang="en-US" sz="1400" dirty="0"/>
+          </a:p>
+        </p:txBody>
+      </p:sp>
+      <p:sp>
+        <p:nvSpPr>
+          <p:cNvPr id="12" name="Text 10"/>
+          <p:cNvSpPr/>
+          <p:nvPr/>
+        </p:nvSpPr>
+        <p:spPr>
+          <a:xfrm>
+            <a:off x="914400" y="3383280"/>
+            <a:ext cx="10332720" cy="594360"/>
+          </a:xfrm>
+          <a:prstGeom prst="rect">
+            <a:avLst/>
+          </a:prstGeom>
+          <a:noFill/>
+          <a:ln/>
+        </p:spPr>
+        <p:txBody>
+          <a:bodyPr wrap="square" rtlCol="0" anchor="ctr"/>
+          <a:lstStyle/>
+          <a:p>
+            <a:pPr indent="0" marL="0">
+              <a:lnSpc>
+                <a:spcPts val="1400"/>
+              </a:lnSpc>
+              <a:buNone/>
+            </a:pPr>
+            <a:r>
+              <a:rPr lang="en-US" sz="1100" dirty="0">
+                <a:solidFill>
+                  <a:srgbClr val="8A7C68"/>
+                </a:solidFill>
+                <a:latin typeface="Segoe UI" pitchFamily="34" charset="0"/>
+                <a:ea typeface="Segoe UI" pitchFamily="34" charset="-122"/>
+                <a:cs typeface="Segoe UI" pitchFamily="34" charset="-120"/>
+              </a:rPr>
+              <a:t>L'email envoye a contact@kojibuild.com quand quelqu'un utilise 'Signaler un probleme technique' contient desormais le nom et l'email de la personne, le nom de l'entreprise (y compris pour un ouvrier, celle qui l'emploie), la page d'origine et le type de compte, en plus du message. Repondre directement a cet email (fonction 'Repondre' de la messagerie) contacte la personne, sans avoir a chercher son adresse ailleurs.</a:t>
+            </a:r>
+            <a:endParaRPr lang="en-US" sz="1100" dirty="0"/>
+          </a:p>
+        </p:txBody>
+      </p:sp>
+      <p:sp>
+        <p:nvSpPr>
+          <p:cNvPr id="13" name="Text 11"/>
           <p:cNvSpPr/>
           <p:nvPr/>
         </p:nvSpPr>
@@ -25550,7 +25678,7 @@
       </p:sp>
       <p:sp>
         <p:nvSpPr>
-          <p:cNvPr id="10" name="Text 8"/>
+          <p:cNvPr id="14" name="Text 12"/>
           <p:cNvSpPr/>
           <p:nvPr/>
         </p:nvSpPr>

</xml_diff>

<commit_message>
Fiabilise l'acces client (identifiant/mdp) a la signature d'un devis
- lib/client-portal-access.js : logique de creation d'acces client
  extraite en module partage (etait dupliquee dans signatures/[token]).
- accepter un devis manuellement (signature en personne/verbale)
  cree desormais aussi l'acces client, comme le fait deja la signature
  via Koji Signature -- avant, ce chemin ne le faisait jamais.
- /api/client-portal-info (POST, nouveau) : pour un chantier deja
  signe sans acces client (devis signe sans email ni telephone),
  permet de saisir un contact et de creer l'acces a la demande.
- app/chantiers/page.jsx : carte "Ce client n'a pas d'acces" avec
  formulaire email/telephone quand c'est le cas.

Co-Authored-By: Claude Sonnet 5 <noreply@anthropic.com>
</commit_message>
<xml_diff>
--- a/docs/manager-recap/Recap-Koji-Manager.pptx
+++ b/docs/manager-recap/Recap-Koji-Manager.pptx
@@ -12162,7 +12162,7 @@
                 <a:ea typeface="Georgia" pitchFamily="34" charset="-122"/>
                 <a:cs typeface="Georgia" pitchFamily="34" charset="-120"/>
               </a:rPr>
-              <a:t>121</a:t>
+              <a:t>122</a:t>
             </a:r>
             <a:endParaRPr lang="en-US" sz="3200" dirty="0"/>
           </a:p>
@@ -12372,7 +12372,7 @@
                 <a:ea typeface="Georgia" pitchFamily="34" charset="-122"/>
                 <a:cs typeface="Georgia" pitchFamily="34" charset="-120"/>
               </a:rPr>
-              <a:t>48</a:t>
+              <a:t>49</a:t>
             </a:r>
             <a:endParaRPr lang="en-US" sz="3200" dirty="0"/>
           </a:p>
@@ -14318,7 +14318,7 @@
                 <a:ea typeface="Segoe UI" pitchFamily="34" charset="-122"/>
                 <a:cs typeface="Segoe UI" pitchFamily="34" charset="-120"/>
               </a:rPr>
-              <a:t>48 mise(s) à jour</a:t>
+              <a:t>49 mise(s) à jour</a:t>
             </a:r>
             <a:endParaRPr lang="en-US" sz="1200" dirty="0"/>
           </a:p>
@@ -17296,7 +17296,135 @@
       </p:sp>
       <p:sp>
         <p:nvSpPr>
-          <p:cNvPr id="13" name="Text 11"/>
+          <p:cNvPr id="13" name="Shape 11"/>
+          <p:cNvSpPr/>
+          <p:nvPr/>
+        </p:nvSpPr>
+        <p:spPr>
+          <a:xfrm>
+            <a:off x="640080" y="4160520"/>
+            <a:ext cx="10881360" cy="1097280"/>
+          </a:xfrm>
+          <a:prstGeom prst="roundRect">
+            <a:avLst>
+              <a:gd name="adj" fmla="val 5000"/>
+            </a:avLst>
+          </a:prstGeom>
+          <a:solidFill>
+            <a:srgbClr val="FFFFFF"/>
+          </a:solidFill>
+          <a:ln w="12700">
+            <a:solidFill>
+              <a:srgbClr val="E4DCCB"/>
+            </a:solidFill>
+            <a:prstDash val="solid"/>
+          </a:ln>
+        </p:spPr>
+      </p:sp>
+      <p:sp>
+        <p:nvSpPr>
+          <p:cNvPr id="14" name="Shape 12"/>
+          <p:cNvSpPr/>
+          <p:nvPr/>
+        </p:nvSpPr>
+        <p:spPr>
+          <a:xfrm>
+            <a:off x="640080" y="4160520"/>
+            <a:ext cx="54864" cy="1097280"/>
+          </a:xfrm>
+          <a:prstGeom prst="rect">
+            <a:avLst/>
+          </a:prstGeom>
+          <a:solidFill>
+            <a:srgbClr val="9A4C1F"/>
+          </a:solidFill>
+          <a:ln/>
+        </p:spPr>
+      </p:sp>
+      <p:sp>
+        <p:nvSpPr>
+          <p:cNvPr id="15" name="Text 13"/>
+          <p:cNvSpPr/>
+          <p:nvPr/>
+        </p:nvSpPr>
+        <p:spPr>
+          <a:xfrm>
+            <a:off x="914400" y="4270248"/>
+            <a:ext cx="10332720" cy="365760"/>
+          </a:xfrm>
+          <a:prstGeom prst="rect">
+            <a:avLst/>
+          </a:prstGeom>
+          <a:noFill/>
+          <a:ln/>
+        </p:spPr>
+        <p:txBody>
+          <a:bodyPr wrap="square" rtlCol="0" anchor="ctr"/>
+          <a:lstStyle/>
+          <a:p>
+            <a:pPr indent="0" marL="0">
+              <a:buNone/>
+            </a:pPr>
+            <a:r>
+              <a:rPr lang="en-US" sz="1400" b="1" dirty="0">
+                <a:solidFill>
+                  <a:srgbClr val="1B1F3B"/>
+                </a:solidFill>
+                <a:latin typeface="Segoe UI" pitchFamily="34" charset="0"/>
+                <a:ea typeface="Segoe UI" pitchFamily="34" charset="-122"/>
+                <a:cs typeface="Segoe UI" pitchFamily="34" charset="-120"/>
+              </a:rPr>
+              <a:t>Acces client (identifiant + mot de passe) fiabilise a la signature</a:t>
+            </a:r>
+            <a:endParaRPr lang="en-US" sz="1400" dirty="0"/>
+          </a:p>
+        </p:txBody>
+      </p:sp>
+      <p:sp>
+        <p:nvSpPr>
+          <p:cNvPr id="16" name="Text 14"/>
+          <p:cNvSpPr/>
+          <p:nvPr/>
+        </p:nvSpPr>
+        <p:spPr>
+          <a:xfrm>
+            <a:off x="914400" y="4617720"/>
+            <a:ext cx="10332720" cy="594360"/>
+          </a:xfrm>
+          <a:prstGeom prst="rect">
+            <a:avLst/>
+          </a:prstGeom>
+          <a:noFill/>
+          <a:ln/>
+        </p:spPr>
+        <p:txBody>
+          <a:bodyPr wrap="square" rtlCol="0" anchor="ctr"/>
+          <a:lstStyle/>
+          <a:p>
+            <a:pPr indent="0" marL="0">
+              <a:lnSpc>
+                <a:spcPts val="1400"/>
+              </a:lnSpc>
+              <a:buNone/>
+            </a:pPr>
+            <a:r>
+              <a:rPr lang="en-US" sz="1100" dirty="0">
+                <a:solidFill>
+                  <a:srgbClr val="8A7C68"/>
+                </a:solidFill>
+                <a:latin typeface="Segoe UI" pitchFamily="34" charset="0"/>
+                <a:ea typeface="Segoe UI" pitchFamily="34" charset="-122"/>
+                <a:cs typeface="Segoe UI" pitchFamily="34" charset="-120"/>
+              </a:rPr>
+              <a:t>Avant, l'identifiant et le mot de passe donnes au client pour suivre son chantier n'etaient crees que si le client remplissait lui-meme son email/telephone sur le formulaire de signature Koji Signature (facultatif) -- et jamais du tout quand le devis etait marque 'accepte manuellement' (signature en personne/verbale). Desormais : accepter un devis manuellement cree aussi cet acces (a partir de l'email/telephone deja renseigne sur le devis), et pour un chantier deja signe qui n'en a toujours pas, une nouvelle carte sur la fiche chantier permet de saisir l'email ou le telephone du client et de creer l'acces a la demande.</a:t>
+            </a:r>
+            <a:endParaRPr lang="en-US" sz="1100" dirty="0"/>
+          </a:p>
+        </p:txBody>
+      </p:sp>
+      <p:sp>
+        <p:nvSpPr>
+          <p:cNvPr id="17" name="Text 15"/>
           <p:cNvSpPr/>
           <p:nvPr/>
         </p:nvSpPr>
@@ -17335,7 +17463,7 @@
       </p:sp>
       <p:sp>
         <p:nvSpPr>
-          <p:cNvPr id="14" name="Text 12"/>
+          <p:cNvPr id="18" name="Text 16"/>
           <p:cNvSpPr/>
           <p:nvPr/>
         </p:nvSpPr>

</xml_diff>

<commit_message>
Fix: signer un devis sans chantier lie ne creait plus rien
lib/quote-projects.js's generateTasksForSignedQuote no-opait
silencieusement si le devis n'avait pas de chantier_id (cas d'un
devis cree hors du parcours "nouveau chantier") -- le signer ne
faisait alors litteralement rien cote suivi, sans erreur visible.

Ajoute ensureChantierForQuote : cree le chantier manquant a la
signature (Koji Signature ou acceptation manuelle), avant la
generation des taches. scripts/repair-signed-quotes-without-chantier.mjs
corrige les devis deja signes dans ce cas (2 trouves et corriges).

Co-Authored-By: Claude Sonnet 5 <noreply@anthropic.com>
</commit_message>
<xml_diff>
--- a/docs/manager-recap/Recap-Koji-Manager.pptx
+++ b/docs/manager-recap/Recap-Koji-Manager.pptx
@@ -12251,7 +12251,7 @@
                 <a:ea typeface="Georgia" pitchFamily="34" charset="-122"/>
                 <a:cs typeface="Georgia" pitchFamily="34" charset="-120"/>
               </a:rPr>
-              <a:t>124</a:t>
+              <a:t>125</a:t>
             </a:r>
             <a:endParaRPr lang="en-US" sz="3200" dirty="0"/>
           </a:p>
@@ -12461,7 +12461,7 @@
                 <a:ea typeface="Georgia" pitchFamily="34" charset="-122"/>
                 <a:cs typeface="Georgia" pitchFamily="34" charset="-120"/>
               </a:rPr>
-              <a:t>49</a:t>
+              <a:t>50</a:t>
             </a:r>
             <a:endParaRPr lang="en-US" sz="3200" dirty="0"/>
           </a:p>
@@ -15129,7 +15129,7 @@
                 <a:ea typeface="Segoe UI" pitchFamily="34" charset="-122"/>
                 <a:cs typeface="Segoe UI" pitchFamily="34" charset="-120"/>
               </a:rPr>
-              <a:t>49 mise(s) à jour</a:t>
+              <a:t>50 mise(s) à jour</a:t>
             </a:r>
             <a:endParaRPr lang="en-US" sz="1200" dirty="0"/>
           </a:p>
@@ -18235,7 +18235,135 @@
       </p:sp>
       <p:sp>
         <p:nvSpPr>
-          <p:cNvPr id="17" name="Text 15"/>
+          <p:cNvPr id="17" name="Shape 15"/>
+          <p:cNvSpPr/>
+          <p:nvPr/>
+        </p:nvSpPr>
+        <p:spPr>
+          <a:xfrm>
+            <a:off x="640080" y="5394960"/>
+            <a:ext cx="10881360" cy="1097280"/>
+          </a:xfrm>
+          <a:prstGeom prst="roundRect">
+            <a:avLst>
+              <a:gd name="adj" fmla="val 5000"/>
+            </a:avLst>
+          </a:prstGeom>
+          <a:solidFill>
+            <a:srgbClr val="FFFFFF"/>
+          </a:solidFill>
+          <a:ln w="12700">
+            <a:solidFill>
+              <a:srgbClr val="E4DCCB"/>
+            </a:solidFill>
+            <a:prstDash val="solid"/>
+          </a:ln>
+        </p:spPr>
+      </p:sp>
+      <p:sp>
+        <p:nvSpPr>
+          <p:cNvPr id="18" name="Shape 16"/>
+          <p:cNvSpPr/>
+          <p:nvPr/>
+        </p:nvSpPr>
+        <p:spPr>
+          <a:xfrm>
+            <a:off x="640080" y="5394960"/>
+            <a:ext cx="54864" cy="1097280"/>
+          </a:xfrm>
+          <a:prstGeom prst="rect">
+            <a:avLst/>
+          </a:prstGeom>
+          <a:solidFill>
+            <a:srgbClr val="9A4C1F"/>
+          </a:solidFill>
+          <a:ln/>
+        </p:spPr>
+      </p:sp>
+      <p:sp>
+        <p:nvSpPr>
+          <p:cNvPr id="19" name="Text 17"/>
+          <p:cNvSpPr/>
+          <p:nvPr/>
+        </p:nvSpPr>
+        <p:spPr>
+          <a:xfrm>
+            <a:off x="914400" y="5504688"/>
+            <a:ext cx="10332720" cy="365760"/>
+          </a:xfrm>
+          <a:prstGeom prst="rect">
+            <a:avLst/>
+          </a:prstGeom>
+          <a:noFill/>
+          <a:ln/>
+        </p:spPr>
+        <p:txBody>
+          <a:bodyPr wrap="square" rtlCol="0" anchor="ctr"/>
+          <a:lstStyle/>
+          <a:p>
+            <a:pPr indent="0" marL="0">
+              <a:buNone/>
+            </a:pPr>
+            <a:r>
+              <a:rPr lang="en-US" sz="1400" b="1" dirty="0">
+                <a:solidFill>
+                  <a:srgbClr val="1B1F3B"/>
+                </a:solidFill>
+                <a:latin typeface="Segoe UI" pitchFamily="34" charset="0"/>
+                <a:ea typeface="Segoe UI" pitchFamily="34" charset="-122"/>
+                <a:cs typeface="Segoe UI" pitchFamily="34" charset="-120"/>
+              </a:rPr>
+              <a:t>Un devis signe sans chantier lie ne disparaissait plus dans le vide</a:t>
+            </a:r>
+            <a:endParaRPr lang="en-US" sz="1400" dirty="0"/>
+          </a:p>
+        </p:txBody>
+      </p:sp>
+      <p:sp>
+        <p:nvSpPr>
+          <p:cNvPr id="20" name="Text 18"/>
+          <p:cNvSpPr/>
+          <p:nvPr/>
+        </p:nvSpPr>
+        <p:spPr>
+          <a:xfrm>
+            <a:off x="914400" y="5852160"/>
+            <a:ext cx="10332720" cy="594360"/>
+          </a:xfrm>
+          <a:prstGeom prst="rect">
+            <a:avLst/>
+          </a:prstGeom>
+          <a:noFill/>
+          <a:ln/>
+        </p:spPr>
+        <p:txBody>
+          <a:bodyPr wrap="square" rtlCol="0" anchor="ctr"/>
+          <a:lstStyle/>
+          <a:p>
+            <a:pPr indent="0" marL="0">
+              <a:lnSpc>
+                <a:spcPts val="1400"/>
+              </a:lnSpc>
+              <a:buNone/>
+            </a:pPr>
+            <a:r>
+              <a:rPr lang="en-US" sz="1100" dirty="0">
+                <a:solidFill>
+                  <a:srgbClr val="8A7C68"/>
+                </a:solidFill>
+                <a:latin typeface="Segoe UI" pitchFamily="34" charset="0"/>
+                <a:ea typeface="Segoe UI" pitchFamily="34" charset="-122"/>
+                <a:cs typeface="Segoe UI" pitchFamily="34" charset="-120"/>
+              </a:rPr>
+              <a:t>Bug trouve : un devis cree hors du parcours 'nouveau chantier' (par exemple depuis la liste generale des devis) n'etait rattache a aucun chantier ; le signer (signature client ou acceptation manuelle) ne creait alors rien et le devis restait introuvable dans Chantiers, sans aucune erreur. Corrige : signer un devis sans chantier lie en cree desormais un automatiquement. Deux devis deja signes dans ce cas (comptes existants) ont ete corriges directement en base.</a:t>
+            </a:r>
+            <a:endParaRPr lang="en-US" sz="1100" dirty="0"/>
+          </a:p>
+        </p:txBody>
+      </p:sp>
+      <p:sp>
+        <p:nvSpPr>
+          <p:cNvPr id="21" name="Text 19"/>
           <p:cNvSpPr/>
           <p:nvPr/>
         </p:nvSpPr>
@@ -18274,7 +18402,7 @@
       </p:sp>
       <p:sp>
         <p:nvSpPr>
-          <p:cNvPr id="18" name="Text 16"/>
+          <p:cNvPr id="22" name="Text 20"/>
           <p:cNvSpPr/>
           <p:nvPr/>
         </p:nvSpPr>

</xml_diff>

<commit_message>
Chiffre d'affaires: page dediee, icone euro, design plus vif
- La pastille de l'accueil renvoie maintenant vers une page separee
  (/chiffre-affaires) au lieu de deplier le detail sur place.
- Icone corrigee en symbole euro (affichait un dollar par erreur).
- Degrade bleu-violet + accent dore, plus affirme que le bleu marine
  uni precedent.

Co-Authored-By: Claude Sonnet 5 <noreply@anthropic.com>
</commit_message>
<xml_diff>
--- a/docs/manager-recap/Recap-Koji-Manager.pptx
+++ b/docs/manager-recap/Recap-Koji-Manager.pptx
@@ -12518,7 +12518,7 @@
                 <a:ea typeface="Georgia" pitchFamily="34" charset="-122"/>
                 <a:cs typeface="Georgia" pitchFamily="34" charset="-120"/>
               </a:rPr>
-              <a:t>128</a:t>
+              <a:t>129</a:t>
             </a:r>
             <a:endParaRPr lang="en-US" sz="3200" dirty="0"/>
           </a:p>
@@ -12623,7 +12623,7 @@
                 <a:ea typeface="Georgia" pitchFamily="34" charset="-122"/>
                 <a:cs typeface="Georgia" pitchFamily="34" charset="-120"/>
               </a:rPr>
-              <a:t>66</a:t>
+              <a:t>67</a:t>
             </a:r>
             <a:endParaRPr lang="en-US" sz="3200" dirty="0"/>
           </a:p>
@@ -15833,7 +15833,135 @@
       </p:sp>
       <p:sp>
         <p:nvSpPr>
-          <p:cNvPr id="9" name="Text 7"/>
+          <p:cNvPr id="9" name="Shape 7"/>
+          <p:cNvSpPr/>
+          <p:nvPr/>
+        </p:nvSpPr>
+        <p:spPr>
+          <a:xfrm>
+            <a:off x="640080" y="2926080"/>
+            <a:ext cx="10881360" cy="1097280"/>
+          </a:xfrm>
+          <a:prstGeom prst="roundRect">
+            <a:avLst>
+              <a:gd name="adj" fmla="val 5000"/>
+            </a:avLst>
+          </a:prstGeom>
+          <a:solidFill>
+            <a:srgbClr val="FFFFFF"/>
+          </a:solidFill>
+          <a:ln w="12700">
+            <a:solidFill>
+              <a:srgbClr val="E4DCCB"/>
+            </a:solidFill>
+            <a:prstDash val="solid"/>
+          </a:ln>
+        </p:spPr>
+      </p:sp>
+      <p:sp>
+        <p:nvSpPr>
+          <p:cNvPr id="10" name="Shape 8"/>
+          <p:cNvSpPr/>
+          <p:nvPr/>
+        </p:nvSpPr>
+        <p:spPr>
+          <a:xfrm>
+            <a:off x="640080" y="2926080"/>
+            <a:ext cx="54864" cy="1097280"/>
+          </a:xfrm>
+          <a:prstGeom prst="rect">
+            <a:avLst/>
+          </a:prstGeom>
+          <a:solidFill>
+            <a:srgbClr val="1D6FE0"/>
+          </a:solidFill>
+          <a:ln/>
+        </p:spPr>
+      </p:sp>
+      <p:sp>
+        <p:nvSpPr>
+          <p:cNvPr id="11" name="Text 9"/>
+          <p:cNvSpPr/>
+          <p:nvPr/>
+        </p:nvSpPr>
+        <p:spPr>
+          <a:xfrm>
+            <a:off x="914400" y="3035808"/>
+            <a:ext cx="10332720" cy="365760"/>
+          </a:xfrm>
+          <a:prstGeom prst="rect">
+            <a:avLst/>
+          </a:prstGeom>
+          <a:noFill/>
+          <a:ln/>
+        </p:spPr>
+        <p:txBody>
+          <a:bodyPr wrap="square" rtlCol="0" anchor="ctr"/>
+          <a:lstStyle/>
+          <a:p>
+            <a:pPr indent="0" marL="0">
+              <a:buNone/>
+            </a:pPr>
+            <a:r>
+              <a:rPr lang="en-US" sz="1400" b="1" dirty="0">
+                <a:solidFill>
+                  <a:srgbClr val="1B1F3B"/>
+                </a:solidFill>
+                <a:latin typeface="Segoe UI" pitchFamily="34" charset="0"/>
+                <a:ea typeface="Segoe UI" pitchFamily="34" charset="-122"/>
+                <a:cs typeface="Segoe UI" pitchFamily="34" charset="-120"/>
+              </a:rPr>
+              <a:t>Chiffre d'affaires: page dediee au lieu d'un depliant sur place</a:t>
+            </a:r>
+            <a:endParaRPr lang="en-US" sz="1400" dirty="0"/>
+          </a:p>
+        </p:txBody>
+      </p:sp>
+      <p:sp>
+        <p:nvSpPr>
+          <p:cNvPr id="12" name="Text 10"/>
+          <p:cNvSpPr/>
+          <p:nvPr/>
+        </p:nvSpPr>
+        <p:spPr>
+          <a:xfrm>
+            <a:off x="914400" y="3383280"/>
+            <a:ext cx="10332720" cy="594360"/>
+          </a:xfrm>
+          <a:prstGeom prst="rect">
+            <a:avLst/>
+          </a:prstGeom>
+          <a:noFill/>
+          <a:ln/>
+        </p:spPr>
+        <p:txBody>
+          <a:bodyPr wrap="square" rtlCol="0" anchor="ctr"/>
+          <a:lstStyle/>
+          <a:p>
+            <a:pPr indent="0" marL="0">
+              <a:lnSpc>
+                <a:spcPts val="1400"/>
+              </a:lnSpc>
+              <a:buNone/>
+            </a:pPr>
+            <a:r>
+              <a:rPr lang="en-US" sz="1100" dirty="0">
+                <a:solidFill>
+                  <a:srgbClr val="8A7C68"/>
+                </a:solidFill>
+                <a:latin typeface="Segoe UI" pitchFamily="34" charset="0"/>
+                <a:ea typeface="Segoe UI" pitchFamily="34" charset="-122"/>
+                <a:cs typeface="Segoe UI" pitchFamily="34" charset="-120"/>
+              </a:rPr>
+              <a:t>Cliquer sur la pastille 'Chiffre d'affaires' de l'accueil ouvre desormais une page separee (/chiffre-affaires) avec le detail complet, plutot que de deplier le contenu sur la meme page. Icone changee pour un symbole euro (au lieu d'un symbole dollar par erreur), et couleurs de la pastille rendues plus vives (degrade bleu-violet avec accent dore) suite a son retour sur le design precedent.</a:t>
+            </a:r>
+            <a:endParaRPr lang="en-US" sz="1100" dirty="0"/>
+          </a:p>
+        </p:txBody>
+      </p:sp>
+      <p:sp>
+        <p:nvSpPr>
+          <p:cNvPr id="13" name="Text 11"/>
           <p:cNvSpPr/>
           <p:nvPr/>
         </p:nvSpPr>
@@ -15872,7 +16000,7 @@
       </p:sp>
       <p:sp>
         <p:nvSpPr>
-          <p:cNvPr id="10" name="Text 8"/>
+          <p:cNvPr id="14" name="Text 12"/>
           <p:cNvSpPr/>
           <p:nvPr/>
         </p:nvSpPr>
@@ -18229,7 +18357,7 @@
                 <a:ea typeface="Segoe UI" pitchFamily="34" charset="-122"/>
                 <a:cs typeface="Segoe UI" pitchFamily="34" charset="-120"/>
               </a:rPr>
-              <a:t>66 mise(s) à jour</a:t>
+              <a:t>67 mise(s) à jour</a:t>
             </a:r>
             <a:endParaRPr lang="en-US" sz="1200" dirty="0"/>
           </a:p>

</xml_diff>

<commit_message>
Documente le dictionnaire de vocabulaire metier et met a jour le recap manager
- Nouveau document Word (docs/dictionnaire-metiers/) : algorithme complet de
  reconnaissance du metier — dictionnaire, desambiguisation, cadrage par
  metier, les 11 questions fixes, garde-fous.
- Recap manager (docs/manager-recap/) : 5 entrees ajoutees pour le travail
  recent sur l'assistant Radar des Chantiers (dictionnaire de vocabulaire,
  desambiguisation, confirmation d'adresse, message d'intro vague, cadrage
  par metier, reponses imprecises).

Co-Authored-By: Claude Sonnet 5 <noreply@anthropic.com>
</commit_message>
<xml_diff>
--- a/docs/manager-recap/Recap-Koji-Manager.pptx
+++ b/docs/manager-recap/Recap-Koji-Manager.pptx
@@ -62,9 +62,11 @@
     <p:sldId id="310" r:id="rId56"/>
     <p:sldId id="311" r:id="rId57"/>
     <p:sldId id="312" r:id="rId58"/>
+    <p:sldId id="313" r:id="rId59"/>
+    <p:sldId id="314" r:id="rId60"/>
   </p:sldIdLst>
   <p:notesMasterIdLst>
-    <p:notesMasterId r:id="rId59"/>
+    <p:notesMasterId r:id="rId61"/>
   </p:notesMasterIdLst>
   <p:sldSz cx="12191695" cy="6858000"/>
   <p:notesSz cx="6858000" cy="12191695"/>
@@ -5158,6 +5160,182 @@
             <a:fld id="{F7021451-1387-4CA6-816F-3879F97B5CBC}" type="slidenum">
               <a:rPr lang="en-US"/>
               <a:t>57</a:t>
+            </a:fld>
+            <a:endParaRPr lang="en-US"/>
+          </a:p>
+        </p:txBody>
+      </p:sp>
+    </p:spTree>
+    <p:extLst>
+      <p:ext uri="{BB962C8B-B14F-4D97-AF65-F5344CB8AC3E}">
+        <p14:creationId xmlns:p14="http://schemas.microsoft.com/office/powerpoint/2010/main" val="1024086991"/>
+      </p:ext>
+    </p:extLst>
+  </p:cSld>
+  <p:clrMapOvr>
+    <a:masterClrMapping/>
+  </p:clrMapOvr>
+</p:notes>
+</file>
+
+<file path=ppt/notesSlides/notesSlide58.xml><?xml version="1.0" encoding="utf-8"?>
+<p:notes xmlns:a="http://schemas.openxmlformats.org/drawingml/2006/main" xmlns:r="http://schemas.openxmlformats.org/officeDocument/2006/relationships" xmlns:p="http://schemas.openxmlformats.org/presentationml/2006/main">
+  <p:cSld>
+    <p:spTree>
+      <p:nvGrpSpPr>
+        <p:cNvPr id="1" name=""/>
+        <p:cNvGrpSpPr/>
+        <p:nvPr/>
+      </p:nvGrpSpPr>
+      <p:grpSpPr>
+        <a:xfrm>
+          <a:off x="0" y="0"/>
+          <a:ext cx="0" cy="0"/>
+          <a:chOff x="0" y="0"/>
+          <a:chExt cx="0" cy="0"/>
+        </a:xfrm>
+      </p:grpSpPr>
+      <p:sp>
+        <p:nvSpPr>
+          <p:cNvPr id="2" name="Slide Image Placeholder 1"/>
+          <p:cNvSpPr>
+            <a:spLocks noGrp="1" noRot="1" noChangeAspect="1"/>
+          </p:cNvSpPr>
+          <p:nvPr>
+            <p:ph type="sldImg"/>
+          </p:nvPr>
+        </p:nvSpPr>
+        <p:spPr/>
+      </p:sp>
+      <p:sp>
+        <p:nvSpPr>
+          <p:cNvPr id="3" name="Notes Placeholder 2"/>
+          <p:cNvSpPr>
+            <a:spLocks noGrp="1"/>
+          </p:cNvSpPr>
+          <p:nvPr>
+            <p:ph type="body" idx="1"/>
+          </p:nvPr>
+        </p:nvSpPr>
+        <p:spPr/>
+        <p:txBody>
+          <a:bodyPr/>
+          <a:lstStyle/>
+          <a:p>
+            <a:r>
+              <a:rPr lang="en-US" dirty="0"/>
+              <a:t/>
+            </a:r>
+            <a:endParaRPr lang="en-US" dirty="0"/>
+          </a:p>
+        </p:txBody>
+      </p:sp>
+      <p:sp>
+        <p:nvSpPr>
+          <p:cNvPr id="4" name="Slide Number Placeholder 3"/>
+          <p:cNvSpPr>
+            <a:spLocks noGrp="1"/>
+          </p:cNvSpPr>
+          <p:nvPr>
+            <p:ph type="sldNum" sz="quarter" idx="10"/>
+          </p:nvPr>
+        </p:nvSpPr>
+        <p:spPr/>
+        <p:txBody>
+          <a:bodyPr/>
+          <a:lstStyle/>
+          <a:p>
+            <a:fld id="{F7021451-1387-4CA6-816F-3879F97B5CBC}" type="slidenum">
+              <a:rPr lang="en-US"/>
+              <a:t>58</a:t>
+            </a:fld>
+            <a:endParaRPr lang="en-US"/>
+          </a:p>
+        </p:txBody>
+      </p:sp>
+    </p:spTree>
+    <p:extLst>
+      <p:ext uri="{BB962C8B-B14F-4D97-AF65-F5344CB8AC3E}">
+        <p14:creationId xmlns:p14="http://schemas.microsoft.com/office/powerpoint/2010/main" val="1024086991"/>
+      </p:ext>
+    </p:extLst>
+  </p:cSld>
+  <p:clrMapOvr>
+    <a:masterClrMapping/>
+  </p:clrMapOvr>
+</p:notes>
+</file>
+
+<file path=ppt/notesSlides/notesSlide59.xml><?xml version="1.0" encoding="utf-8"?>
+<p:notes xmlns:a="http://schemas.openxmlformats.org/drawingml/2006/main" xmlns:r="http://schemas.openxmlformats.org/officeDocument/2006/relationships" xmlns:p="http://schemas.openxmlformats.org/presentationml/2006/main">
+  <p:cSld>
+    <p:spTree>
+      <p:nvGrpSpPr>
+        <p:cNvPr id="1" name=""/>
+        <p:cNvGrpSpPr/>
+        <p:nvPr/>
+      </p:nvGrpSpPr>
+      <p:grpSpPr>
+        <a:xfrm>
+          <a:off x="0" y="0"/>
+          <a:ext cx="0" cy="0"/>
+          <a:chOff x="0" y="0"/>
+          <a:chExt cx="0" cy="0"/>
+        </a:xfrm>
+      </p:grpSpPr>
+      <p:sp>
+        <p:nvSpPr>
+          <p:cNvPr id="2" name="Slide Image Placeholder 1"/>
+          <p:cNvSpPr>
+            <a:spLocks noGrp="1" noRot="1" noChangeAspect="1"/>
+          </p:cNvSpPr>
+          <p:nvPr>
+            <p:ph type="sldImg"/>
+          </p:nvPr>
+        </p:nvSpPr>
+        <p:spPr/>
+      </p:sp>
+      <p:sp>
+        <p:nvSpPr>
+          <p:cNvPr id="3" name="Notes Placeholder 2"/>
+          <p:cNvSpPr>
+            <a:spLocks noGrp="1"/>
+          </p:cNvSpPr>
+          <p:nvPr>
+            <p:ph type="body" idx="1"/>
+          </p:nvPr>
+        </p:nvSpPr>
+        <p:spPr/>
+        <p:txBody>
+          <a:bodyPr/>
+          <a:lstStyle/>
+          <a:p>
+            <a:r>
+              <a:rPr lang="en-US" dirty="0"/>
+              <a:t/>
+            </a:r>
+            <a:endParaRPr lang="en-US" dirty="0"/>
+          </a:p>
+        </p:txBody>
+      </p:sp>
+      <p:sp>
+        <p:nvSpPr>
+          <p:cNvPr id="4" name="Slide Number Placeholder 3"/>
+          <p:cNvSpPr>
+            <a:spLocks noGrp="1"/>
+          </p:cNvSpPr>
+          <p:nvPr>
+            <p:ph type="sldNum" sz="quarter" idx="10"/>
+          </p:nvPr>
+        </p:nvSpPr>
+        <p:spPr/>
+        <p:txBody>
+          <a:bodyPr/>
+          <a:lstStyle/>
+          <a:p>
+            <a:fld id="{F7021451-1387-4CA6-816F-3879F97B5CBC}" type="slidenum">
+              <a:rPr lang="en-US"/>
+              <a:t>59</a:t>
             </a:fld>
             <a:endParaRPr lang="en-US"/>
           </a:p>
@@ -12607,7 +12785,7 @@
                 <a:ea typeface="Georgia" pitchFamily="34" charset="-122"/>
                 <a:cs typeface="Georgia" pitchFamily="34" charset="-120"/>
               </a:rPr>
-              <a:t>130</a:t>
+              <a:t>136</a:t>
             </a:r>
             <a:endParaRPr lang="en-US" sz="3200" dirty="0"/>
           </a:p>
@@ -12817,7 +12995,7 @@
                 <a:ea typeface="Georgia" pitchFamily="34" charset="-122"/>
                 <a:cs typeface="Georgia" pitchFamily="34" charset="-120"/>
               </a:rPr>
-              <a:t>51</a:t>
+              <a:t>57</a:t>
             </a:r>
             <a:endParaRPr lang="en-US" sz="3200" dirty="0"/>
           </a:p>
@@ -16627,7 +16805,7 @@
                 <a:ea typeface="Segoe UI" pitchFamily="34" charset="-122"/>
                 <a:cs typeface="Segoe UI" pitchFamily="34" charset="-120"/>
               </a:rPr>
-              <a:t>51 mise(s) à jour</a:t>
+              <a:t>57 mise(s) à jour</a:t>
             </a:r>
             <a:endParaRPr lang="en-US" sz="1200" dirty="0"/>
           </a:p>
@@ -28632,7 +28810,7 @@
     <p:bg>
       <p:bgPr>
         <a:solidFill>
-          <a:srgbClr val="0B1030"/>
+          <a:srgbClr val="F3EEE3"/>
         </a:solidFill>
       </p:bgPr>
     </p:bg>
@@ -28658,14 +28836,16 @@
         </p:nvSpPr>
         <p:spPr>
           <a:xfrm>
-            <a:off x="0" y="3246120"/>
-            <a:ext cx="12191695" cy="54864"/>
-          </a:xfrm>
-          <a:prstGeom prst="rect">
-            <a:avLst/>
+            <a:off x="640080" y="411480"/>
+            <a:ext cx="2377440" cy="365760"/>
+          </a:xfrm>
+          <a:prstGeom prst="roundRect">
+            <a:avLst>
+              <a:gd name="adj" fmla="val 50000"/>
+            </a:avLst>
           </a:prstGeom>
           <a:solidFill>
-            <a:srgbClr val="386641"/>
+            <a:srgbClr val="F5E6DA"/>
           </a:solidFill>
           <a:ln/>
         </p:spPr>
@@ -28678,118 +28858,591 @@
         </p:nvSpPr>
         <p:spPr>
           <a:xfrm>
-            <a:off x="640080" y="2468880"/>
-            <a:ext cx="10058400" cy="914400"/>
-          </a:xfrm>
-          <a:prstGeom prst="rect">
-            <a:avLst/>
-          </a:prstGeom>
-          <a:noFill/>
-          <a:ln/>
-        </p:spPr>
-        <p:txBody>
-          <a:bodyPr wrap="square" rtlCol="0" anchor="ctr"/>
-          <a:lstStyle/>
-          <a:p>
-            <a:pPr indent="0" marL="0">
-              <a:buNone/>
-            </a:pPr>
-            <a:r>
-              <a:rPr lang="en-US" sz="3800" b="1" dirty="0">
-                <a:solidFill>
-                  <a:srgbClr val="FFFFFF"/>
+            <a:off x="640080" y="411480"/>
+            <a:ext cx="2377440" cy="365760"/>
+          </a:xfrm>
+          <a:prstGeom prst="rect">
+            <a:avLst/>
+          </a:prstGeom>
+          <a:noFill/>
+          <a:ln/>
+        </p:spPr>
+        <p:txBody>
+          <a:bodyPr wrap="square" rtlCol="0" anchor="ctr"/>
+          <a:lstStyle/>
+          <a:p>
+            <a:pPr algn="ctr" indent="0" marL="0">
+              <a:buNone/>
+            </a:pPr>
+            <a:r>
+              <a:rPr lang="en-US" sz="1000" b="1" spc="100" kern="0" dirty="0">
+                <a:solidFill>
+                  <a:srgbClr val="9A4C1F"/>
+                </a:solidFill>
+                <a:latin typeface="Segoe UI" pitchFamily="34" charset="0"/>
+                <a:ea typeface="Segoe UI" pitchFamily="34" charset="-122"/>
+                <a:cs typeface="Segoe UI" pitchFamily="34" charset="-120"/>
+              </a:rPr>
+              <a:t>BACKEND</a:t>
+            </a:r>
+            <a:endParaRPr lang="en-US" sz="1000" dirty="0"/>
+          </a:p>
+        </p:txBody>
+      </p:sp>
+      <p:sp>
+        <p:nvSpPr>
+          <p:cNvPr id="4" name="Text 2"/>
+          <p:cNvSpPr/>
+          <p:nvPr/>
+        </p:nvSpPr>
+        <p:spPr>
+          <a:xfrm>
+            <a:off x="640080" y="868680"/>
+            <a:ext cx="10515600" cy="548640"/>
+          </a:xfrm>
+          <a:prstGeom prst="rect">
+            <a:avLst/>
+          </a:prstGeom>
+          <a:noFill/>
+          <a:ln/>
+        </p:spPr>
+        <p:txBody>
+          <a:bodyPr wrap="square" rtlCol="0" anchor="ctr"/>
+          <a:lstStyle/>
+          <a:p>
+            <a:pPr indent="0" marL="0">
+              <a:buNone/>
+            </a:pPr>
+            <a:r>
+              <a:rPr lang="en-US" sz="2400" b="1" dirty="0">
+                <a:solidFill>
+                  <a:srgbClr val="1B1F3B"/>
                 </a:solidFill>
                 <a:latin typeface="Georgia" pitchFamily="34" charset="0"/>
                 <a:ea typeface="Georgia" pitchFamily="34" charset="-122"/>
                 <a:cs typeface="Georgia" pitchFamily="34" charset="-120"/>
               </a:rPr>
-              <a:t>Base de données</a:t>
-            </a:r>
-            <a:endParaRPr lang="en-US" sz="3800" dirty="0"/>
-          </a:p>
-        </p:txBody>
-      </p:sp>
-      <p:sp>
-        <p:nvSpPr>
-          <p:cNvPr id="4" name="Text 2"/>
-          <p:cNvSpPr/>
-          <p:nvPr/>
-        </p:nvSpPr>
-        <p:spPr>
-          <a:xfrm>
-            <a:off x="640080" y="3429000"/>
-            <a:ext cx="10058400" cy="457200"/>
-          </a:xfrm>
-          <a:prstGeom prst="rect">
-            <a:avLst/>
-          </a:prstGeom>
-          <a:noFill/>
-          <a:ln/>
-        </p:spPr>
-        <p:txBody>
-          <a:bodyPr wrap="square" rtlCol="0" anchor="ctr"/>
-          <a:lstStyle/>
-          <a:p>
-            <a:pPr indent="0" marL="0">
-              <a:buNone/>
-            </a:pPr>
-            <a:r>
-              <a:rPr lang="en-US" sz="1500" dirty="0">
-                <a:solidFill>
-                  <a:srgbClr val="C7C9E0"/>
-                </a:solidFill>
-                <a:latin typeface="Segoe UI" pitchFamily="34" charset="0"/>
-                <a:ea typeface="Segoe UI" pitchFamily="34" charset="-122"/>
-                <a:cs typeface="Segoe UI" pitchFamily="34" charset="-120"/>
-              </a:rPr>
-              <a:t>Modèle de données et infrastructure</a:t>
-            </a:r>
-            <a:endParaRPr lang="en-US" sz="1500" dirty="0"/>
-          </a:p>
-        </p:txBody>
-      </p:sp>
-      <p:sp>
-        <p:nvSpPr>
-          <p:cNvPr id="5" name="Text 3"/>
-          <p:cNvSpPr/>
-          <p:nvPr/>
-        </p:nvSpPr>
-        <p:spPr>
-          <a:xfrm>
-            <a:off x="640080" y="3931920"/>
-            <a:ext cx="5486400" cy="365760"/>
-          </a:xfrm>
-          <a:prstGeom prst="rect">
-            <a:avLst/>
-          </a:prstGeom>
-          <a:noFill/>
-          <a:ln/>
-        </p:spPr>
-        <p:txBody>
-          <a:bodyPr wrap="square" rtlCol="0" anchor="ctr"/>
-          <a:lstStyle/>
-          <a:p>
-            <a:pPr indent="0" marL="0">
-              <a:buNone/>
-            </a:pPr>
-            <a:r>
-              <a:rPr lang="en-US" sz="1200" b="1" dirty="0">
-                <a:solidFill>
-                  <a:srgbClr val="C9A96A"/>
-                </a:solidFill>
-                <a:latin typeface="Segoe UI" pitchFamily="34" charset="0"/>
-                <a:ea typeface="Segoe UI" pitchFamily="34" charset="-122"/>
-                <a:cs typeface="Segoe UI" pitchFamily="34" charset="-120"/>
-              </a:rPr>
-              <a:t>11 mise(s) à jour</a:t>
-            </a:r>
-            <a:endParaRPr lang="en-US" sz="1200" dirty="0"/>
-          </a:p>
-        </p:txBody>
-      </p:sp>
-      <p:sp>
-        <p:nvSpPr>
-          <p:cNvPr id="6" name="Text 4"/>
+              <a:t>Radar des Chantiers</a:t>
+            </a:r>
+            <a:endParaRPr lang="en-US" sz="2400" dirty="0"/>
+          </a:p>
+        </p:txBody>
+      </p:sp>
+      <p:sp>
+        <p:nvSpPr>
+          <p:cNvPr id="5" name="Shape 3"/>
+          <p:cNvSpPr/>
+          <p:nvPr/>
+        </p:nvSpPr>
+        <p:spPr>
+          <a:xfrm>
+            <a:off x="640080" y="1691640"/>
+            <a:ext cx="10881360" cy="1097280"/>
+          </a:xfrm>
+          <a:prstGeom prst="roundRect">
+            <a:avLst>
+              <a:gd name="adj" fmla="val 5000"/>
+            </a:avLst>
+          </a:prstGeom>
+          <a:solidFill>
+            <a:srgbClr val="FFFFFF"/>
+          </a:solidFill>
+          <a:ln w="12700">
+            <a:solidFill>
+              <a:srgbClr val="E4DCCB"/>
+            </a:solidFill>
+            <a:prstDash val="solid"/>
+          </a:ln>
+        </p:spPr>
+      </p:sp>
+      <p:sp>
+        <p:nvSpPr>
+          <p:cNvPr id="6" name="Shape 4"/>
+          <p:cNvSpPr/>
+          <p:nvPr/>
+        </p:nvSpPr>
+        <p:spPr>
+          <a:xfrm>
+            <a:off x="640080" y="1691640"/>
+            <a:ext cx="54864" cy="1097280"/>
+          </a:xfrm>
+          <a:prstGeom prst="rect">
+            <a:avLst/>
+          </a:prstGeom>
+          <a:solidFill>
+            <a:srgbClr val="9A4C1F"/>
+          </a:solidFill>
+          <a:ln/>
+        </p:spPr>
+      </p:sp>
+      <p:sp>
+        <p:nvSpPr>
+          <p:cNvPr id="7" name="Text 5"/>
+          <p:cNvSpPr/>
+          <p:nvPr/>
+        </p:nvSpPr>
+        <p:spPr>
+          <a:xfrm>
+            <a:off x="914400" y="1801368"/>
+            <a:ext cx="10332720" cy="365760"/>
+          </a:xfrm>
+          <a:prstGeom prst="rect">
+            <a:avLst/>
+          </a:prstGeom>
+          <a:noFill/>
+          <a:ln/>
+        </p:spPr>
+        <p:txBody>
+          <a:bodyPr wrap="square" rtlCol="0" anchor="ctr"/>
+          <a:lstStyle/>
+          <a:p>
+            <a:pPr indent="0" marL="0">
+              <a:buNone/>
+            </a:pPr>
+            <a:r>
+              <a:rPr lang="en-US" sz="1400" b="1" dirty="0">
+                <a:solidFill>
+                  <a:srgbClr val="1B1F3B"/>
+                </a:solidFill>
+                <a:latin typeface="Segoe UI" pitchFamily="34" charset="0"/>
+                <a:ea typeface="Segoe UI" pitchFamily="34" charset="-122"/>
+                <a:cs typeface="Segoe UI" pitchFamily="34" charset="-120"/>
+              </a:rPr>
+              <a:t>Dictionnaire de vocabulaire metier pour l'assistant de creation d'offre</a:t>
+            </a:r>
+            <a:endParaRPr lang="en-US" sz="1400" dirty="0"/>
+          </a:p>
+        </p:txBody>
+      </p:sp>
+      <p:sp>
+        <p:nvSpPr>
+          <p:cNvPr id="8" name="Text 6"/>
+          <p:cNvSpPr/>
+          <p:nvPr/>
+        </p:nvSpPr>
+        <p:spPr>
+          <a:xfrm>
+            <a:off x="914400" y="2148840"/>
+            <a:ext cx="10332720" cy="594360"/>
+          </a:xfrm>
+          <a:prstGeom prst="rect">
+            <a:avLst/>
+          </a:prstGeom>
+          <a:noFill/>
+          <a:ln/>
+        </p:spPr>
+        <p:txBody>
+          <a:bodyPr wrap="square" rtlCol="0" anchor="ctr"/>
+          <a:lstStyle/>
+          <a:p>
+            <a:pPr indent="0" marL="0">
+              <a:lnSpc>
+                <a:spcPts val="1400"/>
+              </a:lnSpc>
+              <a:buNone/>
+            </a:pPr>
+            <a:r>
+              <a:rPr lang="en-US" sz="1100" dirty="0">
+                <a:solidFill>
+                  <a:srgbClr val="8A7C68"/>
+                </a:solidFill>
+                <a:latin typeface="Segoe UI" pitchFamily="34" charset="0"/>
+                <a:ea typeface="Segoe UI" pitchFamily="34" charset="-122"/>
+                <a:cs typeface="Segoe UI" pitchFamily="34" charset="-120"/>
+              </a:rPr>
+              <a:t>Dans le parcours 'Creer une offre' (assistant conversationnel), taper un seul mot de metier ('electricite', 'plomberie', 'climatisation'...) n'etait pas reconnu : l'assistant le jugeait trop vague et redemandait de preciser en boucle. Il reconnait desormais ces mots instantanement et adapte la suite des questions au metier concerne. Trois metiers ajoutes au passage (Macon, Chauffagiste, Climaticien), qui n'existaient pas encore dans l'application.</a:t>
+            </a:r>
+            <a:endParaRPr lang="en-US" sz="1100" dirty="0"/>
+          </a:p>
+        </p:txBody>
+      </p:sp>
+      <p:sp>
+        <p:nvSpPr>
+          <p:cNvPr id="9" name="Shape 7"/>
+          <p:cNvSpPr/>
+          <p:nvPr/>
+        </p:nvSpPr>
+        <p:spPr>
+          <a:xfrm>
+            <a:off x="640080" y="2926080"/>
+            <a:ext cx="10881360" cy="1097280"/>
+          </a:xfrm>
+          <a:prstGeom prst="roundRect">
+            <a:avLst>
+              <a:gd name="adj" fmla="val 5000"/>
+            </a:avLst>
+          </a:prstGeom>
+          <a:solidFill>
+            <a:srgbClr val="FFFFFF"/>
+          </a:solidFill>
+          <a:ln w="12700">
+            <a:solidFill>
+              <a:srgbClr val="E4DCCB"/>
+            </a:solidFill>
+            <a:prstDash val="solid"/>
+          </a:ln>
+        </p:spPr>
+      </p:sp>
+      <p:sp>
+        <p:nvSpPr>
+          <p:cNvPr id="10" name="Shape 8"/>
+          <p:cNvSpPr/>
+          <p:nvPr/>
+        </p:nvSpPr>
+        <p:spPr>
+          <a:xfrm>
+            <a:off x="640080" y="2926080"/>
+            <a:ext cx="54864" cy="1097280"/>
+          </a:xfrm>
+          <a:prstGeom prst="rect">
+            <a:avLst/>
+          </a:prstGeom>
+          <a:solidFill>
+            <a:srgbClr val="9A4C1F"/>
+          </a:solidFill>
+          <a:ln/>
+        </p:spPr>
+      </p:sp>
+      <p:sp>
+        <p:nvSpPr>
+          <p:cNvPr id="11" name="Text 9"/>
+          <p:cNvSpPr/>
+          <p:nvPr/>
+        </p:nvSpPr>
+        <p:spPr>
+          <a:xfrm>
+            <a:off x="914400" y="3035808"/>
+            <a:ext cx="10332720" cy="365760"/>
+          </a:xfrm>
+          <a:prstGeom prst="rect">
+            <a:avLst/>
+          </a:prstGeom>
+          <a:noFill/>
+          <a:ln/>
+        </p:spPr>
+        <p:txBody>
+          <a:bodyPr wrap="square" rtlCol="0" anchor="ctr"/>
+          <a:lstStyle/>
+          <a:p>
+            <a:pPr indent="0" marL="0">
+              <a:buNone/>
+            </a:pPr>
+            <a:r>
+              <a:rPr lang="en-US" sz="1400" b="1" dirty="0">
+                <a:solidFill>
+                  <a:srgbClr val="1B1F3B"/>
+                </a:solidFill>
+                <a:latin typeface="Segoe UI" pitchFamily="34" charset="0"/>
+                <a:ea typeface="Segoe UI" pitchFamily="34" charset="-122"/>
+                <a:cs typeface="Segoe UI" pitchFamily="34" charset="-120"/>
+              </a:rPr>
+              <a:t>L'assistant demande desormais quel metier est concerne si plusieurs sont evoques</a:t>
+            </a:r>
+            <a:endParaRPr lang="en-US" sz="1400" dirty="0"/>
+          </a:p>
+        </p:txBody>
+      </p:sp>
+      <p:sp>
+        <p:nvSpPr>
+          <p:cNvPr id="12" name="Text 10"/>
+          <p:cNvSpPr/>
+          <p:nvPr/>
+        </p:nvSpPr>
+        <p:spPr>
+          <a:xfrm>
+            <a:off x="914400" y="3383280"/>
+            <a:ext cx="10332720" cy="594360"/>
+          </a:xfrm>
+          <a:prstGeom prst="rect">
+            <a:avLst/>
+          </a:prstGeom>
+          <a:noFill/>
+          <a:ln/>
+        </p:spPr>
+        <p:txBody>
+          <a:bodyPr wrap="square" rtlCol="0" anchor="ctr"/>
+          <a:lstStyle/>
+          <a:p>
+            <a:pPr indent="0" marL="0">
+              <a:lnSpc>
+                <a:spcPts val="1400"/>
+              </a:lnSpc>
+              <a:buNone/>
+            </a:pPr>
+            <a:r>
+              <a:rPr lang="en-US" sz="1100" dirty="0">
+                <a:solidFill>
+                  <a:srgbClr val="8A7C68"/>
+                </a:solidFill>
+                <a:latin typeface="Segoe UI" pitchFamily="34" charset="0"/>
+                <a:ea typeface="Segoe UI" pitchFamily="34" charset="-122"/>
+                <a:cs typeface="Segoe UI" pitchFamily="34" charset="-120"/>
+              </a:rPr>
+              <a:t>Quand un client decrit un projet touchant plusieurs corps de metier a la fois (ex: 'carrelage et plomberie'), l'assistant proposait auparavant de deviner via l'IA sans jamais demander confirmation. Il propose maintenant les metiers reconnus en boutons a choisir, avec une option 'Autre, precisez' si aucun ne correspond.</a:t>
+            </a:r>
+            <a:endParaRPr lang="en-US" sz="1100" dirty="0"/>
+          </a:p>
+        </p:txBody>
+      </p:sp>
+      <p:sp>
+        <p:nvSpPr>
+          <p:cNvPr id="13" name="Shape 11"/>
+          <p:cNvSpPr/>
+          <p:nvPr/>
+        </p:nvSpPr>
+        <p:spPr>
+          <a:xfrm>
+            <a:off x="640080" y="4160520"/>
+            <a:ext cx="10881360" cy="1097280"/>
+          </a:xfrm>
+          <a:prstGeom prst="roundRect">
+            <a:avLst>
+              <a:gd name="adj" fmla="val 5000"/>
+            </a:avLst>
+          </a:prstGeom>
+          <a:solidFill>
+            <a:srgbClr val="FFFFFF"/>
+          </a:solidFill>
+          <a:ln w="12700">
+            <a:solidFill>
+              <a:srgbClr val="E4DCCB"/>
+            </a:solidFill>
+            <a:prstDash val="solid"/>
+          </a:ln>
+        </p:spPr>
+      </p:sp>
+      <p:sp>
+        <p:nvSpPr>
+          <p:cNvPr id="14" name="Shape 12"/>
+          <p:cNvSpPr/>
+          <p:nvPr/>
+        </p:nvSpPr>
+        <p:spPr>
+          <a:xfrm>
+            <a:off x="640080" y="4160520"/>
+            <a:ext cx="54864" cy="1097280"/>
+          </a:xfrm>
+          <a:prstGeom prst="rect">
+            <a:avLst/>
+          </a:prstGeom>
+          <a:solidFill>
+            <a:srgbClr val="9A4C1F"/>
+          </a:solidFill>
+          <a:ln/>
+        </p:spPr>
+      </p:sp>
+      <p:sp>
+        <p:nvSpPr>
+          <p:cNvPr id="15" name="Text 13"/>
+          <p:cNvSpPr/>
+          <p:nvPr/>
+        </p:nvSpPr>
+        <p:spPr>
+          <a:xfrm>
+            <a:off x="914400" y="4270248"/>
+            <a:ext cx="10332720" cy="365760"/>
+          </a:xfrm>
+          <a:prstGeom prst="rect">
+            <a:avLst/>
+          </a:prstGeom>
+          <a:noFill/>
+          <a:ln/>
+        </p:spPr>
+        <p:txBody>
+          <a:bodyPr wrap="square" rtlCol="0" anchor="ctr"/>
+          <a:lstStyle/>
+          <a:p>
+            <a:pPr indent="0" marL="0">
+              <a:buNone/>
+            </a:pPr>
+            <a:r>
+              <a:rPr lang="en-US" sz="1400" b="1" dirty="0">
+                <a:solidFill>
+                  <a:srgbClr val="1B1F3B"/>
+                </a:solidFill>
+                <a:latin typeface="Segoe UI" pitchFamily="34" charset="0"/>
+                <a:ea typeface="Segoe UI" pitchFamily="34" charset="-122"/>
+                <a:cs typeface="Segoe UI" pitchFamily="34" charset="-120"/>
+              </a:rPr>
+              <a:t>Confirmation demandee si l'adresse tapee ne precise pas la ville</a:t>
+            </a:r>
+            <a:endParaRPr lang="en-US" sz="1400" dirty="0"/>
+          </a:p>
+        </p:txBody>
+      </p:sp>
+      <p:sp>
+        <p:nvSpPr>
+          <p:cNvPr id="16" name="Text 14"/>
+          <p:cNvSpPr/>
+          <p:nvPr/>
+        </p:nvSpPr>
+        <p:spPr>
+          <a:xfrm>
+            <a:off x="914400" y="4617720"/>
+            <a:ext cx="10332720" cy="594360"/>
+          </a:xfrm>
+          <a:prstGeom prst="rect">
+            <a:avLst/>
+          </a:prstGeom>
+          <a:noFill/>
+          <a:ln/>
+        </p:spPr>
+        <p:txBody>
+          <a:bodyPr wrap="square" rtlCol="0" anchor="ctr"/>
+          <a:lstStyle/>
+          <a:p>
+            <a:pPr indent="0" marL="0">
+              <a:lnSpc>
+                <a:spcPts val="1400"/>
+              </a:lnSpc>
+              <a:buNone/>
+            </a:pPr>
+            <a:r>
+              <a:rPr lang="en-US" sz="1100" dirty="0">
+                <a:solidFill>
+                  <a:srgbClr val="8A7C68"/>
+                </a:solidFill>
+                <a:latin typeface="Segoe UI" pitchFamily="34" charset="0"/>
+                <a:ea typeface="Segoe UI" pitchFamily="34" charset="-122"/>
+                <a:cs typeface="Segoe UI" pitchFamily="34" charset="-120"/>
+              </a:rPr>
+              <a:t>Un numero et une rue reconnus par le service d'adresses peuvent correspondre a une ville que le client n'a jamais tapee (ex: '98 quai de la loire' se resout a Paris sans que 'Paris' soit ecrit). Avant, cette ville devinee etait validee silencieusement. L'assistant demande desormais confirmation avant de continuer.</a:t>
+            </a:r>
+            <a:endParaRPr lang="en-US" sz="1100" dirty="0"/>
+          </a:p>
+        </p:txBody>
+      </p:sp>
+      <p:sp>
+        <p:nvSpPr>
+          <p:cNvPr id="17" name="Shape 15"/>
+          <p:cNvSpPr/>
+          <p:nvPr/>
+        </p:nvSpPr>
+        <p:spPr>
+          <a:xfrm>
+            <a:off x="640080" y="5394960"/>
+            <a:ext cx="10881360" cy="1097280"/>
+          </a:xfrm>
+          <a:prstGeom prst="roundRect">
+            <a:avLst>
+              <a:gd name="adj" fmla="val 5000"/>
+            </a:avLst>
+          </a:prstGeom>
+          <a:solidFill>
+            <a:srgbClr val="FFFFFF"/>
+          </a:solidFill>
+          <a:ln w="12700">
+            <a:solidFill>
+              <a:srgbClr val="E4DCCB"/>
+            </a:solidFill>
+            <a:prstDash val="solid"/>
+          </a:ln>
+        </p:spPr>
+      </p:sp>
+      <p:sp>
+        <p:nvSpPr>
+          <p:cNvPr id="18" name="Shape 16"/>
+          <p:cNvSpPr/>
+          <p:nvPr/>
+        </p:nvSpPr>
+        <p:spPr>
+          <a:xfrm>
+            <a:off x="640080" y="5394960"/>
+            <a:ext cx="54864" cy="1097280"/>
+          </a:xfrm>
+          <a:prstGeom prst="rect">
+            <a:avLst/>
+          </a:prstGeom>
+          <a:solidFill>
+            <a:srgbClr val="9A4C1F"/>
+          </a:solidFill>
+          <a:ln/>
+        </p:spPr>
+      </p:sp>
+      <p:sp>
+        <p:nvSpPr>
+          <p:cNvPr id="19" name="Text 17"/>
+          <p:cNvSpPr/>
+          <p:nvPr/>
+        </p:nvSpPr>
+        <p:spPr>
+          <a:xfrm>
+            <a:off x="914400" y="5504688"/>
+            <a:ext cx="10332720" cy="365760"/>
+          </a:xfrm>
+          <a:prstGeom prst="rect">
+            <a:avLst/>
+          </a:prstGeom>
+          <a:noFill/>
+          <a:ln/>
+        </p:spPr>
+        <p:txBody>
+          <a:bodyPr wrap="square" rtlCol="0" anchor="ctr"/>
+          <a:lstStyle/>
+          <a:p>
+            <a:pPr indent="0" marL="0">
+              <a:buNone/>
+            </a:pPr>
+            <a:r>
+              <a:rPr lang="en-US" sz="1400" b="1" dirty="0">
+                <a:solidFill>
+                  <a:srgbClr val="1B1F3B"/>
+                </a:solidFill>
+                <a:latin typeface="Segoe UI" pitchFamily="34" charset="0"/>
+                <a:ea typeface="Segoe UI" pitchFamily="34" charset="-122"/>
+                <a:cs typeface="Segoe UI" pitchFamily="34" charset="-120"/>
+              </a:rPr>
+              <a:t>Le tout premier message du client est mieux compris</a:t>
+            </a:r>
+            <a:endParaRPr lang="en-US" sz="1400" dirty="0"/>
+          </a:p>
+        </p:txBody>
+      </p:sp>
+      <p:sp>
+        <p:nvSpPr>
+          <p:cNvPr id="20" name="Text 18"/>
+          <p:cNvSpPr/>
+          <p:nvPr/>
+        </p:nvSpPr>
+        <p:spPr>
+          <a:xfrm>
+            <a:off x="914400" y="5852160"/>
+            <a:ext cx="10332720" cy="594360"/>
+          </a:xfrm>
+          <a:prstGeom prst="rect">
+            <a:avLst/>
+          </a:prstGeom>
+          <a:noFill/>
+          <a:ln/>
+        </p:spPr>
+        <p:txBody>
+          <a:bodyPr wrap="square" rtlCol="0" anchor="ctr"/>
+          <a:lstStyle/>
+          <a:p>
+            <a:pPr indent="0" marL="0">
+              <a:lnSpc>
+                <a:spcPts val="1400"/>
+              </a:lnSpc>
+              <a:buNone/>
+            </a:pPr>
+            <a:r>
+              <a:rPr lang="en-US" sz="1100" dirty="0">
+                <a:solidFill>
+                  <a:srgbClr val="8A7C68"/>
+                </a:solidFill>
+                <a:latin typeface="Segoe UI" pitchFamily="34" charset="0"/>
+                <a:ea typeface="Segoe UI" pitchFamily="34" charset="-122"/>
+                <a:cs typeface="Segoe UI" pitchFamily="34" charset="-120"/>
+              </a:rPr>
+              <a:t>Un message trop vague pour decrire un projet ('offre', 'bonjour', 'test'...) relance desormais une demande de precision au lieu d'etre accepte tel quel comme description du projet. A l'inverse, les questions de logistique qui n'ont pas de sens pour le projet decrit (l'ascenseur pour un rez-de-chaussee, les dimensions pour une simple reparation) sont sautees automatiquement.</a:t>
+            </a:r>
+            <a:endParaRPr lang="en-US" sz="1100" dirty="0"/>
+          </a:p>
+        </p:txBody>
+      </p:sp>
+      <p:sp>
+        <p:nvSpPr>
+          <p:cNvPr id="21" name="Text 19"/>
           <p:cNvSpPr/>
           <p:nvPr/>
         </p:nvSpPr>
@@ -28828,7 +29481,7 @@
       </p:sp>
       <p:sp>
         <p:nvSpPr>
-          <p:cNvPr id="7" name="Text 5"/>
+          <p:cNvPr id="22" name="Text 20"/>
           <p:cNvSpPr/>
           <p:nvPr/>
         </p:nvSpPr>
@@ -29636,7 +30289,7 @@
             </a:avLst>
           </a:prstGeom>
           <a:solidFill>
-            <a:srgbClr val="E6EFE4"/>
+            <a:srgbClr val="F5E6DA"/>
           </a:solidFill>
           <a:ln/>
         </p:spPr>
@@ -29668,13 +30321,13 @@
             <a:r>
               <a:rPr lang="en-US" sz="1000" b="1" spc="100" kern="0" dirty="0">
                 <a:solidFill>
-                  <a:srgbClr val="386641"/>
-                </a:solidFill>
-                <a:latin typeface="Segoe UI" pitchFamily="34" charset="0"/>
-                <a:ea typeface="Segoe UI" pitchFamily="34" charset="-122"/>
-                <a:cs typeface="Segoe UI" pitchFamily="34" charset="-120"/>
-              </a:rPr>
-              <a:t>BASE DE DONNÉES</a:t>
+                  <a:srgbClr val="9A4C1F"/>
+                </a:solidFill>
+                <a:latin typeface="Segoe UI" pitchFamily="34" charset="0"/>
+                <a:ea typeface="Segoe UI" pitchFamily="34" charset="-122"/>
+                <a:cs typeface="Segoe UI" pitchFamily="34" charset="-120"/>
+              </a:rPr>
+              <a:t>BACKEND</a:t>
             </a:r>
             <a:endParaRPr lang="en-US" sz="1000" dirty="0"/>
           </a:p>
@@ -29713,7 +30366,7 @@
                 <a:ea typeface="Georgia" pitchFamily="34" charset="-122"/>
                 <a:cs typeface="Georgia" pitchFamily="34" charset="-120"/>
               </a:rPr>
-              <a:t>Fondations</a:t>
+              <a:t>Radar des Chantiers (suite)</a:t>
             </a:r>
             <a:endParaRPr lang="en-US" sz="2400" dirty="0"/>
           </a:p>
@@ -29761,7 +30414,7 @@
             <a:avLst/>
           </a:prstGeom>
           <a:solidFill>
-            <a:srgbClr val="386641"/>
+            <a:srgbClr val="9A4C1F"/>
           </a:solidFill>
           <a:ln/>
         </p:spPr>
@@ -29799,7 +30452,7 @@
                 <a:ea typeface="Segoe UI" pitchFamily="34" charset="-122"/>
                 <a:cs typeface="Segoe UI" pitchFamily="34" charset="-120"/>
               </a:rPr>
-              <a:t>Connexion Vercel / configuration environnement</a:t>
+              <a:t>Questions ciblees sur la nature des travaux avant les questions de logistique</a:t>
             </a:r>
             <a:endParaRPr lang="en-US" sz="1400" dirty="0"/>
           </a:p>
@@ -29841,7 +30494,7 @@
                 <a:ea typeface="Segoe UI" pitchFamily="34" charset="-122"/>
                 <a:cs typeface="Segoe UI" pitchFamily="34" charset="-120"/>
               </a:rPr>
-              <a:t>Correction de la configuration d'authentification et du SMTP sur l'environnement de production Vercel.</a:t>
+              <a:t>Des que le metier est identifie, l'assistant pose jusqu'a 3 questions specifiques a ce metier (ex: pour de la climatisation, quel type d'installation) avant d'enchainer sur les questions habituelles (adresse, etage, dimensions...). Les reponses possibles sont proposees en boutons quand c'est pertinent, avec toujours une option pour preciser librement.</a:t>
             </a:r>
             <a:endParaRPr lang="en-US" sz="1100" dirty="0"/>
           </a:p>
@@ -29849,7 +30502,135 @@
       </p:sp>
       <p:sp>
         <p:nvSpPr>
-          <p:cNvPr id="9" name="Text 7"/>
+          <p:cNvPr id="9" name="Shape 7"/>
+          <p:cNvSpPr/>
+          <p:nvPr/>
+        </p:nvSpPr>
+        <p:spPr>
+          <a:xfrm>
+            <a:off x="640080" y="2926080"/>
+            <a:ext cx="10881360" cy="1097280"/>
+          </a:xfrm>
+          <a:prstGeom prst="roundRect">
+            <a:avLst>
+              <a:gd name="adj" fmla="val 5000"/>
+            </a:avLst>
+          </a:prstGeom>
+          <a:solidFill>
+            <a:srgbClr val="FFFFFF"/>
+          </a:solidFill>
+          <a:ln w="12700">
+            <a:solidFill>
+              <a:srgbClr val="E4DCCB"/>
+            </a:solidFill>
+            <a:prstDash val="solid"/>
+          </a:ln>
+        </p:spPr>
+      </p:sp>
+      <p:sp>
+        <p:nvSpPr>
+          <p:cNvPr id="10" name="Shape 8"/>
+          <p:cNvSpPr/>
+          <p:nvPr/>
+        </p:nvSpPr>
+        <p:spPr>
+          <a:xfrm>
+            <a:off x="640080" y="2926080"/>
+            <a:ext cx="54864" cy="1097280"/>
+          </a:xfrm>
+          <a:prstGeom prst="rect">
+            <a:avLst/>
+          </a:prstGeom>
+          <a:solidFill>
+            <a:srgbClr val="9A4C1F"/>
+          </a:solidFill>
+          <a:ln/>
+        </p:spPr>
+      </p:sp>
+      <p:sp>
+        <p:nvSpPr>
+          <p:cNvPr id="11" name="Text 9"/>
+          <p:cNvSpPr/>
+          <p:nvPr/>
+        </p:nvSpPr>
+        <p:spPr>
+          <a:xfrm>
+            <a:off x="914400" y="3035808"/>
+            <a:ext cx="10332720" cy="365760"/>
+          </a:xfrm>
+          <a:prstGeom prst="rect">
+            <a:avLst/>
+          </a:prstGeom>
+          <a:noFill/>
+          <a:ln/>
+        </p:spPr>
+        <p:txBody>
+          <a:bodyPr wrap="square" rtlCol="0" anchor="ctr"/>
+          <a:lstStyle/>
+          <a:p>
+            <a:pPr indent="0" marL="0">
+              <a:buNone/>
+            </a:pPr>
+            <a:r>
+              <a:rPr lang="en-US" sz="1400" b="1" dirty="0">
+                <a:solidFill>
+                  <a:srgbClr val="1B1F3B"/>
+                </a:solidFill>
+                <a:latin typeface="Segoe UI" pitchFamily="34" charset="0"/>
+                <a:ea typeface="Segoe UI" pitchFamily="34" charset="-122"/>
+                <a:cs typeface="Segoe UI" pitchFamily="34" charset="-120"/>
+              </a:rPr>
+              <a:t>Une reponse trop vague a une question relance desormais une precision</a:t>
+            </a:r>
+            <a:endParaRPr lang="en-US" sz="1400" dirty="0"/>
+          </a:p>
+        </p:txBody>
+      </p:sp>
+      <p:sp>
+        <p:nvSpPr>
+          <p:cNvPr id="12" name="Text 10"/>
+          <p:cNvSpPr/>
+          <p:nvPr/>
+        </p:nvSpPr>
+        <p:spPr>
+          <a:xfrm>
+            <a:off x="914400" y="3383280"/>
+            <a:ext cx="10332720" cy="594360"/>
+          </a:xfrm>
+          <a:prstGeom prst="rect">
+            <a:avLst/>
+          </a:prstGeom>
+          <a:noFill/>
+          <a:ln/>
+        </p:spPr>
+        <p:txBody>
+          <a:bodyPr wrap="square" rtlCol="0" anchor="ctr"/>
+          <a:lstStyle/>
+          <a:p>
+            <a:pPr indent="0" marL="0">
+              <a:lnSpc>
+                <a:spcPts val="1400"/>
+              </a:lnSpc>
+              <a:buNone/>
+            </a:pPr>
+            <a:r>
+              <a:rPr lang="en-US" sz="1100" dirty="0">
+                <a:solidFill>
+                  <a:srgbClr val="8A7C68"/>
+                </a:solidFill>
+                <a:latin typeface="Segoe UI" pitchFamily="34" charset="0"/>
+                <a:ea typeface="Segoe UI" pitchFamily="34" charset="-122"/>
+                <a:cs typeface="Segoe UI" pitchFamily="34" charset="-120"/>
+              </a:rPr>
+              <a:t>Sur les questions a choix (etage, acces, stationnement, etat de la piece...), une reponse tapee a la main mais trop approximative ('assez facile je pense') etait acceptee telle quelle. L'assistant redemande maintenant une precision, en reproposant les memes choix, plutot que d'avancer avec une information peu fiable.</a:t>
+            </a:r>
+            <a:endParaRPr lang="en-US" sz="1100" dirty="0"/>
+          </a:p>
+        </p:txBody>
+      </p:sp>
+      <p:sp>
+        <p:nvSpPr>
+          <p:cNvPr id="13" name="Text 11"/>
           <p:cNvSpPr/>
           <p:nvPr/>
         </p:nvSpPr>
@@ -29888,7 +30669,7 @@
       </p:sp>
       <p:sp>
         <p:nvSpPr>
-          <p:cNvPr id="10" name="Text 8"/>
+          <p:cNvPr id="14" name="Text 12"/>
           <p:cNvSpPr/>
           <p:nvPr/>
         </p:nvSpPr>
@@ -29939,7 +30720,7 @@
     <p:bg>
       <p:bgPr>
         <a:solidFill>
-          <a:srgbClr val="F3EEE3"/>
+          <a:srgbClr val="0B1030"/>
         </a:solidFill>
       </p:bgPr>
     </p:bg>
@@ -29965,16 +30746,14 @@
         </p:nvSpPr>
         <p:spPr>
           <a:xfrm>
-            <a:off x="640080" y="411480"/>
-            <a:ext cx="2377440" cy="365760"/>
-          </a:xfrm>
-          <a:prstGeom prst="roundRect">
-            <a:avLst>
-              <a:gd name="adj" fmla="val 50000"/>
-            </a:avLst>
+            <a:off x="0" y="3246120"/>
+            <a:ext cx="12191695" cy="54864"/>
+          </a:xfrm>
+          <a:prstGeom prst="rect">
+            <a:avLst/>
           </a:prstGeom>
           <a:solidFill>
-            <a:srgbClr val="E6EFE4"/>
+            <a:srgbClr val="386641"/>
           </a:solidFill>
           <a:ln/>
         </p:spPr>
@@ -29987,207 +30766,118 @@
         </p:nvSpPr>
         <p:spPr>
           <a:xfrm>
-            <a:off x="640080" y="411480"/>
-            <a:ext cx="2377440" cy="365760"/>
-          </a:xfrm>
-          <a:prstGeom prst="rect">
-            <a:avLst/>
-          </a:prstGeom>
-          <a:noFill/>
-          <a:ln/>
-        </p:spPr>
-        <p:txBody>
-          <a:bodyPr wrap="square" rtlCol="0" anchor="ctr"/>
-          <a:lstStyle/>
-          <a:p>
-            <a:pPr algn="ctr" indent="0" marL="0">
-              <a:buNone/>
-            </a:pPr>
-            <a:r>
-              <a:rPr lang="en-US" sz="1000" b="1" spc="100" kern="0" dirty="0">
-                <a:solidFill>
-                  <a:srgbClr val="386641"/>
-                </a:solidFill>
-                <a:latin typeface="Segoe UI" pitchFamily="34" charset="0"/>
-                <a:ea typeface="Segoe UI" pitchFamily="34" charset="-122"/>
-                <a:cs typeface="Segoe UI" pitchFamily="34" charset="-120"/>
-              </a:rPr>
-              <a:t>BASE DE DONNÉES</a:t>
-            </a:r>
-            <a:endParaRPr lang="en-US" sz="1000" dirty="0"/>
-          </a:p>
-        </p:txBody>
-      </p:sp>
-      <p:sp>
-        <p:nvSpPr>
-          <p:cNvPr id="4" name="Text 2"/>
-          <p:cNvSpPr/>
-          <p:nvPr/>
-        </p:nvSpPr>
-        <p:spPr>
-          <a:xfrm>
-            <a:off x="640080" y="868680"/>
-            <a:ext cx="10515600" cy="548640"/>
-          </a:xfrm>
-          <a:prstGeom prst="rect">
-            <a:avLst/>
-          </a:prstGeom>
-          <a:noFill/>
-          <a:ln/>
-        </p:spPr>
-        <p:txBody>
-          <a:bodyPr wrap="square" rtlCol="0" anchor="ctr"/>
-          <a:lstStyle/>
-          <a:p>
-            <a:pPr indent="0" marL="0">
-              <a:buNone/>
-            </a:pPr>
-            <a:r>
-              <a:rPr lang="en-US" sz="2400" b="1" dirty="0">
-                <a:solidFill>
-                  <a:srgbClr val="1B1F3B"/>
+            <a:off x="640080" y="2468880"/>
+            <a:ext cx="10058400" cy="914400"/>
+          </a:xfrm>
+          <a:prstGeom prst="rect">
+            <a:avLst/>
+          </a:prstGeom>
+          <a:noFill/>
+          <a:ln/>
+        </p:spPr>
+        <p:txBody>
+          <a:bodyPr wrap="square" rtlCol="0" anchor="ctr"/>
+          <a:lstStyle/>
+          <a:p>
+            <a:pPr indent="0" marL="0">
+              <a:buNone/>
+            </a:pPr>
+            <a:r>
+              <a:rPr lang="en-US" sz="3800" b="1" dirty="0">
+                <a:solidFill>
+                  <a:srgbClr val="FFFFFF"/>
                 </a:solidFill>
                 <a:latin typeface="Georgia" pitchFamily="34" charset="0"/>
                 <a:ea typeface="Georgia" pitchFamily="34" charset="-122"/>
                 <a:cs typeface="Georgia" pitchFamily="34" charset="-120"/>
               </a:rPr>
-              <a:t>Devis</a:t>
-            </a:r>
-            <a:endParaRPr lang="en-US" sz="2400" dirty="0"/>
-          </a:p>
-        </p:txBody>
-      </p:sp>
-      <p:sp>
-        <p:nvSpPr>
-          <p:cNvPr id="5" name="Shape 3"/>
-          <p:cNvSpPr/>
-          <p:nvPr/>
-        </p:nvSpPr>
-        <p:spPr>
-          <a:xfrm>
-            <a:off x="640080" y="1691640"/>
-            <a:ext cx="10881360" cy="1097280"/>
-          </a:xfrm>
-          <a:prstGeom prst="roundRect">
-            <a:avLst>
-              <a:gd name="adj" fmla="val 5000"/>
-            </a:avLst>
-          </a:prstGeom>
-          <a:solidFill>
-            <a:srgbClr val="FFFFFF"/>
-          </a:solidFill>
-          <a:ln w="12700">
-            <a:solidFill>
-              <a:srgbClr val="E4DCCB"/>
-            </a:solidFill>
-            <a:prstDash val="solid"/>
-          </a:ln>
-        </p:spPr>
-      </p:sp>
-      <p:sp>
-        <p:nvSpPr>
-          <p:cNvPr id="6" name="Shape 4"/>
-          <p:cNvSpPr/>
-          <p:nvPr/>
-        </p:nvSpPr>
-        <p:spPr>
-          <a:xfrm>
-            <a:off x="640080" y="1691640"/>
-            <a:ext cx="54864" cy="1097280"/>
-          </a:xfrm>
-          <a:prstGeom prst="rect">
-            <a:avLst/>
-          </a:prstGeom>
-          <a:solidFill>
-            <a:srgbClr val="386641"/>
-          </a:solidFill>
-          <a:ln/>
-        </p:spPr>
-      </p:sp>
-      <p:sp>
-        <p:nvSpPr>
-          <p:cNvPr id="7" name="Text 5"/>
-          <p:cNvSpPr/>
-          <p:nvPr/>
-        </p:nvSpPr>
-        <p:spPr>
-          <a:xfrm>
-            <a:off x="914400" y="1801368"/>
-            <a:ext cx="10332720" cy="365760"/>
-          </a:xfrm>
-          <a:prstGeom prst="rect">
-            <a:avLst/>
-          </a:prstGeom>
-          <a:noFill/>
-          <a:ln/>
-        </p:spPr>
-        <p:txBody>
-          <a:bodyPr wrap="square" rtlCol="0" anchor="ctr"/>
-          <a:lstStyle/>
-          <a:p>
-            <a:pPr indent="0" marL="0">
-              <a:buNone/>
-            </a:pPr>
-            <a:r>
-              <a:rPr lang="en-US" sz="1400" b="1" dirty="0">
-                <a:solidFill>
-                  <a:srgbClr val="1B1F3B"/>
-                </a:solidFill>
-                <a:latin typeface="Segoe UI" pitchFamily="34" charset="0"/>
-                <a:ea typeface="Segoe UI" pitchFamily="34" charset="-122"/>
-                <a:cs typeface="Segoe UI" pitchFamily="34" charset="-120"/>
-              </a:rPr>
-              <a:t>Migration des devis vers Supabase (table partagée)</a:t>
-            </a:r>
-            <a:endParaRPr lang="en-US" sz="1400" dirty="0"/>
-          </a:p>
-        </p:txBody>
-      </p:sp>
-      <p:sp>
-        <p:nvSpPr>
-          <p:cNvPr id="8" name="Text 6"/>
-          <p:cNvSpPr/>
-          <p:nvPr/>
-        </p:nvSpPr>
-        <p:spPr>
-          <a:xfrm>
-            <a:off x="914400" y="2148840"/>
-            <a:ext cx="10332720" cy="594360"/>
-          </a:xfrm>
-          <a:prstGeom prst="rect">
-            <a:avLst/>
-          </a:prstGeom>
-          <a:noFill/>
-          <a:ln/>
-        </p:spPr>
-        <p:txBody>
-          <a:bodyPr wrap="square" rtlCol="0" anchor="ctr"/>
-          <a:lstStyle/>
-          <a:p>
-            <a:pPr indent="0" marL="0">
-              <a:lnSpc>
-                <a:spcPts val="1400"/>
-              </a:lnSpc>
-              <a:buNone/>
-            </a:pPr>
-            <a:r>
-              <a:rPr lang="en-US" sz="1100" dirty="0">
-                <a:solidFill>
-                  <a:srgbClr val="8A7C68"/>
-                </a:solidFill>
-                <a:latin typeface="Segoe UI" pitchFamily="34" charset="0"/>
-                <a:ea typeface="Segoe UI" pitchFamily="34" charset="-122"/>
-                <a:cs typeface="Segoe UI" pitchFamily="34" charset="-120"/>
-              </a:rPr>
-              <a:t>Les devis créés sur le site web et sur l'application mobile (Firas) vivent désormais dans la même table Supabase 'quotes', avec un mapping bidirectionnel dédié (lib/quote-mapping.js).</a:t>
-            </a:r>
-            <a:endParaRPr lang="en-US" sz="1100" dirty="0"/>
-          </a:p>
-        </p:txBody>
-      </p:sp>
-      <p:sp>
-        <p:nvSpPr>
-          <p:cNvPr id="9" name="Text 7"/>
+              <a:t>Base de données</a:t>
+            </a:r>
+            <a:endParaRPr lang="en-US" sz="3800" dirty="0"/>
+          </a:p>
+        </p:txBody>
+      </p:sp>
+      <p:sp>
+        <p:nvSpPr>
+          <p:cNvPr id="4" name="Text 2"/>
+          <p:cNvSpPr/>
+          <p:nvPr/>
+        </p:nvSpPr>
+        <p:spPr>
+          <a:xfrm>
+            <a:off x="640080" y="3429000"/>
+            <a:ext cx="10058400" cy="457200"/>
+          </a:xfrm>
+          <a:prstGeom prst="rect">
+            <a:avLst/>
+          </a:prstGeom>
+          <a:noFill/>
+          <a:ln/>
+        </p:spPr>
+        <p:txBody>
+          <a:bodyPr wrap="square" rtlCol="0" anchor="ctr"/>
+          <a:lstStyle/>
+          <a:p>
+            <a:pPr indent="0" marL="0">
+              <a:buNone/>
+            </a:pPr>
+            <a:r>
+              <a:rPr lang="en-US" sz="1500" dirty="0">
+                <a:solidFill>
+                  <a:srgbClr val="C7C9E0"/>
+                </a:solidFill>
+                <a:latin typeface="Segoe UI" pitchFamily="34" charset="0"/>
+                <a:ea typeface="Segoe UI" pitchFamily="34" charset="-122"/>
+                <a:cs typeface="Segoe UI" pitchFamily="34" charset="-120"/>
+              </a:rPr>
+              <a:t>Modèle de données et infrastructure</a:t>
+            </a:r>
+            <a:endParaRPr lang="en-US" sz="1500" dirty="0"/>
+          </a:p>
+        </p:txBody>
+      </p:sp>
+      <p:sp>
+        <p:nvSpPr>
+          <p:cNvPr id="5" name="Text 3"/>
+          <p:cNvSpPr/>
+          <p:nvPr/>
+        </p:nvSpPr>
+        <p:spPr>
+          <a:xfrm>
+            <a:off x="640080" y="3931920"/>
+            <a:ext cx="5486400" cy="365760"/>
+          </a:xfrm>
+          <a:prstGeom prst="rect">
+            <a:avLst/>
+          </a:prstGeom>
+          <a:noFill/>
+          <a:ln/>
+        </p:spPr>
+        <p:txBody>
+          <a:bodyPr wrap="square" rtlCol="0" anchor="ctr"/>
+          <a:lstStyle/>
+          <a:p>
+            <a:pPr indent="0" marL="0">
+              <a:buNone/>
+            </a:pPr>
+            <a:r>
+              <a:rPr lang="en-US" sz="1200" b="1" dirty="0">
+                <a:solidFill>
+                  <a:srgbClr val="C9A96A"/>
+                </a:solidFill>
+                <a:latin typeface="Segoe UI" pitchFamily="34" charset="0"/>
+                <a:ea typeface="Segoe UI" pitchFamily="34" charset="-122"/>
+                <a:cs typeface="Segoe UI" pitchFamily="34" charset="-120"/>
+              </a:rPr>
+              <a:t>11 mise(s) à jour</a:t>
+            </a:r>
+            <a:endParaRPr lang="en-US" sz="1200" dirty="0"/>
+          </a:p>
+        </p:txBody>
+      </p:sp>
+      <p:sp>
+        <p:nvSpPr>
+          <p:cNvPr id="6" name="Text 4"/>
           <p:cNvSpPr/>
           <p:nvPr/>
         </p:nvSpPr>
@@ -30226,7 +30916,7 @@
       </p:sp>
       <p:sp>
         <p:nvSpPr>
-          <p:cNvPr id="10" name="Text 8"/>
+          <p:cNvPr id="7" name="Text 5"/>
           <p:cNvSpPr/>
           <p:nvPr/>
         </p:nvSpPr>
@@ -30389,7 +31079,7 @@
                 <a:ea typeface="Georgia" pitchFamily="34" charset="-122"/>
                 <a:cs typeface="Georgia" pitchFamily="34" charset="-120"/>
               </a:rPr>
-              <a:t>Chantiers</a:t>
+              <a:t>Fondations</a:t>
             </a:r>
             <a:endParaRPr lang="en-US" sz="2400" dirty="0"/>
           </a:p>
@@ -30475,7 +31165,7 @@
                 <a:ea typeface="Segoe UI" pitchFamily="34" charset="-122"/>
                 <a:cs typeface="Segoe UI" pitchFamily="34" charset="-120"/>
               </a:rPr>
-              <a:t>Connexion Supabase : chantiers, planning, fournitures</a:t>
+              <a:t>Connexion Vercel / configuration environnement</a:t>
             </a:r>
             <a:endParaRPr lang="en-US" sz="1400" dirty="0"/>
           </a:p>
@@ -30517,7 +31207,7 @@
                 <a:ea typeface="Segoe UI" pitchFamily="34" charset="-122"/>
                 <a:cs typeface="Segoe UI" pitchFamily="34" charset="-120"/>
               </a:rPr>
-              <a:t>Ces trois modules sont branchés sur la base partagée avec l'application mobile ; les comptes utilisateurs sont également partagés entre les deux plateformes.</a:t>
+              <a:t>Correction de la configuration d'authentification et du SMTP sur l'environnement de production Vercel.</a:t>
             </a:r>
             <a:endParaRPr lang="en-US" sz="1100" dirty="0"/>
           </a:p>
@@ -30727,7 +31417,7 @@
                 <a:ea typeface="Georgia" pitchFamily="34" charset="-122"/>
                 <a:cs typeface="Georgia" pitchFamily="34" charset="-120"/>
               </a:rPr>
-              <a:t>Équipe</a:t>
+              <a:t>Devis</a:t>
             </a:r>
             <a:endParaRPr lang="en-US" sz="2400" dirty="0"/>
           </a:p>
@@ -30813,7 +31503,7 @@
                 <a:ea typeface="Segoe UI" pitchFamily="34" charset="-122"/>
                 <a:cs typeface="Segoe UI" pitchFamily="34" charset="-120"/>
               </a:rPr>
-              <a:t>Nouvelle donnée : heures contractuelles par ouvrier</a:t>
+              <a:t>Migration des devis vers Supabase (table partagée)</a:t>
             </a:r>
             <a:endParaRPr lang="en-US" sz="1400" dirty="0"/>
           </a:p>
@@ -30855,7 +31545,7 @@
                 <a:ea typeface="Segoe UI" pitchFamily="34" charset="-122"/>
                 <a:cs typeface="Segoe UI" pitchFamily="34" charset="-120"/>
               </a:rPr>
-              <a:t>Ajout d'un paramètre 'heures contractuelles / semaine' (35h par défaut) sur chaque fiche ouvrier, utilisé pour le calcul des écarts.</a:t>
+              <a:t>Les devis créés sur le site web et sur l'application mobile (Firas) vivent désormais dans la même table Supabase 'quotes', avec un mapping bidirectionnel dédié (lib/quote-mapping.js).</a:t>
             </a:r>
             <a:endParaRPr lang="en-US" sz="1100" dirty="0"/>
           </a:p>
@@ -31065,7 +31755,7 @@
                 <a:ea typeface="Georgia" pitchFamily="34" charset="-122"/>
                 <a:cs typeface="Georgia" pitchFamily="34" charset="-120"/>
               </a:rPr>
-              <a:t>Accueil &amp; stabilité</a:t>
+              <a:t>Chantiers</a:t>
             </a:r>
             <a:endParaRPr lang="en-US" sz="2400" dirty="0"/>
           </a:p>
@@ -31151,7 +31841,7 @@
                 <a:ea typeface="Segoe UI" pitchFamily="34" charset="-122"/>
                 <a:cs typeface="Segoe UI" pitchFamily="34" charset="-120"/>
               </a:rPr>
-              <a:t>Nettoyage du backend</a:t>
+              <a:t>Connexion Supabase : chantiers, planning, fournitures</a:t>
             </a:r>
             <a:endParaRPr lang="en-US" sz="1400" dirty="0"/>
           </a:p>
@@ -31193,7 +31883,7 @@
                 <a:ea typeface="Segoe UI" pitchFamily="34" charset="-122"/>
                 <a:cs typeface="Segoe UI" pitchFamily="34" charset="-120"/>
               </a:rPr>
-              <a:t>Audit complet des routes serveur : suppression du code mort (module Marketplace), vérification de la cohérence entre données locales et données Supabase sur l'ensemble de l'application.</a:t>
+              <a:t>Ces trois modules sont branchés sur la base partagée avec l'application mobile ; les comptes utilisateurs sont également partagés entre les deux plateformes.</a:t>
             </a:r>
             <a:endParaRPr lang="en-US" sz="1100" dirty="0"/>
           </a:p>
@@ -31403,7 +32093,7 @@
                 <a:ea typeface="Georgia" pitchFamily="34" charset="-122"/>
                 <a:cs typeface="Georgia" pitchFamily="34" charset="-120"/>
               </a:rPr>
-              <a:t>Maintenance technique</a:t>
+              <a:t>Équipe</a:t>
             </a:r>
             <a:endParaRPr lang="en-US" sz="2400" dirty="0"/>
           </a:p>
@@ -31489,7 +32179,7 @@
                 <a:ea typeface="Segoe UI" pitchFamily="34" charset="-122"/>
                 <a:cs typeface="Segoe UI" pitchFamily="34" charset="-120"/>
               </a:rPr>
-              <a:t>Nettoyage approfondi du code</a:t>
+              <a:t>Nouvelle donnée : heures contractuelles par ouvrier</a:t>
             </a:r>
             <a:endParaRPr lang="en-US" sz="1400" dirty="0"/>
           </a:p>
@@ -31531,7 +32221,7 @@
                 <a:ea typeface="Segoe UI" pitchFamily="34" charset="-122"/>
                 <a:cs typeface="Segoe UI" pitchFamily="34" charset="-120"/>
               </a:rPr>
-              <a:t>Audit complet du projet (pages, routes, fonctions, dépendances) pour repérer tout ce qui n'était plus utilisé ; suppression de 6 pages orphelines (onboarding, welcome, compte, anciennes pages devis en 3 étapes), d'une route de connexion de démonstration, d'un dossier de composants dupliqué obsolète, de plusieurs fonctions inutilisées et d'une dépendance logicielle non utilisée — sans toucher aux fonctionnalités actives.</a:t>
+              <a:t>Ajout d'un paramètre 'heures contractuelles / semaine' (35h par défaut) sur chaque fiche ouvrier, utilisé pour le calcul des écarts.</a:t>
             </a:r>
             <a:endParaRPr lang="en-US" sz="1100" dirty="0"/>
           </a:p>
@@ -31539,263 +32229,7 @@
       </p:sp>
       <p:sp>
         <p:nvSpPr>
-          <p:cNvPr id="9" name="Shape 7"/>
-          <p:cNvSpPr/>
-          <p:nvPr/>
-        </p:nvSpPr>
-        <p:spPr>
-          <a:xfrm>
-            <a:off x="640080" y="2926080"/>
-            <a:ext cx="10881360" cy="1097280"/>
-          </a:xfrm>
-          <a:prstGeom prst="roundRect">
-            <a:avLst>
-              <a:gd name="adj" fmla="val 5000"/>
-            </a:avLst>
-          </a:prstGeom>
-          <a:solidFill>
-            <a:srgbClr val="FFFFFF"/>
-          </a:solidFill>
-          <a:ln w="12700">
-            <a:solidFill>
-              <a:srgbClr val="E4DCCB"/>
-            </a:solidFill>
-            <a:prstDash val="solid"/>
-          </a:ln>
-        </p:spPr>
-      </p:sp>
-      <p:sp>
-        <p:nvSpPr>
-          <p:cNvPr id="10" name="Shape 8"/>
-          <p:cNvSpPr/>
-          <p:nvPr/>
-        </p:nvSpPr>
-        <p:spPr>
-          <a:xfrm>
-            <a:off x="640080" y="2926080"/>
-            <a:ext cx="54864" cy="1097280"/>
-          </a:xfrm>
-          <a:prstGeom prst="rect">
-            <a:avLst/>
-          </a:prstGeom>
-          <a:solidFill>
-            <a:srgbClr val="386641"/>
-          </a:solidFill>
-          <a:ln/>
-        </p:spPr>
-      </p:sp>
-      <p:sp>
-        <p:nvSpPr>
-          <p:cNvPr id="11" name="Text 9"/>
-          <p:cNvSpPr/>
-          <p:nvPr/>
-        </p:nvSpPr>
-        <p:spPr>
-          <a:xfrm>
-            <a:off x="914400" y="3035808"/>
-            <a:ext cx="10332720" cy="365760"/>
-          </a:xfrm>
-          <a:prstGeom prst="rect">
-            <a:avLst/>
-          </a:prstGeom>
-          <a:noFill/>
-          <a:ln/>
-        </p:spPr>
-        <p:txBody>
-          <a:bodyPr wrap="square" rtlCol="0" anchor="ctr"/>
-          <a:lstStyle/>
-          <a:p>
-            <a:pPr indent="0" marL="0">
-              <a:buNone/>
-            </a:pPr>
-            <a:r>
-              <a:rPr lang="en-US" sz="1400" b="1" dirty="0">
-                <a:solidFill>
-                  <a:srgbClr val="1B1F3B"/>
-                </a:solidFill>
-                <a:latin typeface="Segoe UI" pitchFamily="34" charset="0"/>
-                <a:ea typeface="Segoe UI" pitchFamily="34" charset="-122"/>
-                <a:cs typeface="Segoe UI" pitchFamily="34" charset="-120"/>
-              </a:rPr>
-              <a:t>Suppression de code mort dans la génération de devis</a:t>
-            </a:r>
-            <a:endParaRPr lang="en-US" sz="1400" dirty="0"/>
-          </a:p>
-        </p:txBody>
-      </p:sp>
-      <p:sp>
-        <p:nvSpPr>
-          <p:cNvPr id="12" name="Text 10"/>
-          <p:cNvSpPr/>
-          <p:nvPr/>
-        </p:nvSpPr>
-        <p:spPr>
-          <a:xfrm>
-            <a:off x="914400" y="3383280"/>
-            <a:ext cx="10332720" cy="594360"/>
-          </a:xfrm>
-          <a:prstGeom prst="rect">
-            <a:avLst/>
-          </a:prstGeom>
-          <a:noFill/>
-          <a:ln/>
-        </p:spPr>
-        <p:txBody>
-          <a:bodyPr wrap="square" rtlCol="0" anchor="ctr"/>
-          <a:lstStyle/>
-          <a:p>
-            <a:pPr indent="0" marL="0">
-              <a:lnSpc>
-                <a:spcPts val="1400"/>
-              </a:lnSpc>
-              <a:buNone/>
-            </a:pPr>
-            <a:r>
-              <a:rPr lang="en-US" sz="1100" dirty="0">
-                <a:solidFill>
-                  <a:srgbClr val="8A7C68"/>
-                </a:solidFill>
-                <a:latin typeface="Segoe UI" pitchFamily="34" charset="0"/>
-                <a:ea typeface="Segoe UI" pitchFamily="34" charset="-122"/>
-                <a:cs typeface="Segoe UI" pitchFamily="34" charset="-120"/>
-              </a:rPr>
-              <a:t>Un ancien générateur de devis PDF, devenu inaccessible après une précédente refonte (code jamais exécuté), a été retiré du fichier technique de génération de documents.</a:t>
-            </a:r>
-            <a:endParaRPr lang="en-US" sz="1100" dirty="0"/>
-          </a:p>
-        </p:txBody>
-      </p:sp>
-      <p:sp>
-        <p:nvSpPr>
-          <p:cNvPr id="13" name="Shape 11"/>
-          <p:cNvSpPr/>
-          <p:nvPr/>
-        </p:nvSpPr>
-        <p:spPr>
-          <a:xfrm>
-            <a:off x="640080" y="4160520"/>
-            <a:ext cx="10881360" cy="1097280"/>
-          </a:xfrm>
-          <a:prstGeom prst="roundRect">
-            <a:avLst>
-              <a:gd name="adj" fmla="val 5000"/>
-            </a:avLst>
-          </a:prstGeom>
-          <a:solidFill>
-            <a:srgbClr val="FFFFFF"/>
-          </a:solidFill>
-          <a:ln w="12700">
-            <a:solidFill>
-              <a:srgbClr val="E4DCCB"/>
-            </a:solidFill>
-            <a:prstDash val="solid"/>
-          </a:ln>
-        </p:spPr>
-      </p:sp>
-      <p:sp>
-        <p:nvSpPr>
-          <p:cNvPr id="14" name="Shape 12"/>
-          <p:cNvSpPr/>
-          <p:nvPr/>
-        </p:nvSpPr>
-        <p:spPr>
-          <a:xfrm>
-            <a:off x="640080" y="4160520"/>
-            <a:ext cx="54864" cy="1097280"/>
-          </a:xfrm>
-          <a:prstGeom prst="rect">
-            <a:avLst/>
-          </a:prstGeom>
-          <a:solidFill>
-            <a:srgbClr val="386641"/>
-          </a:solidFill>
-          <a:ln/>
-        </p:spPr>
-      </p:sp>
-      <p:sp>
-        <p:nvSpPr>
-          <p:cNvPr id="15" name="Text 13"/>
-          <p:cNvSpPr/>
-          <p:nvPr/>
-        </p:nvSpPr>
-        <p:spPr>
-          <a:xfrm>
-            <a:off x="914400" y="4270248"/>
-            <a:ext cx="10332720" cy="365760"/>
-          </a:xfrm>
-          <a:prstGeom prst="rect">
-            <a:avLst/>
-          </a:prstGeom>
-          <a:noFill/>
-          <a:ln/>
-        </p:spPr>
-        <p:txBody>
-          <a:bodyPr wrap="square" rtlCol="0" anchor="ctr"/>
-          <a:lstStyle/>
-          <a:p>
-            <a:pPr indent="0" marL="0">
-              <a:buNone/>
-            </a:pPr>
-            <a:r>
-              <a:rPr lang="en-US" sz="1400" b="1" dirty="0">
-                <a:solidFill>
-                  <a:srgbClr val="1B1F3B"/>
-                </a:solidFill>
-                <a:latin typeface="Segoe UI" pitchFamily="34" charset="0"/>
-                <a:ea typeface="Segoe UI" pitchFamily="34" charset="-122"/>
-                <a:cs typeface="Segoe UI" pitchFamily="34" charset="-120"/>
-              </a:rPr>
-              <a:t>Suppression de code mort dans l'export Word des devis</a:t>
-            </a:r>
-            <a:endParaRPr lang="en-US" sz="1400" dirty="0"/>
-          </a:p>
-        </p:txBody>
-      </p:sp>
-      <p:sp>
-        <p:nvSpPr>
-          <p:cNvPr id="16" name="Text 14"/>
-          <p:cNvSpPr/>
-          <p:nvPr/>
-        </p:nvSpPr>
-        <p:spPr>
-          <a:xfrm>
-            <a:off x="914400" y="4617720"/>
-            <a:ext cx="10332720" cy="594360"/>
-          </a:xfrm>
-          <a:prstGeom prst="rect">
-            <a:avLst/>
-          </a:prstGeom>
-          <a:noFill/>
-          <a:ln/>
-        </p:spPr>
-        <p:txBody>
-          <a:bodyPr wrap="square" rtlCol="0" anchor="ctr"/>
-          <a:lstStyle/>
-          <a:p>
-            <a:pPr indent="0" marL="0">
-              <a:lnSpc>
-                <a:spcPts val="1400"/>
-              </a:lnSpc>
-              <a:buNone/>
-            </a:pPr>
-            <a:r>
-              <a:rPr lang="en-US" sz="1100" dirty="0">
-                <a:solidFill>
-                  <a:srgbClr val="8A7C68"/>
-                </a:solidFill>
-                <a:latin typeface="Segoe UI" pitchFamily="34" charset="0"/>
-                <a:ea typeface="Segoe UI" pitchFamily="34" charset="-122"/>
-                <a:cs typeface="Segoe UI" pitchFamily="34" charset="-120"/>
-              </a:rPr>
-              <a:t>Un second bloc de génération de document, devenu inaccessible après une précédente refonte (jamais exécuté), a été retiré du fichier technique de génération de documents.</a:t>
-            </a:r>
-            <a:endParaRPr lang="en-US" sz="1100" dirty="0"/>
-          </a:p>
-        </p:txBody>
-      </p:sp>
-      <p:sp>
-        <p:nvSpPr>
-          <p:cNvPr id="17" name="Text 15"/>
+          <p:cNvPr id="9" name="Text 7"/>
           <p:cNvSpPr/>
           <p:nvPr/>
         </p:nvSpPr>
@@ -31834,7 +32268,7 @@
       </p:sp>
       <p:sp>
         <p:nvSpPr>
-          <p:cNvPr id="18" name="Text 16"/>
+          <p:cNvPr id="10" name="Text 8"/>
           <p:cNvSpPr/>
           <p:nvPr/>
         </p:nvSpPr>
@@ -31997,7 +32431,7 @@
                 <a:ea typeface="Georgia" pitchFamily="34" charset="-122"/>
                 <a:cs typeface="Georgia" pitchFamily="34" charset="-120"/>
               </a:rPr>
-              <a:t>Sécurité</a:t>
+              <a:t>Accueil &amp; stabilité</a:t>
             </a:r>
             <a:endParaRPr lang="en-US" sz="2400" dirty="0"/>
           </a:p>
@@ -32083,7 +32517,7 @@
                 <a:ea typeface="Segoe UI" pitchFamily="34" charset="-122"/>
                 <a:cs typeface="Segoe UI" pitchFamily="34" charset="-120"/>
               </a:rPr>
-              <a:t>Base de données partagée verrouillée</a:t>
+              <a:t>Nettoyage du backend</a:t>
             </a:r>
             <a:endParaRPr lang="en-US" sz="1400" dirty="0"/>
           </a:p>
@@ -32125,7 +32559,7 @@
                 <a:ea typeface="Segoe UI" pitchFamily="34" charset="-122"/>
                 <a:cs typeface="Segoe UI" pitchFamily="34" charset="-120"/>
               </a:rPr>
-              <a:t>La table contenant l'essentiel des données de l'application était lisible par n'importe qui sur internet avec la simple clé publique du site, sans connexion. L'application y accède désormais avec une clé privée réservée au serveur, ce qui permet de fermer complètement l'accès public sans rien casser.</a:t>
+              <a:t>Audit complet des routes serveur : suppression du code mort (module Marketplace), vérification de la cohérence entre données locales et données Supabase sur l'ensemble de l'application.</a:t>
             </a:r>
             <a:endParaRPr lang="en-US" sz="1100" dirty="0"/>
           </a:p>
@@ -32133,263 +32567,7 @@
       </p:sp>
       <p:sp>
         <p:nvSpPr>
-          <p:cNvPr id="9" name="Shape 7"/>
-          <p:cNvSpPr/>
-          <p:nvPr/>
-        </p:nvSpPr>
-        <p:spPr>
-          <a:xfrm>
-            <a:off x="640080" y="2926080"/>
-            <a:ext cx="10881360" cy="1097280"/>
-          </a:xfrm>
-          <a:prstGeom prst="roundRect">
-            <a:avLst>
-              <a:gd name="adj" fmla="val 5000"/>
-            </a:avLst>
-          </a:prstGeom>
-          <a:solidFill>
-            <a:srgbClr val="FFFFFF"/>
-          </a:solidFill>
-          <a:ln w="12700">
-            <a:solidFill>
-              <a:srgbClr val="E4DCCB"/>
-            </a:solidFill>
-            <a:prstDash val="solid"/>
-          </a:ln>
-        </p:spPr>
-      </p:sp>
-      <p:sp>
-        <p:nvSpPr>
-          <p:cNvPr id="10" name="Shape 8"/>
-          <p:cNvSpPr/>
-          <p:nvPr/>
-        </p:nvSpPr>
-        <p:spPr>
-          <a:xfrm>
-            <a:off x="640080" y="2926080"/>
-            <a:ext cx="54864" cy="1097280"/>
-          </a:xfrm>
-          <a:prstGeom prst="rect">
-            <a:avLst/>
-          </a:prstGeom>
-          <a:solidFill>
-            <a:srgbClr val="386641"/>
-          </a:solidFill>
-          <a:ln/>
-        </p:spPr>
-      </p:sp>
-      <p:sp>
-        <p:nvSpPr>
-          <p:cNvPr id="11" name="Text 9"/>
-          <p:cNvSpPr/>
-          <p:nvPr/>
-        </p:nvSpPr>
-        <p:spPr>
-          <a:xfrm>
-            <a:off x="914400" y="3035808"/>
-            <a:ext cx="10332720" cy="365760"/>
-          </a:xfrm>
-          <a:prstGeom prst="rect">
-            <a:avLst/>
-          </a:prstGeom>
-          <a:noFill/>
-          <a:ln/>
-        </p:spPr>
-        <p:txBody>
-          <a:bodyPr wrap="square" rtlCol="0" anchor="ctr"/>
-          <a:lstStyle/>
-          <a:p>
-            <a:pPr indent="0" marL="0">
-              <a:buNone/>
-            </a:pPr>
-            <a:r>
-              <a:rPr lang="en-US" sz="1400" b="1" dirty="0">
-                <a:solidFill>
-                  <a:srgbClr val="1B1F3B"/>
-                </a:solidFill>
-                <a:latin typeface="Segoe UI" pitchFamily="34" charset="0"/>
-                <a:ea typeface="Segoe UI" pitchFamily="34" charset="-122"/>
-                <a:cs typeface="Segoe UI" pitchFamily="34" charset="-120"/>
-              </a:rPr>
-              <a:t>Fichier de base de données retiré du dépôt Git</a:t>
-            </a:r>
-            <a:endParaRPr lang="en-US" sz="1400" dirty="0"/>
-          </a:p>
-        </p:txBody>
-      </p:sp>
-      <p:sp>
-        <p:nvSpPr>
-          <p:cNvPr id="12" name="Text 10"/>
-          <p:cNvSpPr/>
-          <p:nvPr/>
-        </p:nvSpPr>
-        <p:spPr>
-          <a:xfrm>
-            <a:off x="914400" y="3383280"/>
-            <a:ext cx="10332720" cy="594360"/>
-          </a:xfrm>
-          <a:prstGeom prst="rect">
-            <a:avLst/>
-          </a:prstGeom>
-          <a:noFill/>
-          <a:ln/>
-        </p:spPr>
-        <p:txBody>
-          <a:bodyPr wrap="square" rtlCol="0" anchor="ctr"/>
-          <a:lstStyle/>
-          <a:p>
-            <a:pPr indent="0" marL="0">
-              <a:lnSpc>
-                <a:spcPts val="1400"/>
-              </a:lnSpc>
-              <a:buNone/>
-            </a:pPr>
-            <a:r>
-              <a:rPr lang="en-US" sz="1100" dirty="0">
-                <a:solidFill>
-                  <a:srgbClr val="8A7C68"/>
-                </a:solidFill>
-                <a:latin typeface="Segoe UI" pitchFamily="34" charset="0"/>
-                <a:ea typeface="Segoe UI" pitchFamily="34" charset="-122"/>
-                <a:cs typeface="Segoe UI" pitchFamily="34" charset="-120"/>
-              </a:rPr>
-              <a:t>Un fichier contenant une copie complète de la base de données de développement, avec des mots de passe réels en clair, était suivi par Git depuis plusieurs mois. Retiré du suivi et exclu définitivement.</a:t>
-            </a:r>
-            <a:endParaRPr lang="en-US" sz="1100" dirty="0"/>
-          </a:p>
-        </p:txBody>
-      </p:sp>
-      <p:sp>
-        <p:nvSpPr>
-          <p:cNvPr id="13" name="Shape 11"/>
-          <p:cNvSpPr/>
-          <p:nvPr/>
-        </p:nvSpPr>
-        <p:spPr>
-          <a:xfrm>
-            <a:off x="640080" y="4160520"/>
-            <a:ext cx="10881360" cy="1097280"/>
-          </a:xfrm>
-          <a:prstGeom prst="roundRect">
-            <a:avLst>
-              <a:gd name="adj" fmla="val 5000"/>
-            </a:avLst>
-          </a:prstGeom>
-          <a:solidFill>
-            <a:srgbClr val="FFFFFF"/>
-          </a:solidFill>
-          <a:ln w="12700">
-            <a:solidFill>
-              <a:srgbClr val="E4DCCB"/>
-            </a:solidFill>
-            <a:prstDash val="solid"/>
-          </a:ln>
-        </p:spPr>
-      </p:sp>
-      <p:sp>
-        <p:nvSpPr>
-          <p:cNvPr id="14" name="Shape 12"/>
-          <p:cNvSpPr/>
-          <p:nvPr/>
-        </p:nvSpPr>
-        <p:spPr>
-          <a:xfrm>
-            <a:off x="640080" y="4160520"/>
-            <a:ext cx="54864" cy="1097280"/>
-          </a:xfrm>
-          <a:prstGeom prst="rect">
-            <a:avLst/>
-          </a:prstGeom>
-          <a:solidFill>
-            <a:srgbClr val="386641"/>
-          </a:solidFill>
-          <a:ln/>
-        </p:spPr>
-      </p:sp>
-      <p:sp>
-        <p:nvSpPr>
-          <p:cNvPr id="15" name="Text 13"/>
-          <p:cNvSpPr/>
-          <p:nvPr/>
-        </p:nvSpPr>
-        <p:spPr>
-          <a:xfrm>
-            <a:off x="914400" y="4270248"/>
-            <a:ext cx="10332720" cy="365760"/>
-          </a:xfrm>
-          <a:prstGeom prst="rect">
-            <a:avLst/>
-          </a:prstGeom>
-          <a:noFill/>
-          <a:ln/>
-        </p:spPr>
-        <p:txBody>
-          <a:bodyPr wrap="square" rtlCol="0" anchor="ctr"/>
-          <a:lstStyle/>
-          <a:p>
-            <a:pPr indent="0" marL="0">
-              <a:buNone/>
-            </a:pPr>
-            <a:r>
-              <a:rPr lang="en-US" sz="1400" b="1" dirty="0">
-                <a:solidFill>
-                  <a:srgbClr val="1B1F3B"/>
-                </a:solidFill>
-                <a:latin typeface="Segoe UI" pitchFamily="34" charset="0"/>
-                <a:ea typeface="Segoe UI" pitchFamily="34" charset="-122"/>
-                <a:cs typeface="Segoe UI" pitchFamily="34" charset="-120"/>
-              </a:rPr>
-              <a:t>Verrouillage de la base partagée écrit dans le script d'installation</a:t>
-            </a:r>
-            <a:endParaRPr lang="en-US" sz="1400" dirty="0"/>
-          </a:p>
-        </p:txBody>
-      </p:sp>
-      <p:sp>
-        <p:nvSpPr>
-          <p:cNvPr id="16" name="Text 14"/>
-          <p:cNvSpPr/>
-          <p:nvPr/>
-        </p:nvSpPr>
-        <p:spPr>
-          <a:xfrm>
-            <a:off x="914400" y="4617720"/>
-            <a:ext cx="10332720" cy="594360"/>
-          </a:xfrm>
-          <a:prstGeom prst="rect">
-            <a:avLst/>
-          </a:prstGeom>
-          <a:noFill/>
-          <a:ln/>
-        </p:spPr>
-        <p:txBody>
-          <a:bodyPr wrap="square" rtlCol="0" anchor="ctr"/>
-          <a:lstStyle/>
-          <a:p>
-            <a:pPr indent="0" marL="0">
-              <a:lnSpc>
-                <a:spcPts val="1400"/>
-              </a:lnSpc>
-              <a:buNone/>
-            </a:pPr>
-            <a:r>
-              <a:rPr lang="en-US" sz="1100" dirty="0">
-                <a:solidFill>
-                  <a:srgbClr val="8A7C68"/>
-                </a:solidFill>
-                <a:latin typeface="Segoe UI" pitchFamily="34" charset="0"/>
-                <a:ea typeface="Segoe UI" pitchFamily="34" charset="-122"/>
-                <a:cs typeface="Segoe UI" pitchFamily="34" charset="-120"/>
-              </a:rPr>
-              <a:t>La commande qui ferme complètement l'accès public à la table de données partagée a été ajoutée au script SQL du projet, prête à être exécutée dans le tableau de bord Supabase.</a:t>
-            </a:r>
-            <a:endParaRPr lang="en-US" sz="1100" dirty="0"/>
-          </a:p>
-        </p:txBody>
-      </p:sp>
-      <p:sp>
-        <p:nvSpPr>
-          <p:cNvPr id="17" name="Text 15"/>
+          <p:cNvPr id="9" name="Text 7"/>
           <p:cNvSpPr/>
           <p:nvPr/>
         </p:nvSpPr>
@@ -32428,7 +32606,7 @@
       </p:sp>
       <p:sp>
         <p:nvSpPr>
-          <p:cNvPr id="18" name="Text 16"/>
+          <p:cNvPr id="10" name="Text 8"/>
           <p:cNvSpPr/>
           <p:nvPr/>
         </p:nvSpPr>
@@ -32476,6 +32654,1194 @@
 <file path=ppt/slides/slide57.xml><?xml version="1.0" encoding="utf-8"?>
 <p:sld xmlns:a="http://schemas.openxmlformats.org/drawingml/2006/main" xmlns:r="http://schemas.openxmlformats.org/officeDocument/2006/relationships" xmlns:p="http://schemas.openxmlformats.org/presentationml/2006/main">
   <p:cSld name="Slide 57">
+    <p:bg>
+      <p:bgPr>
+        <a:solidFill>
+          <a:srgbClr val="F3EEE3"/>
+        </a:solidFill>
+      </p:bgPr>
+    </p:bg>
+    <p:spTree>
+      <p:nvGrpSpPr>
+        <p:cNvPr id="1" name=""/>
+        <p:cNvGrpSpPr/>
+        <p:nvPr/>
+      </p:nvGrpSpPr>
+      <p:grpSpPr>
+        <a:xfrm>
+          <a:off x="0" y="0"/>
+          <a:ext cx="0" cy="0"/>
+          <a:chOff x="0" y="0"/>
+          <a:chExt cx="0" cy="0"/>
+        </a:xfrm>
+      </p:grpSpPr>
+      <p:sp>
+        <p:nvSpPr>
+          <p:cNvPr id="2" name="Shape 0"/>
+          <p:cNvSpPr/>
+          <p:nvPr/>
+        </p:nvSpPr>
+        <p:spPr>
+          <a:xfrm>
+            <a:off x="640080" y="411480"/>
+            <a:ext cx="2377440" cy="365760"/>
+          </a:xfrm>
+          <a:prstGeom prst="roundRect">
+            <a:avLst>
+              <a:gd name="adj" fmla="val 50000"/>
+            </a:avLst>
+          </a:prstGeom>
+          <a:solidFill>
+            <a:srgbClr val="E6EFE4"/>
+          </a:solidFill>
+          <a:ln/>
+        </p:spPr>
+      </p:sp>
+      <p:sp>
+        <p:nvSpPr>
+          <p:cNvPr id="3" name="Text 1"/>
+          <p:cNvSpPr/>
+          <p:nvPr/>
+        </p:nvSpPr>
+        <p:spPr>
+          <a:xfrm>
+            <a:off x="640080" y="411480"/>
+            <a:ext cx="2377440" cy="365760"/>
+          </a:xfrm>
+          <a:prstGeom prst="rect">
+            <a:avLst/>
+          </a:prstGeom>
+          <a:noFill/>
+          <a:ln/>
+        </p:spPr>
+        <p:txBody>
+          <a:bodyPr wrap="square" rtlCol="0" anchor="ctr"/>
+          <a:lstStyle/>
+          <a:p>
+            <a:pPr algn="ctr" indent="0" marL="0">
+              <a:buNone/>
+            </a:pPr>
+            <a:r>
+              <a:rPr lang="en-US" sz="1000" b="1" spc="100" kern="0" dirty="0">
+                <a:solidFill>
+                  <a:srgbClr val="386641"/>
+                </a:solidFill>
+                <a:latin typeface="Segoe UI" pitchFamily="34" charset="0"/>
+                <a:ea typeface="Segoe UI" pitchFamily="34" charset="-122"/>
+                <a:cs typeface="Segoe UI" pitchFamily="34" charset="-120"/>
+              </a:rPr>
+              <a:t>BASE DE DONNÉES</a:t>
+            </a:r>
+            <a:endParaRPr lang="en-US" sz="1000" dirty="0"/>
+          </a:p>
+        </p:txBody>
+      </p:sp>
+      <p:sp>
+        <p:nvSpPr>
+          <p:cNvPr id="4" name="Text 2"/>
+          <p:cNvSpPr/>
+          <p:nvPr/>
+        </p:nvSpPr>
+        <p:spPr>
+          <a:xfrm>
+            <a:off x="640080" y="868680"/>
+            <a:ext cx="10515600" cy="548640"/>
+          </a:xfrm>
+          <a:prstGeom prst="rect">
+            <a:avLst/>
+          </a:prstGeom>
+          <a:noFill/>
+          <a:ln/>
+        </p:spPr>
+        <p:txBody>
+          <a:bodyPr wrap="square" rtlCol="0" anchor="ctr"/>
+          <a:lstStyle/>
+          <a:p>
+            <a:pPr indent="0" marL="0">
+              <a:buNone/>
+            </a:pPr>
+            <a:r>
+              <a:rPr lang="en-US" sz="2400" b="1" dirty="0">
+                <a:solidFill>
+                  <a:srgbClr val="1B1F3B"/>
+                </a:solidFill>
+                <a:latin typeface="Georgia" pitchFamily="34" charset="0"/>
+                <a:ea typeface="Georgia" pitchFamily="34" charset="-122"/>
+                <a:cs typeface="Georgia" pitchFamily="34" charset="-120"/>
+              </a:rPr>
+              <a:t>Maintenance technique</a:t>
+            </a:r>
+            <a:endParaRPr lang="en-US" sz="2400" dirty="0"/>
+          </a:p>
+        </p:txBody>
+      </p:sp>
+      <p:sp>
+        <p:nvSpPr>
+          <p:cNvPr id="5" name="Shape 3"/>
+          <p:cNvSpPr/>
+          <p:nvPr/>
+        </p:nvSpPr>
+        <p:spPr>
+          <a:xfrm>
+            <a:off x="640080" y="1691640"/>
+            <a:ext cx="10881360" cy="1097280"/>
+          </a:xfrm>
+          <a:prstGeom prst="roundRect">
+            <a:avLst>
+              <a:gd name="adj" fmla="val 5000"/>
+            </a:avLst>
+          </a:prstGeom>
+          <a:solidFill>
+            <a:srgbClr val="FFFFFF"/>
+          </a:solidFill>
+          <a:ln w="12700">
+            <a:solidFill>
+              <a:srgbClr val="E4DCCB"/>
+            </a:solidFill>
+            <a:prstDash val="solid"/>
+          </a:ln>
+        </p:spPr>
+      </p:sp>
+      <p:sp>
+        <p:nvSpPr>
+          <p:cNvPr id="6" name="Shape 4"/>
+          <p:cNvSpPr/>
+          <p:nvPr/>
+        </p:nvSpPr>
+        <p:spPr>
+          <a:xfrm>
+            <a:off x="640080" y="1691640"/>
+            <a:ext cx="54864" cy="1097280"/>
+          </a:xfrm>
+          <a:prstGeom prst="rect">
+            <a:avLst/>
+          </a:prstGeom>
+          <a:solidFill>
+            <a:srgbClr val="386641"/>
+          </a:solidFill>
+          <a:ln/>
+        </p:spPr>
+      </p:sp>
+      <p:sp>
+        <p:nvSpPr>
+          <p:cNvPr id="7" name="Text 5"/>
+          <p:cNvSpPr/>
+          <p:nvPr/>
+        </p:nvSpPr>
+        <p:spPr>
+          <a:xfrm>
+            <a:off x="914400" y="1801368"/>
+            <a:ext cx="10332720" cy="365760"/>
+          </a:xfrm>
+          <a:prstGeom prst="rect">
+            <a:avLst/>
+          </a:prstGeom>
+          <a:noFill/>
+          <a:ln/>
+        </p:spPr>
+        <p:txBody>
+          <a:bodyPr wrap="square" rtlCol="0" anchor="ctr"/>
+          <a:lstStyle/>
+          <a:p>
+            <a:pPr indent="0" marL="0">
+              <a:buNone/>
+            </a:pPr>
+            <a:r>
+              <a:rPr lang="en-US" sz="1400" b="1" dirty="0">
+                <a:solidFill>
+                  <a:srgbClr val="1B1F3B"/>
+                </a:solidFill>
+                <a:latin typeface="Segoe UI" pitchFamily="34" charset="0"/>
+                <a:ea typeface="Segoe UI" pitchFamily="34" charset="-122"/>
+                <a:cs typeface="Segoe UI" pitchFamily="34" charset="-120"/>
+              </a:rPr>
+              <a:t>Nettoyage approfondi du code</a:t>
+            </a:r>
+            <a:endParaRPr lang="en-US" sz="1400" dirty="0"/>
+          </a:p>
+        </p:txBody>
+      </p:sp>
+      <p:sp>
+        <p:nvSpPr>
+          <p:cNvPr id="8" name="Text 6"/>
+          <p:cNvSpPr/>
+          <p:nvPr/>
+        </p:nvSpPr>
+        <p:spPr>
+          <a:xfrm>
+            <a:off x="914400" y="2148840"/>
+            <a:ext cx="10332720" cy="594360"/>
+          </a:xfrm>
+          <a:prstGeom prst="rect">
+            <a:avLst/>
+          </a:prstGeom>
+          <a:noFill/>
+          <a:ln/>
+        </p:spPr>
+        <p:txBody>
+          <a:bodyPr wrap="square" rtlCol="0" anchor="ctr"/>
+          <a:lstStyle/>
+          <a:p>
+            <a:pPr indent="0" marL="0">
+              <a:lnSpc>
+                <a:spcPts val="1400"/>
+              </a:lnSpc>
+              <a:buNone/>
+            </a:pPr>
+            <a:r>
+              <a:rPr lang="en-US" sz="1100" dirty="0">
+                <a:solidFill>
+                  <a:srgbClr val="8A7C68"/>
+                </a:solidFill>
+                <a:latin typeface="Segoe UI" pitchFamily="34" charset="0"/>
+                <a:ea typeface="Segoe UI" pitchFamily="34" charset="-122"/>
+                <a:cs typeface="Segoe UI" pitchFamily="34" charset="-120"/>
+              </a:rPr>
+              <a:t>Audit complet du projet (pages, routes, fonctions, dépendances) pour repérer tout ce qui n'était plus utilisé ; suppression de 6 pages orphelines (onboarding, welcome, compte, anciennes pages devis en 3 étapes), d'une route de connexion de démonstration, d'un dossier de composants dupliqué obsolète, de plusieurs fonctions inutilisées et d'une dépendance logicielle non utilisée — sans toucher aux fonctionnalités actives.</a:t>
+            </a:r>
+            <a:endParaRPr lang="en-US" sz="1100" dirty="0"/>
+          </a:p>
+        </p:txBody>
+      </p:sp>
+      <p:sp>
+        <p:nvSpPr>
+          <p:cNvPr id="9" name="Shape 7"/>
+          <p:cNvSpPr/>
+          <p:nvPr/>
+        </p:nvSpPr>
+        <p:spPr>
+          <a:xfrm>
+            <a:off x="640080" y="2926080"/>
+            <a:ext cx="10881360" cy="1097280"/>
+          </a:xfrm>
+          <a:prstGeom prst="roundRect">
+            <a:avLst>
+              <a:gd name="adj" fmla="val 5000"/>
+            </a:avLst>
+          </a:prstGeom>
+          <a:solidFill>
+            <a:srgbClr val="FFFFFF"/>
+          </a:solidFill>
+          <a:ln w="12700">
+            <a:solidFill>
+              <a:srgbClr val="E4DCCB"/>
+            </a:solidFill>
+            <a:prstDash val="solid"/>
+          </a:ln>
+        </p:spPr>
+      </p:sp>
+      <p:sp>
+        <p:nvSpPr>
+          <p:cNvPr id="10" name="Shape 8"/>
+          <p:cNvSpPr/>
+          <p:nvPr/>
+        </p:nvSpPr>
+        <p:spPr>
+          <a:xfrm>
+            <a:off x="640080" y="2926080"/>
+            <a:ext cx="54864" cy="1097280"/>
+          </a:xfrm>
+          <a:prstGeom prst="rect">
+            <a:avLst/>
+          </a:prstGeom>
+          <a:solidFill>
+            <a:srgbClr val="386641"/>
+          </a:solidFill>
+          <a:ln/>
+        </p:spPr>
+      </p:sp>
+      <p:sp>
+        <p:nvSpPr>
+          <p:cNvPr id="11" name="Text 9"/>
+          <p:cNvSpPr/>
+          <p:nvPr/>
+        </p:nvSpPr>
+        <p:spPr>
+          <a:xfrm>
+            <a:off x="914400" y="3035808"/>
+            <a:ext cx="10332720" cy="365760"/>
+          </a:xfrm>
+          <a:prstGeom prst="rect">
+            <a:avLst/>
+          </a:prstGeom>
+          <a:noFill/>
+          <a:ln/>
+        </p:spPr>
+        <p:txBody>
+          <a:bodyPr wrap="square" rtlCol="0" anchor="ctr"/>
+          <a:lstStyle/>
+          <a:p>
+            <a:pPr indent="0" marL="0">
+              <a:buNone/>
+            </a:pPr>
+            <a:r>
+              <a:rPr lang="en-US" sz="1400" b="1" dirty="0">
+                <a:solidFill>
+                  <a:srgbClr val="1B1F3B"/>
+                </a:solidFill>
+                <a:latin typeface="Segoe UI" pitchFamily="34" charset="0"/>
+                <a:ea typeface="Segoe UI" pitchFamily="34" charset="-122"/>
+                <a:cs typeface="Segoe UI" pitchFamily="34" charset="-120"/>
+              </a:rPr>
+              <a:t>Suppression de code mort dans la génération de devis</a:t>
+            </a:r>
+            <a:endParaRPr lang="en-US" sz="1400" dirty="0"/>
+          </a:p>
+        </p:txBody>
+      </p:sp>
+      <p:sp>
+        <p:nvSpPr>
+          <p:cNvPr id="12" name="Text 10"/>
+          <p:cNvSpPr/>
+          <p:nvPr/>
+        </p:nvSpPr>
+        <p:spPr>
+          <a:xfrm>
+            <a:off x="914400" y="3383280"/>
+            <a:ext cx="10332720" cy="594360"/>
+          </a:xfrm>
+          <a:prstGeom prst="rect">
+            <a:avLst/>
+          </a:prstGeom>
+          <a:noFill/>
+          <a:ln/>
+        </p:spPr>
+        <p:txBody>
+          <a:bodyPr wrap="square" rtlCol="0" anchor="ctr"/>
+          <a:lstStyle/>
+          <a:p>
+            <a:pPr indent="0" marL="0">
+              <a:lnSpc>
+                <a:spcPts val="1400"/>
+              </a:lnSpc>
+              <a:buNone/>
+            </a:pPr>
+            <a:r>
+              <a:rPr lang="en-US" sz="1100" dirty="0">
+                <a:solidFill>
+                  <a:srgbClr val="8A7C68"/>
+                </a:solidFill>
+                <a:latin typeface="Segoe UI" pitchFamily="34" charset="0"/>
+                <a:ea typeface="Segoe UI" pitchFamily="34" charset="-122"/>
+                <a:cs typeface="Segoe UI" pitchFamily="34" charset="-120"/>
+              </a:rPr>
+              <a:t>Un ancien générateur de devis PDF, devenu inaccessible après une précédente refonte (code jamais exécuté), a été retiré du fichier technique de génération de documents.</a:t>
+            </a:r>
+            <a:endParaRPr lang="en-US" sz="1100" dirty="0"/>
+          </a:p>
+        </p:txBody>
+      </p:sp>
+      <p:sp>
+        <p:nvSpPr>
+          <p:cNvPr id="13" name="Shape 11"/>
+          <p:cNvSpPr/>
+          <p:nvPr/>
+        </p:nvSpPr>
+        <p:spPr>
+          <a:xfrm>
+            <a:off x="640080" y="4160520"/>
+            <a:ext cx="10881360" cy="1097280"/>
+          </a:xfrm>
+          <a:prstGeom prst="roundRect">
+            <a:avLst>
+              <a:gd name="adj" fmla="val 5000"/>
+            </a:avLst>
+          </a:prstGeom>
+          <a:solidFill>
+            <a:srgbClr val="FFFFFF"/>
+          </a:solidFill>
+          <a:ln w="12700">
+            <a:solidFill>
+              <a:srgbClr val="E4DCCB"/>
+            </a:solidFill>
+            <a:prstDash val="solid"/>
+          </a:ln>
+        </p:spPr>
+      </p:sp>
+      <p:sp>
+        <p:nvSpPr>
+          <p:cNvPr id="14" name="Shape 12"/>
+          <p:cNvSpPr/>
+          <p:nvPr/>
+        </p:nvSpPr>
+        <p:spPr>
+          <a:xfrm>
+            <a:off x="640080" y="4160520"/>
+            <a:ext cx="54864" cy="1097280"/>
+          </a:xfrm>
+          <a:prstGeom prst="rect">
+            <a:avLst/>
+          </a:prstGeom>
+          <a:solidFill>
+            <a:srgbClr val="386641"/>
+          </a:solidFill>
+          <a:ln/>
+        </p:spPr>
+      </p:sp>
+      <p:sp>
+        <p:nvSpPr>
+          <p:cNvPr id="15" name="Text 13"/>
+          <p:cNvSpPr/>
+          <p:nvPr/>
+        </p:nvSpPr>
+        <p:spPr>
+          <a:xfrm>
+            <a:off x="914400" y="4270248"/>
+            <a:ext cx="10332720" cy="365760"/>
+          </a:xfrm>
+          <a:prstGeom prst="rect">
+            <a:avLst/>
+          </a:prstGeom>
+          <a:noFill/>
+          <a:ln/>
+        </p:spPr>
+        <p:txBody>
+          <a:bodyPr wrap="square" rtlCol="0" anchor="ctr"/>
+          <a:lstStyle/>
+          <a:p>
+            <a:pPr indent="0" marL="0">
+              <a:buNone/>
+            </a:pPr>
+            <a:r>
+              <a:rPr lang="en-US" sz="1400" b="1" dirty="0">
+                <a:solidFill>
+                  <a:srgbClr val="1B1F3B"/>
+                </a:solidFill>
+                <a:latin typeface="Segoe UI" pitchFamily="34" charset="0"/>
+                <a:ea typeface="Segoe UI" pitchFamily="34" charset="-122"/>
+                <a:cs typeface="Segoe UI" pitchFamily="34" charset="-120"/>
+              </a:rPr>
+              <a:t>Suppression de code mort dans l'export Word des devis</a:t>
+            </a:r>
+            <a:endParaRPr lang="en-US" sz="1400" dirty="0"/>
+          </a:p>
+        </p:txBody>
+      </p:sp>
+      <p:sp>
+        <p:nvSpPr>
+          <p:cNvPr id="16" name="Text 14"/>
+          <p:cNvSpPr/>
+          <p:nvPr/>
+        </p:nvSpPr>
+        <p:spPr>
+          <a:xfrm>
+            <a:off x="914400" y="4617720"/>
+            <a:ext cx="10332720" cy="594360"/>
+          </a:xfrm>
+          <a:prstGeom prst="rect">
+            <a:avLst/>
+          </a:prstGeom>
+          <a:noFill/>
+          <a:ln/>
+        </p:spPr>
+        <p:txBody>
+          <a:bodyPr wrap="square" rtlCol="0" anchor="ctr"/>
+          <a:lstStyle/>
+          <a:p>
+            <a:pPr indent="0" marL="0">
+              <a:lnSpc>
+                <a:spcPts val="1400"/>
+              </a:lnSpc>
+              <a:buNone/>
+            </a:pPr>
+            <a:r>
+              <a:rPr lang="en-US" sz="1100" dirty="0">
+                <a:solidFill>
+                  <a:srgbClr val="8A7C68"/>
+                </a:solidFill>
+                <a:latin typeface="Segoe UI" pitchFamily="34" charset="0"/>
+                <a:ea typeface="Segoe UI" pitchFamily="34" charset="-122"/>
+                <a:cs typeface="Segoe UI" pitchFamily="34" charset="-120"/>
+              </a:rPr>
+              <a:t>Un second bloc de génération de document, devenu inaccessible après une précédente refonte (jamais exécuté), a été retiré du fichier technique de génération de documents.</a:t>
+            </a:r>
+            <a:endParaRPr lang="en-US" sz="1100" dirty="0"/>
+          </a:p>
+        </p:txBody>
+      </p:sp>
+      <p:sp>
+        <p:nvSpPr>
+          <p:cNvPr id="17" name="Text 15"/>
+          <p:cNvSpPr/>
+          <p:nvPr/>
+        </p:nvSpPr>
+        <p:spPr>
+          <a:xfrm>
+            <a:off x="365760" y="6510528"/>
+            <a:ext cx="5486400" cy="274320"/>
+          </a:xfrm>
+          <a:prstGeom prst="rect">
+            <a:avLst/>
+          </a:prstGeom>
+          <a:noFill/>
+          <a:ln/>
+        </p:spPr>
+        <p:txBody>
+          <a:bodyPr wrap="square" rtlCol="0" anchor="ctr"/>
+          <a:lstStyle/>
+          <a:p>
+            <a:pPr indent="0" marL="0">
+              <a:buNone/>
+            </a:pPr>
+            <a:r>
+              <a:rPr lang="en-US" sz="900" dirty="0">
+                <a:solidFill>
+                  <a:srgbClr val="8A7C68"/>
+                </a:solidFill>
+                <a:latin typeface="Segoe UI" pitchFamily="34" charset="0"/>
+                <a:ea typeface="Segoe UI" pitchFamily="34" charset="-122"/>
+                <a:cs typeface="Segoe UI" pitchFamily="34" charset="-120"/>
+              </a:rPr>
+              <a:t>Koji Web — Récapitulatif technique</a:t>
+            </a:r>
+            <a:endParaRPr lang="en-US" sz="900" dirty="0"/>
+          </a:p>
+        </p:txBody>
+      </p:sp>
+      <p:sp>
+        <p:nvSpPr>
+          <p:cNvPr id="18" name="Text 16"/>
+          <p:cNvSpPr/>
+          <p:nvPr/>
+        </p:nvSpPr>
+        <p:spPr>
+          <a:xfrm>
+            <a:off x="9601200" y="6510528"/>
+            <a:ext cx="2194560" cy="274320"/>
+          </a:xfrm>
+          <a:prstGeom prst="rect">
+            <a:avLst/>
+          </a:prstGeom>
+          <a:noFill/>
+          <a:ln/>
+        </p:spPr>
+        <p:txBody>
+          <a:bodyPr wrap="square" rtlCol="0" anchor="ctr"/>
+          <a:lstStyle/>
+          <a:p>
+            <a:pPr algn="r" indent="0" marL="0">
+              <a:buNone/>
+            </a:pPr>
+            <a:r>
+              <a:rPr lang="en-US" sz="900" dirty="0">
+                <a:solidFill>
+                  <a:srgbClr val="8A7C68"/>
+                </a:solidFill>
+                <a:latin typeface="Segoe UI" pitchFamily="34" charset="0"/>
+                <a:ea typeface="Segoe UI" pitchFamily="34" charset="-122"/>
+                <a:cs typeface="Segoe UI" pitchFamily="34" charset="-120"/>
+              </a:rPr>
+              <a:t>57</a:t>
+            </a:r>
+            <a:endParaRPr lang="en-US" sz="900" dirty="0"/>
+          </a:p>
+        </p:txBody>
+      </p:sp>
+    </p:spTree>
+  </p:cSld>
+  <p:clrMapOvr>
+    <a:masterClrMapping/>
+  </p:clrMapOvr>
+</p:sld>
+</file>
+
+<file path=ppt/slides/slide58.xml><?xml version="1.0" encoding="utf-8"?>
+<p:sld xmlns:a="http://schemas.openxmlformats.org/drawingml/2006/main" xmlns:r="http://schemas.openxmlformats.org/officeDocument/2006/relationships" xmlns:p="http://schemas.openxmlformats.org/presentationml/2006/main">
+  <p:cSld name="Slide 58">
+    <p:bg>
+      <p:bgPr>
+        <a:solidFill>
+          <a:srgbClr val="F3EEE3"/>
+        </a:solidFill>
+      </p:bgPr>
+    </p:bg>
+    <p:spTree>
+      <p:nvGrpSpPr>
+        <p:cNvPr id="1" name=""/>
+        <p:cNvGrpSpPr/>
+        <p:nvPr/>
+      </p:nvGrpSpPr>
+      <p:grpSpPr>
+        <a:xfrm>
+          <a:off x="0" y="0"/>
+          <a:ext cx="0" cy="0"/>
+          <a:chOff x="0" y="0"/>
+          <a:chExt cx="0" cy="0"/>
+        </a:xfrm>
+      </p:grpSpPr>
+      <p:sp>
+        <p:nvSpPr>
+          <p:cNvPr id="2" name="Shape 0"/>
+          <p:cNvSpPr/>
+          <p:nvPr/>
+        </p:nvSpPr>
+        <p:spPr>
+          <a:xfrm>
+            <a:off x="640080" y="411480"/>
+            <a:ext cx="2377440" cy="365760"/>
+          </a:xfrm>
+          <a:prstGeom prst="roundRect">
+            <a:avLst>
+              <a:gd name="adj" fmla="val 50000"/>
+            </a:avLst>
+          </a:prstGeom>
+          <a:solidFill>
+            <a:srgbClr val="E6EFE4"/>
+          </a:solidFill>
+          <a:ln/>
+        </p:spPr>
+      </p:sp>
+      <p:sp>
+        <p:nvSpPr>
+          <p:cNvPr id="3" name="Text 1"/>
+          <p:cNvSpPr/>
+          <p:nvPr/>
+        </p:nvSpPr>
+        <p:spPr>
+          <a:xfrm>
+            <a:off x="640080" y="411480"/>
+            <a:ext cx="2377440" cy="365760"/>
+          </a:xfrm>
+          <a:prstGeom prst="rect">
+            <a:avLst/>
+          </a:prstGeom>
+          <a:noFill/>
+          <a:ln/>
+        </p:spPr>
+        <p:txBody>
+          <a:bodyPr wrap="square" rtlCol="0" anchor="ctr"/>
+          <a:lstStyle/>
+          <a:p>
+            <a:pPr algn="ctr" indent="0" marL="0">
+              <a:buNone/>
+            </a:pPr>
+            <a:r>
+              <a:rPr lang="en-US" sz="1000" b="1" spc="100" kern="0" dirty="0">
+                <a:solidFill>
+                  <a:srgbClr val="386641"/>
+                </a:solidFill>
+                <a:latin typeface="Segoe UI" pitchFamily="34" charset="0"/>
+                <a:ea typeface="Segoe UI" pitchFamily="34" charset="-122"/>
+                <a:cs typeface="Segoe UI" pitchFamily="34" charset="-120"/>
+              </a:rPr>
+              <a:t>BASE DE DONNÉES</a:t>
+            </a:r>
+            <a:endParaRPr lang="en-US" sz="1000" dirty="0"/>
+          </a:p>
+        </p:txBody>
+      </p:sp>
+      <p:sp>
+        <p:nvSpPr>
+          <p:cNvPr id="4" name="Text 2"/>
+          <p:cNvSpPr/>
+          <p:nvPr/>
+        </p:nvSpPr>
+        <p:spPr>
+          <a:xfrm>
+            <a:off x="640080" y="868680"/>
+            <a:ext cx="10515600" cy="548640"/>
+          </a:xfrm>
+          <a:prstGeom prst="rect">
+            <a:avLst/>
+          </a:prstGeom>
+          <a:noFill/>
+          <a:ln/>
+        </p:spPr>
+        <p:txBody>
+          <a:bodyPr wrap="square" rtlCol="0" anchor="ctr"/>
+          <a:lstStyle/>
+          <a:p>
+            <a:pPr indent="0" marL="0">
+              <a:buNone/>
+            </a:pPr>
+            <a:r>
+              <a:rPr lang="en-US" sz="2400" b="1" dirty="0">
+                <a:solidFill>
+                  <a:srgbClr val="1B1F3B"/>
+                </a:solidFill>
+                <a:latin typeface="Georgia" pitchFamily="34" charset="0"/>
+                <a:ea typeface="Georgia" pitchFamily="34" charset="-122"/>
+                <a:cs typeface="Georgia" pitchFamily="34" charset="-120"/>
+              </a:rPr>
+              <a:t>Sécurité</a:t>
+            </a:r>
+            <a:endParaRPr lang="en-US" sz="2400" dirty="0"/>
+          </a:p>
+        </p:txBody>
+      </p:sp>
+      <p:sp>
+        <p:nvSpPr>
+          <p:cNvPr id="5" name="Shape 3"/>
+          <p:cNvSpPr/>
+          <p:nvPr/>
+        </p:nvSpPr>
+        <p:spPr>
+          <a:xfrm>
+            <a:off x="640080" y="1691640"/>
+            <a:ext cx="10881360" cy="1097280"/>
+          </a:xfrm>
+          <a:prstGeom prst="roundRect">
+            <a:avLst>
+              <a:gd name="adj" fmla="val 5000"/>
+            </a:avLst>
+          </a:prstGeom>
+          <a:solidFill>
+            <a:srgbClr val="FFFFFF"/>
+          </a:solidFill>
+          <a:ln w="12700">
+            <a:solidFill>
+              <a:srgbClr val="E4DCCB"/>
+            </a:solidFill>
+            <a:prstDash val="solid"/>
+          </a:ln>
+        </p:spPr>
+      </p:sp>
+      <p:sp>
+        <p:nvSpPr>
+          <p:cNvPr id="6" name="Shape 4"/>
+          <p:cNvSpPr/>
+          <p:nvPr/>
+        </p:nvSpPr>
+        <p:spPr>
+          <a:xfrm>
+            <a:off x="640080" y="1691640"/>
+            <a:ext cx="54864" cy="1097280"/>
+          </a:xfrm>
+          <a:prstGeom prst="rect">
+            <a:avLst/>
+          </a:prstGeom>
+          <a:solidFill>
+            <a:srgbClr val="386641"/>
+          </a:solidFill>
+          <a:ln/>
+        </p:spPr>
+      </p:sp>
+      <p:sp>
+        <p:nvSpPr>
+          <p:cNvPr id="7" name="Text 5"/>
+          <p:cNvSpPr/>
+          <p:nvPr/>
+        </p:nvSpPr>
+        <p:spPr>
+          <a:xfrm>
+            <a:off x="914400" y="1801368"/>
+            <a:ext cx="10332720" cy="365760"/>
+          </a:xfrm>
+          <a:prstGeom prst="rect">
+            <a:avLst/>
+          </a:prstGeom>
+          <a:noFill/>
+          <a:ln/>
+        </p:spPr>
+        <p:txBody>
+          <a:bodyPr wrap="square" rtlCol="0" anchor="ctr"/>
+          <a:lstStyle/>
+          <a:p>
+            <a:pPr indent="0" marL="0">
+              <a:buNone/>
+            </a:pPr>
+            <a:r>
+              <a:rPr lang="en-US" sz="1400" b="1" dirty="0">
+                <a:solidFill>
+                  <a:srgbClr val="1B1F3B"/>
+                </a:solidFill>
+                <a:latin typeface="Segoe UI" pitchFamily="34" charset="0"/>
+                <a:ea typeface="Segoe UI" pitchFamily="34" charset="-122"/>
+                <a:cs typeface="Segoe UI" pitchFamily="34" charset="-120"/>
+              </a:rPr>
+              <a:t>Base de données partagée verrouillée</a:t>
+            </a:r>
+            <a:endParaRPr lang="en-US" sz="1400" dirty="0"/>
+          </a:p>
+        </p:txBody>
+      </p:sp>
+      <p:sp>
+        <p:nvSpPr>
+          <p:cNvPr id="8" name="Text 6"/>
+          <p:cNvSpPr/>
+          <p:nvPr/>
+        </p:nvSpPr>
+        <p:spPr>
+          <a:xfrm>
+            <a:off x="914400" y="2148840"/>
+            <a:ext cx="10332720" cy="594360"/>
+          </a:xfrm>
+          <a:prstGeom prst="rect">
+            <a:avLst/>
+          </a:prstGeom>
+          <a:noFill/>
+          <a:ln/>
+        </p:spPr>
+        <p:txBody>
+          <a:bodyPr wrap="square" rtlCol="0" anchor="ctr"/>
+          <a:lstStyle/>
+          <a:p>
+            <a:pPr indent="0" marL="0">
+              <a:lnSpc>
+                <a:spcPts val="1400"/>
+              </a:lnSpc>
+              <a:buNone/>
+            </a:pPr>
+            <a:r>
+              <a:rPr lang="en-US" sz="1100" dirty="0">
+                <a:solidFill>
+                  <a:srgbClr val="8A7C68"/>
+                </a:solidFill>
+                <a:latin typeface="Segoe UI" pitchFamily="34" charset="0"/>
+                <a:ea typeface="Segoe UI" pitchFamily="34" charset="-122"/>
+                <a:cs typeface="Segoe UI" pitchFamily="34" charset="-120"/>
+              </a:rPr>
+              <a:t>La table contenant l'essentiel des données de l'application était lisible par n'importe qui sur internet avec la simple clé publique du site, sans connexion. L'application y accède désormais avec une clé privée réservée au serveur, ce qui permet de fermer complètement l'accès public sans rien casser.</a:t>
+            </a:r>
+            <a:endParaRPr lang="en-US" sz="1100" dirty="0"/>
+          </a:p>
+        </p:txBody>
+      </p:sp>
+      <p:sp>
+        <p:nvSpPr>
+          <p:cNvPr id="9" name="Shape 7"/>
+          <p:cNvSpPr/>
+          <p:nvPr/>
+        </p:nvSpPr>
+        <p:spPr>
+          <a:xfrm>
+            <a:off x="640080" y="2926080"/>
+            <a:ext cx="10881360" cy="1097280"/>
+          </a:xfrm>
+          <a:prstGeom prst="roundRect">
+            <a:avLst>
+              <a:gd name="adj" fmla="val 5000"/>
+            </a:avLst>
+          </a:prstGeom>
+          <a:solidFill>
+            <a:srgbClr val="FFFFFF"/>
+          </a:solidFill>
+          <a:ln w="12700">
+            <a:solidFill>
+              <a:srgbClr val="E4DCCB"/>
+            </a:solidFill>
+            <a:prstDash val="solid"/>
+          </a:ln>
+        </p:spPr>
+      </p:sp>
+      <p:sp>
+        <p:nvSpPr>
+          <p:cNvPr id="10" name="Shape 8"/>
+          <p:cNvSpPr/>
+          <p:nvPr/>
+        </p:nvSpPr>
+        <p:spPr>
+          <a:xfrm>
+            <a:off x="640080" y="2926080"/>
+            <a:ext cx="54864" cy="1097280"/>
+          </a:xfrm>
+          <a:prstGeom prst="rect">
+            <a:avLst/>
+          </a:prstGeom>
+          <a:solidFill>
+            <a:srgbClr val="386641"/>
+          </a:solidFill>
+          <a:ln/>
+        </p:spPr>
+      </p:sp>
+      <p:sp>
+        <p:nvSpPr>
+          <p:cNvPr id="11" name="Text 9"/>
+          <p:cNvSpPr/>
+          <p:nvPr/>
+        </p:nvSpPr>
+        <p:spPr>
+          <a:xfrm>
+            <a:off x="914400" y="3035808"/>
+            <a:ext cx="10332720" cy="365760"/>
+          </a:xfrm>
+          <a:prstGeom prst="rect">
+            <a:avLst/>
+          </a:prstGeom>
+          <a:noFill/>
+          <a:ln/>
+        </p:spPr>
+        <p:txBody>
+          <a:bodyPr wrap="square" rtlCol="0" anchor="ctr"/>
+          <a:lstStyle/>
+          <a:p>
+            <a:pPr indent="0" marL="0">
+              <a:buNone/>
+            </a:pPr>
+            <a:r>
+              <a:rPr lang="en-US" sz="1400" b="1" dirty="0">
+                <a:solidFill>
+                  <a:srgbClr val="1B1F3B"/>
+                </a:solidFill>
+                <a:latin typeface="Segoe UI" pitchFamily="34" charset="0"/>
+                <a:ea typeface="Segoe UI" pitchFamily="34" charset="-122"/>
+                <a:cs typeface="Segoe UI" pitchFamily="34" charset="-120"/>
+              </a:rPr>
+              <a:t>Fichier de base de données retiré du dépôt Git</a:t>
+            </a:r>
+            <a:endParaRPr lang="en-US" sz="1400" dirty="0"/>
+          </a:p>
+        </p:txBody>
+      </p:sp>
+      <p:sp>
+        <p:nvSpPr>
+          <p:cNvPr id="12" name="Text 10"/>
+          <p:cNvSpPr/>
+          <p:nvPr/>
+        </p:nvSpPr>
+        <p:spPr>
+          <a:xfrm>
+            <a:off x="914400" y="3383280"/>
+            <a:ext cx="10332720" cy="594360"/>
+          </a:xfrm>
+          <a:prstGeom prst="rect">
+            <a:avLst/>
+          </a:prstGeom>
+          <a:noFill/>
+          <a:ln/>
+        </p:spPr>
+        <p:txBody>
+          <a:bodyPr wrap="square" rtlCol="0" anchor="ctr"/>
+          <a:lstStyle/>
+          <a:p>
+            <a:pPr indent="0" marL="0">
+              <a:lnSpc>
+                <a:spcPts val="1400"/>
+              </a:lnSpc>
+              <a:buNone/>
+            </a:pPr>
+            <a:r>
+              <a:rPr lang="en-US" sz="1100" dirty="0">
+                <a:solidFill>
+                  <a:srgbClr val="8A7C68"/>
+                </a:solidFill>
+                <a:latin typeface="Segoe UI" pitchFamily="34" charset="0"/>
+                <a:ea typeface="Segoe UI" pitchFamily="34" charset="-122"/>
+                <a:cs typeface="Segoe UI" pitchFamily="34" charset="-120"/>
+              </a:rPr>
+              <a:t>Un fichier contenant une copie complète de la base de données de développement, avec des mots de passe réels en clair, était suivi par Git depuis plusieurs mois. Retiré du suivi et exclu définitivement.</a:t>
+            </a:r>
+            <a:endParaRPr lang="en-US" sz="1100" dirty="0"/>
+          </a:p>
+        </p:txBody>
+      </p:sp>
+      <p:sp>
+        <p:nvSpPr>
+          <p:cNvPr id="13" name="Shape 11"/>
+          <p:cNvSpPr/>
+          <p:nvPr/>
+        </p:nvSpPr>
+        <p:spPr>
+          <a:xfrm>
+            <a:off x="640080" y="4160520"/>
+            <a:ext cx="10881360" cy="1097280"/>
+          </a:xfrm>
+          <a:prstGeom prst="roundRect">
+            <a:avLst>
+              <a:gd name="adj" fmla="val 5000"/>
+            </a:avLst>
+          </a:prstGeom>
+          <a:solidFill>
+            <a:srgbClr val="FFFFFF"/>
+          </a:solidFill>
+          <a:ln w="12700">
+            <a:solidFill>
+              <a:srgbClr val="E4DCCB"/>
+            </a:solidFill>
+            <a:prstDash val="solid"/>
+          </a:ln>
+        </p:spPr>
+      </p:sp>
+      <p:sp>
+        <p:nvSpPr>
+          <p:cNvPr id="14" name="Shape 12"/>
+          <p:cNvSpPr/>
+          <p:nvPr/>
+        </p:nvSpPr>
+        <p:spPr>
+          <a:xfrm>
+            <a:off x="640080" y="4160520"/>
+            <a:ext cx="54864" cy="1097280"/>
+          </a:xfrm>
+          <a:prstGeom prst="rect">
+            <a:avLst/>
+          </a:prstGeom>
+          <a:solidFill>
+            <a:srgbClr val="386641"/>
+          </a:solidFill>
+          <a:ln/>
+        </p:spPr>
+      </p:sp>
+      <p:sp>
+        <p:nvSpPr>
+          <p:cNvPr id="15" name="Text 13"/>
+          <p:cNvSpPr/>
+          <p:nvPr/>
+        </p:nvSpPr>
+        <p:spPr>
+          <a:xfrm>
+            <a:off x="914400" y="4270248"/>
+            <a:ext cx="10332720" cy="365760"/>
+          </a:xfrm>
+          <a:prstGeom prst="rect">
+            <a:avLst/>
+          </a:prstGeom>
+          <a:noFill/>
+          <a:ln/>
+        </p:spPr>
+        <p:txBody>
+          <a:bodyPr wrap="square" rtlCol="0" anchor="ctr"/>
+          <a:lstStyle/>
+          <a:p>
+            <a:pPr indent="0" marL="0">
+              <a:buNone/>
+            </a:pPr>
+            <a:r>
+              <a:rPr lang="en-US" sz="1400" b="1" dirty="0">
+                <a:solidFill>
+                  <a:srgbClr val="1B1F3B"/>
+                </a:solidFill>
+                <a:latin typeface="Segoe UI" pitchFamily="34" charset="0"/>
+                <a:ea typeface="Segoe UI" pitchFamily="34" charset="-122"/>
+                <a:cs typeface="Segoe UI" pitchFamily="34" charset="-120"/>
+              </a:rPr>
+              <a:t>Verrouillage de la base partagée écrit dans le script d'installation</a:t>
+            </a:r>
+            <a:endParaRPr lang="en-US" sz="1400" dirty="0"/>
+          </a:p>
+        </p:txBody>
+      </p:sp>
+      <p:sp>
+        <p:nvSpPr>
+          <p:cNvPr id="16" name="Text 14"/>
+          <p:cNvSpPr/>
+          <p:nvPr/>
+        </p:nvSpPr>
+        <p:spPr>
+          <a:xfrm>
+            <a:off x="914400" y="4617720"/>
+            <a:ext cx="10332720" cy="594360"/>
+          </a:xfrm>
+          <a:prstGeom prst="rect">
+            <a:avLst/>
+          </a:prstGeom>
+          <a:noFill/>
+          <a:ln/>
+        </p:spPr>
+        <p:txBody>
+          <a:bodyPr wrap="square" rtlCol="0" anchor="ctr"/>
+          <a:lstStyle/>
+          <a:p>
+            <a:pPr indent="0" marL="0">
+              <a:lnSpc>
+                <a:spcPts val="1400"/>
+              </a:lnSpc>
+              <a:buNone/>
+            </a:pPr>
+            <a:r>
+              <a:rPr lang="en-US" sz="1100" dirty="0">
+                <a:solidFill>
+                  <a:srgbClr val="8A7C68"/>
+                </a:solidFill>
+                <a:latin typeface="Segoe UI" pitchFamily="34" charset="0"/>
+                <a:ea typeface="Segoe UI" pitchFamily="34" charset="-122"/>
+                <a:cs typeface="Segoe UI" pitchFamily="34" charset="-120"/>
+              </a:rPr>
+              <a:t>La commande qui ferme complètement l'accès public à la table de données partagée a été ajoutée au script SQL du projet, prête à être exécutée dans le tableau de bord Supabase.</a:t>
+            </a:r>
+            <a:endParaRPr lang="en-US" sz="1100" dirty="0"/>
+          </a:p>
+        </p:txBody>
+      </p:sp>
+      <p:sp>
+        <p:nvSpPr>
+          <p:cNvPr id="17" name="Text 15"/>
+          <p:cNvSpPr/>
+          <p:nvPr/>
+        </p:nvSpPr>
+        <p:spPr>
+          <a:xfrm>
+            <a:off x="365760" y="6510528"/>
+            <a:ext cx="5486400" cy="274320"/>
+          </a:xfrm>
+          <a:prstGeom prst="rect">
+            <a:avLst/>
+          </a:prstGeom>
+          <a:noFill/>
+          <a:ln/>
+        </p:spPr>
+        <p:txBody>
+          <a:bodyPr wrap="square" rtlCol="0" anchor="ctr"/>
+          <a:lstStyle/>
+          <a:p>
+            <a:pPr indent="0" marL="0">
+              <a:buNone/>
+            </a:pPr>
+            <a:r>
+              <a:rPr lang="en-US" sz="900" dirty="0">
+                <a:solidFill>
+                  <a:srgbClr val="8A7C68"/>
+                </a:solidFill>
+                <a:latin typeface="Segoe UI" pitchFamily="34" charset="0"/>
+                <a:ea typeface="Segoe UI" pitchFamily="34" charset="-122"/>
+                <a:cs typeface="Segoe UI" pitchFamily="34" charset="-120"/>
+              </a:rPr>
+              <a:t>Koji Web — Récapitulatif technique</a:t>
+            </a:r>
+            <a:endParaRPr lang="en-US" sz="900" dirty="0"/>
+          </a:p>
+        </p:txBody>
+      </p:sp>
+      <p:sp>
+        <p:nvSpPr>
+          <p:cNvPr id="18" name="Text 16"/>
+          <p:cNvSpPr/>
+          <p:nvPr/>
+        </p:nvSpPr>
+        <p:spPr>
+          <a:xfrm>
+            <a:off x="9601200" y="6510528"/>
+            <a:ext cx="2194560" cy="274320"/>
+          </a:xfrm>
+          <a:prstGeom prst="rect">
+            <a:avLst/>
+          </a:prstGeom>
+          <a:noFill/>
+          <a:ln/>
+        </p:spPr>
+        <p:txBody>
+          <a:bodyPr wrap="square" rtlCol="0" anchor="ctr"/>
+          <a:lstStyle/>
+          <a:p>
+            <a:pPr algn="r" indent="0" marL="0">
+              <a:buNone/>
+            </a:pPr>
+            <a:r>
+              <a:rPr lang="en-US" sz="900" dirty="0">
+                <a:solidFill>
+                  <a:srgbClr val="8A7C68"/>
+                </a:solidFill>
+                <a:latin typeface="Segoe UI" pitchFamily="34" charset="0"/>
+                <a:ea typeface="Segoe UI" pitchFamily="34" charset="-122"/>
+                <a:cs typeface="Segoe UI" pitchFamily="34" charset="-120"/>
+              </a:rPr>
+              <a:t>58</a:t>
+            </a:r>
+            <a:endParaRPr lang="en-US" sz="900" dirty="0"/>
+          </a:p>
+        </p:txBody>
+      </p:sp>
+    </p:spTree>
+  </p:cSld>
+  <p:clrMapOvr>
+    <a:masterClrMapping/>
+  </p:clrMapOvr>
+</p:sld>
+</file>
+
+<file path=ppt/slides/slide59.xml><?xml version="1.0" encoding="utf-8"?>
+<p:sld xmlns:a="http://schemas.openxmlformats.org/drawingml/2006/main" xmlns:r="http://schemas.openxmlformats.org/officeDocument/2006/relationships" xmlns:p="http://schemas.openxmlformats.org/presentationml/2006/main">
+  <p:cSld name="Slide 59">
     <p:bg>
       <p:bgPr>
         <a:solidFill>

</xml_diff>